<commit_message>
Deck: slide 2 is the title and a news screenshot; D and P(fail) move to the model slide
- "The puzzle: who runs?" with a CryptoSlate screenshot (12 Oct 2026, FSB warns
  stablecoins can face runs even fully reserved), captioned with outlet, date, site
- figures/deck/news_fsb_2026-10-12.png: headless Firefox capture, cropped to the hero
- the outcome definitions now sit as a bullet on "The model in one picture"

Co-Authored-By: Claude Fable 5.1 <noreply@anthropic.com>
</commit_message>
<xml_diff>
--- a/docs/deck_2026-10-26_seminar.pptx
+++ b/docs/deck_2026-10-26_seminar.pptx
@@ -130,7 +130,7 @@
   <p:extLst>
     <p:ext uri="{521415D9-36F7-43E2-AB2F-B90AF26B5E84}">
       <p14:sectionLst xmlns:p14="http://schemas.microsoft.com/office/powerpoint/2010/main">
-        <p14:section name="Opening" id="{3d6dfd1a-c677-eda8-d4b3-acbc1cb46f82}">
+        <p14:section name="Opening" id="{f012b5cf-c93c-135a-065d-f612df317736}">
           <p14:sldIdLst>
             <p14:sldId id="256"/>
             <p14:sldId id="257"/>
@@ -144,13 +144,13 @@
             <p14:sldId id="265"/>
           </p14:sldIdLst>
         </p14:section>
-        <p14:section name="The model" id="{574aeb74-a2c1-471e-74f9-2577ad5000f3}">
+        <p14:section name="The model" id="{e9e34b79-d097-3f71-acb9-97b569b0fe6f}">
           <p14:sldIdLst>
             <p14:sldId id="266"/>
             <p14:sldId id="267"/>
           </p14:sldIdLst>
         </p14:section>
-        <p14:section name="Results" id="{8f4bd9b0-6480-5c00-f3fa-b2d08b25b632}">
+        <p14:section name="Results" id="{19d055d8-5dd2-1fe6-5e78-ec98aa1c4ecf}">
           <p14:sldIdLst>
             <p14:sldId id="268"/>
             <p14:sldId id="269"/>
@@ -158,17 +158,17 @@
             <p14:sldId id="271"/>
           </p14:sldIdLst>
         </p14:section>
-        <p14:section name="Validation" id="{88d0649b-6dbb-0d9b-576e-a7a7298cb198}">
+        <p14:section name="Validation" id="{7d1f650e-d851-0ec3-9bd6-bb1aa889c585}">
           <p14:sldIdLst>
             <p14:sldId id="272"/>
           </p14:sldIdLst>
         </p14:section>
-        <p14:section name="Close" id="{d1a86f69-0ecc-a79f-6f5d-4115012b9caf}">
+        <p14:section name="Close" id="{d1aa692c-05c2-d5af-e394-dbc0c614ae80}">
           <p14:sldIdLst>
             <p14:sldId id="273"/>
           </p14:sldIdLst>
         </p14:section>
-        <p14:section name="Backup" id="{d32d1c94-2944-21c6-83f2-769a6ed9eade}">
+        <p14:section name="Backup" id="{9cc6fec1-8058-488f-6b31-9cb5c20afb40}">
           <p14:sldIdLst>
             <p14:sldId id="274"/>
             <p14:sldId id="275"/>
@@ -1550,7 +1550,7 @@
           <a:p>
             <a:r>
               <a:rPr lang="en-US" dirty="0"/>
-              <a:t>~1.5 min. Theory (Diamond–Dybvig) says runs can happen; it is silent on who runs first and how a run spreads. Optional visual: a historical photo of a bank run.</a:t>
+              <a:t>~1.5 min. Raise the question only: who runs? Theory (Diamond–Dybvig) says runs can happen; it is silent on who runs first and how a run spreads. The screenshot: the FSB warned the G20 on 12 October 2026 that a fully reserved stablecoin can still face a redemption run. Even a regulator thinking about a modern run asks whether one happens, not who starts it. Alternative screenshot in figures/deck is not provided; the Nano Banc failure (25 September 2026, American Banker) was a capital failure, not a run.</a:t>
             </a:r>
             <a:endParaRPr lang="en-US" dirty="0"/>
           </a:p>
@@ -4202,8 +4202,8 @@
         </p:nvSpPr>
         <p:spPr>
           <a:xfrm>
-            <a:off x="4244873" y="3291840"/>
-            <a:ext cx="4441927" cy="1325880"/>
+            <a:off x="4244873" y="3200400"/>
+            <a:ext cx="4441927" cy="1371600"/>
           </a:xfrm>
           <a:prstGeom prst="rect">
             <a:avLst/>
@@ -4217,56 +4217,74 @@
           <a:p>
             <a:pPr marL="177800" indent="-177800">
               <a:spcAft>
-                <a:spcPts val="500"/>
+                <a:spcPts val="400"/>
               </a:spcAft>
               <a:buSzPct val="100000"/>
               <a:buChar char="•"/>
             </a:pPr>
             <a:r>
-              <a:rPr lang="en-US" sz="1200" dirty="0">
+              <a:rPr lang="en-US" sz="1150" dirty="0">
                 <a:solidFill>
                   <a:schemeClr val="tx1"/>
                 </a:solidFill>
               </a:rPr>
               <a:t>One bank that sells its long asset at a discount when cash runs short (a fire-sale bank)</a:t>
             </a:r>
-            <a:endParaRPr lang="en-US" sz="1200" dirty="0"/>
+            <a:endParaRPr lang="en-US" sz="1150" dirty="0"/>
           </a:p>
           <a:p>
             <a:pPr marL="177800" indent="-177800">
               <a:spcAft>
-                <a:spcPts val="500"/>
+                <a:spcPts val="400"/>
               </a:spcAft>
               <a:buSzPct val="100000"/>
               <a:buChar char="•"/>
             </a:pPr>
             <a:r>
-              <a:rPr lang="en-US" sz="1200" dirty="0">
+              <a:rPr lang="en-US" sz="1150" dirty="0">
                 <a:solidFill>
                   <a:schemeClr val="tx1"/>
                 </a:solidFill>
               </a:rPr>
               <a:t>Each tick a depositor sees neighbours’ withdrawals and the public news, blends them with a private signal, and withdraws if that pays</a:t>
             </a:r>
-            <a:endParaRPr lang="en-US" sz="1200" dirty="0"/>
+            <a:endParaRPr lang="en-US" sz="1150" dirty="0"/>
           </a:p>
           <a:p>
             <a:pPr marL="177800" indent="-177800">
               <a:spcAft>
-                <a:spcPts val="500"/>
+                <a:spcPts val="400"/>
               </a:spcAft>
               <a:buSzPct val="100000"/>
               <a:buChar char="•"/>
             </a:pPr>
             <a:r>
-              <a:rPr lang="en-US" sz="1200" dirty="0">
+              <a:rPr lang="en-US" sz="1150" dirty="0">
                 <a:solidFill>
                   <a:schemeClr val="tx1"/>
                 </a:solidFill>
               </a:rPr>
               <a:t>A public signal can be absent, accurate, or outdated</a:t>
             </a:r>
-            <a:endParaRPr lang="en-US" sz="1200" dirty="0"/>
+            <a:endParaRPr lang="en-US" sz="1150" dirty="0"/>
+          </a:p>
+          <a:p>
+            <a:pPr marL="177800" indent="-177800">
+              <a:spcAft>
+                <a:spcPts val="400"/>
+              </a:spcAft>
+              <a:buSzPct val="100000"/>
+              <a:buChar char="•"/>
+            </a:pPr>
+            <a:r>
+              <a:rPr lang="en-US" sz="1150" dirty="0">
+                <a:solidFill>
+                  <a:schemeClr val="tx1"/>
+                </a:solidFill>
+              </a:rPr>
+              <a:t>Outcomes: D = individualists’ minus collectivists’ withdrawal share (those not hit by the shock); P(fail) = share of runs that fail</a:t>
+            </a:r>
+            <a:endParaRPr lang="en-US" sz="1150" dirty="0"/>
           </a:p>
         </p:txBody>
       </p:sp>
@@ -8968,49 +8986,46 @@
                   <a:schemeClr val="tx2"/>
                 </a:solidFill>
               </a:rPr>
-              <a:t>The puzzle: who runs, and how a run spreads</a:t>
+              <a:t>The puzzle: who runs?</a:t>
             </a:r>
             <a:endParaRPr lang="en-US" sz="2400" dirty="0"/>
           </a:p>
         </p:txBody>
       </p:sp>
-      <p:sp>
-        <p:nvSpPr>
-          <p:cNvPr id="3" name="card-Diamond–Dybvig"/>
-          <p:cNvSpPr/>
-          <p:nvPr/>
-        </p:nvSpPr>
-        <p:spPr>
-          <a:xfrm>
-            <a:off x="457200" y="1051560"/>
-            <a:ext cx="2651760" cy="1463040"/>
-          </a:xfrm>
-          <a:prstGeom prst="roundRect">
-            <a:avLst>
-              <a:gd name="adj" fmla="val 5000"/>
-            </a:avLst>
-          </a:prstGeom>
-          <a:solidFill>
-            <a:schemeClr val="bg2"/>
-          </a:solidFill>
-          <a:ln w="12700">
-            <a:solidFill>
-              <a:schemeClr val="bg2"/>
-            </a:solidFill>
-            <a:prstDash val="solid"/>
-          </a:ln>
-        </p:spPr>
-      </p:sp>
-      <p:sp>
-        <p:nvSpPr>
-          <p:cNvPr id="4" name="card-head"/>
+      <p:pic>
+        <p:nvPicPr>
+          <p:cNvPr id="3" name="news" descr="Screenshot of a CryptoSlate news article dated 12 October 2026: Global watchdog warns the $300 billion stablecoin market could face bank runs even with full reserves. The FSB says cross-border liquidity mismatches could trigger redemption crises and threaten dollar pegs as regulators prepare for G20 discussions.">    </p:cNvPr>
+          <p:cNvPicPr>
+            <a:picLocks noChangeAspect="1"/>
+          </p:cNvPicPr>
+          <p:nvPr/>
+        </p:nvPicPr>
+        <p:blipFill>
+          <a:blip r:embed="rId1"/>
+          <a:stretch>
+            <a:fillRect/>
+          </a:stretch>
+        </p:blipFill>
+        <p:spPr>
+          <a:xfrm>
+            <a:off x="2414267" y="1051560"/>
+            <a:ext cx="4315465" cy="3337560"/>
+          </a:xfrm>
+          <a:prstGeom prst="rect">
+            <a:avLst/>
+          </a:prstGeom>
+        </p:spPr>
+      </p:pic>
+      <p:sp>
+        <p:nvSpPr>
+          <p:cNvPr id="4" name="caption"/>
           <p:cNvSpPr txBox="1"/>
           <p:nvPr/>
         </p:nvSpPr>
         <p:spPr>
           <a:xfrm>
-            <a:off x="594360" y="1143000"/>
-            <a:ext cx="2377440" cy="292608"/>
+            <a:off x="2414267" y="4434840"/>
+            <a:ext cx="4315465" cy="274320"/>
           </a:xfrm>
           <a:prstGeom prst="rect">
             <a:avLst/>
@@ -9026,526 +9041,14 @@
               <a:buNone/>
             </a:pPr>
             <a:r>
-              <a:rPr lang="en-US" sz="1300" b="1" dirty="0">
-                <a:solidFill>
-                  <a:schemeClr val="tx2"/>
-                </a:solidFill>
-              </a:rPr>
-              <a:t>Diamond–Dybvig</a:t>
-            </a:r>
-            <a:endParaRPr lang="en-US" sz="1300" dirty="0"/>
-          </a:p>
-        </p:txBody>
-      </p:sp>
-      <p:sp>
-        <p:nvSpPr>
-          <p:cNvPr id="5" name="card-body"/>
-          <p:cNvSpPr txBox="1"/>
-          <p:nvPr/>
-        </p:nvSpPr>
-        <p:spPr>
-          <a:xfrm>
-            <a:off x="594360" y="1463040"/>
-            <a:ext cx="2377440" cy="960120"/>
-          </a:xfrm>
-          <a:prstGeom prst="rect">
-            <a:avLst/>
-          </a:prstGeom>
-          <a:noFill/>
-          <a:ln/>
-        </p:spPr>
-        <p:txBody>
-          <a:bodyPr wrap="square" lIns="0" tIns="0" rIns="0" bIns="0" rtlCol="0" anchor="t"/>
-          <a:lstStyle/>
-          <a:p>
-            <a:pPr indent="0" marL="0">
-              <a:buNone/>
-            </a:pPr>
-            <a:r>
-              <a:rPr lang="en-US" sz="1150" dirty="0">
-                <a:solidFill>
-                  <a:schemeClr val="tx1"/>
-                </a:solidFill>
-              </a:rPr>
-              <a:t>A run is an equilibrium. The theory says runs can happen; it says nothing about who runs first or how a run spreads.</a:t>
-            </a:r>
-            <a:endParaRPr lang="en-US" sz="1150" dirty="0"/>
-          </a:p>
-        </p:txBody>
-      </p:sp>
-      <p:sp>
-        <p:nvSpPr>
-          <p:cNvPr id="6" name="card-Chapter 1: theory"/>
-          <p:cNvSpPr/>
-          <p:nvPr/>
-        </p:nvSpPr>
-        <p:spPr>
-          <a:xfrm>
-            <a:off x="3246120" y="1051560"/>
-            <a:ext cx="2651760" cy="1463040"/>
-          </a:xfrm>
-          <a:prstGeom prst="roundRect">
-            <a:avLst>
-              <a:gd name="adj" fmla="val 5000"/>
-            </a:avLst>
-          </a:prstGeom>
-          <a:solidFill>
-            <a:schemeClr val="bg2"/>
-          </a:solidFill>
-          <a:ln w="12700">
-            <a:solidFill>
-              <a:schemeClr val="bg2"/>
-            </a:solidFill>
-            <a:prstDash val="solid"/>
-          </a:ln>
-        </p:spPr>
-      </p:sp>
-      <p:sp>
-        <p:nvSpPr>
-          <p:cNvPr id="7" name="card-head"/>
-          <p:cNvSpPr txBox="1"/>
-          <p:nvPr/>
-        </p:nvSpPr>
-        <p:spPr>
-          <a:xfrm>
-            <a:off x="3383280" y="1143000"/>
-            <a:ext cx="2377440" cy="292608"/>
-          </a:xfrm>
-          <a:prstGeom prst="rect">
-            <a:avLst/>
-          </a:prstGeom>
-          <a:noFill/>
-          <a:ln/>
-        </p:spPr>
-        <p:txBody>
-          <a:bodyPr wrap="square" lIns="0" tIns="0" rIns="0" bIns="0" rtlCol="0" anchor="ctr"/>
-          <a:lstStyle/>
-          <a:p>
-            <a:pPr indent="0" marL="0">
-              <a:buNone/>
-            </a:pPr>
-            <a:r>
-              <a:rPr lang="en-US" sz="1300" b="1" dirty="0">
-                <a:solidFill>
-                  <a:schemeClr val="tx2"/>
-                </a:solidFill>
-              </a:rPr>
-              <a:t>Chapter 1: theory</a:t>
-            </a:r>
-            <a:endParaRPr lang="en-US" sz="1300" dirty="0"/>
-          </a:p>
-        </p:txBody>
-      </p:sp>
-      <p:sp>
-        <p:nvSpPr>
-          <p:cNvPr id="8" name="card-body"/>
-          <p:cNvSpPr txBox="1"/>
-          <p:nvPr/>
-        </p:nvSpPr>
-        <p:spPr>
-          <a:xfrm>
-            <a:off x="3383280" y="1463040"/>
-            <a:ext cx="2377440" cy="960120"/>
-          </a:xfrm>
-          <a:prstGeom prst="rect">
-            <a:avLst/>
-          </a:prstGeom>
-          <a:noFill/>
-          <a:ln/>
-        </p:spPr>
-        <p:txBody>
-          <a:bodyPr wrap="square" lIns="0" tIns="0" rIns="0" bIns="0" rtlCol="0" anchor="t"/>
-          <a:lstStyle/>
-          <a:p>
-            <a:pPr indent="0" marL="0">
-              <a:buNone/>
-            </a:pPr>
-            <a:r>
-              <a:rPr lang="en-US" sz="1150" dirty="0">
-                <a:solidFill>
-                  <a:schemeClr val="tx1"/>
-                </a:solidFill>
-              </a:rPr>
-              <a:t>Depositors differ in how much they weigh their own information against public news and what others do. That difference predicts who moves first, and in which direction, given the news.</a:t>
-            </a:r>
-            <a:endParaRPr lang="en-US" sz="1150" dirty="0"/>
-          </a:p>
-        </p:txBody>
-      </p:sp>
-      <p:sp>
-        <p:nvSpPr>
-          <p:cNvPr id="9" name="card-Chapter 2: Celsius"/>
-          <p:cNvSpPr/>
-          <p:nvPr/>
-        </p:nvSpPr>
-        <p:spPr>
-          <a:xfrm>
-            <a:off x="6035040" y="1051560"/>
-            <a:ext cx="2651760" cy="1463040"/>
-          </a:xfrm>
-          <a:prstGeom prst="roundRect">
-            <a:avLst>
-              <a:gd name="adj" fmla="val 5000"/>
-            </a:avLst>
-          </a:prstGeom>
-          <a:solidFill>
-            <a:schemeClr val="bg2"/>
-          </a:solidFill>
-          <a:ln w="12700">
-            <a:solidFill>
-              <a:schemeClr val="bg2"/>
-            </a:solidFill>
-            <a:prstDash val="solid"/>
-          </a:ln>
-        </p:spPr>
-      </p:sp>
-      <p:sp>
-        <p:nvSpPr>
-          <p:cNvPr id="10" name="card-head"/>
-          <p:cNvSpPr txBox="1"/>
-          <p:nvPr/>
-        </p:nvSpPr>
-        <p:spPr>
-          <a:xfrm>
-            <a:off x="6172200" y="1143000"/>
-            <a:ext cx="2377440" cy="292608"/>
-          </a:xfrm>
-          <a:prstGeom prst="rect">
-            <a:avLst/>
-          </a:prstGeom>
-          <a:noFill/>
-          <a:ln/>
-        </p:spPr>
-        <p:txBody>
-          <a:bodyPr wrap="square" lIns="0" tIns="0" rIns="0" bIns="0" rtlCol="0" anchor="ctr"/>
-          <a:lstStyle/>
-          <a:p>
-            <a:pPr indent="0" marL="0">
-              <a:buNone/>
-            </a:pPr>
-            <a:r>
-              <a:rPr lang="en-US" sz="1300" b="1" dirty="0">
-                <a:solidFill>
-                  <a:schemeClr val="tx2"/>
-                </a:solidFill>
-              </a:rPr>
-              <a:t>Chapter 2: Celsius</a:t>
-            </a:r>
-            <a:endParaRPr lang="en-US" sz="1300" dirty="0"/>
-          </a:p>
-        </p:txBody>
-      </p:sp>
-      <p:sp>
-        <p:nvSpPr>
-          <p:cNvPr id="11" name="card-body"/>
-          <p:cNvSpPr txBox="1"/>
-          <p:nvPr/>
-        </p:nvSpPr>
-        <p:spPr>
-          <a:xfrm>
-            <a:off x="6172200" y="1463040"/>
-            <a:ext cx="2377440" cy="960120"/>
-          </a:xfrm>
-          <a:prstGeom prst="rect">
-            <a:avLst/>
-          </a:prstGeom>
-          <a:noFill/>
-          <a:ln/>
-        </p:spPr>
-        <p:txBody>
-          <a:bodyPr wrap="square" lIns="0" tIns="0" rIns="0" bIns="0" rtlCol="0" anchor="t"/>
-          <a:lstStyle/>
-          <a:p>
-            <a:pPr indent="0" marL="0">
-              <a:buNone/>
-            </a:pPr>
-            <a:r>
-              <a:rPr lang="en-US" sz="1150" dirty="0">
-                <a:solidFill>
-                  <a:schemeClr val="tx1"/>
-                </a:solidFill>
-              </a:rPr>
-              <a:t>Those differences show up in real withdrawals. But one platform and one shock cannot vary the mix of depositors or the information they received.</a:t>
-            </a:r>
-            <a:endParaRPr lang="en-US" sz="1150" dirty="0"/>
-          </a:p>
-        </p:txBody>
-      </p:sp>
-      <p:sp>
-        <p:nvSpPr>
-          <p:cNvPr id="12" name="ch3"/>
-          <p:cNvSpPr/>
-          <p:nvPr/>
-        </p:nvSpPr>
-        <p:spPr>
-          <a:xfrm>
-            <a:off x="457200" y="2651760"/>
-            <a:ext cx="8229600" cy="868680"/>
-          </a:xfrm>
-          <a:prstGeom prst="roundRect">
-            <a:avLst>
-              <a:gd name="adj" fmla="val 8421"/>
-            </a:avLst>
-          </a:prstGeom>
-          <a:solidFill>
-            <a:schemeClr val="accent4"/>
-          </a:solidFill>
-          <a:ln w="12700">
-            <a:solidFill>
-              <a:schemeClr val="accent4"/>
-            </a:solidFill>
-            <a:prstDash val="solid"/>
-          </a:ln>
-        </p:spPr>
-      </p:sp>
-      <p:sp>
-        <p:nvSpPr>
-          <p:cNvPr id="13" name="ch3-text"/>
-          <p:cNvSpPr txBox="1"/>
-          <p:nvPr/>
-        </p:nvSpPr>
-        <p:spPr>
-          <a:xfrm>
-            <a:off x="594360" y="2697480"/>
-            <a:ext cx="7955280" cy="777240"/>
-          </a:xfrm>
-          <a:prstGeom prst="rect">
-            <a:avLst/>
-          </a:prstGeom>
-          <a:noFill/>
-          <a:ln/>
-        </p:spPr>
-        <p:txBody>
-          <a:bodyPr wrap="square" lIns="0" tIns="0" rIns="0" bIns="0" rtlCol="0" anchor="ctr"/>
-          <a:lstStyle/>
-          <a:p>
-            <a:pPr indent="0" marL="0">
-              <a:buNone/>
-            </a:pPr>
-            <a:r>
-              <a:rPr lang="en-US" sz="1250" b="1" dirty="0">
-                <a:solidFill>
-                  <a:schemeClr val="accent1"/>
-                </a:solidFill>
-              </a:rPr>
-              <a:t>Chapter 3, this talk: </a:t>
-            </a:r>
-            <a:pPr indent="0" marL="0">
-              <a:buNone/>
-            </a:pPr>
-            <a:r>
-              <a:rPr lang="en-US" sz="1250" dirty="0">
-                <a:solidFill>
-                  <a:schemeClr val="tx1"/>
-                </a:solidFill>
-              </a:rPr>
-              <a:t>a population of interacting depositors in which the mix of types, the public signal, deposit concentration and the bank’s contract can each be varied. Does the theory’s mechanism survive there?</a:t>
-            </a:r>
-            <a:endParaRPr lang="en-US" sz="1250" dirty="0"/>
-          </a:p>
-        </p:txBody>
-      </p:sp>
-      <p:sp>
-        <p:nvSpPr>
-          <p:cNvPr id="14" name="def-D"/>
-          <p:cNvSpPr/>
-          <p:nvPr/>
-        </p:nvSpPr>
-        <p:spPr>
-          <a:xfrm>
-            <a:off x="457200" y="3657600"/>
-            <a:ext cx="4023360" cy="914400"/>
-          </a:xfrm>
-          <a:prstGeom prst="roundRect">
-            <a:avLst>
-              <a:gd name="adj" fmla="val 8000"/>
-            </a:avLst>
-          </a:prstGeom>
-          <a:solidFill>
-            <a:schemeClr val="bg2"/>
-          </a:solidFill>
-          <a:ln w="12700">
-            <a:solidFill>
-              <a:schemeClr val="bg2"/>
-            </a:solidFill>
-            <a:prstDash val="solid"/>
-          </a:ln>
-        </p:spPr>
-      </p:sp>
-      <p:sp>
-        <p:nvSpPr>
-          <p:cNvPr id="15" name="def-big"/>
-          <p:cNvSpPr txBox="1"/>
-          <p:nvPr/>
-        </p:nvSpPr>
-        <p:spPr>
-          <a:xfrm>
-            <a:off x="594360" y="3703320"/>
-            <a:ext cx="1188720" cy="822960"/>
-          </a:xfrm>
-          <a:prstGeom prst="rect">
-            <a:avLst/>
-          </a:prstGeom>
-          <a:noFill/>
-          <a:ln/>
-        </p:spPr>
-        <p:txBody>
-          <a:bodyPr wrap="square" lIns="0" tIns="0" rIns="0" bIns="0" rtlCol="0" anchor="ctr"/>
-          <a:lstStyle/>
-          <a:p>
-            <a:pPr indent="0" marL="0">
-              <a:buNone/>
-            </a:pPr>
-            <a:r>
-              <a:rPr lang="en-US" sz="2400" b="1" dirty="0">
-                <a:solidFill>
-                  <a:schemeClr val="accent1"/>
-                </a:solidFill>
-                <a:latin typeface="Cambria" pitchFamily="34" charset="0"/>
-                <a:ea typeface="Cambria" pitchFamily="34" charset="-122"/>
-                <a:cs typeface="Cambria" pitchFamily="34" charset="-120"/>
-              </a:rPr>
-              <a:t>D</a:t>
-            </a:r>
-            <a:endParaRPr lang="en-US" sz="2400" dirty="0"/>
-          </a:p>
-        </p:txBody>
-      </p:sp>
-      <p:sp>
-        <p:nvSpPr>
-          <p:cNvPr id="16" name="def-label"/>
-          <p:cNvSpPr txBox="1"/>
-          <p:nvPr/>
-        </p:nvSpPr>
-        <p:spPr>
-          <a:xfrm>
-            <a:off x="1828800" y="3703320"/>
-            <a:ext cx="2560320" cy="822960"/>
-          </a:xfrm>
-          <a:prstGeom prst="rect">
-            <a:avLst/>
-          </a:prstGeom>
-          <a:noFill/>
-          <a:ln/>
-        </p:spPr>
-        <p:txBody>
-          <a:bodyPr wrap="square" lIns="0" tIns="0" rIns="0" bIns="0" rtlCol="0" anchor="ctr"/>
-          <a:lstStyle/>
-          <a:p>
-            <a:pPr indent="0" marL="0">
-              <a:buNone/>
-            </a:pPr>
-            <a:r>
-              <a:rPr lang="en-US" sz="1100" dirty="0">
+              <a:rPr lang="en-US" sz="1000" i="1" dirty="0">
                 <a:solidFill>
                   <a:schemeClr val="accent3"/>
                 </a:solidFill>
               </a:rPr>
-              <a:t>share of individualists who withdraw minus share of collectivists, among depositors the shock did not hit</a:t>
-            </a:r>
-            <a:endParaRPr lang="en-US" sz="1100" dirty="0"/>
-          </a:p>
-        </p:txBody>
-      </p:sp>
-      <p:sp>
-        <p:nvSpPr>
-          <p:cNvPr id="17" name="def-P(fail)"/>
-          <p:cNvSpPr/>
-          <p:nvPr/>
-        </p:nvSpPr>
-        <p:spPr>
-          <a:xfrm>
-            <a:off x="4663440" y="3657600"/>
-            <a:ext cx="4023360" cy="914400"/>
-          </a:xfrm>
-          <a:prstGeom prst="roundRect">
-            <a:avLst>
-              <a:gd name="adj" fmla="val 8000"/>
-            </a:avLst>
-          </a:prstGeom>
-          <a:solidFill>
-            <a:schemeClr val="bg2"/>
-          </a:solidFill>
-          <a:ln w="12700">
-            <a:solidFill>
-              <a:schemeClr val="bg2"/>
-            </a:solidFill>
-            <a:prstDash val="solid"/>
-          </a:ln>
-        </p:spPr>
-      </p:sp>
-      <p:sp>
-        <p:nvSpPr>
-          <p:cNvPr id="18" name="def-big"/>
-          <p:cNvSpPr txBox="1"/>
-          <p:nvPr/>
-        </p:nvSpPr>
-        <p:spPr>
-          <a:xfrm>
-            <a:off x="4800600" y="3703320"/>
-            <a:ext cx="1188720" cy="822960"/>
-          </a:xfrm>
-          <a:prstGeom prst="rect">
-            <a:avLst/>
-          </a:prstGeom>
-          <a:noFill/>
-          <a:ln/>
-        </p:spPr>
-        <p:txBody>
-          <a:bodyPr wrap="square" lIns="0" tIns="0" rIns="0" bIns="0" rtlCol="0" anchor="ctr"/>
-          <a:lstStyle/>
-          <a:p>
-            <a:pPr indent="0" marL="0">
-              <a:buNone/>
-            </a:pPr>
-            <a:r>
-              <a:rPr lang="en-US" sz="2400" b="1" dirty="0">
-                <a:solidFill>
-                  <a:schemeClr val="accent1"/>
-                </a:solidFill>
-                <a:latin typeface="Cambria" pitchFamily="34" charset="0"/>
-                <a:ea typeface="Cambria" pitchFamily="34" charset="-122"/>
-                <a:cs typeface="Cambria" pitchFamily="34" charset="-120"/>
-              </a:rPr>
-              <a:t>P(fail)</a:t>
-            </a:r>
-            <a:endParaRPr lang="en-US" sz="2400" dirty="0"/>
-          </a:p>
-        </p:txBody>
-      </p:sp>
-      <p:sp>
-        <p:nvSpPr>
-          <p:cNvPr id="19" name="def-label"/>
-          <p:cNvSpPr txBox="1"/>
-          <p:nvPr/>
-        </p:nvSpPr>
-        <p:spPr>
-          <a:xfrm>
-            <a:off x="6035040" y="3703320"/>
-            <a:ext cx="2560320" cy="822960"/>
-          </a:xfrm>
-          <a:prstGeom prst="rect">
-            <a:avLst/>
-          </a:prstGeom>
-          <a:noFill/>
-          <a:ln/>
-        </p:spPr>
-        <p:txBody>
-          <a:bodyPr wrap="square" lIns="0" tIns="0" rIns="0" bIns="0" rtlCol="0" anchor="ctr"/>
-          <a:lstStyle/>
-          <a:p>
-            <a:pPr indent="0" marL="0">
-              <a:buNone/>
-            </a:pPr>
-            <a:r>
-              <a:rPr lang="en-US" sz="1100" dirty="0">
-                <a:solidFill>
-                  <a:schemeClr val="accent3"/>
-                </a:solidFill>
-              </a:rPr>
-              <a:t>share of runs that end with the bank failing</a:t>
-            </a:r>
-            <a:endParaRPr lang="en-US" sz="1100" dirty="0"/>
+              <a:t>CryptoSlate, 12 October 2026, on the Financial Stability Board’s note to the G20. Screenshot, cryptoslate.com.</a:t>
+            </a:r>
+            <a:endParaRPr lang="en-US" sz="1000" dirty="0"/>
           </a:p>
         </p:txBody>
       </p:sp>

</xml_diff>

<commit_message>
Deck: ladder rungs renamed to variation in the signal, location, interpretation (slides 3, 9, 10)
Co-Authored-By: Claude Fable 5.1 <noreply@anthropic.com>
</commit_message>
<xml_diff>
--- a/docs/deck_2026-10-26_seminar.pptx
+++ b/docs/deck_2026-10-26_seminar.pptx
@@ -130,7 +130,7 @@
   <p:extLst>
     <p:ext uri="{521415D9-36F7-43E2-AB2F-B90AF26B5E84}">
       <p14:sectionLst xmlns:p14="http://schemas.microsoft.com/office/powerpoint/2010/main">
-        <p14:section name="Opening" id="{f012b5cf-c93c-135a-065d-f612df317736}">
+        <p14:section name="Opening" id="{fc99952a-6794-1891-26c7-702b3cd86b60}">
           <p14:sldIdLst>
             <p14:sldId id="256"/>
             <p14:sldId id="257"/>
@@ -144,13 +144,13 @@
             <p14:sldId id="265"/>
           </p14:sldIdLst>
         </p14:section>
-        <p14:section name="The model" id="{e9e34b79-d097-3f71-acb9-97b569b0fe6f}">
+        <p14:section name="The model" id="{0dde5ee3-a046-b01a-b73b-54bbf70e5c45}">
           <p14:sldIdLst>
             <p14:sldId id="266"/>
             <p14:sldId id="267"/>
           </p14:sldIdLst>
         </p14:section>
-        <p14:section name="Results" id="{19d055d8-5dd2-1fe6-5e78-ec98aa1c4ecf}">
+        <p14:section name="Results" id="{14df31ad-f514-0cba-3a85-e70f167580d4}">
           <p14:sldIdLst>
             <p14:sldId id="268"/>
             <p14:sldId id="269"/>
@@ -158,17 +158,17 @@
             <p14:sldId id="271"/>
           </p14:sldIdLst>
         </p14:section>
-        <p14:section name="Validation" id="{7d1f650e-d851-0ec3-9bd6-bb1aa889c585}">
+        <p14:section name="Validation" id="{28059c1d-8ccf-7393-06a7-8cb9fbff8ca6}">
           <p14:sldIdLst>
             <p14:sldId id="272"/>
           </p14:sldIdLst>
         </p14:section>
-        <p14:section name="Close" id="{d1aa692c-05c2-d5af-e394-dbc0c614ae80}">
+        <p14:section name="Close" id="{1f8e9766-2fe0-8653-fea5-2e8f66c801b8}">
           <p14:sldIdLst>
             <p14:sldId id="273"/>
           </p14:sldIdLst>
         </p14:section>
-        <p14:section name="Backup" id="{9cc6fec1-8058-488f-6b31-9cb5c20afb40}">
+        <p14:section name="Backup" id="{1fb69547-7fc4-5f95-ab04-f12a1da29936}">
           <p14:sldIdLst>
             <p14:sldId id="274"/>
             <p14:sldId id="275"/>
@@ -670,7 +670,7 @@
           <a:p>
             <a:r>
               <a:rPr lang="en-US" dirty="0"/>
-              <a:t>~1 min. The ladder: dispersion of the signal (Goldstein-Pauzner: same signal technology, different draws, which selects the equilibrium), heterogeneity in delivery (who hears it, from whom, when: Kelly-O Grada, Iyer-Puri, Cookson et al.), heterogeneity in interpretation (the same two signals, different dispositional weights; culture is the stable source). Rung 1 orders depositors by luck, rung 2 by position, rung 3 by who they are, and only rung 3 predicts that the order flips with the sign of the public error. Nearest cousins to acknowledge if asked: Izmalkov-Yildiz 2010 (heterogeneous priors), He-Manela 2016 (information acquisition).</a:t>
+              <a:t>~1 min. The ladder: variation in the signal (Goldstein-Pauzner: same signal technology, different draws, which selects the equilibrium), variation in location (who hears it, from whom, when: Kelly-O Grada, Iyer-Puri, Cookson et al.), variation in interpretation (the same two signals, different dispositional weights; culture is the stable source). Rung 1 orders depositors by luck, rung 2 by position, rung 3 by who they are, and only rung 3 predicts that the order flips with the sign of the public error. Nearest cousins to acknowledge if asked: Izmalkov-Yildiz 2010 (heterogeneous priors), He-Manela 2016 (information acquisition).</a:t>
             </a:r>
             <a:endParaRPr lang="en-US" dirty="0"/>
           </a:p>
@@ -2078,7 +2078,7 @@
           <a:p>
             <a:r>
               <a:rPr lang="en-US" dirty="0"/>
-              <a:t>~1 min. The two mechanisms the literature has used to answer who runs and when. Dispersion: Goldstein-Pauzner's noisy private signal, the device that gives Diamond-Dybvig an equilibrium-selection mechanism; depositors are ex ante identical, so the order is luck. Delivery: the network and media literature; the order is position. Both are consistent with identical processing.</a:t>
+              <a:t>~1 min. The two mechanisms the literature has used to answer who runs and when. Variation in the signal: Goldstein-Pauzner's noisy private draw (same technology, different draws), the device that gives Diamond-Dybvig an equilibrium-selection mechanism; depositors are ex ante identical, so the order is luck. Variation in location: the network and media literature; the order is position. Both are consistent with identical processing. The third rung, variation in interpretation, is where this dissertation sits.</a:t>
             </a:r>
             <a:endParaRPr lang="en-US" dirty="0"/>
           </a:p>
@@ -2606,7 +2606,7 @@
           <a:p>
             <a:r>
               <a:rPr lang="en-US" dirty="0"/>
-              <a:t>~1 min. Why Chapter 3 is a simulation. Chapter 1 relaxed the Bayesian precision answer and kept the rest of Goldstein-Pauzner so the threshold equilibrium survives. The ABM relaxes dispersion, delivery and interpretation together, plus the incentive side, which no closed-form model could carry; that is what lets the channel decomposition (lambda on the neighbour blend vs the news blend) be measured at all.</a:t>
+              <a:t>~1 min. Why Chapter 3 is a simulation. Chapter 1 relaxed the Bayesian precision answer and kept the rest of Goldstein-Pauzner so the threshold equilibrium survives. The ABM varies the signal, location and interpretation together, plus the incentive side, which no closed-form model could carry; that is what lets the channel decomposition (lambda on the neighbour blend vs the news blend) be measured at all.</a:t>
             </a:r>
             <a:endParaRPr lang="en-US" dirty="0"/>
           </a:p>
@@ -3539,7 +3539,7 @@
                   <a:schemeClr val="tx2"/>
                 </a:solidFill>
               </a:rPr>
-              <a:t>The ladder: dispersed, delivered, interpreted</a:t>
+              <a:t>The ladder: signal, location, interpretation</a:t>
             </a:r>
             <a:endParaRPr lang="en-US" sz="2400" dirty="0"/>
           </a:p>
@@ -3547,7 +3547,7 @@
       </p:sp>
       <p:pic>
         <p:nvPicPr>
-          <p:cNvPr id="3" name="ladder" descr="Three panels. Dispersed: one bank fundamental sends a noisy private signal to each depositor, who line up from run to stay. Delivered: a network in which the signal has reached some depositors from a first hearer and not others. Interpreted: the same private and public signals reach an individualist, who leans on the private signal, and a collectivist, who leans on the public one; culture sets the weight.">    </p:cNvPr>
+          <p:cNvPr id="3" name="ladder" descr="Three panels. Signal: one bank fundamental sends a noisy private signal to each depositor, who line up from run to stay. Location: a network in which the signal has reached some depositors from a first hearer and not others. Interpretation: the same private and public signals reach an individualist, who leans on the private signal, and a collectivist, who leans on the public one; culture sets the weight.">    </p:cNvPr>
           <p:cNvPicPr>
             <a:picLocks noChangeAspect="1"/>
           </p:cNvPicPr>
@@ -10096,7 +10096,7 @@
                   <a:schemeClr val="tx2"/>
                 </a:solidFill>
               </a:rPr>
-              <a:t>Who runs, and when, has been answered two ways: by luck and by position.</a:t>
+              <a:t>Who runs, and when, has been answered two ways: by what a depositor drew and by where they sit.</a:t>
             </a:r>
             <a:endParaRPr lang="en-US" sz="1700" dirty="0"/>
           </a:p>
@@ -10136,7 +10136,7 @@
                   <a:schemeClr val="tx1"/>
                 </a:solidFill>
               </a:rPr>
-              <a:t>Dispersion. </a:t>
+              <a:t>Variation in the signal. </a:t>
             </a:r>
             <a:pPr indent="0" marL="0">
               <a:spcAft>
@@ -10168,7 +10168,7 @@
                   <a:schemeClr val="tx1"/>
                 </a:solidFill>
               </a:rPr>
-              <a:t>Delivery. </a:t>
+              <a:t>Variation in location. </a:t>
             </a:r>
             <a:pPr indent="0" marL="0">
               <a:spcAft>
@@ -12186,7 +12186,7 @@
                   <a:schemeClr val="tx1"/>
                 </a:solidFill>
               </a:rPr>
-              <a:t>Dispersion (a private draw per depositor), delivery (a network, neighbours’ withdrawals arriving tick by tick, public news absent, accurate or stale), interpretation (λ, formed in a cultural warm-up), plus deposit sizes, risk preferences and the contract.</a:t>
+              <a:t>The signal (a private draw per depositor), location (a network, neighbours’ withdrawals arriving tick by tick, public news absent, accurate or stale), interpretation (λ, formed in a cultural warm-up), plus deposit sizes, risk preferences and the contract.</a:t>
             </a:r>
             <a:endParaRPr lang="en-US" sz="1400" dirty="0"/>
           </a:p>

</xml_diff>

<commit_message>
Deck: Goldstein-Pauzner is static, so slide 3 says who runs, not who runs first
Co-Authored-By: Claude Fable 5.1 <noreply@anthropic.com>
</commit_message>
<xml_diff>
--- a/docs/deck_2026-10-26_seminar.pptx
+++ b/docs/deck_2026-10-26_seminar.pptx
@@ -130,7 +130,7 @@
   <p:extLst>
     <p:ext uri="{521415D9-36F7-43E2-AB2F-B90AF26B5E84}">
       <p14:sectionLst xmlns:p14="http://schemas.microsoft.com/office/powerpoint/2010/main">
-        <p14:section name="Opening" id="{fc99952a-6794-1891-26c7-702b3cd86b60}">
+        <p14:section name="Opening" id="{aeb81448-a301-79bf-b808-78467e587f4e}">
           <p14:sldIdLst>
             <p14:sldId id="256"/>
             <p14:sldId id="257"/>
@@ -144,13 +144,13 @@
             <p14:sldId id="265"/>
           </p14:sldIdLst>
         </p14:section>
-        <p14:section name="The model" id="{0dde5ee3-a046-b01a-b73b-54bbf70e5c45}">
+        <p14:section name="The model" id="{e9e6278b-4834-3dce-0379-cf39c1383116}">
           <p14:sldIdLst>
             <p14:sldId id="266"/>
             <p14:sldId id="267"/>
           </p14:sldIdLst>
         </p14:section>
-        <p14:section name="Results" id="{14df31ad-f514-0cba-3a85-e70f167580d4}">
+        <p14:section name="Results" id="{82291f85-92a5-30ea-7752-70a01a7217aa}">
           <p14:sldIdLst>
             <p14:sldId id="268"/>
             <p14:sldId id="269"/>
@@ -158,17 +158,17 @@
             <p14:sldId id="271"/>
           </p14:sldIdLst>
         </p14:section>
-        <p14:section name="Validation" id="{28059c1d-8ccf-7393-06a7-8cb9fbff8ca6}">
+        <p14:section name="Validation" id="{64bb2175-ae54-414d-3928-7faa0b2f8445}">
           <p14:sldIdLst>
             <p14:sldId id="272"/>
           </p14:sldIdLst>
         </p14:section>
-        <p14:section name="Close" id="{1f8e9766-2fe0-8653-fea5-2e8f66c801b8}">
+        <p14:section name="Close" id="{d736efe2-8d2e-8157-9ee2-ab42ad7540a9}">
           <p14:sldIdLst>
             <p14:sldId id="273"/>
           </p14:sldIdLst>
         </p14:section>
-        <p14:section name="Backup" id="{1fb69547-7fc4-5f95-ab04-f12a1da29936}">
+        <p14:section name="Backup" id="{d05939e3-f4fc-5ece-c57a-fd09324bae9a}">
           <p14:sldIdLst>
             <p14:sldId id="274"/>
             <p14:sldId id="275"/>
@@ -2078,7 +2078,7 @@
           <a:p>
             <a:r>
               <a:rPr lang="en-US" dirty="0"/>
-              <a:t>~1 min. The two mechanisms the literature has used to answer who runs and when. Variation in the signal: Goldstein-Pauzner's noisy private draw (same technology, different draws), the device that gives Diamond-Dybvig an equilibrium-selection mechanism; depositors are ex ante identical, so the order is luck. Variation in location: the network and media literature; the order is position. Both are consistent with identical processing. The third rung, variation in interpretation, is where this dissertation sits.</a:t>
+              <a:t>~1 min. The two mechanisms the literature has used to answer who runs and when. Variation in the signal: Goldstein-Pauzner's noisy private draw (same technology, different draws), the device that gives Diamond-Dybvig an equilibrium-selection mechanism; depositors are ex ante identical, so who runs is luck. Note the model is static: for an intermediate fundamental a fraction runs (those below the threshold draw), not everyone or nobody; the all-or-nothing picture is the zero-noise limit. Timing only enters with the network literature. Variation in location: the network and media literature; the order is position. Both are consistent with identical processing. The third rung, variation in interpretation, is where this dissertation sits.</a:t>
             </a:r>
             <a:endParaRPr lang="en-US" dirty="0"/>
           </a:p>
@@ -10150,7 +10150,7 @@
                   <a:schemeClr val="tx1"/>
                 </a:solidFill>
               </a:rPr>
-              <a:t>Goldstein–Pauzner give every depositor a noisy draw of the same signal. The draw breaks common knowledge and selects the equilibrium. Who runs first is whoever drew low.</a:t>
+              <a:t>Goldstein–Pauzner give every depositor a noisy draw of the same signal. The draw breaks common knowledge and selects the equilibrium. Who runs is whoever drew low; everyone decides at once, so there is no first.</a:t>
             </a:r>
             <a:endParaRPr lang="en-US" sz="1400" dirty="0"/>
           </a:p>
@@ -11826,7 +11826,7 @@
                   <a:schemeClr val="tx1"/>
                 </a:solidFill>
               </a:rPr>
-              <a:t>A stale public signal and heterogeneous dispositional weights inside Goldstein–Pauzner. Prediction: who runs first reverses with the sign of the public error.</a:t>
+              <a:t>A stale public signal and heterogeneous dispositional weights inside Goldstein–Pauzner. Prediction: which type runs reverses with the sign of the public error.</a:t>
             </a:r>
             <a:endParaRPr lang="en-US" sz="1400" dirty="0"/>
           </a:p>

</xml_diff>

<commit_message>
Deck: slide 3 title and lead merged into "Who runs? Luck of the draw, and location"
Co-Authored-By: Claude Fable 5.1 <noreply@anthropic.com>
</commit_message>
<xml_diff>
--- a/docs/deck_2026-10-26_seminar.pptx
+++ b/docs/deck_2026-10-26_seminar.pptx
@@ -130,7 +130,7 @@
   <p:extLst>
     <p:ext uri="{521415D9-36F7-43E2-AB2F-B90AF26B5E84}">
       <p14:sectionLst xmlns:p14="http://schemas.microsoft.com/office/powerpoint/2010/main">
-        <p14:section name="Opening" id="{aeb81448-a301-79bf-b808-78467e587f4e}">
+        <p14:section name="Opening" id="{7f6ab689-e716-50b2-a8ef-bd79688c58af}">
           <p14:sldIdLst>
             <p14:sldId id="256"/>
             <p14:sldId id="257"/>
@@ -144,13 +144,13 @@
             <p14:sldId id="265"/>
           </p14:sldIdLst>
         </p14:section>
-        <p14:section name="The model" id="{e9e6278b-4834-3dce-0379-cf39c1383116}">
+        <p14:section name="The model" id="{2f5aba78-8008-3114-d10d-af08b27c9fc7}">
           <p14:sldIdLst>
             <p14:sldId id="266"/>
             <p14:sldId id="267"/>
           </p14:sldIdLst>
         </p14:section>
-        <p14:section name="Results" id="{82291f85-92a5-30ea-7752-70a01a7217aa}">
+        <p14:section name="Results" id="{f897c536-0899-5807-fd68-c845caa705bd}">
           <p14:sldIdLst>
             <p14:sldId id="268"/>
             <p14:sldId id="269"/>
@@ -158,17 +158,17 @@
             <p14:sldId id="271"/>
           </p14:sldIdLst>
         </p14:section>
-        <p14:section name="Validation" id="{64bb2175-ae54-414d-3928-7faa0b2f8445}">
+        <p14:section name="Validation" id="{034c4000-e196-635d-6d30-dad78092c2df}">
           <p14:sldIdLst>
             <p14:sldId id="272"/>
           </p14:sldIdLst>
         </p14:section>
-        <p14:section name="Close" id="{d736efe2-8d2e-8157-9ee2-ab42ad7540a9}">
+        <p14:section name="Close" id="{a1fe47ac-9984-e7ba-d204-c2aec107f240}">
           <p14:sldIdLst>
             <p14:sldId id="273"/>
           </p14:sldIdLst>
         </p14:section>
-        <p14:section name="Backup" id="{d05939e3-f4fc-5ece-c57a-fd09324bae9a}">
+        <p14:section name="Backup" id="{53d3af6e-e97e-e219-9c6e-cdeb02f9417f}">
           <p14:sldIdLst>
             <p14:sldId id="274"/>
             <p14:sldId id="275"/>
@@ -9994,7 +9994,7 @@
                   <a:schemeClr val="tx2"/>
                 </a:solidFill>
               </a:rPr>
-              <a:t>Two mechanisms the literature has used</a:t>
+              <a:t>Who runs? Luck of the draw, and location</a:t>
             </a:r>
             <a:endParaRPr lang="en-US" sz="2400" dirty="0"/>
           </a:p>
@@ -10068,50 +10068,14 @@
       </p:sp>
       <p:sp>
         <p:nvSpPr>
-          <p:cNvPr id="5" name="step-lead"/>
+          <p:cNvPr id="5" name="step-items"/>
           <p:cNvSpPr txBox="1"/>
           <p:nvPr/>
         </p:nvSpPr>
         <p:spPr>
           <a:xfrm>
-            <a:off x="1005840" y="1051560"/>
-            <a:ext cx="7680960" cy="868680"/>
-          </a:xfrm>
-          <a:prstGeom prst="rect">
-            <a:avLst/>
-          </a:prstGeom>
-          <a:noFill/>
-          <a:ln/>
-        </p:spPr>
-        <p:txBody>
-          <a:bodyPr wrap="square" lIns="0" tIns="0" rIns="0" bIns="0" rtlCol="0" anchor="ctr"/>
-          <a:lstStyle/>
-          <a:p>
-            <a:pPr indent="0" marL="0">
-              <a:buNone/>
-            </a:pPr>
-            <a:r>
-              <a:rPr lang="en-US" sz="1700" b="1" dirty="0">
-                <a:solidFill>
-                  <a:schemeClr val="tx2"/>
-                </a:solidFill>
-              </a:rPr>
-              <a:t>Who runs, and when, has been answered two ways: by what a depositor drew and by where they sit.</a:t>
-            </a:r>
-            <a:endParaRPr lang="en-US" sz="1700" dirty="0"/>
-          </a:p>
-        </p:txBody>
-      </p:sp>
-      <p:sp>
-        <p:nvSpPr>
-          <p:cNvPr id="6" name="step-items"/>
-          <p:cNvSpPr txBox="1"/>
-          <p:nvPr/>
-        </p:nvSpPr>
-        <p:spPr>
-          <a:xfrm>
-            <a:off x="1005840" y="2103120"/>
-            <a:ext cx="7680960" cy="2103120"/>
+            <a:off x="1005840" y="1188720"/>
+            <a:ext cx="7680960" cy="3017520"/>
           </a:xfrm>
           <a:prstGeom prst="rect">
             <a:avLst/>

</xml_diff>

<commit_message>
Deck: slide 3 as two columns (signal, location); step chips dropped from the argument slides
Co-Authored-By: Claude Fable 5.1 <noreply@anthropic.com>
</commit_message>
<xml_diff>
--- a/docs/deck_2026-10-26_seminar.pptx
+++ b/docs/deck_2026-10-26_seminar.pptx
@@ -130,7 +130,7 @@
   <p:extLst>
     <p:ext uri="{521415D9-36F7-43E2-AB2F-B90AF26B5E84}">
       <p14:sectionLst xmlns:p14="http://schemas.microsoft.com/office/powerpoint/2010/main">
-        <p14:section name="Opening" id="{7f6ab689-e716-50b2-a8ef-bd79688c58af}">
+        <p14:section name="Opening" id="{70025f63-efd5-e29a-856c-c6602e47857e}">
           <p14:sldIdLst>
             <p14:sldId id="256"/>
             <p14:sldId id="257"/>
@@ -144,13 +144,13 @@
             <p14:sldId id="265"/>
           </p14:sldIdLst>
         </p14:section>
-        <p14:section name="The model" id="{2f5aba78-8008-3114-d10d-af08b27c9fc7}">
+        <p14:section name="The model" id="{2948d255-8d00-162f-351f-91fa56728d8e}">
           <p14:sldIdLst>
             <p14:sldId id="266"/>
             <p14:sldId id="267"/>
           </p14:sldIdLst>
         </p14:section>
-        <p14:section name="Results" id="{f897c536-0899-5807-fd68-c845caa705bd}">
+        <p14:section name="Results" id="{f655b5de-7699-ff94-0fe7-681cde8e72db}">
           <p14:sldIdLst>
             <p14:sldId id="268"/>
             <p14:sldId id="269"/>
@@ -158,17 +158,17 @@
             <p14:sldId id="271"/>
           </p14:sldIdLst>
         </p14:section>
-        <p14:section name="Validation" id="{034c4000-e196-635d-6d30-dad78092c2df}">
+        <p14:section name="Validation" id="{28a5e1c3-06ca-d1ba-bc8d-8cdc7f033f42}">
           <p14:sldIdLst>
             <p14:sldId id="272"/>
           </p14:sldIdLst>
         </p14:section>
-        <p14:section name="Close" id="{a1fe47ac-9984-e7ba-d204-c2aec107f240}">
+        <p14:section name="Close" id="{59c474d2-9f0f-4e71-c13f-c018b0fe8be5}">
           <p14:sldIdLst>
             <p14:sldId id="273"/>
           </p14:sldIdLst>
         </p14:section>
-        <p14:section name="Backup" id="{53d3af6e-e97e-e219-9c6e-cdeb02f9417f}">
+        <p14:section name="Backup" id="{f92e3103-2798-48c5-cd09-0aafd52eebd4}">
           <p14:sldIdLst>
             <p14:sldId id="274"/>
             <p14:sldId id="275"/>
@@ -2078,7 +2078,7 @@
           <a:p>
             <a:r>
               <a:rPr lang="en-US" dirty="0"/>
-              <a:t>~1 min. The two mechanisms the literature has used to answer who runs and when. Variation in the signal: Goldstein-Pauzner's noisy private draw (same technology, different draws), the device that gives Diamond-Dybvig an equilibrium-selection mechanism; depositors are ex ante identical, so who runs is luck. Note the model is static: for an intermediate fundamental a fraction runs (those below the threshold draw), not everyone or nobody; the all-or-nothing picture is the zero-noise limit. Timing only enters with the network literature. Variation in location: the network and media literature; the order is position. Both are consistent with identical processing. The third rung, variation in interpretation, is where this dissertation sits.</a:t>
+              <a:t>~1 min. The two mechanisms the literature has used to answer who runs. Variation in the signal: Goldstein-Pauzner's noisy private draw (same technology, different draws), the device that gives Diamond-Dybvig an equilibrium-selection mechanism; depositors are ex ante identical, so who runs is luck. The model is static: for an intermediate fundamental a fraction runs (those below the threshold draw), not everyone or nobody; all-or-nothing is the zero-noise limit. Timing only enters with the network literature. Variation in location: networks and media; the order is position. Both are fruitful and both are consistent with identical processing: the same Bayesian, with the same prior, sits at every node. The third rung, variation in interpretation, is where this dissertation sits.</a:t>
             </a:r>
             <a:endParaRPr lang="en-US" dirty="0"/>
           </a:p>
@@ -10002,26 +10002,26 @@
       </p:sp>
       <p:sp>
         <p:nvSpPr>
-          <p:cNvPr id="3" name="chip"/>
+          <p:cNvPr id="3" name="mech-0"/>
           <p:cNvSpPr/>
           <p:nvPr/>
         </p:nvSpPr>
         <p:spPr>
           <a:xfrm>
-            <a:off x="457200" y="1143000"/>
-            <a:ext cx="384048" cy="384048"/>
+            <a:off x="457200" y="1051560"/>
+            <a:ext cx="4023360" cy="2514600"/>
           </a:xfrm>
           <a:prstGeom prst="roundRect">
             <a:avLst>
-              <a:gd name="adj" fmla="val 14286"/>
+              <a:gd name="adj" fmla="val 2909"/>
             </a:avLst>
           </a:prstGeom>
           <a:solidFill>
-            <a:schemeClr val="accent1"/>
+            <a:schemeClr val="bg2"/>
           </a:solidFill>
           <a:ln w="12700">
             <a:solidFill>
-              <a:schemeClr val="accent1"/>
+              <a:schemeClr val="bg2"/>
             </a:solidFill>
             <a:prstDash val="solid"/>
           </a:ln>
@@ -10029,14 +10029,14 @@
       </p:sp>
       <p:sp>
         <p:nvSpPr>
-          <p:cNvPr id="4" name="chip-label"/>
+          <p:cNvPr id="4" name="mech-head"/>
           <p:cNvSpPr txBox="1"/>
           <p:nvPr/>
         </p:nvSpPr>
         <p:spPr>
           <a:xfrm>
-            <a:off x="457200" y="1143000"/>
-            <a:ext cx="384048" cy="384048"/>
+            <a:off x="640080" y="1143000"/>
+            <a:ext cx="3657600" cy="365760"/>
           </a:xfrm>
           <a:prstGeom prst="rect">
             <a:avLst/>
@@ -10048,34 +10048,31 @@
           <a:bodyPr wrap="square" lIns="0" tIns="0" rIns="0" bIns="0" rtlCol="0" anchor="ctr"/>
           <a:lstStyle/>
           <a:p>
-            <a:pPr algn="ctr" indent="0" marL="0">
-              <a:buNone/>
-            </a:pPr>
-            <a:r>
-              <a:rPr lang="en-US" sz="1300" b="1" dirty="0">
-                <a:solidFill>
-                  <a:schemeClr val="bg1"/>
-                </a:solidFill>
-                <a:latin typeface="Cambria" pitchFamily="34" charset="0"/>
-                <a:ea typeface="Cambria" pitchFamily="34" charset="-122"/>
-                <a:cs typeface="Cambria" pitchFamily="34" charset="-120"/>
-              </a:rPr>
-              <a:t>1</a:t>
-            </a:r>
-            <a:endParaRPr lang="en-US" sz="1300" dirty="0"/>
-          </a:p>
-        </p:txBody>
-      </p:sp>
-      <p:sp>
-        <p:nvSpPr>
-          <p:cNvPr id="5" name="step-items"/>
+            <a:pPr indent="0" marL="0">
+              <a:buNone/>
+            </a:pPr>
+            <a:r>
+              <a:rPr lang="en-US" sz="1800" b="1" dirty="0">
+                <a:solidFill>
+                  <a:schemeClr val="accent1"/>
+                </a:solidFill>
+              </a:rPr>
+              <a:t>Variation in the signal</a:t>
+            </a:r>
+            <a:endParaRPr lang="en-US" sz="1800" dirty="0"/>
+          </a:p>
+        </p:txBody>
+      </p:sp>
+      <p:sp>
+        <p:nvSpPr>
+          <p:cNvPr id="5" name="bullets"/>
           <p:cNvSpPr txBox="1"/>
           <p:nvPr/>
         </p:nvSpPr>
         <p:spPr>
           <a:xfrm>
-            <a:off x="1005840" y="1188720"/>
-            <a:ext cx="7680960" cy="3017520"/>
+            <a:off x="640080" y="1600200"/>
+            <a:ext cx="3657600" cy="1874520"/>
           </a:xfrm>
           <a:prstGeom prst="rect">
             <a:avLst/>
@@ -10089,88 +10086,167 @@
           <a:p>
             <a:pPr marL="177800" indent="-177800">
               <a:spcAft>
-                <a:spcPts val="900"/>
+                <a:spcPts val="800"/>
               </a:spcAft>
               <a:buSzPct val="100000"/>
               <a:buChar char="•"/>
             </a:pPr>
             <a:r>
-              <a:rPr lang="en-US" sz="1400" b="1" dirty="0">
+              <a:rPr lang="en-US" sz="1400" dirty="0">
                 <a:solidFill>
                   <a:schemeClr val="tx1"/>
                 </a:solidFill>
               </a:rPr>
-              <a:t>Variation in the signal. </a:t>
-            </a:r>
-            <a:pPr indent="0" marL="0">
-              <a:spcAft>
-                <a:spcPts val="900"/>
-              </a:spcAft>
-              <a:buNone/>
-            </a:pPr>
-            <a:r>
-              <a:rPr lang="en-US" sz="1400" dirty="0">
-                <a:solidFill>
-                  <a:schemeClr val="tx1"/>
-                </a:solidFill>
-              </a:rPr>
-              <a:t>Goldstein–Pauzner give every depositor a noisy draw of the same signal. The draw breaks common knowledge and selects the equilibrium. Who runs is whoever drew low; everyone decides at once, so there is no first.</a:t>
+              <a:t>Goldstein–Pauzner: every depositor gets a noisy draw of the same signal</a:t>
             </a:r>
             <a:endParaRPr lang="en-US" sz="1400" dirty="0"/>
           </a:p>
           <a:p>
             <a:pPr marL="177800" indent="-177800">
               <a:spcAft>
-                <a:spcPts val="900"/>
+                <a:spcPts val="800"/>
               </a:spcAft>
               <a:buSzPct val="100000"/>
               <a:buChar char="•"/>
             </a:pPr>
             <a:r>
-              <a:rPr lang="en-US" sz="1400" b="1" dirty="0">
+              <a:rPr lang="en-US" sz="1400" dirty="0">
                 <a:solidFill>
                   <a:schemeClr val="tx1"/>
                 </a:solidFill>
               </a:rPr>
-              <a:t>Variation in location. </a:t>
-            </a:r>
-            <a:pPr indent="0" marL="0">
-              <a:spcAft>
-                <a:spcPts val="900"/>
-              </a:spcAft>
-              <a:buNone/>
-            </a:pPr>
-            <a:r>
-              <a:rPr lang="en-US" sz="1400" dirty="0">
-                <a:solidFill>
-                  <a:schemeClr val="tx1"/>
-                </a:solidFill>
-              </a:rPr>
-              <a:t>Networks and media decide who hears what, from whom, when (Kelly–Ó Gráda, Iyer–Puri, Cookson et al.). Who runs first is whoever sits nearest the source.</a:t>
+              <a:t>The draw breaks common knowledge and selects the equilibrium</a:t>
             </a:r>
             <a:endParaRPr lang="en-US" sz="1400" dirty="0"/>
           </a:p>
           <a:p>
             <a:pPr marL="177800" indent="-177800">
               <a:spcAft>
-                <a:spcPts val="900"/>
+                <a:spcPts val="800"/>
               </a:spcAft>
               <a:buSzPct val="100000"/>
               <a:buChar char="•"/>
             </a:pPr>
             <a:r>
-              <a:rPr lang="en-US" sz="1400" b="1" dirty="0">
+              <a:rPr lang="en-US" sz="1400" dirty="0">
                 <a:solidFill>
                   <a:schemeClr val="tx1"/>
                 </a:solidFill>
               </a:rPr>
-              <a:t>Both are fruitful. </a:t>
-            </a:r>
+              <a:t>Who runs: whoever drew low</a:t>
+            </a:r>
+            <a:endParaRPr lang="en-US" sz="1400" dirty="0"/>
+          </a:p>
+          <a:p>
+            <a:pPr marL="177800" indent="-177800">
+              <a:spcAft>
+                <a:spcPts val="800"/>
+              </a:spcAft>
+              <a:buSzPct val="100000"/>
+              <a:buChar char="•"/>
+            </a:pPr>
+            <a:r>
+              <a:rPr lang="en-US" sz="1400" dirty="0">
+                <a:solidFill>
+                  <a:schemeClr val="tx1"/>
+                </a:solidFill>
+              </a:rPr>
+              <a:t>Everyone decides at once, so there is no first</a:t>
+            </a:r>
+            <a:endParaRPr lang="en-US" sz="1400" dirty="0"/>
+          </a:p>
+        </p:txBody>
+      </p:sp>
+      <p:sp>
+        <p:nvSpPr>
+          <p:cNvPr id="6" name="mech-1"/>
+          <p:cNvSpPr/>
+          <p:nvPr/>
+        </p:nvSpPr>
+        <p:spPr>
+          <a:xfrm>
+            <a:off x="4663440" y="1051560"/>
+            <a:ext cx="4023360" cy="2514600"/>
+          </a:xfrm>
+          <a:prstGeom prst="roundRect">
+            <a:avLst>
+              <a:gd name="adj" fmla="val 2909"/>
+            </a:avLst>
+          </a:prstGeom>
+          <a:solidFill>
+            <a:schemeClr val="bg2"/>
+          </a:solidFill>
+          <a:ln w="12700">
+            <a:solidFill>
+              <a:schemeClr val="bg2"/>
+            </a:solidFill>
+            <a:prstDash val="solid"/>
+          </a:ln>
+        </p:spPr>
+      </p:sp>
+      <p:sp>
+        <p:nvSpPr>
+          <p:cNvPr id="7" name="mech-head"/>
+          <p:cNvSpPr txBox="1"/>
+          <p:nvPr/>
+        </p:nvSpPr>
+        <p:spPr>
+          <a:xfrm>
+            <a:off x="4846320" y="1143000"/>
+            <a:ext cx="3657600" cy="365760"/>
+          </a:xfrm>
+          <a:prstGeom prst="rect">
+            <a:avLst/>
+          </a:prstGeom>
+          <a:noFill/>
+          <a:ln/>
+        </p:spPr>
+        <p:txBody>
+          <a:bodyPr wrap="square" lIns="0" tIns="0" rIns="0" bIns="0" rtlCol="0" anchor="ctr"/>
+          <a:lstStyle/>
+          <a:p>
             <a:pPr indent="0" marL="0">
+              <a:buNone/>
+            </a:pPr>
+            <a:r>
+              <a:rPr lang="en-US" sz="1800" b="1" dirty="0">
+                <a:solidFill>
+                  <a:schemeClr val="accent1"/>
+                </a:solidFill>
+              </a:rPr>
+              <a:t>Variation in location</a:t>
+            </a:r>
+            <a:endParaRPr lang="en-US" sz="1800" dirty="0"/>
+          </a:p>
+        </p:txBody>
+      </p:sp>
+      <p:sp>
+        <p:nvSpPr>
+          <p:cNvPr id="8" name="bullets"/>
+          <p:cNvSpPr txBox="1"/>
+          <p:nvPr/>
+        </p:nvSpPr>
+        <p:spPr>
+          <a:xfrm>
+            <a:off x="4846320" y="1600200"/>
+            <a:ext cx="3657600" cy="1874520"/>
+          </a:xfrm>
+          <a:prstGeom prst="rect">
+            <a:avLst/>
+          </a:prstGeom>
+          <a:noFill/>
+          <a:ln/>
+        </p:spPr>
+        <p:txBody>
+          <a:bodyPr wrap="square" lIns="0" tIns="0" rIns="0" bIns="0" rtlCol="0" anchor="t"/>
+          <a:lstStyle/>
+          <a:p>
+            <a:pPr marL="177800" indent="-177800">
               <a:spcAft>
-                <a:spcPts val="900"/>
+                <a:spcPts val="800"/>
               </a:spcAft>
-              <a:buNone/>
+              <a:buSzPct val="100000"/>
+              <a:buChar char="•"/>
             </a:pPr>
             <a:r>
               <a:rPr lang="en-US" sz="1400" dirty="0">
@@ -10178,7 +10254,43 @@
                   <a:schemeClr val="tx1"/>
                 </a:solidFill>
               </a:rPr>
-              <a:t>Neither says anything about the depositor: the same Bayesian, with the same prior, sits at every node.</a:t>
+              <a:t>Networks and media decide who hears what, from whom, when</a:t>
+            </a:r>
+            <a:endParaRPr lang="en-US" sz="1400" dirty="0"/>
+          </a:p>
+          <a:p>
+            <a:pPr marL="177800" indent="-177800">
+              <a:spcAft>
+                <a:spcPts val="800"/>
+              </a:spcAft>
+              <a:buSzPct val="100000"/>
+              <a:buChar char="•"/>
+            </a:pPr>
+            <a:r>
+              <a:rPr lang="en-US" sz="1400" dirty="0">
+                <a:solidFill>
+                  <a:schemeClr val="tx1"/>
+                </a:solidFill>
+              </a:rPr>
+              <a:t>Kelly–Ó Gráda, Iyer–Puri, Cookson et al.</a:t>
+            </a:r>
+            <a:endParaRPr lang="en-US" sz="1400" dirty="0"/>
+          </a:p>
+          <a:p>
+            <a:pPr marL="177800" indent="-177800">
+              <a:spcAft>
+                <a:spcPts val="800"/>
+              </a:spcAft>
+              <a:buSzPct val="100000"/>
+              <a:buChar char="•"/>
+            </a:pPr>
+            <a:r>
+              <a:rPr lang="en-US" sz="1400" dirty="0">
+                <a:solidFill>
+                  <a:schemeClr val="tx1"/>
+                </a:solidFill>
+              </a:rPr>
+              <a:t>Who runs first: whoever sits nearest the source</a:t>
             </a:r>
             <a:endParaRPr lang="en-US" sz="1400" dirty="0"/>
           </a:p>
@@ -10294,41 +10406,14 @@
       </p:sp>
       <p:sp>
         <p:nvSpPr>
-          <p:cNvPr id="3" name="chip"/>
-          <p:cNvSpPr/>
-          <p:nvPr/>
-        </p:nvSpPr>
-        <p:spPr>
-          <a:xfrm>
-            <a:off x="457200" y="1143000"/>
-            <a:ext cx="384048" cy="384048"/>
-          </a:xfrm>
-          <a:prstGeom prst="roundRect">
-            <a:avLst>
-              <a:gd name="adj" fmla="val 14286"/>
-            </a:avLst>
-          </a:prstGeom>
-          <a:solidFill>
-            <a:schemeClr val="accent1"/>
-          </a:solidFill>
-          <a:ln w="12700">
-            <a:solidFill>
-              <a:schemeClr val="accent1"/>
-            </a:solidFill>
-            <a:prstDash val="solid"/>
-          </a:ln>
-        </p:spPr>
-      </p:sp>
-      <p:sp>
-        <p:nvSpPr>
-          <p:cNvPr id="4" name="chip-label"/>
+          <p:cNvPr id="3" name="step-lead"/>
           <p:cNvSpPr txBox="1"/>
           <p:nvPr/>
         </p:nvSpPr>
         <p:spPr>
           <a:xfrm>
-            <a:off x="457200" y="1143000"/>
-            <a:ext cx="384048" cy="384048"/>
+            <a:off x="457200" y="1051560"/>
+            <a:ext cx="8229600" cy="868680"/>
           </a:xfrm>
           <a:prstGeom prst="rect">
             <a:avLst/>
@@ -10340,70 +10425,31 @@
           <a:bodyPr wrap="square" lIns="0" tIns="0" rIns="0" bIns="0" rtlCol="0" anchor="ctr"/>
           <a:lstStyle/>
           <a:p>
-            <a:pPr algn="ctr" indent="0" marL="0">
-              <a:buNone/>
-            </a:pPr>
-            <a:r>
-              <a:rPr lang="en-US" sz="1300" b="1" dirty="0">
-                <a:solidFill>
-                  <a:schemeClr val="bg1"/>
-                </a:solidFill>
-                <a:latin typeface="Cambria" pitchFamily="34" charset="0"/>
-                <a:ea typeface="Cambria" pitchFamily="34" charset="-122"/>
-                <a:cs typeface="Cambria" pitchFamily="34" charset="-120"/>
-              </a:rPr>
-              <a:t>2</a:t>
-            </a:r>
-            <a:endParaRPr lang="en-US" sz="1300" dirty="0"/>
-          </a:p>
-        </p:txBody>
-      </p:sp>
-      <p:sp>
-        <p:nvSpPr>
-          <p:cNvPr id="5" name="step-lead"/>
+            <a:pPr indent="0" marL="0">
+              <a:buNone/>
+            </a:pPr>
+            <a:r>
+              <a:rPr lang="en-US" sz="1700" b="1" dirty="0">
+                <a:solidFill>
+                  <a:schemeClr val="tx2"/>
+                </a:solidFill>
+              </a:rPr>
+              <a:t>Which signal does a depositor act on, and in what proportion?</a:t>
+            </a:r>
+            <a:endParaRPr lang="en-US" sz="1700" dirty="0"/>
+          </a:p>
+        </p:txBody>
+      </p:sp>
+      <p:sp>
+        <p:nvSpPr>
+          <p:cNvPr id="4" name="step-items"/>
           <p:cNvSpPr txBox="1"/>
           <p:nvPr/>
         </p:nvSpPr>
         <p:spPr>
           <a:xfrm>
-            <a:off x="1005840" y="1051560"/>
-            <a:ext cx="7680960" cy="868680"/>
-          </a:xfrm>
-          <a:prstGeom prst="rect">
-            <a:avLst/>
-          </a:prstGeom>
-          <a:noFill/>
-          <a:ln/>
-        </p:spPr>
-        <p:txBody>
-          <a:bodyPr wrap="square" lIns="0" tIns="0" rIns="0" bIns="0" rtlCol="0" anchor="ctr"/>
-          <a:lstStyle/>
-          <a:p>
-            <a:pPr indent="0" marL="0">
-              <a:buNone/>
-            </a:pPr>
-            <a:r>
-              <a:rPr lang="en-US" sz="1700" b="1" dirty="0">
-                <a:solidFill>
-                  <a:schemeClr val="tx2"/>
-                </a:solidFill>
-              </a:rPr>
-              <a:t>Which signal does a depositor act on, and in what proportion?</a:t>
-            </a:r>
-            <a:endParaRPr lang="en-US" sz="1700" dirty="0"/>
-          </a:p>
-        </p:txBody>
-      </p:sp>
-      <p:sp>
-        <p:nvSpPr>
-          <p:cNvPr id="6" name="step-items"/>
-          <p:cNvSpPr txBox="1"/>
-          <p:nvPr/>
-        </p:nvSpPr>
-        <p:spPr>
-          <a:xfrm>
-            <a:off x="1005840" y="2103120"/>
-            <a:ext cx="7680960" cy="2103120"/>
+            <a:off x="457200" y="2103120"/>
+            <a:ext cx="8229600" cy="2103120"/>
           </a:xfrm>
           <a:prstGeom prst="rect">
             <a:avLst/>
@@ -10622,41 +10668,14 @@
       </p:sp>
       <p:sp>
         <p:nvSpPr>
-          <p:cNvPr id="3" name="chip"/>
-          <p:cNvSpPr/>
-          <p:nvPr/>
-        </p:nvSpPr>
-        <p:spPr>
-          <a:xfrm>
-            <a:off x="457200" y="1143000"/>
-            <a:ext cx="384048" cy="384048"/>
-          </a:xfrm>
-          <a:prstGeom prst="roundRect">
-            <a:avLst>
-              <a:gd name="adj" fmla="val 14286"/>
-            </a:avLst>
-          </a:prstGeom>
-          <a:solidFill>
-            <a:schemeClr val="accent1"/>
-          </a:solidFill>
-          <a:ln w="12700">
-            <a:solidFill>
-              <a:schemeClr val="accent1"/>
-            </a:solidFill>
-            <a:prstDash val="solid"/>
-          </a:ln>
-        </p:spPr>
-      </p:sp>
-      <p:sp>
-        <p:nvSpPr>
-          <p:cNvPr id="4" name="chip-label"/>
+          <p:cNvPr id="3" name="step-lead"/>
           <p:cNvSpPr txBox="1"/>
           <p:nvPr/>
         </p:nvSpPr>
         <p:spPr>
           <a:xfrm>
-            <a:off x="457200" y="1143000"/>
-            <a:ext cx="384048" cy="384048"/>
+            <a:off x="457200" y="1051560"/>
+            <a:ext cx="8229600" cy="868680"/>
           </a:xfrm>
           <a:prstGeom prst="rect">
             <a:avLst/>
@@ -10668,70 +10687,31 @@
           <a:bodyPr wrap="square" lIns="0" tIns="0" rIns="0" bIns="0" rtlCol="0" anchor="ctr"/>
           <a:lstStyle/>
           <a:p>
-            <a:pPr algn="ctr" indent="0" marL="0">
-              <a:buNone/>
-            </a:pPr>
-            <a:r>
-              <a:rPr lang="en-US" sz="1300" b="1" dirty="0">
-                <a:solidFill>
-                  <a:schemeClr val="bg1"/>
-                </a:solidFill>
-                <a:latin typeface="Cambria" pitchFamily="34" charset="0"/>
-                <a:ea typeface="Cambria" pitchFamily="34" charset="-122"/>
-                <a:cs typeface="Cambria" pitchFamily="34" charset="-120"/>
-              </a:rPr>
-              <a:t>3</a:t>
-            </a:r>
-            <a:endParaRPr lang="en-US" sz="1300" dirty="0"/>
-          </a:p>
-        </p:txBody>
-      </p:sp>
-      <p:sp>
-        <p:nvSpPr>
-          <p:cNvPr id="5" name="step-lead"/>
+            <a:pPr indent="0" marL="0">
+              <a:buNone/>
+            </a:pPr>
+            <a:r>
+              <a:rPr lang="en-US" sz="1700" b="1" dirty="0">
+                <a:solidFill>
+                  <a:schemeClr val="tx2"/>
+                </a:solidFill>
+              </a:rPr>
+              <a:t>Weight on the public signal = its precision relative to the private one. The same for everyone, and vanishing.</a:t>
+            </a:r>
+            <a:endParaRPr lang="en-US" sz="1700" dirty="0"/>
+          </a:p>
+        </p:txBody>
+      </p:sp>
+      <p:sp>
+        <p:nvSpPr>
+          <p:cNvPr id="4" name="step-items"/>
           <p:cNvSpPr txBox="1"/>
           <p:nvPr/>
         </p:nvSpPr>
         <p:spPr>
           <a:xfrm>
-            <a:off x="1005840" y="1051560"/>
-            <a:ext cx="7680960" cy="868680"/>
-          </a:xfrm>
-          <a:prstGeom prst="rect">
-            <a:avLst/>
-          </a:prstGeom>
-          <a:noFill/>
-          <a:ln/>
-        </p:spPr>
-        <p:txBody>
-          <a:bodyPr wrap="square" lIns="0" tIns="0" rIns="0" bIns="0" rtlCol="0" anchor="ctr"/>
-          <a:lstStyle/>
-          <a:p>
-            <a:pPr indent="0" marL="0">
-              <a:buNone/>
-            </a:pPr>
-            <a:r>
-              <a:rPr lang="en-US" sz="1700" b="1" dirty="0">
-                <a:solidFill>
-                  <a:schemeClr val="tx2"/>
-                </a:solidFill>
-              </a:rPr>
-              <a:t>Weight on the public signal = its precision relative to the private one. The same for everyone, and vanishing.</a:t>
-            </a:r>
-            <a:endParaRPr lang="en-US" sz="1700" dirty="0"/>
-          </a:p>
-        </p:txBody>
-      </p:sp>
-      <p:sp>
-        <p:nvSpPr>
-          <p:cNvPr id="6" name="step-items"/>
-          <p:cNvSpPr txBox="1"/>
-          <p:nvPr/>
-        </p:nvSpPr>
-        <p:spPr>
-          <a:xfrm>
-            <a:off x="1005840" y="2103120"/>
-            <a:ext cx="7680960" cy="2103120"/>
+            <a:off x="457200" y="2103120"/>
+            <a:ext cx="8229600" cy="2103120"/>
           </a:xfrm>
           <a:prstGeom prst="rect">
             <a:avLst/>
@@ -10950,41 +10930,14 @@
       </p:sp>
       <p:sp>
         <p:nvSpPr>
-          <p:cNvPr id="3" name="chip"/>
-          <p:cNvSpPr/>
-          <p:nvPr/>
-        </p:nvSpPr>
-        <p:spPr>
-          <a:xfrm>
-            <a:off x="457200" y="1143000"/>
-            <a:ext cx="384048" cy="384048"/>
-          </a:xfrm>
-          <a:prstGeom prst="roundRect">
-            <a:avLst>
-              <a:gd name="adj" fmla="val 14286"/>
-            </a:avLst>
-          </a:prstGeom>
-          <a:solidFill>
-            <a:schemeClr val="accent1"/>
-          </a:solidFill>
-          <a:ln w="12700">
-            <a:solidFill>
-              <a:schemeClr val="accent1"/>
-            </a:solidFill>
-            <a:prstDash val="solid"/>
-          </a:ln>
-        </p:spPr>
-      </p:sp>
-      <p:sp>
-        <p:nvSpPr>
-          <p:cNvPr id="4" name="chip-label"/>
+          <p:cNvPr id="3" name="step-lead"/>
           <p:cNvSpPr txBox="1"/>
           <p:nvPr/>
         </p:nvSpPr>
         <p:spPr>
           <a:xfrm>
-            <a:off x="457200" y="1143000"/>
-            <a:ext cx="384048" cy="384048"/>
+            <a:off x="457200" y="1051560"/>
+            <a:ext cx="8229600" cy="868680"/>
           </a:xfrm>
           <a:prstGeom prst="rect">
             <a:avLst/>
@@ -10996,70 +10949,31 @@
           <a:bodyPr wrap="square" lIns="0" tIns="0" rIns="0" bIns="0" rtlCol="0" anchor="ctr"/>
           <a:lstStyle/>
           <a:p>
-            <a:pPr algn="ctr" indent="0" marL="0">
-              <a:buNone/>
-            </a:pPr>
-            <a:r>
-              <a:rPr lang="en-US" sz="1300" b="1" dirty="0">
-                <a:solidFill>
-                  <a:schemeClr val="bg1"/>
-                </a:solidFill>
-                <a:latin typeface="Cambria" pitchFamily="34" charset="0"/>
-                <a:ea typeface="Cambria" pitchFamily="34" charset="-122"/>
-                <a:cs typeface="Cambria" pitchFamily="34" charset="-120"/>
-              </a:rPr>
-              <a:t>4</a:t>
-            </a:r>
-            <a:endParaRPr lang="en-US" sz="1300" dirty="0"/>
-          </a:p>
-        </p:txBody>
-      </p:sp>
-      <p:sp>
-        <p:nvSpPr>
-          <p:cNvPr id="5" name="step-lead"/>
+            <a:pPr indent="0" marL="0">
+              <a:buNone/>
+            </a:pPr>
+            <a:r>
+              <a:rPr lang="en-US" sz="1700" b="1" dirty="0">
+                <a:solidFill>
+                  <a:schemeClr val="tx2"/>
+                </a:solidFill>
+              </a:rPr>
+              <a:t>Panics are open disagreements between the public line and private evidence, and depositors split on which to trust.</a:t>
+            </a:r>
+            <a:endParaRPr lang="en-US" sz="1700" dirty="0"/>
+          </a:p>
+        </p:txBody>
+      </p:sp>
+      <p:sp>
+        <p:nvSpPr>
+          <p:cNvPr id="4" name="step-items"/>
           <p:cNvSpPr txBox="1"/>
           <p:nvPr/>
         </p:nvSpPr>
         <p:spPr>
           <a:xfrm>
-            <a:off x="1005840" y="1051560"/>
-            <a:ext cx="7680960" cy="868680"/>
-          </a:xfrm>
-          <a:prstGeom prst="rect">
-            <a:avLst/>
-          </a:prstGeom>
-          <a:noFill/>
-          <a:ln/>
-        </p:spPr>
-        <p:txBody>
-          <a:bodyPr wrap="square" lIns="0" tIns="0" rIns="0" bIns="0" rtlCol="0" anchor="ctr"/>
-          <a:lstStyle/>
-          <a:p>
-            <a:pPr indent="0" marL="0">
-              <a:buNone/>
-            </a:pPr>
-            <a:r>
-              <a:rPr lang="en-US" sz="1700" b="1" dirty="0">
-                <a:solidFill>
-                  <a:schemeClr val="tx2"/>
-                </a:solidFill>
-              </a:rPr>
-              <a:t>Panics are open disagreements between the public line and private evidence, and depositors split on which to trust.</a:t>
-            </a:r>
-            <a:endParaRPr lang="en-US" sz="1700" dirty="0"/>
-          </a:p>
-        </p:txBody>
-      </p:sp>
-      <p:sp>
-        <p:nvSpPr>
-          <p:cNvPr id="6" name="step-items"/>
-          <p:cNvSpPr txBox="1"/>
-          <p:nvPr/>
-        </p:nvSpPr>
-        <p:spPr>
-          <a:xfrm>
-            <a:off x="1005840" y="2103120"/>
-            <a:ext cx="7680960" cy="2103120"/>
+            <a:off x="457200" y="2103120"/>
+            <a:ext cx="8229600" cy="2103120"/>
           </a:xfrm>
           <a:prstGeom prst="rect">
             <a:avLst/>
@@ -11170,14 +11084,14 @@
       </p:sp>
       <p:sp>
         <p:nvSpPr>
-          <p:cNvPr id="7" name="step-foot"/>
+          <p:cNvPr id="5" name="step-foot"/>
           <p:cNvSpPr txBox="1"/>
           <p:nvPr/>
         </p:nvSpPr>
         <p:spPr>
           <a:xfrm>
-            <a:off x="1005840" y="4251960"/>
-            <a:ext cx="7680960" cy="320040"/>
+            <a:off x="457200" y="4251960"/>
+            <a:ext cx="8229600" cy="320040"/>
           </a:xfrm>
           <a:prstGeom prst="rect">
             <a:avLst/>
@@ -11314,41 +11228,14 @@
       </p:sp>
       <p:sp>
         <p:nvSpPr>
-          <p:cNvPr id="3" name="chip"/>
-          <p:cNvSpPr/>
-          <p:nvPr/>
-        </p:nvSpPr>
-        <p:spPr>
-          <a:xfrm>
-            <a:off x="457200" y="1143000"/>
-            <a:ext cx="384048" cy="384048"/>
-          </a:xfrm>
-          <a:prstGeom prst="roundRect">
-            <a:avLst>
-              <a:gd name="adj" fmla="val 14286"/>
-            </a:avLst>
-          </a:prstGeom>
-          <a:solidFill>
-            <a:schemeClr val="accent1"/>
-          </a:solidFill>
-          <a:ln w="12700">
-            <a:solidFill>
-              <a:schemeClr val="accent1"/>
-            </a:solidFill>
-            <a:prstDash val="solid"/>
-          </a:ln>
-        </p:spPr>
-      </p:sp>
-      <p:sp>
-        <p:nvSpPr>
-          <p:cNvPr id="4" name="chip-label"/>
+          <p:cNvPr id="3" name="step-lead"/>
           <p:cNvSpPr txBox="1"/>
           <p:nvPr/>
         </p:nvSpPr>
         <p:spPr>
           <a:xfrm>
-            <a:off x="457200" y="1143000"/>
-            <a:ext cx="384048" cy="384048"/>
+            <a:off x="457200" y="1051560"/>
+            <a:ext cx="8229600" cy="868680"/>
           </a:xfrm>
           <a:prstGeom prst="rect">
             <a:avLst/>
@@ -11360,70 +11247,31 @@
           <a:bodyPr wrap="square" lIns="0" tIns="0" rIns="0" bIns="0" rtlCol="0" anchor="ctr"/>
           <a:lstStyle/>
           <a:p>
-            <a:pPr algn="ctr" indent="0" marL="0">
-              <a:buNone/>
-            </a:pPr>
-            <a:r>
-              <a:rPr lang="en-US" sz="1300" b="1" dirty="0">
-                <a:solidFill>
-                  <a:schemeClr val="bg1"/>
-                </a:solidFill>
-                <a:latin typeface="Cambria" pitchFamily="34" charset="0"/>
-                <a:ea typeface="Cambria" pitchFamily="34" charset="-122"/>
-                <a:cs typeface="Cambria" pitchFamily="34" charset="-120"/>
-              </a:rPr>
-              <a:t>5</a:t>
-            </a:r>
-            <a:endParaRPr lang="en-US" sz="1300" dirty="0"/>
-          </a:p>
-        </p:txBody>
-      </p:sp>
-      <p:sp>
-        <p:nvSpPr>
-          <p:cNvPr id="5" name="step-lead"/>
+            <a:pPr indent="0" marL="0">
+              <a:buNone/>
+            </a:pPr>
+            <a:r>
+              <a:rPr lang="en-US" sz="1700" b="1" dirty="0">
+                <a:solidFill>
+                  <a:schemeClr val="tx2"/>
+                </a:solidFill>
+              </a:rPr>
+              <a:t>Culture supplies a weight that differs across depositors, is set before the run, and does not move with the information environment.</a:t>
+            </a:r>
+            <a:endParaRPr lang="en-US" sz="1700" dirty="0"/>
+          </a:p>
+        </p:txBody>
+      </p:sp>
+      <p:sp>
+        <p:nvSpPr>
+          <p:cNvPr id="4" name="step-items"/>
           <p:cNvSpPr txBox="1"/>
           <p:nvPr/>
         </p:nvSpPr>
         <p:spPr>
           <a:xfrm>
-            <a:off x="1005840" y="1051560"/>
-            <a:ext cx="7680960" cy="868680"/>
-          </a:xfrm>
-          <a:prstGeom prst="rect">
-            <a:avLst/>
-          </a:prstGeom>
-          <a:noFill/>
-          <a:ln/>
-        </p:spPr>
-        <p:txBody>
-          <a:bodyPr wrap="square" lIns="0" tIns="0" rIns="0" bIns="0" rtlCol="0" anchor="ctr"/>
-          <a:lstStyle/>
-          <a:p>
-            <a:pPr indent="0" marL="0">
-              <a:buNone/>
-            </a:pPr>
-            <a:r>
-              <a:rPr lang="en-US" sz="1700" b="1" dirty="0">
-                <a:solidFill>
-                  <a:schemeClr val="tx2"/>
-                </a:solidFill>
-              </a:rPr>
-              <a:t>Culture supplies a weight that differs across depositors, is set before the run, and does not move with the information environment.</a:t>
-            </a:r>
-            <a:endParaRPr lang="en-US" sz="1700" dirty="0"/>
-          </a:p>
-        </p:txBody>
-      </p:sp>
-      <p:sp>
-        <p:nvSpPr>
-          <p:cNvPr id="6" name="step-items"/>
-          <p:cNvSpPr txBox="1"/>
-          <p:nvPr/>
-        </p:nvSpPr>
-        <p:spPr>
-          <a:xfrm>
-            <a:off x="1005840" y="2103120"/>
-            <a:ext cx="7680960" cy="2103120"/>
+            <a:off x="457200" y="2103120"/>
+            <a:ext cx="8229600" cy="2103120"/>
           </a:xfrm>
           <a:prstGeom prst="rect">
             <a:avLst/>
@@ -11642,41 +11490,14 @@
       </p:sp>
       <p:sp>
         <p:nvSpPr>
-          <p:cNvPr id="3" name="chip"/>
-          <p:cNvSpPr/>
-          <p:nvPr/>
-        </p:nvSpPr>
-        <p:spPr>
-          <a:xfrm>
-            <a:off x="457200" y="1143000"/>
-            <a:ext cx="384048" cy="384048"/>
-          </a:xfrm>
-          <a:prstGeom prst="roundRect">
-            <a:avLst>
-              <a:gd name="adj" fmla="val 14286"/>
-            </a:avLst>
-          </a:prstGeom>
-          <a:solidFill>
-            <a:schemeClr val="accent1"/>
-          </a:solidFill>
-          <a:ln w="12700">
-            <a:solidFill>
-              <a:schemeClr val="accent1"/>
-            </a:solidFill>
-            <a:prstDash val="solid"/>
-          </a:ln>
-        </p:spPr>
-      </p:sp>
-      <p:sp>
-        <p:nvSpPr>
-          <p:cNvPr id="4" name="chip-label"/>
+          <p:cNvPr id="3" name="step-lead"/>
           <p:cNvSpPr txBox="1"/>
           <p:nvPr/>
         </p:nvSpPr>
         <p:spPr>
           <a:xfrm>
-            <a:off x="457200" y="1143000"/>
-            <a:ext cx="384048" cy="384048"/>
+            <a:off x="457200" y="1051560"/>
+            <a:ext cx="8229600" cy="868680"/>
           </a:xfrm>
           <a:prstGeom prst="rect">
             <a:avLst/>
@@ -11688,70 +11509,31 @@
           <a:bodyPr wrap="square" lIns="0" tIns="0" rIns="0" bIns="0" rtlCol="0" anchor="ctr"/>
           <a:lstStyle/>
           <a:p>
-            <a:pPr algn="ctr" indent="0" marL="0">
-              <a:buNone/>
-            </a:pPr>
-            <a:r>
-              <a:rPr lang="en-US" sz="1300" b="1" dirty="0">
-                <a:solidFill>
-                  <a:schemeClr val="bg1"/>
-                </a:solidFill>
-                <a:latin typeface="Cambria" pitchFamily="34" charset="0"/>
-                <a:ea typeface="Cambria" pitchFamily="34" charset="-122"/>
-                <a:cs typeface="Cambria" pitchFamily="34" charset="-120"/>
-              </a:rPr>
-              <a:t>6</a:t>
-            </a:r>
-            <a:endParaRPr lang="en-US" sz="1300" dirty="0"/>
-          </a:p>
-        </p:txBody>
-      </p:sp>
-      <p:sp>
-        <p:nvSpPr>
-          <p:cNvPr id="5" name="step-lead"/>
+            <a:pPr indent="0" marL="0">
+              <a:buNone/>
+            </a:pPr>
+            <a:r>
+              <a:rPr lang="en-US" sz="1700" b="1" dirty="0">
+                <a:solidFill>
+                  <a:schemeClr val="tx2"/>
+                </a:solidFill>
+              </a:rPr>
+              <a:t>The weight is the depositor’s psychological characteristic; culture is the population-level source.</a:t>
+            </a:r>
+            <a:endParaRPr lang="en-US" sz="1700" dirty="0"/>
+          </a:p>
+        </p:txBody>
+      </p:sp>
+      <p:sp>
+        <p:nvSpPr>
+          <p:cNvPr id="4" name="step-items"/>
           <p:cNvSpPr txBox="1"/>
           <p:nvPr/>
         </p:nvSpPr>
         <p:spPr>
           <a:xfrm>
-            <a:off x="1005840" y="1051560"/>
-            <a:ext cx="7680960" cy="868680"/>
-          </a:xfrm>
-          <a:prstGeom prst="rect">
-            <a:avLst/>
-          </a:prstGeom>
-          <a:noFill/>
-          <a:ln/>
-        </p:spPr>
-        <p:txBody>
-          <a:bodyPr wrap="square" lIns="0" tIns="0" rIns="0" bIns="0" rtlCol="0" anchor="ctr"/>
-          <a:lstStyle/>
-          <a:p>
-            <a:pPr indent="0" marL="0">
-              <a:buNone/>
-            </a:pPr>
-            <a:r>
-              <a:rPr lang="en-US" sz="1700" b="1" dirty="0">
-                <a:solidFill>
-                  <a:schemeClr val="tx2"/>
-                </a:solidFill>
-              </a:rPr>
-              <a:t>The weight is the depositor’s psychological characteristic; culture is the population-level source.</a:t>
-            </a:r>
-            <a:endParaRPr lang="en-US" sz="1700" dirty="0"/>
-          </a:p>
-        </p:txBody>
-      </p:sp>
-      <p:sp>
-        <p:nvSpPr>
-          <p:cNvPr id="6" name="step-items"/>
-          <p:cNvSpPr txBox="1"/>
-          <p:nvPr/>
-        </p:nvSpPr>
-        <p:spPr>
-          <a:xfrm>
-            <a:off x="1005840" y="2103120"/>
-            <a:ext cx="7680960" cy="2103120"/>
+            <a:off x="457200" y="2103120"/>
+            <a:ext cx="8229600" cy="2103120"/>
           </a:xfrm>
           <a:prstGeom prst="rect">
             <a:avLst/>
@@ -11970,41 +11752,14 @@
       </p:sp>
       <p:sp>
         <p:nvSpPr>
-          <p:cNvPr id="3" name="chip"/>
-          <p:cNvSpPr/>
-          <p:nvPr/>
-        </p:nvSpPr>
-        <p:spPr>
-          <a:xfrm>
-            <a:off x="457200" y="1143000"/>
-            <a:ext cx="384048" cy="384048"/>
-          </a:xfrm>
-          <a:prstGeom prst="roundRect">
-            <a:avLst>
-              <a:gd name="adj" fmla="val 14286"/>
-            </a:avLst>
-          </a:prstGeom>
-          <a:solidFill>
-            <a:schemeClr val="accent1"/>
-          </a:solidFill>
-          <a:ln w="12700">
-            <a:solidFill>
-              <a:schemeClr val="accent1"/>
-            </a:solidFill>
-            <a:prstDash val="solid"/>
-          </a:ln>
-        </p:spPr>
-      </p:sp>
-      <p:sp>
-        <p:nvSpPr>
-          <p:cNvPr id="4" name="chip-label"/>
+          <p:cNvPr id="3" name="step-lead"/>
           <p:cNvSpPr txBox="1"/>
           <p:nvPr/>
         </p:nvSpPr>
         <p:spPr>
           <a:xfrm>
-            <a:off x="457200" y="1143000"/>
-            <a:ext cx="384048" cy="384048"/>
+            <a:off x="457200" y="1051560"/>
+            <a:ext cx="8229600" cy="868680"/>
           </a:xfrm>
           <a:prstGeom prst="rect">
             <a:avLst/>
@@ -12016,70 +11771,31 @@
           <a:bodyPr wrap="square" lIns="0" tIns="0" rIns="0" bIns="0" rtlCol="0" anchor="ctr"/>
           <a:lstStyle/>
           <a:p>
-            <a:pPr algn="ctr" indent="0" marL="0">
-              <a:buNone/>
-            </a:pPr>
-            <a:r>
-              <a:rPr lang="en-US" sz="1300" b="1" dirty="0">
-                <a:solidFill>
-                  <a:schemeClr val="bg1"/>
-                </a:solidFill>
-                <a:latin typeface="Cambria" pitchFamily="34" charset="0"/>
-                <a:ea typeface="Cambria" pitchFamily="34" charset="-122"/>
-                <a:cs typeface="Cambria" pitchFamily="34" charset="-120"/>
-              </a:rPr>
-              <a:t>7</a:t>
-            </a:r>
-            <a:endParaRPr lang="en-US" sz="1300" dirty="0"/>
-          </a:p>
-        </p:txBody>
-      </p:sp>
-      <p:sp>
-        <p:nvSpPr>
-          <p:cNvPr id="5" name="step-lead"/>
+            <a:pPr indent="0" marL="0">
+              <a:buNone/>
+            </a:pPr>
+            <a:r>
+              <a:rPr lang="en-US" sz="1700" b="1" dirty="0">
+                <a:solidFill>
+                  <a:schemeClr val="tx2"/>
+                </a:solidFill>
+              </a:rPr>
+              <a:t>Chapter 1 relaxed one assumption. The agent-based model relaxes the rest at once, and lets the three rungs interact.</a:t>
+            </a:r>
+            <a:endParaRPr lang="en-US" sz="1700" dirty="0"/>
+          </a:p>
+        </p:txBody>
+      </p:sp>
+      <p:sp>
+        <p:nvSpPr>
+          <p:cNvPr id="4" name="step-items"/>
           <p:cNvSpPr txBox="1"/>
           <p:nvPr/>
         </p:nvSpPr>
         <p:spPr>
           <a:xfrm>
-            <a:off x="1005840" y="1051560"/>
-            <a:ext cx="7680960" cy="868680"/>
-          </a:xfrm>
-          <a:prstGeom prst="rect">
-            <a:avLst/>
-          </a:prstGeom>
-          <a:noFill/>
-          <a:ln/>
-        </p:spPr>
-        <p:txBody>
-          <a:bodyPr wrap="square" lIns="0" tIns="0" rIns="0" bIns="0" rtlCol="0" anchor="ctr"/>
-          <a:lstStyle/>
-          <a:p>
-            <a:pPr indent="0" marL="0">
-              <a:buNone/>
-            </a:pPr>
-            <a:r>
-              <a:rPr lang="en-US" sz="1700" b="1" dirty="0">
-                <a:solidFill>
-                  <a:schemeClr val="tx2"/>
-                </a:solidFill>
-              </a:rPr>
-              <a:t>Chapter 1 relaxed one assumption. The agent-based model relaxes the rest at once, and lets the three rungs interact.</a:t>
-            </a:r>
-            <a:endParaRPr lang="en-US" sz="1700" dirty="0"/>
-          </a:p>
-        </p:txBody>
-      </p:sp>
-      <p:sp>
-        <p:nvSpPr>
-          <p:cNvPr id="6" name="step-items"/>
-          <p:cNvSpPr txBox="1"/>
-          <p:nvPr/>
-        </p:nvSpPr>
-        <p:spPr>
-          <a:xfrm>
-            <a:off x="1005840" y="2103120"/>
-            <a:ext cx="7680960" cy="2103120"/>
+            <a:off x="457200" y="2103120"/>
+            <a:ext cx="8229600" cy="2103120"/>
           </a:xfrm>
           <a:prstGeom prst="rect">
             <a:avLst/>

</xml_diff>

<commit_message>
Deck: simulation slide no longer names the precision ratio
Co-Authored-By: Claude Fable 5.1 <noreply@anthropic.com>
</commit_message>
<xml_diff>
--- a/docs/deck_2026-10-26_seminar.pptx
+++ b/docs/deck_2026-10-26_seminar.pptx
@@ -129,7 +129,7 @@
   <p:extLst>
     <p:ext uri="{521415D9-36F7-43E2-AB2F-B90AF26B5E84}">
       <p14:sectionLst xmlns:p14="http://schemas.microsoft.com/office/powerpoint/2010/main">
-        <p14:section name="Opening" id="{849ee837-bfee-fd69-b4cc-5daac7405823}">
+        <p14:section name="Opening" id="{54f783ce-4342-bc4b-b6ea-b2554af04876}">
           <p14:sldIdLst>
             <p14:sldId id="256"/>
             <p14:sldId id="257"/>
@@ -142,13 +142,13 @@
             <p14:sldId id="264"/>
           </p14:sldIdLst>
         </p14:section>
-        <p14:section name="The model" id="{f54b7945-b27d-90d7-54c4-776168f161eb}">
+        <p14:section name="The model" id="{dcf1a77c-604d-8a0c-d591-275fd5ec57d4}">
           <p14:sldIdLst>
             <p14:sldId id="265"/>
             <p14:sldId id="266"/>
           </p14:sldIdLst>
         </p14:section>
-        <p14:section name="Results" id="{28d41edb-9045-168b-84c7-c226ea5a5d30}">
+        <p14:section name="Results" id="{d599b507-ebe5-bf5a-1c4e-826fa99cbdd8}">
           <p14:sldIdLst>
             <p14:sldId id="267"/>
             <p14:sldId id="268"/>
@@ -156,17 +156,17 @@
             <p14:sldId id="270"/>
           </p14:sldIdLst>
         </p14:section>
-        <p14:section name="Validation" id="{b31626ba-d5d1-1804-bd31-09af4f60edad}">
+        <p14:section name="Validation" id="{2a46ce99-5571-441e-1a0d-e1fe91aab1db}">
           <p14:sldIdLst>
             <p14:sldId id="271"/>
           </p14:sldIdLst>
         </p14:section>
-        <p14:section name="Close" id="{eb02f48d-9578-4977-2b96-19f9b95b1548}">
+        <p14:section name="Close" id="{9b71076e-d3df-954b-1f42-2c3112b72f13}">
           <p14:sldIdLst>
             <p14:sldId id="272"/>
           </p14:sldIdLst>
         </p14:section>
-        <p14:section name="Backup" id="{cb5a5549-3c60-3396-0be1-811bd6396036}">
+        <p14:section name="Backup" id="{ccd3d01f-d003-54b8-ffe1-2e8a531c1d23}">
           <p14:sldIdLst>
             <p14:sldId id="273"/>
             <p14:sldId id="274"/>
@@ -11265,7 +11265,7 @@
                   <a:schemeClr val="tx1"/>
                 </a:solidFill>
               </a:rPr>
-              <a:t>The precision ratio became a stable, heterogeneous weight on a stale public signal. Everything else stayed: a continuum of depositors, one simultaneous move, no network.</a:t>
+              <a:t>The one-size-fits-all weight on public news became a stable, heterogeneous weight on a stale public signal. Everything else stayed: a continuum of depositors, one simultaneous move, no network.</a:t>
             </a:r>
             <a:endParaRPr lang="en-US" sz="1400" dirty="0"/>
           </a:p>

</xml_diff>

<commit_message>
Deck: on-slide chapter references reworded for the standalone-paper framing
Co-Authored-By: Claude Fable 5.1 <noreply@anthropic.com>
</commit_message>
<xml_diff>
--- a/docs/deck_2026-10-26_seminar.pptx
+++ b/docs/deck_2026-10-26_seminar.pptx
@@ -127,7 +127,7 @@
   <p:extLst>
     <p:ext uri="{521415D9-36F7-43E2-AB2F-B90AF26B5E84}">
       <p14:sectionLst xmlns:p14="http://schemas.microsoft.com/office/powerpoint/2010/main">
-        <p14:section name="Opening" id="{f9a93707-d652-f290-439a-7fc98332332b}">
+        <p14:section name="Opening" id="{f591b675-597b-d965-19c9-32905a11ed92}">
           <p14:sldIdLst>
             <p14:sldId id="256"/>
             <p14:sldId id="257"/>
@@ -138,13 +138,13 @@
             <p14:sldId id="262"/>
           </p14:sldIdLst>
         </p14:section>
-        <p14:section name="The model" id="{002b32cb-b0be-cdc2-80e3-579a51ef4379}">
+        <p14:section name="The model" id="{54086bea-1782-8cb1-5127-9db92fdceec2}">
           <p14:sldIdLst>
             <p14:sldId id="263"/>
             <p14:sldId id="264"/>
           </p14:sldIdLst>
         </p14:section>
-        <p14:section name="Results" id="{cbb8f48e-47fd-6b36-ecdd-d1cb7eb4b159}">
+        <p14:section name="Results" id="{0e485032-1caa-bfd6-1e64-302a20c0a63f}">
           <p14:sldIdLst>
             <p14:sldId id="265"/>
             <p14:sldId id="266"/>
@@ -152,17 +152,17 @@
             <p14:sldId id="268"/>
           </p14:sldIdLst>
         </p14:section>
-        <p14:section name="Validation" id="{224acc20-6cd9-cb76-084c-53cf6061a7ec}">
+        <p14:section name="Validation" id="{fb91d5cf-01b3-f5c3-dbb5-372bb3c7e895}">
           <p14:sldIdLst>
             <p14:sldId id="269"/>
           </p14:sldIdLst>
         </p14:section>
-        <p14:section name="Close" id="{11d9ca33-be8e-4bb6-b3d1-fd8bfc3b73f4}">
+        <p14:section name="Close" id="{5f504854-4cf6-20ca-ee1e-220956e2d5fa}">
           <p14:sldIdLst>
             <p14:sldId id="270"/>
           </p14:sldIdLst>
         </p14:section>
-        <p14:section name="Backup" id="{bba43f02-58f1-25f3-0b2e-5a84a09d759c}">
+        <p14:section name="Backup" id="{26652913-41d4-51e8-82e5-d42d11bf377e}">
           <p14:sldIdLst>
             <p14:sldId id="271"/>
             <p14:sldId id="272"/>
@@ -5324,7 +5324,7 @@
                   <a:schemeClr val="accent3"/>
                 </a:solidFill>
               </a:rPr>
-              <a:t>D relative to no news, against how far the public news sits from the truth. Shaded: where Chapter 1 predicts the sign.</a:t>
+              <a:t>D relative to no news, against how far the public news sits from the truth. Shaded: where the theory predicts the sign.</a:t>
             </a:r>
             <a:endParaRPr lang="en-US" sz="1000" dirty="0"/>
           </a:p>
@@ -6758,7 +6758,7 @@
                   <a:schemeClr val="tx1"/>
                 </a:solidFill>
               </a:rPr>
-              <a:t>Super-individuals, to match how the largest depositors exit (Chapter 2 docking)</a:t>
+              <a:t>Super-individuals, to match how the largest depositors exited Celsius</a:t>
             </a:r>
             <a:endParaRPr lang="en-US" sz="1100" dirty="0"/>
           </a:p>
@@ -7249,7 +7249,7 @@
                   <a:schemeClr val="accent3"/>
                 </a:solidFill>
               </a:rPr>
-              <a:t>G1′, G4′, G2a′, G3 and G3c (post hoc). Rows: risk-neutral all-or-nothing, CARA partial, capped reference bank. Filled dot: pooled; hollow: each λ pair. Shaded: Chapter 1’s predicted sign.</a:t>
+              <a:t>G1′, G4′, G2a′, G3 and G3c (post hoc). Rows: risk-neutral all-or-nothing, CARA partial, capped reference bank. Filled dot: pooled; hollow: each λ pair. Shaded: the theory’s predicted sign.</a:t>
             </a:r>
             <a:endParaRPr lang="en-US" sz="1000" dirty="0"/>
           </a:p>

</xml_diff>

<commit_message>
Deck: talk retitled Agent-based Diamond–Dybvig with cultural heterogeneity
Co-Authored-By: Claude Fable 5.1 <noreply@anthropic.com>
</commit_message>
<xml_diff>
--- a/docs/deck_2026-10-26_seminar.pptx
+++ b/docs/deck_2026-10-26_seminar.pptx
@@ -127,7 +127,7 @@
   <p:extLst>
     <p:ext uri="{521415D9-36F7-43E2-AB2F-B90AF26B5E84}">
       <p14:sectionLst xmlns:p14="http://schemas.microsoft.com/office/powerpoint/2010/main">
-        <p14:section name="Opening" id="{f591b675-597b-d965-19c9-32905a11ed92}">
+        <p14:section name="Opening" id="{1d3cf074-4e85-e669-07bc-149a0e6a9387}">
           <p14:sldIdLst>
             <p14:sldId id="256"/>
             <p14:sldId id="257"/>
@@ -138,13 +138,13 @@
             <p14:sldId id="262"/>
           </p14:sldIdLst>
         </p14:section>
-        <p14:section name="The model" id="{54086bea-1782-8cb1-5127-9db92fdceec2}">
+        <p14:section name="The model" id="{7f159a6e-6da6-e182-4d0b-b4b8328511dd}">
           <p14:sldIdLst>
             <p14:sldId id="263"/>
             <p14:sldId id="264"/>
           </p14:sldIdLst>
         </p14:section>
-        <p14:section name="Results" id="{0e485032-1caa-bfd6-1e64-302a20c0a63f}">
+        <p14:section name="Results" id="{e28da7c2-1af7-15c3-cdc5-d024f3c142cd}">
           <p14:sldIdLst>
             <p14:sldId id="265"/>
             <p14:sldId id="266"/>
@@ -152,17 +152,17 @@
             <p14:sldId id="268"/>
           </p14:sldIdLst>
         </p14:section>
-        <p14:section name="Validation" id="{fb91d5cf-01b3-f5c3-dbb5-372bb3c7e895}">
+        <p14:section name="Validation" id="{92d4872b-54e6-1898-d1fb-ffbe85238d1f}">
           <p14:sldIdLst>
             <p14:sldId id="269"/>
           </p14:sldIdLst>
         </p14:section>
-        <p14:section name="Close" id="{5f504854-4cf6-20ca-ee1e-220956e2d5fa}">
+        <p14:section name="Close" id="{b13baee5-89da-91ae-9db4-6594eda1351e}">
           <p14:sldIdLst>
             <p14:sldId id="270"/>
           </p14:sldIdLst>
         </p14:section>
-        <p14:section name="Backup" id="{26652913-41d4-51e8-82e5-d42d11bf377e}">
+        <p14:section name="Backup" id="{7b94ca39-9de4-0073-627d-5bffea7a4e7e}">
           <p14:sldIdLst>
             <p14:sldId id="271"/>
             <p14:sldId id="272"/>
@@ -2611,7 +2611,7 @@
                   <a:schemeClr val="accent3"/>
                 </a:solidFill>
               </a:rPr>
-              <a:t>A bank run model for the twentieth century</a:t>
+              <a:t>Agent-based Diamond–Dybvig with cultural heterogeneity</a:t>
             </a:r>
             <a:endParaRPr lang="en-US" sz="900" dirty="0"/>
           </a:p>
@@ -3154,7 +3154,7 @@
                   <a:schemeClr val="bg1"/>
                 </a:solidFill>
               </a:rPr>
-              <a:t>A bank run model for the twentieth century</a:t>
+              <a:t>Agent-based Diamond–Dybvig with cultural heterogeneity</a:t>
             </a:r>
             <a:endParaRPr lang="en-US" sz="3400" dirty="0"/>
           </a:p>

</xml_diff>

<commit_message>
Deck: subtitle dropped from the title slide
Co-Authored-By: Claude Fable 5.1 <noreply@anthropic.com>
</commit_message>
<xml_diff>
--- a/docs/deck_2026-10-26_seminar.pptx
+++ b/docs/deck_2026-10-26_seminar.pptx
@@ -127,7 +127,7 @@
   <p:extLst>
     <p:ext uri="{521415D9-36F7-43E2-AB2F-B90AF26B5E84}">
       <p14:sectionLst xmlns:p14="http://schemas.microsoft.com/office/powerpoint/2010/main">
-        <p14:section name="Opening" id="{1d3cf074-4e85-e669-07bc-149a0e6a9387}">
+        <p14:section name="Opening" id="{d15b5380-53c5-9d8b-7dad-974d29844b4a}">
           <p14:sldIdLst>
             <p14:sldId id="256"/>
             <p14:sldId id="257"/>
@@ -138,13 +138,13 @@
             <p14:sldId id="262"/>
           </p14:sldIdLst>
         </p14:section>
-        <p14:section name="The model" id="{7f159a6e-6da6-e182-4d0b-b4b8328511dd}">
+        <p14:section name="The model" id="{a7fe3828-ed72-f34e-d8f3-86ab0a0ade73}">
           <p14:sldIdLst>
             <p14:sldId id="263"/>
             <p14:sldId id="264"/>
           </p14:sldIdLst>
         </p14:section>
-        <p14:section name="Results" id="{e28da7c2-1af7-15c3-cdc5-d024f3c142cd}">
+        <p14:section name="Results" id="{77a6db49-88e6-fca9-a2f8-f065211da351}">
           <p14:sldIdLst>
             <p14:sldId id="265"/>
             <p14:sldId id="266"/>
@@ -152,17 +152,17 @@
             <p14:sldId id="268"/>
           </p14:sldIdLst>
         </p14:section>
-        <p14:section name="Validation" id="{92d4872b-54e6-1898-d1fb-ffbe85238d1f}">
+        <p14:section name="Validation" id="{da5fa61d-7361-f704-6396-858d136567f6}">
           <p14:sldIdLst>
             <p14:sldId id="269"/>
           </p14:sldIdLst>
         </p14:section>
-        <p14:section name="Close" id="{b13baee5-89da-91ae-9db4-6594eda1351e}">
+        <p14:section name="Close" id="{08b16241-9d90-7acb-a054-b17bd4d80e56}">
           <p14:sldIdLst>
             <p14:sldId id="270"/>
           </p14:sldIdLst>
         </p14:section>
-        <p14:section name="Backup" id="{7b94ca39-9de4-0073-627d-5bffea7a4e7e}">
+        <p14:section name="Backup" id="{207e92fd-a4f5-21f5-77d3-3f8fe1e53cf5}">
           <p14:sldIdLst>
             <p14:sldId id="271"/>
             <p14:sldId id="272"/>
@@ -576,7 +576,7 @@
           <a:p>
             <a:r>
               <a:rPr lang="en-US" dirty="0"/>
-              <a:t>Working title is the chapter title; change for the seminar if you like. ~0.5 min.</a:t>
+              <a:t>~0.5 min.</a:t>
             </a:r>
             <a:endParaRPr lang="en-US" dirty="0"/>
           </a:p>
@@ -3190,20 +3190,6 @@
               <a:rPr lang="en-US" sz="1800" dirty="0">
                 <a:solidFill>
                   <a:schemeClr val="accent4"/>
-                </a:solidFill>
-              </a:rPr>
-              <a:t>Who runs, and how a run spreads: an agent-based test of the theory</a:t>
-            </a:r>
-            <a:endParaRPr lang="en-US" sz="1800" dirty="0"/>
-          </a:p>
-          <a:p>
-            <a:pPr indent="0" marL="0">
-              <a:buNone/>
-            </a:pPr>
-            <a:r>
-              <a:rPr lang="en-US" sz="1400" dirty="0">
-                <a:solidFill>
-                  <a:schemeClr val="accent3"/>
                 </a:solidFill>
               </a:rPr>
               <a:t>Walter Stover  ·  George Mason University  ·  26 October 2026</a:t>

</xml_diff>

<commit_message>
Deck: slide 4 titled Variation in interpretation, lead reworded
Co-Authored-By: Claude Fable 5.1 <noreply@anthropic.com>
</commit_message>
<xml_diff>
--- a/docs/deck_2026-10-26_seminar.pptx
+++ b/docs/deck_2026-10-26_seminar.pptx
@@ -127,7 +127,7 @@
   <p:extLst>
     <p:ext uri="{521415D9-36F7-43E2-AB2F-B90AF26B5E84}">
       <p14:sectionLst xmlns:p14="http://schemas.microsoft.com/office/powerpoint/2010/main">
-        <p14:section name="Opening" id="{d15b5380-53c5-9d8b-7dad-974d29844b4a}">
+        <p14:section name="Opening" id="{54c199ad-e31e-6a87-f1e2-f9d683adb658}">
           <p14:sldIdLst>
             <p14:sldId id="256"/>
             <p14:sldId id="257"/>
@@ -138,13 +138,13 @@
             <p14:sldId id="262"/>
           </p14:sldIdLst>
         </p14:section>
-        <p14:section name="The model" id="{a7fe3828-ed72-f34e-d8f3-86ab0a0ade73}">
+        <p14:section name="The model" id="{bd929cbf-afb3-4c6c-e313-3310ae061ccf}">
           <p14:sldIdLst>
             <p14:sldId id="263"/>
             <p14:sldId id="264"/>
           </p14:sldIdLst>
         </p14:section>
-        <p14:section name="Results" id="{77a6db49-88e6-fca9-a2f8-f065211da351}">
+        <p14:section name="Results" id="{a62ac3fb-3354-551b-28a1-d127b91fa064}">
           <p14:sldIdLst>
             <p14:sldId id="265"/>
             <p14:sldId id="266"/>
@@ -152,17 +152,17 @@
             <p14:sldId id="268"/>
           </p14:sldIdLst>
         </p14:section>
-        <p14:section name="Validation" id="{da5fa61d-7361-f704-6396-858d136567f6}">
+        <p14:section name="Validation" id="{708d25ea-d98e-db39-e8c4-2fd155458fbf}">
           <p14:sldIdLst>
             <p14:sldId id="269"/>
           </p14:sldIdLst>
         </p14:section>
-        <p14:section name="Close" id="{08b16241-9d90-7acb-a054-b17bd4d80e56}">
+        <p14:section name="Close" id="{f022dfb2-da13-37df-c1b7-b47806a6db0f}">
           <p14:sldIdLst>
             <p14:sldId id="270"/>
           </p14:sldIdLst>
         </p14:section>
-        <p14:section name="Backup" id="{207e92fd-a4f5-21f5-77d3-3f8fe1e53cf5}">
+        <p14:section name="Backup" id="{c091252d-acab-bbe9-79b8-33afc35b2086}">
           <p14:sldIdLst>
             <p14:sldId id="271"/>
             <p14:sldId id="272"/>
@@ -8419,7 +8419,7 @@
                   <a:schemeClr val="tx2"/>
                 </a:solidFill>
               </a:rPr>
-              <a:t>With two signals, a third question appears</a:t>
+              <a:t>Variation in interpretation</a:t>
             </a:r>
             <a:endParaRPr lang="en-US" sz="2400" dirty="0"/>
           </a:p>
@@ -8455,7 +8455,7 @@
                   <a:schemeClr val="tx2"/>
                 </a:solidFill>
               </a:rPr>
-              <a:t>Which signal does a depositor act on, and in what proportion?</a:t>
+              <a:t>When there are two signals, which signal does a depositor act on, and in what proportion?</a:t>
             </a:r>
             <a:endParaRPr lang="en-US" sz="1700" dirty="0"/>
           </a:p>

</xml_diff>

<commit_message>
Deck: ladder slide replaced by the aggregator equation (one weight on two signals) after the culture slide
Co-Authored-By: Claude Fable 5.1 <noreply@anthropic.com>
</commit_message>
<xml_diff>
--- a/docs/deck_2026-10-26_seminar.pptx
+++ b/docs/deck_2026-10-26_seminar.pptx
@@ -126,7 +126,7 @@
   <p:extLst>
     <p:ext uri="{521415D9-36F7-43E2-AB2F-B90AF26B5E84}">
       <p14:sectionLst xmlns:p14="http://schemas.microsoft.com/office/powerpoint/2010/main">
-        <p14:section name="Opening" id="{2f1dcad3-958c-d353-e35b-97829a00eb1c}">
+        <p14:section name="Opening" id="{38f2f7b6-4f00-4256-6d0f-c1d03ed050ae}">
           <p14:sldIdLst>
             <p14:sldId id="256"/>
             <p14:sldId id="257"/>
@@ -136,13 +136,13 @@
             <p14:sldId id="261"/>
           </p14:sldIdLst>
         </p14:section>
-        <p14:section name="The model" id="{dd27b7fe-d3dd-a096-5fa7-c1ef7af34f9b}">
+        <p14:section name="The model" id="{fd43a280-0a9c-5794-1f48-6c4092cc82ac}">
           <p14:sldIdLst>
             <p14:sldId id="262"/>
             <p14:sldId id="263"/>
           </p14:sldIdLst>
         </p14:section>
-        <p14:section name="Results" id="{4678a944-3cdc-1a9d-72f2-21811f6b4087}">
+        <p14:section name="Results" id="{5817c6c6-979e-cd9b-7c08-d4bc68add732}">
           <p14:sldIdLst>
             <p14:sldId id="264"/>
             <p14:sldId id="265"/>
@@ -150,17 +150,17 @@
             <p14:sldId id="267"/>
           </p14:sldIdLst>
         </p14:section>
-        <p14:section name="Validation" id="{da2a085d-e910-4f99-02f7-d20b1348fce6}">
+        <p14:section name="Validation" id="{c6126056-7f46-5a0e-f527-b09765bb04a0}">
           <p14:sldIdLst>
             <p14:sldId id="268"/>
           </p14:sldIdLst>
         </p14:section>
-        <p14:section name="Close" id="{ba6b389a-1350-f68c-2588-0f3332085e9a}">
+        <p14:section name="Close" id="{0b49eb75-640f-46e7-aaea-4598aca7d471}">
           <p14:sldIdLst>
             <p14:sldId id="269"/>
           </p14:sldIdLst>
         </p14:section>
-        <p14:section name="Backup" id="{ab6faf5d-9fcb-4fac-3801-838b4a801cda}">
+        <p14:section name="Backup" id="{8c1cda2f-6360-0d05-bcfb-be50caae211b}">
           <p14:sldIdLst>
             <p14:sldId id="270"/>
             <p14:sldId id="271"/>
@@ -1982,7 +1982,7 @@
           <a:p>
             <a:r>
               <a:rPr lang="en-US" dirty="0"/>
-              <a:t>~1 min. The ladder: variation in the signal (Goldstein-Pauzner: same signal technology, different draws, which selects the equilibrium), variation in location (who hears it, from whom, when: Kelly-O Grada, Iyer-Puri, Cookson et al.), variation in interpretation (the same two signals, different dispositional weights; culture is the stable source). Rung 1 orders depositors by luck, rung 2 by position, rung 3 by who they are, and only rung 3 predicts that the order flips with the sign of the public error. Nearest cousins to acknowledge if asked: Izmalkov-Yildiz 2010 (heterogeneous priors), He-Manela 2016 (information acquisition).</a:t>
+              <a:t>~1.5 min. The whole model in one line: a depositor blends what they are told with what they see, and the blend weight is a disposition, not a precision calculation (Chapter 1 writes it omega; the simulation writes it lambda). Subtracting the two types' estimates gives the wedge (lambda_C minus lambda_I)(x minus y): with the same pair of signals, the individualist's estimate is lower whenever private evidence is worse than the public line, so individualists run on a wider set of signals when the news is stale-optimistic, and the inclusion reverses when the news is stale-pessimistic. That is the sorting prediction the simulation tests. In the simulation, the public side is what neighbours do and what the news says, and lambda is drawn per agent in a cultural warm-up. Next: the simulation itself.</a:t>
             </a:r>
             <a:endParaRPr lang="en-US" dirty="0"/>
           </a:p>
@@ -8321,50 +8321,26 @@
                   <a:schemeClr val="tx2"/>
                 </a:solidFill>
               </a:rPr>
-              <a:t>The ladder: signal, location, interpretation</a:t>
+              <a:t>The model: one weight on two signals</a:t>
             </a:r>
             <a:endParaRPr lang="en-US" sz="2400" dirty="0"/>
           </a:p>
         </p:txBody>
       </p:sp>
-      <p:pic>
-        <p:nvPicPr>
-          <p:cNvPr id="3" name="ladder" descr="Three panels. Signal: one bank fundamental sends a noisy private signal to each depositor, who line up from run to stay. Location: a network in which the signal has reached some depositors from a first hearer and not others. Interpretation: the same private and public signals reach an individualist, who leans on the private signal, and a collectivist, who leans on the public one; culture sets the weight.">    </p:cNvPr>
-          <p:cNvPicPr>
-            <a:picLocks noChangeAspect="1"/>
-          </p:cNvPicPr>
-          <p:nvPr/>
-        </p:nvPicPr>
-        <p:blipFill>
-          <a:blip r:embed="rId1"/>
-          <a:stretch>
-            <a:fillRect/>
-          </a:stretch>
-        </p:blipFill>
-        <p:spPr>
-          <a:xfrm>
-            <a:off x="653339" y="1097280"/>
-            <a:ext cx="7837322" cy="2743200"/>
-          </a:xfrm>
-          <a:prstGeom prst="rect">
-            <a:avLst/>
-          </a:prstGeom>
-        </p:spPr>
-      </p:pic>
-      <p:sp>
-        <p:nvSpPr>
-          <p:cNvPr id="4" name="ladder-note"/>
+      <p:sp>
+        <p:nvSpPr>
+          <p:cNvPr id="3" name="eq-card"/>
           <p:cNvSpPr/>
           <p:nvPr/>
         </p:nvSpPr>
         <p:spPr>
           <a:xfrm>
-            <a:off x="457200" y="3977640"/>
-            <a:ext cx="8229600" cy="566928"/>
+            <a:off x="457200" y="1051560"/>
+            <a:ext cx="8229600" cy="1143000"/>
           </a:xfrm>
           <a:prstGeom prst="roundRect">
             <a:avLst>
-              <a:gd name="adj" fmla="val 12903"/>
+              <a:gd name="adj" fmla="val 6400"/>
             </a:avLst>
           </a:prstGeom>
           <a:solidFill>
@@ -8380,14 +8356,14 @@
       </p:sp>
       <p:sp>
         <p:nvSpPr>
-          <p:cNvPr id="5" name="ladder-text"/>
+          <p:cNvPr id="4" name="eq"/>
           <p:cNvSpPr txBox="1"/>
           <p:nvPr/>
         </p:nvSpPr>
         <p:spPr>
           <a:xfrm>
-            <a:off x="594360" y="4005072"/>
-            <a:ext cx="7955280" cy="512064"/>
+            <a:off x="640080" y="1097280"/>
+            <a:ext cx="7863840" cy="685800"/>
           </a:xfrm>
           <a:prstGeom prst="rect">
             <a:avLst/>
@@ -8399,40 +8375,834 @@
           <a:bodyPr wrap="square" lIns="0" tIns="0" rIns="0" bIns="0" rtlCol="0" anchor="ctr"/>
           <a:lstStyle/>
           <a:p>
-            <a:pPr indent="0" marL="0">
-              <a:buNone/>
-            </a:pPr>
-            <a:r>
-              <a:rPr lang="en-US" sz="1200" dirty="0">
+            <a:pPr algn="ctr" indent="0" marL="0">
+              <a:buNone/>
+            </a:pPr>
+            <a:r>
+              <a:rPr lang="en-US" sz="3000" i="1" dirty="0">
+                <a:solidFill>
+                  <a:schemeClr val="tx2"/>
+                </a:solidFill>
+                <a:latin typeface="Cambria" pitchFamily="34" charset="0"/>
+                <a:ea typeface="Cambria" pitchFamily="34" charset="-122"/>
+                <a:cs typeface="Cambria" pitchFamily="34" charset="-120"/>
+              </a:rPr>
+              <a:t>ŝ</a:t>
+            </a:r>
+            <a:pPr algn="ctr" indent="0" marL="0">
+              <a:buNone/>
+            </a:pPr>
+            <a:r>
+              <a:rPr lang="en-US" sz="3000" i="1" baseline="-40000" dirty="0">
+                <a:solidFill>
+                  <a:schemeClr val="tx2"/>
+                </a:solidFill>
+                <a:latin typeface="Cambria" pitchFamily="34" charset="0"/>
+                <a:ea typeface="Cambria" pitchFamily="34" charset="-122"/>
+                <a:cs typeface="Cambria" pitchFamily="34" charset="-120"/>
+              </a:rPr>
+              <a:t>i</a:t>
+            </a:r>
+            <a:pPr algn="ctr" indent="0" marL="0">
+              <a:buNone/>
+            </a:pPr>
+            <a:r>
+              <a:rPr lang="en-US" sz="3000" dirty="0">
+                <a:solidFill>
+                  <a:schemeClr val="tx2"/>
+                </a:solidFill>
+                <a:latin typeface="Cambria" pitchFamily="34" charset="0"/>
+                <a:ea typeface="Cambria" pitchFamily="34" charset="-122"/>
+                <a:cs typeface="Cambria" pitchFamily="34" charset="-120"/>
+              </a:rPr>
+              <a:t>  =  λ</a:t>
+            </a:r>
+            <a:pPr algn="ctr" indent="0" marL="0">
+              <a:buNone/>
+            </a:pPr>
+            <a:r>
+              <a:rPr lang="en-US" sz="3000" i="1" baseline="-40000" dirty="0">
+                <a:solidFill>
+                  <a:schemeClr val="tx2"/>
+                </a:solidFill>
+                <a:latin typeface="Cambria" pitchFamily="34" charset="0"/>
+                <a:ea typeface="Cambria" pitchFamily="34" charset="-122"/>
+                <a:cs typeface="Cambria" pitchFamily="34" charset="-120"/>
+              </a:rPr>
+              <a:t>i</a:t>
+            </a:r>
+            <a:pPr algn="ctr" indent="0" marL="0">
+              <a:buNone/>
+            </a:pPr>
+            <a:r>
+              <a:rPr lang="en-US" sz="3000" dirty="0">
+                <a:solidFill>
+                  <a:schemeClr val="tx2"/>
+                </a:solidFill>
+                <a:latin typeface="Cambria" pitchFamily="34" charset="0"/>
+                <a:ea typeface="Cambria" pitchFamily="34" charset="-122"/>
+                <a:cs typeface="Cambria" pitchFamily="34" charset="-120"/>
+              </a:rPr>
+              <a:t> · </a:t>
+            </a:r>
+            <a:pPr algn="ctr" indent="0" marL="0">
+              <a:buNone/>
+            </a:pPr>
+            <a:r>
+              <a:rPr lang="en-US" sz="3000" i="1" dirty="0">
+                <a:solidFill>
+                  <a:schemeClr val="tx2"/>
+                </a:solidFill>
+                <a:latin typeface="Cambria" pitchFamily="34" charset="0"/>
+                <a:ea typeface="Cambria" pitchFamily="34" charset="-122"/>
+                <a:cs typeface="Cambria" pitchFamily="34" charset="-120"/>
+              </a:rPr>
+              <a:t>y</a:t>
+            </a:r>
+            <a:pPr algn="ctr" indent="0" marL="0">
+              <a:buNone/>
+            </a:pPr>
+            <a:r>
+              <a:rPr lang="en-US" sz="3000" dirty="0">
+                <a:solidFill>
+                  <a:schemeClr val="tx2"/>
+                </a:solidFill>
+                <a:latin typeface="Cambria" pitchFamily="34" charset="0"/>
+                <a:ea typeface="Cambria" pitchFamily="34" charset="-122"/>
+                <a:cs typeface="Cambria" pitchFamily="34" charset="-120"/>
+              </a:rPr>
+              <a:t>  +  (1 − λ</a:t>
+            </a:r>
+            <a:pPr algn="ctr" indent="0" marL="0">
+              <a:buNone/>
+            </a:pPr>
+            <a:r>
+              <a:rPr lang="en-US" sz="3000" i="1" baseline="-40000" dirty="0">
+                <a:solidFill>
+                  <a:schemeClr val="tx2"/>
+                </a:solidFill>
+                <a:latin typeface="Cambria" pitchFamily="34" charset="0"/>
+                <a:ea typeface="Cambria" pitchFamily="34" charset="-122"/>
+                <a:cs typeface="Cambria" pitchFamily="34" charset="-120"/>
+              </a:rPr>
+              <a:t>i</a:t>
+            </a:r>
+            <a:pPr algn="ctr" indent="0" marL="0">
+              <a:buNone/>
+            </a:pPr>
+            <a:r>
+              <a:rPr lang="en-US" sz="3000" dirty="0">
+                <a:solidFill>
+                  <a:schemeClr val="tx2"/>
+                </a:solidFill>
+                <a:latin typeface="Cambria" pitchFamily="34" charset="0"/>
+                <a:ea typeface="Cambria" pitchFamily="34" charset="-122"/>
+                <a:cs typeface="Cambria" pitchFamily="34" charset="-120"/>
+              </a:rPr>
+              <a:t>) · </a:t>
+            </a:r>
+            <a:pPr algn="ctr" indent="0" marL="0">
+              <a:buNone/>
+            </a:pPr>
+            <a:r>
+              <a:rPr lang="en-US" sz="3000" i="1" dirty="0">
+                <a:solidFill>
+                  <a:schemeClr val="tx2"/>
+                </a:solidFill>
+                <a:latin typeface="Cambria" pitchFamily="34" charset="0"/>
+                <a:ea typeface="Cambria" pitchFamily="34" charset="-122"/>
+                <a:cs typeface="Cambria" pitchFamily="34" charset="-120"/>
+              </a:rPr>
+              <a:t>x</a:t>
+            </a:r>
+            <a:pPr algn="ctr" indent="0" marL="0">
+              <a:buNone/>
+            </a:pPr>
+            <a:r>
+              <a:rPr lang="en-US" sz="3000" i="1" baseline="-40000" dirty="0">
+                <a:solidFill>
+                  <a:schemeClr val="tx2"/>
+                </a:solidFill>
+                <a:latin typeface="Cambria" pitchFamily="34" charset="0"/>
+                <a:ea typeface="Cambria" pitchFamily="34" charset="-122"/>
+                <a:cs typeface="Cambria" pitchFamily="34" charset="-120"/>
+              </a:rPr>
+              <a:t>i</a:t>
+            </a:r>
+            <a:endParaRPr lang="en-US" sz="3000" dirty="0"/>
+          </a:p>
+        </p:txBody>
+      </p:sp>
+      <p:sp>
+        <p:nvSpPr>
+          <p:cNvPr id="5" name="eq-sub"/>
+          <p:cNvSpPr txBox="1"/>
+          <p:nvPr/>
+        </p:nvSpPr>
+        <p:spPr>
+          <a:xfrm>
+            <a:off x="640080" y="1783080"/>
+            <a:ext cx="7863840" cy="320040"/>
+          </a:xfrm>
+          <a:prstGeom prst="rect">
+            <a:avLst/>
+          </a:prstGeom>
+          <a:noFill/>
+          <a:ln/>
+        </p:spPr>
+        <p:txBody>
+          <a:bodyPr wrap="square" lIns="0" tIns="0" rIns="0" bIns="0" rtlCol="0" anchor="ctr"/>
+          <a:lstStyle/>
+          <a:p>
+            <a:pPr algn="ctr" indent="0" marL="0">
+              <a:buNone/>
+            </a:pPr>
+            <a:r>
+              <a:rPr lang="en-US" sz="1200" i="1" dirty="0">
                 <a:solidFill>
                   <a:schemeClr val="accent3"/>
                 </a:solidFill>
               </a:rPr>
-              <a:t>Rungs 1 and 2 are the literature. </a:t>
-            </a:r>
-            <a:pPr indent="0" marL="0">
-              <a:buNone/>
-            </a:pPr>
-            <a:r>
-              <a:rPr lang="en-US" sz="1200" b="1" dirty="0">
+              <a:t>the depositor’s estimate of the bank, compared with a threshold: run if it falls below</a:t>
+            </a:r>
+            <a:endParaRPr lang="en-US" sz="1200" dirty="0"/>
+          </a:p>
+        </p:txBody>
+      </p:sp>
+      <p:sp>
+        <p:nvSpPr>
+          <p:cNvPr id="6" name="term-0"/>
+          <p:cNvSpPr/>
+          <p:nvPr/>
+        </p:nvSpPr>
+        <p:spPr>
+          <a:xfrm>
+            <a:off x="457200" y="2331720"/>
+            <a:ext cx="2651760" cy="1188720"/>
+          </a:xfrm>
+          <a:prstGeom prst="roundRect">
+            <a:avLst>
+              <a:gd name="adj" fmla="val 6154"/>
+            </a:avLst>
+          </a:prstGeom>
+          <a:solidFill>
+            <a:schemeClr val="bg2"/>
+          </a:solidFill>
+          <a:ln w="12700">
+            <a:solidFill>
+              <a:schemeClr val="bg2"/>
+            </a:solidFill>
+            <a:prstDash val="solid"/>
+          </a:ln>
+        </p:spPr>
+      </p:sp>
+      <p:sp>
+        <p:nvSpPr>
+          <p:cNvPr id="7" name="term-head"/>
+          <p:cNvSpPr txBox="1"/>
+          <p:nvPr/>
+        </p:nvSpPr>
+        <p:spPr>
+          <a:xfrm>
+            <a:off x="594360" y="2377440"/>
+            <a:ext cx="2423160" cy="457200"/>
+          </a:xfrm>
+          <a:prstGeom prst="rect">
+            <a:avLst/>
+          </a:prstGeom>
+          <a:noFill/>
+          <a:ln/>
+        </p:spPr>
+        <p:txBody>
+          <a:bodyPr wrap="square" lIns="0" tIns="0" rIns="0" bIns="0" rtlCol="0" anchor="ctr"/>
+          <a:lstStyle/>
+          <a:p>
+            <a:pPr indent="0" marL="0">
+              <a:buNone/>
+            </a:pPr>
+            <a:r>
+              <a:rPr lang="en-US" sz="2200" i="1" dirty="0">
+                <a:solidFill>
+                  <a:schemeClr val="tx2"/>
+                </a:solidFill>
+                <a:latin typeface="Cambria" pitchFamily="34" charset="0"/>
+                <a:ea typeface="Cambria" pitchFamily="34" charset="-122"/>
+                <a:cs typeface="Cambria" pitchFamily="34" charset="-120"/>
+              </a:rPr>
+              <a:t>x</a:t>
+            </a:r>
+            <a:pPr indent="0" marL="0">
+              <a:buNone/>
+            </a:pPr>
+            <a:r>
+              <a:rPr lang="en-US" sz="2200" i="1" baseline="-40000" dirty="0">
+                <a:solidFill>
+                  <a:schemeClr val="tx2"/>
+                </a:solidFill>
+                <a:latin typeface="Cambria" pitchFamily="34" charset="0"/>
+                <a:ea typeface="Cambria" pitchFamily="34" charset="-122"/>
+                <a:cs typeface="Cambria" pitchFamily="34" charset="-120"/>
+              </a:rPr>
+              <a:t>i</a:t>
+            </a:r>
+            <a:pPr indent="0" marL="0">
+              <a:buNone/>
+            </a:pPr>
+            <a:r>
+              <a:rPr lang="en-US" sz="1250" b="1" dirty="0">
+                <a:solidFill>
+                  <a:schemeClr val="tx1"/>
+                </a:solidFill>
+              </a:rPr>
+              <a:t>   what the depositor sees</a:t>
+            </a:r>
+            <a:endParaRPr lang="en-US" sz="2200" dirty="0"/>
+          </a:p>
+        </p:txBody>
+      </p:sp>
+      <p:sp>
+        <p:nvSpPr>
+          <p:cNvPr id="8" name="term-body"/>
+          <p:cNvSpPr txBox="1"/>
+          <p:nvPr/>
+        </p:nvSpPr>
+        <p:spPr>
+          <a:xfrm>
+            <a:off x="594360" y="2834640"/>
+            <a:ext cx="2423160" cy="640080"/>
+          </a:xfrm>
+          <a:prstGeom prst="rect">
+            <a:avLst/>
+          </a:prstGeom>
+          <a:noFill/>
+          <a:ln/>
+        </p:spPr>
+        <p:txBody>
+          <a:bodyPr wrap="square" lIns="0" tIns="0" rIns="0" bIns="0" rtlCol="0" anchor="t"/>
+          <a:lstStyle/>
+          <a:p>
+            <a:pPr indent="0" marL="0">
+              <a:buNone/>
+            </a:pPr>
+            <a:r>
+              <a:rPr lang="en-US" sz="1150" dirty="0">
+                <a:solidFill>
+                  <a:schemeClr val="accent3"/>
+                </a:solidFill>
+              </a:rPr>
+              <a:t>a private signal of the fundamental, one noisy draw each</a:t>
+            </a:r>
+            <a:endParaRPr lang="en-US" sz="1150" dirty="0"/>
+          </a:p>
+        </p:txBody>
+      </p:sp>
+      <p:sp>
+        <p:nvSpPr>
+          <p:cNvPr id="9" name="term-1"/>
+          <p:cNvSpPr/>
+          <p:nvPr/>
+        </p:nvSpPr>
+        <p:spPr>
+          <a:xfrm>
+            <a:off x="3246120" y="2331720"/>
+            <a:ext cx="2651760" cy="1188720"/>
+          </a:xfrm>
+          <a:prstGeom prst="roundRect">
+            <a:avLst>
+              <a:gd name="adj" fmla="val 6154"/>
+            </a:avLst>
+          </a:prstGeom>
+          <a:solidFill>
+            <a:schemeClr val="bg2"/>
+          </a:solidFill>
+          <a:ln w="12700">
+            <a:solidFill>
+              <a:schemeClr val="bg2"/>
+            </a:solidFill>
+            <a:prstDash val="solid"/>
+          </a:ln>
+        </p:spPr>
+      </p:sp>
+      <p:sp>
+        <p:nvSpPr>
+          <p:cNvPr id="10" name="term-head"/>
+          <p:cNvSpPr txBox="1"/>
+          <p:nvPr/>
+        </p:nvSpPr>
+        <p:spPr>
+          <a:xfrm>
+            <a:off x="3383280" y="2377440"/>
+            <a:ext cx="2423160" cy="457200"/>
+          </a:xfrm>
+          <a:prstGeom prst="rect">
+            <a:avLst/>
+          </a:prstGeom>
+          <a:noFill/>
+          <a:ln/>
+        </p:spPr>
+        <p:txBody>
+          <a:bodyPr wrap="square" lIns="0" tIns="0" rIns="0" bIns="0" rtlCol="0" anchor="ctr"/>
+          <a:lstStyle/>
+          <a:p>
+            <a:pPr indent="0" marL="0">
+              <a:buNone/>
+            </a:pPr>
+            <a:r>
+              <a:rPr lang="en-US" sz="2200" i="1" dirty="0">
+                <a:solidFill>
+                  <a:schemeClr val="accent3"/>
+                </a:solidFill>
+                <a:latin typeface="Cambria" pitchFamily="34" charset="0"/>
+                <a:ea typeface="Cambria" pitchFamily="34" charset="-122"/>
+                <a:cs typeface="Cambria" pitchFamily="34" charset="-120"/>
+              </a:rPr>
+              <a:t>y</a:t>
+            </a:r>
+            <a:pPr indent="0" marL="0">
+              <a:buNone/>
+            </a:pPr>
+            <a:pPr indent="0" marL="0">
+              <a:buNone/>
+            </a:pPr>
+            <a:r>
+              <a:rPr lang="en-US" sz="1250" b="1" dirty="0">
+                <a:solidFill>
+                  <a:schemeClr val="tx1"/>
+                </a:solidFill>
+              </a:rPr>
+              <a:t>   what the depositor is told</a:t>
+            </a:r>
+            <a:endParaRPr lang="en-US" sz="2200" dirty="0"/>
+          </a:p>
+        </p:txBody>
+      </p:sp>
+      <p:sp>
+        <p:nvSpPr>
+          <p:cNvPr id="11" name="term-body"/>
+          <p:cNvSpPr txBox="1"/>
+          <p:nvPr/>
+        </p:nvSpPr>
+        <p:spPr>
+          <a:xfrm>
+            <a:off x="3383280" y="2834640"/>
+            <a:ext cx="2423160" cy="640080"/>
+          </a:xfrm>
+          <a:prstGeom prst="rect">
+            <a:avLst/>
+          </a:prstGeom>
+          <a:noFill/>
+          <a:ln/>
+        </p:spPr>
+        <p:txBody>
+          <a:bodyPr wrap="square" lIns="0" tIns="0" rIns="0" bIns="0" rtlCol="0" anchor="t"/>
+          <a:lstStyle/>
+          <a:p>
+            <a:pPr indent="0" marL="0">
+              <a:buNone/>
+            </a:pPr>
+            <a:r>
+              <a:rPr lang="en-US" sz="1150" dirty="0">
+                <a:solidFill>
+                  <a:schemeClr val="accent3"/>
+                </a:solidFill>
+              </a:rPr>
+              <a:t>a public signal, common to all, which can be stale</a:t>
+            </a:r>
+            <a:endParaRPr lang="en-US" sz="1150" dirty="0"/>
+          </a:p>
+        </p:txBody>
+      </p:sp>
+      <p:sp>
+        <p:nvSpPr>
+          <p:cNvPr id="12" name="term-2"/>
+          <p:cNvSpPr/>
+          <p:nvPr/>
+        </p:nvSpPr>
+        <p:spPr>
+          <a:xfrm>
+            <a:off x="6035040" y="2331720"/>
+            <a:ext cx="2651760" cy="1188720"/>
+          </a:xfrm>
+          <a:prstGeom prst="roundRect">
+            <a:avLst>
+              <a:gd name="adj" fmla="val 6154"/>
+            </a:avLst>
+          </a:prstGeom>
+          <a:solidFill>
+            <a:schemeClr val="bg2"/>
+          </a:solidFill>
+          <a:ln w="12700">
+            <a:solidFill>
+              <a:schemeClr val="bg2"/>
+            </a:solidFill>
+            <a:prstDash val="solid"/>
+          </a:ln>
+        </p:spPr>
+      </p:sp>
+      <p:sp>
+        <p:nvSpPr>
+          <p:cNvPr id="13" name="term-head"/>
+          <p:cNvSpPr txBox="1"/>
+          <p:nvPr/>
+        </p:nvSpPr>
+        <p:spPr>
+          <a:xfrm>
+            <a:off x="6172200" y="2377440"/>
+            <a:ext cx="2423160" cy="457200"/>
+          </a:xfrm>
+          <a:prstGeom prst="rect">
+            <a:avLst/>
+          </a:prstGeom>
+          <a:noFill/>
+          <a:ln/>
+        </p:spPr>
+        <p:txBody>
+          <a:bodyPr wrap="square" lIns="0" tIns="0" rIns="0" bIns="0" rtlCol="0" anchor="ctr"/>
+          <a:lstStyle/>
+          <a:p>
+            <a:pPr indent="0" marL="0">
+              <a:buNone/>
+            </a:pPr>
+            <a:r>
+              <a:rPr lang="en-US" sz="2200" i="1" dirty="0">
                 <a:solidFill>
                   <a:schemeClr val="accent1"/>
                 </a:solidFill>
-              </a:rPr>
-              <a:t>Rung 3 is this paper: </a:t>
-            </a:r>
-            <a:pPr indent="0" marL="0">
-              <a:buNone/>
-            </a:pPr>
-            <a:r>
-              <a:rPr lang="en-US" sz="1200" dirty="0">
+                <a:latin typeface="Cambria" pitchFamily="34" charset="0"/>
+                <a:ea typeface="Cambria" pitchFamily="34" charset="-122"/>
+                <a:cs typeface="Cambria" pitchFamily="34" charset="-120"/>
+              </a:rPr>
+              <a:t>λ</a:t>
+            </a:r>
+            <a:pPr indent="0" marL="0">
+              <a:buNone/>
+            </a:pPr>
+            <a:r>
+              <a:rPr lang="en-US" sz="2200" i="1" baseline="-40000" dirty="0">
+                <a:solidFill>
+                  <a:schemeClr val="accent1"/>
+                </a:solidFill>
+                <a:latin typeface="Cambria" pitchFamily="34" charset="0"/>
+                <a:ea typeface="Cambria" pitchFamily="34" charset="-122"/>
+                <a:cs typeface="Cambria" pitchFamily="34" charset="-120"/>
+              </a:rPr>
+              <a:t>i</a:t>
+            </a:r>
+            <a:pPr indent="0" marL="0">
+              <a:buNone/>
+            </a:pPr>
+            <a:r>
+              <a:rPr lang="en-US" sz="1250" b="1" dirty="0">
                 <a:solidFill>
                   <a:schemeClr val="tx1"/>
                 </a:solidFill>
               </a:rPr>
-              <a:t>the only one that orders depositors by a trait, and reverses when the public line is too optimistic or too pessimistic.</a:t>
-            </a:r>
-            <a:endParaRPr lang="en-US" sz="1200" dirty="0"/>
+              <a:t>   weight on the public line</a:t>
+            </a:r>
+            <a:endParaRPr lang="en-US" sz="2200" dirty="0"/>
+          </a:p>
+        </p:txBody>
+      </p:sp>
+      <p:sp>
+        <p:nvSpPr>
+          <p:cNvPr id="14" name="term-body"/>
+          <p:cNvSpPr txBox="1"/>
+          <p:nvPr/>
+        </p:nvSpPr>
+        <p:spPr>
+          <a:xfrm>
+            <a:off x="6172200" y="2834640"/>
+            <a:ext cx="2423160" cy="640080"/>
+          </a:xfrm>
+          <a:prstGeom prst="rect">
+            <a:avLst/>
+          </a:prstGeom>
+          <a:noFill/>
+          <a:ln/>
+        </p:spPr>
+        <p:txBody>
+          <a:bodyPr wrap="square" lIns="0" tIns="0" rIns="0" bIns="0" rtlCol="0" anchor="t"/>
+          <a:lstStyle/>
+          <a:p>
+            <a:pPr indent="0" marL="0">
+              <a:buNone/>
+            </a:pPr>
+            <a:r>
+              <a:rPr lang="en-US" sz="1150" dirty="0">
+                <a:solidFill>
+                  <a:schemeClr val="accent3"/>
+                </a:solidFill>
+              </a:rPr>
+              <a:t>a disposition set before the run; culture is its source</a:t>
+            </a:r>
+            <a:endParaRPr lang="en-US" sz="1150" dirty="0"/>
+          </a:p>
+        </p:txBody>
+      </p:sp>
+      <p:sp>
+        <p:nvSpPr>
+          <p:cNvPr id="15" name="wedge"/>
+          <p:cNvSpPr txBox="1"/>
+          <p:nvPr/>
+        </p:nvSpPr>
+        <p:spPr>
+          <a:xfrm>
+            <a:off x="457200" y="3657600"/>
+            <a:ext cx="8229600" cy="777240"/>
+          </a:xfrm>
+          <a:prstGeom prst="rect">
+            <a:avLst/>
+          </a:prstGeom>
+          <a:noFill/>
+          <a:ln/>
+        </p:spPr>
+        <p:txBody>
+          <a:bodyPr wrap="square" lIns="0" tIns="0" rIns="0" bIns="0" rtlCol="0" anchor="t"/>
+          <a:lstStyle/>
+          <a:p>
+            <a:pPr indent="0" marL="0">
+              <a:buNone/>
+            </a:pPr>
+            <a:r>
+              <a:rPr lang="en-US" sz="1300" b="1" dirty="0">
+                <a:solidFill>
+                  <a:srgbClr val="EB6834"/>
+                </a:solidFill>
+              </a:rPr>
+              <a:t>Individualists </a:t>
+            </a:r>
+            <a:pPr indent="0" marL="0">
+              <a:buNone/>
+            </a:pPr>
+            <a:r>
+              <a:rPr lang="en-US" sz="1300" dirty="0">
+                <a:solidFill>
+                  <a:schemeClr val="tx1"/>
+                </a:solidFill>
+              </a:rPr>
+              <a:t>λ</a:t>
+            </a:r>
+            <a:pPr indent="0" marL="0">
+              <a:buNone/>
+            </a:pPr>
+            <a:r>
+              <a:rPr lang="en-US" sz="1300" baseline="-40000" dirty="0">
+                <a:solidFill>
+                  <a:schemeClr val="tx1"/>
+                </a:solidFill>
+              </a:rPr>
+              <a:t>I</a:t>
+            </a:r>
+            <a:pPr indent="0" marL="0">
+              <a:buNone/>
+            </a:pPr>
+            <a:r>
+              <a:rPr lang="en-US" sz="1300" dirty="0">
+                <a:solidFill>
+                  <a:schemeClr val="tx1"/>
+                </a:solidFill>
+              </a:rPr>
+              <a:t>  &lt;  λ</a:t>
+            </a:r>
+            <a:pPr indent="0" marL="0">
+              <a:buNone/>
+            </a:pPr>
+            <a:r>
+              <a:rPr lang="en-US" sz="1300" baseline="-40000" dirty="0">
+                <a:solidFill>
+                  <a:schemeClr val="tx1"/>
+                </a:solidFill>
+              </a:rPr>
+              <a:t>C</a:t>
+            </a:r>
+            <a:pPr indent="0" marL="0">
+              <a:buNone/>
+            </a:pPr>
+            <a:r>
+              <a:rPr lang="en-US" sz="1300" b="1" dirty="0">
+                <a:solidFill>
+                  <a:srgbClr val="2A78D6"/>
+                </a:solidFill>
+              </a:rPr>
+              <a:t> collectivists</a:t>
+            </a:r>
+            <a:pPr indent="0" marL="0">
+              <a:buNone/>
+            </a:pPr>
+            <a:r>
+              <a:rPr lang="en-US" sz="1300" dirty="0">
+                <a:solidFill>
+                  <a:schemeClr val="tx1"/>
+                </a:solidFill>
+              </a:rPr>
+              <a:t>.  Same two signals, different estimates: </a:t>
+            </a:r>
+            <a:pPr indent="0" marL="0">
+              <a:buNone/>
+            </a:pPr>
+            <a:r>
+              <a:rPr lang="en-US" sz="1300" i="1" dirty="0">
+                <a:solidFill>
+                  <a:schemeClr val="tx1"/>
+                </a:solidFill>
+              </a:rPr>
+              <a:t>ŝ</a:t>
+            </a:r>
+            <a:pPr indent="0" marL="0">
+              <a:buNone/>
+            </a:pPr>
+            <a:r>
+              <a:rPr lang="en-US" sz="1300" baseline="-40000" dirty="0">
+                <a:solidFill>
+                  <a:schemeClr val="tx1"/>
+                </a:solidFill>
+              </a:rPr>
+              <a:t>I</a:t>
+            </a:r>
+            <a:pPr indent="0" marL="0">
+              <a:buNone/>
+            </a:pPr>
+            <a:r>
+              <a:rPr lang="en-US" sz="1300" dirty="0">
+                <a:solidFill>
+                  <a:schemeClr val="tx1"/>
+                </a:solidFill>
+              </a:rPr>
+              <a:t> − </a:t>
+            </a:r>
+            <a:pPr indent="0" marL="0">
+              <a:buNone/>
+            </a:pPr>
+            <a:r>
+              <a:rPr lang="en-US" sz="1300" i="1" dirty="0">
+                <a:solidFill>
+                  <a:schemeClr val="tx1"/>
+                </a:solidFill>
+              </a:rPr>
+              <a:t>ŝ</a:t>
+            </a:r>
+            <a:pPr indent="0" marL="0">
+              <a:buNone/>
+            </a:pPr>
+            <a:r>
+              <a:rPr lang="en-US" sz="1300" baseline="-40000" dirty="0">
+                <a:solidFill>
+                  <a:schemeClr val="tx1"/>
+                </a:solidFill>
+              </a:rPr>
+              <a:t>C</a:t>
+            </a:r>
+            <a:pPr indent="0" marL="0">
+              <a:buNone/>
+            </a:pPr>
+            <a:r>
+              <a:rPr lang="en-US" sz="1300" dirty="0">
+                <a:solidFill>
+                  <a:schemeClr val="tx1"/>
+                </a:solidFill>
+              </a:rPr>
+              <a:t> = (λ</a:t>
+            </a:r>
+            <a:pPr indent="0" marL="0">
+              <a:buNone/>
+            </a:pPr>
+            <a:r>
+              <a:rPr lang="en-US" sz="1300" baseline="-40000" dirty="0">
+                <a:solidFill>
+                  <a:schemeClr val="tx1"/>
+                </a:solidFill>
+              </a:rPr>
+              <a:t>C</a:t>
+            </a:r>
+            <a:pPr indent="0" marL="0">
+              <a:buNone/>
+            </a:pPr>
+            <a:r>
+              <a:rPr lang="en-US" sz="1300" dirty="0">
+                <a:solidFill>
+                  <a:schemeClr val="tx1"/>
+                </a:solidFill>
+              </a:rPr>
+              <a:t> − λ</a:t>
+            </a:r>
+            <a:pPr indent="0" marL="0">
+              <a:buNone/>
+            </a:pPr>
+            <a:r>
+              <a:rPr lang="en-US" sz="1300" baseline="-40000" dirty="0">
+                <a:solidFill>
+                  <a:schemeClr val="tx1"/>
+                </a:solidFill>
+              </a:rPr>
+              <a:t>I</a:t>
+            </a:r>
+            <a:pPr indent="0" marL="0">
+              <a:buNone/>
+            </a:pPr>
+            <a:r>
+              <a:rPr lang="en-US" sz="1300" dirty="0">
+                <a:solidFill>
+                  <a:schemeClr val="tx1"/>
+                </a:solidFill>
+              </a:rPr>
+              <a:t>)(</a:t>
+            </a:r>
+            <a:pPr indent="0" marL="0">
+              <a:buNone/>
+            </a:pPr>
+            <a:r>
+              <a:rPr lang="en-US" sz="1300" i="1" dirty="0">
+                <a:solidFill>
+                  <a:schemeClr val="tx1"/>
+                </a:solidFill>
+              </a:rPr>
+              <a:t>x</a:t>
+            </a:r>
+            <a:pPr indent="0" marL="0">
+              <a:buNone/>
+            </a:pPr>
+            <a:r>
+              <a:rPr lang="en-US" sz="1300" dirty="0">
+                <a:solidFill>
+                  <a:schemeClr val="tx1"/>
+                </a:solidFill>
+              </a:rPr>
+              <a:t> − </a:t>
+            </a:r>
+            <a:pPr indent="0" marL="0">
+              <a:buNone/>
+            </a:pPr>
+            <a:r>
+              <a:rPr lang="en-US" sz="1300" i="1" dirty="0">
+                <a:solidFill>
+                  <a:schemeClr val="tx1"/>
+                </a:solidFill>
+              </a:rPr>
+              <a:t>y</a:t>
+            </a:r>
+            <a:pPr indent="0" marL="0">
+              <a:buNone/>
+            </a:pPr>
+            <a:r>
+              <a:rPr lang="en-US" sz="1300" dirty="0">
+                <a:solidFill>
+                  <a:schemeClr val="tx1"/>
+                </a:solidFill>
+              </a:rPr>
+              <a:t>). </a:t>
+            </a:r>
+            <a:pPr indent="0" marL="0">
+              <a:buNone/>
+            </a:pPr>
+            <a:r>
+              <a:rPr lang="en-US" sz="1300" b="1" dirty="0">
+                <a:solidFill>
+                  <a:schemeClr val="tx2"/>
+                </a:solidFill>
+              </a:rPr>
+              <a:t>Who runs is sorted by the weight, and the order flips with the sign of the public error.</a:t>
+            </a:r>
+            <a:endParaRPr lang="en-US" sz="1300" dirty="0"/>
           </a:p>
         </p:txBody>
       </p:sp>

</xml_diff>

<commit_message>
Deck: backup slides for the tests forest plot, Celsius docking and the vault bank dropped
Co-Authored-By: Claude Fable 5.1 <noreply@anthropic.com>
</commit_message>
<xml_diff>
--- a/docs/deck_2026-10-26_seminar.pptx
+++ b/docs/deck_2026-10-26_seminar.pptx
@@ -22,12 +22,9 @@
     <p:sldId id="270" r:id="rId16"/>
     <p:sldId id="271" r:id="rId17"/>
     <p:sldId id="272" r:id="rId18"/>
-    <p:sldId id="273" r:id="rId19"/>
-    <p:sldId id="274" r:id="rId20"/>
-    <p:sldId id="275" r:id="rId21"/>
   </p:sldIdLst>
   <p:notesMasterIdLst>
-    <p:notesMasterId r:id="rId22"/>
+    <p:notesMasterId r:id="rId19"/>
   </p:notesMasterIdLst>
   <p:sldSz cx="9144000" cy="5143500"/>
   <p:notesSz cx="5143500" cy="9144000"/>
@@ -126,7 +123,7 @@
   <p:extLst>
     <p:ext uri="{521415D9-36F7-43E2-AB2F-B90AF26B5E84}">
       <p14:sectionLst xmlns:p14="http://schemas.microsoft.com/office/powerpoint/2010/main">
-        <p14:section name="Opening" id="{38f2f7b6-4f00-4256-6d0f-c1d03ed050ae}">
+        <p14:section name="Opening" id="{6d9beb0e-9aa0-932f-c957-19c334b02711}">
           <p14:sldIdLst>
             <p14:sldId id="256"/>
             <p14:sldId id="257"/>
@@ -136,13 +133,13 @@
             <p14:sldId id="261"/>
           </p14:sldIdLst>
         </p14:section>
-        <p14:section name="The model" id="{fd43a280-0a9c-5794-1f48-6c4092cc82ac}">
+        <p14:section name="The model" id="{f46d5627-9b9a-ed28-6843-82e78de20048}">
           <p14:sldIdLst>
             <p14:sldId id="262"/>
             <p14:sldId id="263"/>
           </p14:sldIdLst>
         </p14:section>
-        <p14:section name="Results" id="{5817c6c6-979e-cd9b-7c08-d4bc68add732}">
+        <p14:section name="Results" id="{ef56ac54-c560-7e66-53d4-66abda25c443}">
           <p14:sldIdLst>
             <p14:sldId id="264"/>
             <p14:sldId id="265"/>
@@ -150,24 +147,21 @@
             <p14:sldId id="267"/>
           </p14:sldIdLst>
         </p14:section>
-        <p14:section name="Validation" id="{c6126056-7f46-5a0e-f527-b09765bb04a0}">
+        <p14:section name="Validation" id="{b68adc42-6c9a-eaa4-1a69-b2323fe05bef}">
           <p14:sldIdLst>
             <p14:sldId id="268"/>
           </p14:sldIdLst>
         </p14:section>
-        <p14:section name="Close" id="{0b49eb75-640f-46e7-aaea-4598aca7d471}">
+        <p14:section name="Close" id="{44f77a63-cc4e-d7e3-946d-4444958d8d44}">
           <p14:sldIdLst>
             <p14:sldId id="269"/>
           </p14:sldIdLst>
         </p14:section>
-        <p14:section name="Backup" id="{8c1cda2f-6360-0d05-bcfb-be50caae211b}">
+        <p14:section name="Backup" id="{20089f17-7ff2-3b36-2c21-45ea981cdd02}">
           <p14:sldIdLst>
             <p14:sldId id="270"/>
             <p14:sldId id="271"/>
             <p14:sldId id="272"/>
-            <p14:sldId id="273"/>
-            <p14:sldId id="274"/>
-            <p14:sldId id="275"/>
           </p14:sldIdLst>
         </p14:section>
       </p14:sectionLst>
@@ -1278,7 +1272,7 @@
           <a:p>
             <a:r>
               <a:rPr lang="en-US" dirty="0"/>
-              <a:t>r1k pooled: G1' +0.033, G4' -0.031, G2a' +0.093, all Holm-significant; G2b ordering holds. G3 +0.0034 pooled but (0.3, 0.5) wrong-signed in every bank -&gt; counts against. G3c (post hoc, channel-isolated) +0.019, right-signed in every pair. 3 of 4 confirmatory tests support, in all three banks.</a:t>
+              <a:t>Theta-blend only: +0.14 (Ch 1's sign). Head-count only: -0.07 (opposite). Both: +0.02. The two channels pull in opposite directions; Ch 1's sign survives, damped by herding.</a:t>
             </a:r>
             <a:endParaRPr lang="en-US" dirty="0"/>
           </a:p>
@@ -1302,182 +1296,6 @@
             <a:fld id="{F7021451-1387-4CA6-816F-3879F97B5CBC}" type="slidenum">
               <a:rPr lang="en-US"/>
               <a:t>17</a:t>
-            </a:fld>
-            <a:endParaRPr lang="en-US"/>
-          </a:p>
-        </p:txBody>
-      </p:sp>
-    </p:spTree>
-    <p:extLst>
-      <p:ext uri="{BB962C8B-B14F-4D97-AF65-F5344CB8AC3E}">
-        <p14:creationId xmlns:p14="http://schemas.microsoft.com/office/powerpoint/2010/main" val="1024086991"/>
-      </p:ext>
-    </p:extLst>
-  </p:cSld>
-  <p:clrMapOvr>
-    <a:masterClrMapping/>
-  </p:clrMapOvr>
-</p:notes>
-</file>
-
-<file path=ppt/notesSlides/notesSlide18.xml><?xml version="1.0" encoding="utf-8"?>
-<p:notes xmlns:a="http://schemas.openxmlformats.org/drawingml/2006/main" xmlns:r="http://schemas.openxmlformats.org/officeDocument/2006/relationships" xmlns:p="http://schemas.openxmlformats.org/presentationml/2006/main">
-  <p:cSld>
-    <p:spTree>
-      <p:nvGrpSpPr>
-        <p:cNvPr id="1" name=""/>
-        <p:cNvGrpSpPr/>
-        <p:nvPr/>
-      </p:nvGrpSpPr>
-      <p:grpSpPr>
-        <a:xfrm>
-          <a:off x="0" y="0"/>
-          <a:ext cx="0" cy="0"/>
-          <a:chOff x="0" y="0"/>
-          <a:chExt cx="0" cy="0"/>
-        </a:xfrm>
-      </p:grpSpPr>
-      <p:sp>
-        <p:nvSpPr>
-          <p:cNvPr id="2" name="Slide Image Placeholder 1"/>
-          <p:cNvSpPr>
-            <a:spLocks noGrp="1" noRot="1" noChangeAspect="1"/>
-          </p:cNvSpPr>
-          <p:nvPr>
-            <p:ph type="sldImg"/>
-          </p:nvPr>
-        </p:nvSpPr>
-        <p:spPr/>
-      </p:sp>
-      <p:sp>
-        <p:nvSpPr>
-          <p:cNvPr id="3" name="Notes Placeholder 2"/>
-          <p:cNvSpPr>
-            <a:spLocks noGrp="1"/>
-          </p:cNvSpPr>
-          <p:nvPr>
-            <p:ph type="body" idx="1"/>
-          </p:nvPr>
-        </p:nvSpPr>
-        <p:spPr/>
-        <p:txBody>
-          <a:bodyPr/>
-          <a:lstStyle/>
-          <a:p>
-            <a:r>
-              <a:rPr lang="en-US" dirty="0"/>
-              <a:t>Theta-blend only: +0.14 (Ch 1's sign). Head-count only: -0.07 (opposite). Both: +0.02. The two channels pull in opposite directions; Ch 1's sign survives, damped by herding.</a:t>
-            </a:r>
-            <a:endParaRPr lang="en-US" dirty="0"/>
-          </a:p>
-        </p:txBody>
-      </p:sp>
-      <p:sp>
-        <p:nvSpPr>
-          <p:cNvPr id="4" name="Slide Number Placeholder 3"/>
-          <p:cNvSpPr>
-            <a:spLocks noGrp="1"/>
-          </p:cNvSpPr>
-          <p:nvPr>
-            <p:ph type="sldNum" sz="quarter" idx="10"/>
-          </p:nvPr>
-        </p:nvSpPr>
-        <p:spPr/>
-        <p:txBody>
-          <a:bodyPr/>
-          <a:lstStyle/>
-          <a:p>
-            <a:fld id="{F7021451-1387-4CA6-816F-3879F97B5CBC}" type="slidenum">
-              <a:rPr lang="en-US"/>
-              <a:t>18</a:t>
-            </a:fld>
-            <a:endParaRPr lang="en-US"/>
-          </a:p>
-        </p:txBody>
-      </p:sp>
-    </p:spTree>
-    <p:extLst>
-      <p:ext uri="{BB962C8B-B14F-4D97-AF65-F5344CB8AC3E}">
-        <p14:creationId xmlns:p14="http://schemas.microsoft.com/office/powerpoint/2010/main" val="1024086991"/>
-      </p:ext>
-    </p:extLst>
-  </p:cSld>
-  <p:clrMapOvr>
-    <a:masterClrMapping/>
-  </p:clrMapOvr>
-</p:notes>
-</file>
-
-<file path=ppt/notesSlides/notesSlide19.xml><?xml version="1.0" encoding="utf-8"?>
-<p:notes xmlns:a="http://schemas.openxmlformats.org/drawingml/2006/main" xmlns:r="http://schemas.openxmlformats.org/officeDocument/2006/relationships" xmlns:p="http://schemas.openxmlformats.org/presentationml/2006/main">
-  <p:cSld>
-    <p:spTree>
-      <p:nvGrpSpPr>
-        <p:cNvPr id="1" name=""/>
-        <p:cNvGrpSpPr/>
-        <p:nvPr/>
-      </p:nvGrpSpPr>
-      <p:grpSpPr>
-        <a:xfrm>
-          <a:off x="0" y="0"/>
-          <a:ext cx="0" cy="0"/>
-          <a:chOff x="0" y="0"/>
-          <a:chExt cx="0" cy="0"/>
-        </a:xfrm>
-      </p:grpSpPr>
-      <p:sp>
-        <p:nvSpPr>
-          <p:cNvPr id="2" name="Slide Image Placeholder 1"/>
-          <p:cNvSpPr>
-            <a:spLocks noGrp="1" noRot="1" noChangeAspect="1"/>
-          </p:cNvSpPr>
-          <p:nvPr>
-            <p:ph type="sldImg"/>
-          </p:nvPr>
-        </p:nvSpPr>
-        <p:spPr/>
-      </p:sp>
-      <p:sp>
-        <p:nvSpPr>
-          <p:cNvPr id="3" name="Notes Placeholder 2"/>
-          <p:cNvSpPr>
-            <a:spLocks noGrp="1"/>
-          </p:cNvSpPr>
-          <p:nvPr>
-            <p:ph type="body" idx="1"/>
-          </p:nvPr>
-        </p:nvSpPr>
-        <p:spPr/>
-        <p:txBody>
-          <a:bodyPr/>
-          <a:lstStyle/>
-          <a:p>
-            <a:r>
-              <a:rPr lang="en-US" dirty="0"/>
-              <a:t>Celsius falls from ~0.86 (D1–D5 band 0.82–0.90) to 0.35 (top 0.1%); the ABM stays at 0.93–1.00. The model does not yet reproduce how large depositors exit. Next: super-individuals.</a:t>
-            </a:r>
-            <a:endParaRPr lang="en-US" dirty="0"/>
-          </a:p>
-        </p:txBody>
-      </p:sp>
-      <p:sp>
-        <p:nvSpPr>
-          <p:cNvPr id="4" name="Slide Number Placeholder 3"/>
-          <p:cNvSpPr>
-            <a:spLocks noGrp="1"/>
-          </p:cNvSpPr>
-          <p:nvPr>
-            <p:ph type="sldNum" sz="quarter" idx="10"/>
-          </p:nvPr>
-        </p:nvSpPr>
-        <p:spPr/>
-        <p:txBody>
-          <a:bodyPr/>
-          <a:lstStyle/>
-          <a:p>
-            <a:fld id="{F7021451-1387-4CA6-816F-3879F97B5CBC}" type="slidenum">
-              <a:rPr lang="en-US"/>
-              <a:t>19</a:t>
             </a:fld>
             <a:endParaRPr lang="en-US"/>
           </a:p>
@@ -1566,94 +1384,6 @@
             <a:fld id="{F7021451-1387-4CA6-816F-3879F97B5CBC}" type="slidenum">
               <a:rPr lang="en-US"/>
               <a:t>2</a:t>
-            </a:fld>
-            <a:endParaRPr lang="en-US"/>
-          </a:p>
-        </p:txBody>
-      </p:sp>
-    </p:spTree>
-    <p:extLst>
-      <p:ext uri="{BB962C8B-B14F-4D97-AF65-F5344CB8AC3E}">
-        <p14:creationId xmlns:p14="http://schemas.microsoft.com/office/powerpoint/2010/main" val="1024086991"/>
-      </p:ext>
-    </p:extLst>
-  </p:cSld>
-  <p:clrMapOvr>
-    <a:masterClrMapping/>
-  </p:clrMapOvr>
-</p:notes>
-</file>
-
-<file path=ppt/notesSlides/notesSlide20.xml><?xml version="1.0" encoding="utf-8"?>
-<p:notes xmlns:a="http://schemas.openxmlformats.org/drawingml/2006/main" xmlns:r="http://schemas.openxmlformats.org/officeDocument/2006/relationships" xmlns:p="http://schemas.openxmlformats.org/presentationml/2006/main">
-  <p:cSld>
-    <p:spTree>
-      <p:nvGrpSpPr>
-        <p:cNvPr id="1" name=""/>
-        <p:cNvGrpSpPr/>
-        <p:nvPr/>
-      </p:nvGrpSpPr>
-      <p:grpSpPr>
-        <a:xfrm>
-          <a:off x="0" y="0"/>
-          <a:ext cx="0" cy="0"/>
-          <a:chOff x="0" y="0"/>
-          <a:chExt cx="0" cy="0"/>
-        </a:xfrm>
-      </p:grpSpPr>
-      <p:sp>
-        <p:nvSpPr>
-          <p:cNvPr id="2" name="Slide Image Placeholder 1"/>
-          <p:cNvSpPr>
-            <a:spLocks noGrp="1" noRot="1" noChangeAspect="1"/>
-          </p:cNvSpPr>
-          <p:nvPr>
-            <p:ph type="sldImg"/>
-          </p:nvPr>
-        </p:nvSpPr>
-        <p:spPr/>
-      </p:sp>
-      <p:sp>
-        <p:nvSpPr>
-          <p:cNvPr id="3" name="Notes Placeholder 2"/>
-          <p:cNvSpPr>
-            <a:spLocks noGrp="1"/>
-          </p:cNvSpPr>
-          <p:nvPr>
-            <p:ph type="body" idx="1"/>
-          </p:nvPr>
-        </p:nvSpPr>
-        <p:spPr/>
-        <p:txBody>
-          <a:bodyPr/>
-          <a:lstStyle/>
-          <a:p>
-            <a:r>
-              <a:rPr lang="en-US" dirty="0"/>
-              <a:t>Vault bank, earlier specification (chapter Fig 1). For questions about Ch 1's P6. This figure is also monotone decreasing: P6 (non-monotonic fragility) was predicted in Ch 1 and found in neither bank; the P6b placebo hump was null too.</a:t>
-            </a:r>
-            <a:endParaRPr lang="en-US" dirty="0"/>
-          </a:p>
-        </p:txBody>
-      </p:sp>
-      <p:sp>
-        <p:nvSpPr>
-          <p:cNvPr id="4" name="Slide Number Placeholder 3"/>
-          <p:cNvSpPr>
-            <a:spLocks noGrp="1"/>
-          </p:cNvSpPr>
-          <p:nvPr>
-            <p:ph type="sldNum" sz="quarter" idx="10"/>
-          </p:nvPr>
-        </p:nvSpPr>
-        <p:spPr/>
-        <p:txBody>
-          <a:bodyPr/>
-          <a:lstStyle/>
-          <a:p>
-            <a:fld id="{F7021451-1387-4CA6-816F-3879F97B5CBC}" type="slidenum">
-              <a:rPr lang="en-US"/>
-              <a:t>20</a:t>
             </a:fld>
             <a:endParaRPr lang="en-US"/>
           </a:p>
@@ -6380,7 +6110,7 @@
                   <a:schemeClr val="accent4"/>
                 </a:solidFill>
               </a:rPr>
-              <a:t>Technical versions of the exhibits, the pre-registered tests, channels, and the Celsius docking gap.</a:t>
+              <a:t>Technical versions of the exhibits: who withdraws by type and mix, and which channel carries culture.</a:t>
             </a:r>
             <a:endParaRPr lang="en-US" sz="1600" dirty="0"/>
           </a:p>
@@ -6611,7 +6341,7 @@
                   <a:schemeClr val="tx2"/>
                 </a:solidFill>
               </a:rPr>
-              <a:t>The pre-registered tests, three versions of the bank</a:t>
+              <a:t>Which channel carries culture</a:t>
             </a:r>
             <a:endParaRPr lang="en-US" sz="2400" dirty="0"/>
           </a:p>
@@ -6619,7 +6349,7 @@
       </p:sp>
       <p:pic>
         <p:nvPicPr>
-          <p:cNvPr id="3" name="e03" descr="Forest plot of five tests (G1', G4', G2a', G3, G3c) across three bank versions with pooled estimates and per-pair markers.">    </p:cNvPr>
+          <p:cNvPr id="3" name="e09" descr="Who runs in failed runs with optimistic news when lambda applies only to the neighbour blend, only to the news blend, or both: positive, negative, small positive.">    </p:cNvPr>
           <p:cNvPicPr>
             <a:picLocks noChangeAspect="1"/>
           </p:cNvPicPr>
@@ -6633,8 +6363,8 @@
         </p:blipFill>
         <p:spPr>
           <a:xfrm>
-            <a:off x="882533" y="1051560"/>
-            <a:ext cx="7378934" cy="3383280"/>
+            <a:off x="1547348" y="1051560"/>
+            <a:ext cx="6049305" cy="3383280"/>
           </a:xfrm>
           <a:prstGeom prst="rect">
             <a:avLst/>
@@ -6671,7 +6401,7 @@
                   <a:schemeClr val="accent3"/>
                 </a:solidFill>
               </a:rPr>
-              <a:t>G1′, G4′, G2a′, G3 and G3c (post hoc). Rows: risk-neutral all-or-nothing, CARA partial, capped reference bank. Filled dot: pooled; hollow: each λ pair. Shaded: the theory’s predicted sign.</a:t>
+              <a:t>D in failed runs with optimistic news, when λ weights only the neighbour blend, only the news blend, or both (the model). θ-blend only +0.14; head-count only −0.07; both +0.02.</a:t>
             </a:r>
             <a:endParaRPr lang="en-US" sz="1000" dirty="0"/>
           </a:p>
@@ -6717,342 +6447,6 @@
             <a:fld id="{F7021451-1387-4CA6-816F-3879F97B5CBC}" type="slidenum">
               <a:rPr b="0" lang="en-US"/>
               <a:t>17</a:t>
-            </a:fld>
-            <a:endParaRPr lang="en-US"/>
-          </a:p>
-        </p:txBody>
-      </p:sp>
-    </p:spTree>
-  </p:cSld>
-  <p:clrMapOvr>
-    <a:masterClrMapping/>
-  </p:clrMapOvr>
-</p:sld>
-</file>
-
-<file path=ppt/slides/slide18.xml><?xml version="1.0" encoding="utf-8"?>
-<p:sld xmlns:a="http://schemas.openxmlformats.org/drawingml/2006/main" xmlns:r="http://schemas.openxmlformats.org/officeDocument/2006/relationships" xmlns:p="http://schemas.openxmlformats.org/presentationml/2006/main">
-  <p:cSld name="Slide 18">
-    <p:spTree>
-      <p:nvGrpSpPr>
-        <p:cNvPr id="1" name=""/>
-        <p:cNvGrpSpPr/>
-        <p:nvPr/>
-      </p:nvGrpSpPr>
-      <p:grpSpPr>
-        <a:xfrm>
-          <a:off x="0" y="0"/>
-          <a:ext cx="0" cy="0"/>
-          <a:chOff x="0" y="0"/>
-          <a:chExt cx="0" cy="0"/>
-        </a:xfrm>
-      </p:grpSpPr>
-      <p:sp>
-        <p:nvSpPr>
-          <p:cNvPr id="2" name="Text 0"/>
-          <p:cNvSpPr/>
-          <p:nvPr>
-            <p:ph idx="100" type="title" hasCustomPrompt="1"/>
-          </p:nvPr>
-        </p:nvSpPr>
-        <p:spPr>
-          <a:xfrm>
-            <a:off x="457200" y="274320"/>
-            <a:ext cx="8229600" cy="685800"/>
-          </a:xfrm>
-          <a:prstGeom prst="rect">
-            <a:avLst/>
-          </a:prstGeom>
-          <a:noFill/>
-          <a:ln/>
-        </p:spPr>
-        <p:txBody>
-          <a:bodyPr wrap="square" lIns="0" tIns="0" rIns="0" bIns="0" rtlCol="0" anchor="ctr"/>
-          <a:lstStyle/>
-          <a:p>
-            <a:pPr algn="l" indent="0" marL="0">
-              <a:buNone/>
-            </a:pPr>
-            <a:r>
-              <a:rPr lang="en-US" sz="2400" b="1" dirty="0">
-                <a:solidFill>
-                  <a:schemeClr val="tx2"/>
-                </a:solidFill>
-              </a:rPr>
-              <a:t>Which channel carries culture</a:t>
-            </a:r>
-            <a:endParaRPr lang="en-US" sz="2400" dirty="0"/>
-          </a:p>
-        </p:txBody>
-      </p:sp>
-      <p:pic>
-        <p:nvPicPr>
-          <p:cNvPr id="3" name="e09" descr="Who runs in failed runs with optimistic news when lambda applies only to the neighbour blend, only to the news blend, or both: positive, negative, small positive.">    </p:cNvPr>
-          <p:cNvPicPr>
-            <a:picLocks noChangeAspect="1"/>
-          </p:cNvPicPr>
-          <p:nvPr/>
-        </p:nvPicPr>
-        <p:blipFill>
-          <a:blip r:embed="rId1"/>
-          <a:stretch>
-            <a:fillRect/>
-          </a:stretch>
-        </p:blipFill>
-        <p:spPr>
-          <a:xfrm>
-            <a:off x="1547348" y="1051560"/>
-            <a:ext cx="6049305" cy="3383280"/>
-          </a:xfrm>
-          <a:prstGeom prst="rect">
-            <a:avLst/>
-          </a:prstGeom>
-        </p:spPr>
-      </p:pic>
-      <p:sp>
-        <p:nvSpPr>
-          <p:cNvPr id="4" name="caption"/>
-          <p:cNvSpPr txBox="1"/>
-          <p:nvPr/>
-        </p:nvSpPr>
-        <p:spPr>
-          <a:xfrm>
-            <a:off x="457200" y="4480560"/>
-            <a:ext cx="8229600" cy="274320"/>
-          </a:xfrm>
-          <a:prstGeom prst="rect">
-            <a:avLst/>
-          </a:prstGeom>
-          <a:noFill/>
-          <a:ln/>
-        </p:spPr>
-        <p:txBody>
-          <a:bodyPr wrap="square" lIns="0" tIns="0" rIns="0" bIns="0" rtlCol="0" anchor="ctr"/>
-          <a:lstStyle/>
-          <a:p>
-            <a:pPr indent="0" marL="0">
-              <a:buNone/>
-            </a:pPr>
-            <a:r>
-              <a:rPr lang="en-US" sz="1000" i="1" dirty="0">
-                <a:solidFill>
-                  <a:schemeClr val="accent3"/>
-                </a:solidFill>
-              </a:rPr>
-              <a:t>D in failed runs with optimistic news, when λ weights only the neighbour blend, only the news blend, or both (the model). θ-blend only +0.14; head-count only −0.07; both +0.02.</a:t>
-            </a:r>
-            <a:endParaRPr lang="en-US" sz="1000" dirty="0"/>
-          </a:p>
-        </p:txBody>
-      </p:sp>
-      <p:sp>
-        <p:nvSpPr>
-          <p:cNvPr id="25" name="Slide Number Placeholder 0"/>
-          <p:cNvSpPr>
-            <a:spLocks noGrp="1"/>
-          </p:cNvSpPr>
-          <p:nvPr>
-            <p:ph type="sldNum" sz="quarter" idx="4294967295"/>
-          </p:nvPr>
-        </p:nvSpPr>
-        <p:spPr>
-          <a:xfrm>
-            <a:off x="8321040" y="4754880"/>
-            <a:ext cx="457200" cy="274320"/>
-          </a:xfrm>
-          <a:prstGeom prst="rect">
-            <a:avLst/>
-          </a:prstGeom>
-          <a:extLst>
-            <a:ext uri="{C572A759-6A51-4108-AA02-DFA0A04FC94B}">
-              <ma14:wrappingTextBoxFlag xmlns:ma14="http://schemas.microsoft.com/office/mac/drawingml/2011/main" val="0"/>
-            </a:ext>
-          </a:extLst>
-        </p:spPr>
-        <p:txBody>
-          <a:bodyPr/>
-          <a:lstStyle>
-            <a:lvl1pPr>
-              <a:defRPr sz="900">
-                <a:solidFill>
-                  <a:srgbClr val="6B7280"/>
-                </a:solidFill>
-              </a:defRPr>
-            </a:lvl1pPr>
-          </a:lstStyle>
-          <a:p>
-            <a:pPr algn="r"/>
-            <a:fld id="{F7021451-1387-4CA6-816F-3879F97B5CBC}" type="slidenum">
-              <a:rPr b="0" lang="en-US"/>
-              <a:t>18</a:t>
-            </a:fld>
-            <a:endParaRPr lang="en-US"/>
-          </a:p>
-        </p:txBody>
-      </p:sp>
-    </p:spTree>
-  </p:cSld>
-  <p:clrMapOvr>
-    <a:masterClrMapping/>
-  </p:clrMapOvr>
-</p:sld>
-</file>
-
-<file path=ppt/slides/slide19.xml><?xml version="1.0" encoding="utf-8"?>
-<p:sld xmlns:a="http://schemas.openxmlformats.org/drawingml/2006/main" xmlns:r="http://schemas.openxmlformats.org/officeDocument/2006/relationships" xmlns:p="http://schemas.openxmlformats.org/presentationml/2006/main">
-  <p:cSld name="Slide 19">
-    <p:spTree>
-      <p:nvGrpSpPr>
-        <p:cNvPr id="1" name=""/>
-        <p:cNvGrpSpPr/>
-        <p:nvPr/>
-      </p:nvGrpSpPr>
-      <p:grpSpPr>
-        <a:xfrm>
-          <a:off x="0" y="0"/>
-          <a:ext cx="0" cy="0"/>
-          <a:chOff x="0" y="0"/>
-          <a:chExt cx="0" cy="0"/>
-        </a:xfrm>
-      </p:grpSpPr>
-      <p:sp>
-        <p:nvSpPr>
-          <p:cNvPr id="2" name="Text 0"/>
-          <p:cNvSpPr/>
-          <p:nvPr>
-            <p:ph idx="100" type="title" hasCustomPrompt="1"/>
-          </p:nvPr>
-        </p:nvSpPr>
-        <p:spPr>
-          <a:xfrm>
-            <a:off x="457200" y="274320"/>
-            <a:ext cx="8229600" cy="685800"/>
-          </a:xfrm>
-          <a:prstGeom prst="rect">
-            <a:avLst/>
-          </a:prstGeom>
-          <a:noFill/>
-          <a:ln/>
-        </p:spPr>
-        <p:txBody>
-          <a:bodyPr wrap="square" lIns="0" tIns="0" rIns="0" bIns="0" rtlCol="0" anchor="ctr"/>
-          <a:lstStyle/>
-          <a:p>
-            <a:pPr algn="l" indent="0" marL="0">
-              <a:buNone/>
-            </a:pPr>
-            <a:r>
-              <a:rPr lang="en-US" sz="2400" b="1" dirty="0">
-                <a:solidFill>
-                  <a:schemeClr val="tx2"/>
-                </a:solidFill>
-              </a:rPr>
-              <a:t>Matching Celsius: how large depositors exit</a:t>
-            </a:r>
-            <a:endParaRPr lang="en-US" sz="2400" dirty="0"/>
-          </a:p>
-        </p:txBody>
-      </p:sp>
-      <p:pic>
-        <p:nvPicPr>
-          <p:cNvPr id="3" name="e04" descr="Share of exits that withdraw everything at once by depositor size: Celsius falls from about 0.86 to 0.35 for the largest; the model stays at 0.93 to 1.">    </p:cNvPr>
-          <p:cNvPicPr>
-            <a:picLocks noChangeAspect="1"/>
-          </p:cNvPicPr>
-          <p:nvPr/>
-        </p:nvPicPr>
-        <p:blipFill>
-          <a:blip r:embed="rId1"/>
-          <a:stretch>
-            <a:fillRect/>
-          </a:stretch>
-        </p:blipFill>
-        <p:spPr>
-          <a:xfrm>
-            <a:off x="1882292" y="1051560"/>
-            <a:ext cx="5379415" cy="3383280"/>
-          </a:xfrm>
-          <a:prstGeom prst="rect">
-            <a:avLst/>
-          </a:prstGeom>
-        </p:spPr>
-      </p:pic>
-      <p:sp>
-        <p:nvSpPr>
-          <p:cNvPr id="4" name="caption"/>
-          <p:cNvSpPr txBox="1"/>
-          <p:nvPr/>
-        </p:nvSpPr>
-        <p:spPr>
-          <a:xfrm>
-            <a:off x="457200" y="4480560"/>
-            <a:ext cx="8229600" cy="274320"/>
-          </a:xfrm>
-          <a:prstGeom prst="rect">
-            <a:avLst/>
-          </a:prstGeom>
-          <a:noFill/>
-          <a:ln/>
-        </p:spPr>
-        <p:txBody>
-          <a:bodyPr wrap="square" lIns="0" tIns="0" rIns="0" bIns="0" rtlCol="0" anchor="ctr"/>
-          <a:lstStyle/>
-          <a:p>
-            <a:pPr indent="0" marL="0">
-              <a:buNone/>
-            </a:pPr>
-            <a:r>
-              <a:rPr lang="en-US" sz="1000" i="1" dirty="0">
-                <a:solidFill>
-                  <a:schemeClr val="accent3"/>
-                </a:solidFill>
-              </a:rPr>
-              <a:t>Share of exits that withdraw everything at once, by depositor size. Black: Celsius (band for D1–D5); greys: the model, uncapped and capped.</a:t>
-            </a:r>
-            <a:endParaRPr lang="en-US" sz="1000" dirty="0"/>
-          </a:p>
-        </p:txBody>
-      </p:sp>
-      <p:sp>
-        <p:nvSpPr>
-          <p:cNvPr id="25" name="Slide Number Placeholder 0"/>
-          <p:cNvSpPr>
-            <a:spLocks noGrp="1"/>
-          </p:cNvSpPr>
-          <p:nvPr>
-            <p:ph type="sldNum" sz="quarter" idx="4294967295"/>
-          </p:nvPr>
-        </p:nvSpPr>
-        <p:spPr>
-          <a:xfrm>
-            <a:off x="8321040" y="4754880"/>
-            <a:ext cx="457200" cy="274320"/>
-          </a:xfrm>
-          <a:prstGeom prst="rect">
-            <a:avLst/>
-          </a:prstGeom>
-          <a:extLst>
-            <a:ext uri="{C572A759-6A51-4108-AA02-DFA0A04FC94B}">
-              <ma14:wrappingTextBoxFlag xmlns:ma14="http://schemas.microsoft.com/office/mac/drawingml/2011/main" val="0"/>
-            </a:ext>
-          </a:extLst>
-        </p:spPr>
-        <p:txBody>
-          <a:bodyPr/>
-          <a:lstStyle>
-            <a:lvl1pPr>
-              <a:defRPr sz="900">
-                <a:solidFill>
-                  <a:srgbClr val="6B7280"/>
-                </a:solidFill>
-              </a:defRPr>
-            </a:lvl1pPr>
-          </a:lstStyle>
-          <a:p>
-            <a:pPr algn="r"/>
-            <a:fld id="{F7021451-1387-4CA6-816F-3879F97B5CBC}" type="slidenum">
-              <a:rPr b="0" lang="en-US"/>
-              <a:t>19</a:t>
             </a:fld>
             <a:endParaRPr lang="en-US"/>
           </a:p>
@@ -7221,174 +6615,6 @@
             <a:fld id="{F7021451-1387-4CA6-816F-3879F97B5CBC}" type="slidenum">
               <a:rPr b="0" lang="en-US"/>
               <a:t>2</a:t>
-            </a:fld>
-            <a:endParaRPr lang="en-US"/>
-          </a:p>
-        </p:txBody>
-      </p:sp>
-    </p:spTree>
-  </p:cSld>
-  <p:clrMapOvr>
-    <a:masterClrMapping/>
-  </p:clrMapOvr>
-</p:sld>
-</file>
-
-<file path=ppt/slides/slide20.xml><?xml version="1.0" encoding="utf-8"?>
-<p:sld xmlns:a="http://schemas.openxmlformats.org/drawingml/2006/main" xmlns:r="http://schemas.openxmlformats.org/officeDocument/2006/relationships" xmlns:p="http://schemas.openxmlformats.org/presentationml/2006/main">
-  <p:cSld name="Slide 20">
-    <p:spTree>
-      <p:nvGrpSpPr>
-        <p:cNvPr id="1" name=""/>
-        <p:cNvGrpSpPr/>
-        <p:nvPr/>
-      </p:nvGrpSpPr>
-      <p:grpSpPr>
-        <a:xfrm>
-          <a:off x="0" y="0"/>
-          <a:ext cx="0" cy="0"/>
-          <a:chOff x="0" y="0"/>
-          <a:chExt cx="0" cy="0"/>
-        </a:xfrm>
-      </p:grpSpPr>
-      <p:sp>
-        <p:nvSpPr>
-          <p:cNvPr id="2" name="Text 0"/>
-          <p:cNvSpPr/>
-          <p:nvPr>
-            <p:ph idx="100" type="title" hasCustomPrompt="1"/>
-          </p:nvPr>
-        </p:nvSpPr>
-        <p:spPr>
-          <a:xfrm>
-            <a:off x="457200" y="274320"/>
-            <a:ext cx="8229600" cy="685800"/>
-          </a:xfrm>
-          <a:prstGeom prst="rect">
-            <a:avLst/>
-          </a:prstGeom>
-          <a:noFill/>
-          <a:ln/>
-        </p:spPr>
-        <p:txBody>
-          <a:bodyPr wrap="square" lIns="0" tIns="0" rIns="0" bIns="0" rtlCol="0" anchor="ctr"/>
-          <a:lstStyle/>
-          <a:p>
-            <a:pPr algn="l" indent="0" marL="0">
-              <a:buNone/>
-            </a:pPr>
-            <a:r>
-              <a:rPr lang="en-US" sz="2400" b="1" dirty="0">
-                <a:solidFill>
-                  <a:schemeClr val="tx2"/>
-                </a:solidFill>
-              </a:rPr>
-              <a:t>Earlier specification (vault bank): failure by mix</a:t>
-            </a:r>
-            <a:endParaRPr lang="en-US" sz="2400" dirty="0"/>
-          </a:p>
-        </p:txBody>
-      </p:sp>
-      <p:pic>
-        <p:nvPicPr>
-          <p:cNvPr id="3" name="fig1" descr="Earlier vault-bank specification: probability of a run falls with the share of individualists for all three signal-weighting gaps.">    </p:cNvPr>
-          <p:cNvPicPr>
-            <a:picLocks noChangeAspect="1"/>
-          </p:cNvPicPr>
-          <p:nvPr/>
-        </p:nvPicPr>
-        <p:blipFill>
-          <a:blip r:embed="rId1"/>
-          <a:stretch>
-            <a:fillRect/>
-          </a:stretch>
-        </p:blipFill>
-        <p:spPr>
-          <a:xfrm>
-            <a:off x="1999016" y="1051560"/>
-            <a:ext cx="5145969" cy="3383280"/>
-          </a:xfrm>
-          <a:prstGeom prst="rect">
-            <a:avLst/>
-          </a:prstGeom>
-        </p:spPr>
-      </p:pic>
-      <p:sp>
-        <p:nvSpPr>
-          <p:cNvPr id="4" name="caption"/>
-          <p:cNvSpPr txBox="1"/>
-          <p:nvPr/>
-        </p:nvSpPr>
-        <p:spPr>
-          <a:xfrm>
-            <a:off x="457200" y="4480560"/>
-            <a:ext cx="8229600" cy="274320"/>
-          </a:xfrm>
-          <a:prstGeom prst="rect">
-            <a:avLst/>
-          </a:prstGeom>
-          <a:noFill/>
-          <a:ln/>
-        </p:spPr>
-        <p:txBody>
-          <a:bodyPr wrap="square" lIns="0" tIns="0" rIns="0" bIns="0" rtlCol="0" anchor="ctr"/>
-          <a:lstStyle/>
-          <a:p>
-            <a:pPr indent="0" marL="0">
-              <a:buNone/>
-            </a:pPr>
-            <a:r>
-              <a:rPr lang="en-US" sz="1000" i="1" dirty="0">
-                <a:solidFill>
-                  <a:schemeClr val="accent3"/>
-                </a:solidFill>
-              </a:rPr>
-              <a:t>Vault bank, earlier specification (chapter Figure 1): probability of a run by share of individualists, three λ gaps. Also monotone.</a:t>
-            </a:r>
-            <a:endParaRPr lang="en-US" sz="1000" dirty="0"/>
-          </a:p>
-        </p:txBody>
-      </p:sp>
-      <p:sp>
-        <p:nvSpPr>
-          <p:cNvPr id="25" name="Slide Number Placeholder 0"/>
-          <p:cNvSpPr>
-            <a:spLocks noGrp="1"/>
-          </p:cNvSpPr>
-          <p:nvPr>
-            <p:ph type="sldNum" sz="quarter" idx="4294967295"/>
-          </p:nvPr>
-        </p:nvSpPr>
-        <p:spPr>
-          <a:xfrm>
-            <a:off x="8321040" y="4754880"/>
-            <a:ext cx="457200" cy="274320"/>
-          </a:xfrm>
-          <a:prstGeom prst="rect">
-            <a:avLst/>
-          </a:prstGeom>
-          <a:extLst>
-            <a:ext uri="{C572A759-6A51-4108-AA02-DFA0A04FC94B}">
-              <ma14:wrappingTextBoxFlag xmlns:ma14="http://schemas.microsoft.com/office/mac/drawingml/2011/main" val="0"/>
-            </a:ext>
-          </a:extLst>
-        </p:spPr>
-        <p:txBody>
-          <a:bodyPr/>
-          <a:lstStyle>
-            <a:lvl1pPr>
-              <a:defRPr sz="900">
-                <a:solidFill>
-                  <a:srgbClr val="6B7280"/>
-                </a:solidFill>
-              </a:defRPr>
-            </a:lvl1pPr>
-          </a:lstStyle>
-          <a:p>
-            <a:pPr algn="r"/>
-            <a:fld id="{F7021451-1387-4CA6-816F-3879F97B5CBC}" type="slidenum">
-              <a:rPr b="0" lang="en-US"/>
-              <a:t>20</a:t>
             </a:fld>
             <a:endParaRPr lang="en-US"/>
           </a:p>

</xml_diff>

<commit_message>
Deck: backup section dropped
Co-Authored-By: Claude Fable 5.1 <noreply@anthropic.com>
</commit_message>
<xml_diff>
--- a/docs/deck_2026-10-26_seminar.pptx
+++ b/docs/deck_2026-10-26_seminar.pptx
@@ -19,12 +19,9 @@
     <p:sldId id="267" r:id="rId13"/>
     <p:sldId id="268" r:id="rId14"/>
     <p:sldId id="269" r:id="rId15"/>
-    <p:sldId id="270" r:id="rId16"/>
-    <p:sldId id="271" r:id="rId17"/>
-    <p:sldId id="272" r:id="rId18"/>
   </p:sldIdLst>
   <p:notesMasterIdLst>
-    <p:notesMasterId r:id="rId19"/>
+    <p:notesMasterId r:id="rId16"/>
   </p:notesMasterIdLst>
   <p:sldSz cx="9144000" cy="5143500"/>
   <p:notesSz cx="5143500" cy="9144000"/>
@@ -123,7 +120,7 @@
   <p:extLst>
     <p:ext uri="{521415D9-36F7-43E2-AB2F-B90AF26B5E84}">
       <p14:sectionLst xmlns:p14="http://schemas.microsoft.com/office/powerpoint/2010/main">
-        <p14:section name="Opening" id="{6d9beb0e-9aa0-932f-c957-19c334b02711}">
+        <p14:section name="Opening" id="{55747bc9-fbff-27bd-8aa5-5a4fae069394}">
           <p14:sldIdLst>
             <p14:sldId id="256"/>
             <p14:sldId id="257"/>
@@ -133,13 +130,13 @@
             <p14:sldId id="261"/>
           </p14:sldIdLst>
         </p14:section>
-        <p14:section name="The model" id="{f46d5627-9b9a-ed28-6843-82e78de20048}">
+        <p14:section name="The model" id="{9d0c14df-bb4b-d725-5f23-c886e55d2248}">
           <p14:sldIdLst>
             <p14:sldId id="262"/>
             <p14:sldId id="263"/>
           </p14:sldIdLst>
         </p14:section>
-        <p14:section name="Results" id="{ef56ac54-c560-7e66-53d4-66abda25c443}">
+        <p14:section name="Results" id="{2d66c5e5-8eab-8a04-4be3-89b73e6948d4}">
           <p14:sldIdLst>
             <p14:sldId id="264"/>
             <p14:sldId id="265"/>
@@ -147,21 +144,14 @@
             <p14:sldId id="267"/>
           </p14:sldIdLst>
         </p14:section>
-        <p14:section name="Validation" id="{b68adc42-6c9a-eaa4-1a69-b2323fe05bef}">
+        <p14:section name="Validation" id="{512177da-e3e1-33b4-f7ac-30aa9211fc0b}">
           <p14:sldIdLst>
             <p14:sldId id="268"/>
           </p14:sldIdLst>
         </p14:section>
-        <p14:section name="Close" id="{44f77a63-cc4e-d7e3-946d-4444958d8d44}">
+        <p14:section name="Close" id="{c984a01f-8343-fd6a-056e-d8b13e51c458}">
           <p14:sldIdLst>
             <p14:sldId id="269"/>
-          </p14:sldIdLst>
-        </p14:section>
-        <p14:section name="Backup" id="{20089f17-7ff2-3b36-2c21-45ea981cdd02}">
-          <p14:sldIdLst>
-            <p14:sldId id="270"/>
-            <p14:sldId id="271"/>
-            <p14:sldId id="272"/>
           </p14:sldIdLst>
         </p14:section>
       </p14:sectionLst>
@@ -1032,270 +1022,6 @@
             <a:fld id="{F7021451-1387-4CA6-816F-3879F97B5CBC}" type="slidenum">
               <a:rPr lang="en-US"/>
               <a:t>14</a:t>
-            </a:fld>
-            <a:endParaRPr lang="en-US"/>
-          </a:p>
-        </p:txBody>
-      </p:sp>
-    </p:spTree>
-    <p:extLst>
-      <p:ext uri="{BB962C8B-B14F-4D97-AF65-F5344CB8AC3E}">
-        <p14:creationId xmlns:p14="http://schemas.microsoft.com/office/powerpoint/2010/main" val="1024086991"/>
-      </p:ext>
-    </p:extLst>
-  </p:cSld>
-  <p:clrMapOvr>
-    <a:masterClrMapping/>
-  </p:clrMapOvr>
-</p:notes>
-</file>
-
-<file path=ppt/notesSlides/notesSlide15.xml><?xml version="1.0" encoding="utf-8"?>
-<p:notes xmlns:a="http://schemas.openxmlformats.org/drawingml/2006/main" xmlns:r="http://schemas.openxmlformats.org/officeDocument/2006/relationships" xmlns:p="http://schemas.openxmlformats.org/presentationml/2006/main">
-  <p:cSld>
-    <p:spTree>
-      <p:nvGrpSpPr>
-        <p:cNvPr id="1" name=""/>
-        <p:cNvGrpSpPr/>
-        <p:nvPr/>
-      </p:nvGrpSpPr>
-      <p:grpSpPr>
-        <a:xfrm>
-          <a:off x="0" y="0"/>
-          <a:ext cx="0" cy="0"/>
-          <a:chOff x="0" y="0"/>
-          <a:chExt cx="0" cy="0"/>
-        </a:xfrm>
-      </p:grpSpPr>
-      <p:sp>
-        <p:nvSpPr>
-          <p:cNvPr id="2" name="Slide Image Placeholder 1"/>
-          <p:cNvSpPr>
-            <a:spLocks noGrp="1" noRot="1" noChangeAspect="1"/>
-          </p:cNvSpPr>
-          <p:nvPr>
-            <p:ph type="sldImg"/>
-          </p:nvPr>
-        </p:nvSpPr>
-        <p:spPr/>
-      </p:sp>
-      <p:sp>
-        <p:nvSpPr>
-          <p:cNvPr id="3" name="Notes Placeholder 2"/>
-          <p:cNvSpPr>
-            <a:spLocks noGrp="1"/>
-          </p:cNvSpPr>
-          <p:nvPr>
-            <p:ph type="body" idx="1"/>
-          </p:nvPr>
-        </p:nvSpPr>
-        <p:spPr/>
-        <p:txBody>
-          <a:bodyPr/>
-          <a:lstStyle/>
-          <a:p>
-            <a:r>
-              <a:rPr lang="en-US" dirty="0"/>
-              <a:t/>
-            </a:r>
-            <a:endParaRPr lang="en-US" dirty="0"/>
-          </a:p>
-        </p:txBody>
-      </p:sp>
-      <p:sp>
-        <p:nvSpPr>
-          <p:cNvPr id="4" name="Slide Number Placeholder 3"/>
-          <p:cNvSpPr>
-            <a:spLocks noGrp="1"/>
-          </p:cNvSpPr>
-          <p:nvPr>
-            <p:ph type="sldNum" sz="quarter" idx="10"/>
-          </p:nvPr>
-        </p:nvSpPr>
-        <p:spPr/>
-        <p:txBody>
-          <a:bodyPr/>
-          <a:lstStyle/>
-          <a:p>
-            <a:fld id="{F7021451-1387-4CA6-816F-3879F97B5CBC}" type="slidenum">
-              <a:rPr lang="en-US"/>
-              <a:t>15</a:t>
-            </a:fld>
-            <a:endParaRPr lang="en-US"/>
-          </a:p>
-        </p:txBody>
-      </p:sp>
-    </p:spTree>
-    <p:extLst>
-      <p:ext uri="{BB962C8B-B14F-4D97-AF65-F5344CB8AC3E}">
-        <p14:creationId xmlns:p14="http://schemas.microsoft.com/office/powerpoint/2010/main" val="1024086991"/>
-      </p:ext>
-    </p:extLst>
-  </p:cSld>
-  <p:clrMapOvr>
-    <a:masterClrMapping/>
-  </p:clrMapOvr>
-</p:notes>
-</file>
-
-<file path=ppt/notesSlides/notesSlide16.xml><?xml version="1.0" encoding="utf-8"?>
-<p:notes xmlns:a="http://schemas.openxmlformats.org/drawingml/2006/main" xmlns:r="http://schemas.openxmlformats.org/officeDocument/2006/relationships" xmlns:p="http://schemas.openxmlformats.org/presentationml/2006/main">
-  <p:cSld>
-    <p:spTree>
-      <p:nvGrpSpPr>
-        <p:cNvPr id="1" name=""/>
-        <p:cNvGrpSpPr/>
-        <p:nvPr/>
-      </p:nvGrpSpPr>
-      <p:grpSpPr>
-        <a:xfrm>
-          <a:off x="0" y="0"/>
-          <a:ext cx="0" cy="0"/>
-          <a:chOff x="0" y="0"/>
-          <a:chExt cx="0" cy="0"/>
-        </a:xfrm>
-      </p:grpSpPr>
-      <p:sp>
-        <p:nvSpPr>
-          <p:cNvPr id="2" name="Slide Image Placeholder 1"/>
-          <p:cNvSpPr>
-            <a:spLocks noGrp="1" noRot="1" noChangeAspect="1"/>
-          </p:cNvSpPr>
-          <p:nvPr>
-            <p:ph type="sldImg"/>
-          </p:nvPr>
-        </p:nvSpPr>
-        <p:spPr/>
-      </p:sp>
-      <p:sp>
-        <p:nvSpPr>
-          <p:cNvPr id="3" name="Notes Placeholder 2"/>
-          <p:cNvSpPr>
-            <a:spLocks noGrp="1"/>
-          </p:cNvSpPr>
-          <p:nvPr>
-            <p:ph type="body" idx="1"/>
-          </p:nvPr>
-        </p:nvSpPr>
-        <p:spPr/>
-        <p:txBody>
-          <a:bodyPr/>
-          <a:lstStyle/>
-          <a:p>
-            <a:r>
-              <a:rPr lang="en-US" dirty="0"/>
-              <a:t>Both types withdraw less as mu rises; collectivists above individualists at every mixed mu for the two wide gaps; nearly identical at (0.3, 0.5). Technical labels.</a:t>
-            </a:r>
-            <a:endParaRPr lang="en-US" dirty="0"/>
-          </a:p>
-        </p:txBody>
-      </p:sp>
-      <p:sp>
-        <p:nvSpPr>
-          <p:cNvPr id="4" name="Slide Number Placeholder 3"/>
-          <p:cNvSpPr>
-            <a:spLocks noGrp="1"/>
-          </p:cNvSpPr>
-          <p:nvPr>
-            <p:ph type="sldNum" sz="quarter" idx="10"/>
-          </p:nvPr>
-        </p:nvSpPr>
-        <p:spPr/>
-        <p:txBody>
-          <a:bodyPr/>
-          <a:lstStyle/>
-          <a:p>
-            <a:fld id="{F7021451-1387-4CA6-816F-3879F97B5CBC}" type="slidenum">
-              <a:rPr lang="en-US"/>
-              <a:t>16</a:t>
-            </a:fld>
-            <a:endParaRPr lang="en-US"/>
-          </a:p>
-        </p:txBody>
-      </p:sp>
-    </p:spTree>
-    <p:extLst>
-      <p:ext uri="{BB962C8B-B14F-4D97-AF65-F5344CB8AC3E}">
-        <p14:creationId xmlns:p14="http://schemas.microsoft.com/office/powerpoint/2010/main" val="1024086991"/>
-      </p:ext>
-    </p:extLst>
-  </p:cSld>
-  <p:clrMapOvr>
-    <a:masterClrMapping/>
-  </p:clrMapOvr>
-</p:notes>
-</file>
-
-<file path=ppt/notesSlides/notesSlide17.xml><?xml version="1.0" encoding="utf-8"?>
-<p:notes xmlns:a="http://schemas.openxmlformats.org/drawingml/2006/main" xmlns:r="http://schemas.openxmlformats.org/officeDocument/2006/relationships" xmlns:p="http://schemas.openxmlformats.org/presentationml/2006/main">
-  <p:cSld>
-    <p:spTree>
-      <p:nvGrpSpPr>
-        <p:cNvPr id="1" name=""/>
-        <p:cNvGrpSpPr/>
-        <p:nvPr/>
-      </p:nvGrpSpPr>
-      <p:grpSpPr>
-        <a:xfrm>
-          <a:off x="0" y="0"/>
-          <a:ext cx="0" cy="0"/>
-          <a:chOff x="0" y="0"/>
-          <a:chExt cx="0" cy="0"/>
-        </a:xfrm>
-      </p:grpSpPr>
-      <p:sp>
-        <p:nvSpPr>
-          <p:cNvPr id="2" name="Slide Image Placeholder 1"/>
-          <p:cNvSpPr>
-            <a:spLocks noGrp="1" noRot="1" noChangeAspect="1"/>
-          </p:cNvSpPr>
-          <p:nvPr>
-            <p:ph type="sldImg"/>
-          </p:nvPr>
-        </p:nvSpPr>
-        <p:spPr/>
-      </p:sp>
-      <p:sp>
-        <p:nvSpPr>
-          <p:cNvPr id="3" name="Notes Placeholder 2"/>
-          <p:cNvSpPr>
-            <a:spLocks noGrp="1"/>
-          </p:cNvSpPr>
-          <p:nvPr>
-            <p:ph type="body" idx="1"/>
-          </p:nvPr>
-        </p:nvSpPr>
-        <p:spPr/>
-        <p:txBody>
-          <a:bodyPr/>
-          <a:lstStyle/>
-          <a:p>
-            <a:r>
-              <a:rPr lang="en-US" dirty="0"/>
-              <a:t>Theta-blend only: +0.14 (Ch 1's sign). Head-count only: -0.07 (opposite). Both: +0.02. The two channels pull in opposite directions; Ch 1's sign survives, damped by herding.</a:t>
-            </a:r>
-            <a:endParaRPr lang="en-US" dirty="0"/>
-          </a:p>
-        </p:txBody>
-      </p:sp>
-      <p:sp>
-        <p:nvSpPr>
-          <p:cNvPr id="4" name="Slide Number Placeholder 3"/>
-          <p:cNvSpPr>
-            <a:spLocks noGrp="1"/>
-          </p:cNvSpPr>
-          <p:nvPr>
-            <p:ph type="sldNum" sz="quarter" idx="10"/>
-          </p:nvPr>
-        </p:nvSpPr>
-        <p:spPr/>
-        <p:txBody>
-          <a:bodyPr/>
-          <a:lstStyle/>
-          <a:p>
-            <a:fld id="{F7021451-1387-4CA6-816F-3879F97B5CBC}" type="slidenum">
-              <a:rPr lang="en-US"/>
-              <a:t>17</a:t>
             </a:fld>
             <a:endParaRPr lang="en-US"/>
           </a:p>
@@ -6010,443 +5736,6 @@
             <a:fld id="{F7021451-1387-4CA6-816F-3879F97B5CBC}" type="slidenum">
               <a:rPr b="0" lang="en-US"/>
               <a:t>14</a:t>
-            </a:fld>
-            <a:endParaRPr lang="en-US"/>
-          </a:p>
-        </p:txBody>
-      </p:sp>
-    </p:spTree>
-  </p:cSld>
-  <p:clrMapOvr>
-    <a:masterClrMapping/>
-  </p:clrMapOvr>
-</p:sld>
-</file>
-
-<file path=ppt/slides/slide15.xml><?xml version="1.0" encoding="utf-8"?>
-<p:sld xmlns:a="http://schemas.openxmlformats.org/drawingml/2006/main" xmlns:r="http://schemas.openxmlformats.org/officeDocument/2006/relationships" xmlns:p="http://schemas.openxmlformats.org/presentationml/2006/main">
-  <p:cSld name="Slide 15">
-    <p:spTree>
-      <p:nvGrpSpPr>
-        <p:cNvPr id="1" name=""/>
-        <p:cNvGrpSpPr/>
-        <p:nvPr/>
-      </p:nvGrpSpPr>
-      <p:grpSpPr>
-        <a:xfrm>
-          <a:off x="0" y="0"/>
-          <a:ext cx="0" cy="0"/>
-          <a:chOff x="0" y="0"/>
-          <a:chExt cx="0" cy="0"/>
-        </a:xfrm>
-      </p:grpSpPr>
-      <p:sp>
-        <p:nvSpPr>
-          <p:cNvPr id="2" name="Text 0"/>
-          <p:cNvSpPr/>
-          <p:nvPr>
-            <p:ph idx="100" type="title" hasCustomPrompt="1"/>
-          </p:nvPr>
-        </p:nvSpPr>
-        <p:spPr>
-          <a:xfrm>
-            <a:off x="548640" y="1828800"/>
-            <a:ext cx="8046720" cy="1097280"/>
-          </a:xfrm>
-          <a:prstGeom prst="rect">
-            <a:avLst/>
-          </a:prstGeom>
-          <a:noFill/>
-          <a:ln/>
-        </p:spPr>
-        <p:txBody>
-          <a:bodyPr wrap="square" lIns="0" tIns="0" rIns="0" bIns="0" rtlCol="0" anchor="ctr"/>
-          <a:lstStyle/>
-          <a:p>
-            <a:pPr algn="l" indent="0" marL="0">
-              <a:buNone/>
-            </a:pPr>
-            <a:r>
-              <a:rPr lang="en-US" sz="3200" b="1" dirty="0">
-                <a:solidFill>
-                  <a:schemeClr val="bg1"/>
-                </a:solidFill>
-              </a:rPr>
-              <a:t>Backup</a:t>
-            </a:r>
-            <a:endParaRPr lang="en-US" sz="3200" dirty="0"/>
-          </a:p>
-        </p:txBody>
-      </p:sp>
-      <p:sp>
-        <p:nvSpPr>
-          <p:cNvPr id="3" name="Text 0"/>
-          <p:cNvSpPr/>
-          <p:nvPr>
-            <p:ph idx="101" type="body" hasCustomPrompt="1"/>
-          </p:nvPr>
-        </p:nvSpPr>
-        <p:spPr>
-          <a:xfrm>
-            <a:off x="548640" y="2971800"/>
-            <a:ext cx="8046720" cy="731520"/>
-          </a:xfrm>
-          <a:prstGeom prst="rect">
-            <a:avLst/>
-          </a:prstGeom>
-          <a:noFill/>
-          <a:ln/>
-        </p:spPr>
-        <p:txBody>
-          <a:bodyPr wrap="square" lIns="0" tIns="0" rIns="0" bIns="0" rtlCol="0" anchor="t"/>
-          <a:lstStyle/>
-          <a:p>
-            <a:pPr indent="0" marL="0">
-              <a:buNone/>
-            </a:pPr>
-            <a:r>
-              <a:rPr lang="en-US" sz="1600" dirty="0">
-                <a:solidFill>
-                  <a:schemeClr val="accent4"/>
-                </a:solidFill>
-              </a:rPr>
-              <a:t>Technical versions of the exhibits: who withdraws by type and mix, and which channel carries culture.</a:t>
-            </a:r>
-            <a:endParaRPr lang="en-US" sz="1600" dirty="0"/>
-          </a:p>
-        </p:txBody>
-      </p:sp>
-    </p:spTree>
-  </p:cSld>
-  <p:clrMapOvr>
-    <a:masterClrMapping/>
-  </p:clrMapOvr>
-</p:sld>
-</file>
-
-<file path=ppt/slides/slide16.xml><?xml version="1.0" encoding="utf-8"?>
-<p:sld xmlns:a="http://schemas.openxmlformats.org/drawingml/2006/main" xmlns:r="http://schemas.openxmlformats.org/officeDocument/2006/relationships" xmlns:p="http://schemas.openxmlformats.org/presentationml/2006/main">
-  <p:cSld name="Slide 16">
-    <p:spTree>
-      <p:nvGrpSpPr>
-        <p:cNvPr id="1" name=""/>
-        <p:cNvGrpSpPr/>
-        <p:nvPr/>
-      </p:nvGrpSpPr>
-      <p:grpSpPr>
-        <a:xfrm>
-          <a:off x="0" y="0"/>
-          <a:ext cx="0" cy="0"/>
-          <a:chOff x="0" y="0"/>
-          <a:chExt cx="0" cy="0"/>
-        </a:xfrm>
-      </p:grpSpPr>
-      <p:sp>
-        <p:nvSpPr>
-          <p:cNvPr id="2" name="Text 0"/>
-          <p:cNvSpPr/>
-          <p:nvPr>
-            <p:ph idx="100" type="title" hasCustomPrompt="1"/>
-          </p:nvPr>
-        </p:nvSpPr>
-        <p:spPr>
-          <a:xfrm>
-            <a:off x="457200" y="274320"/>
-            <a:ext cx="8229600" cy="685800"/>
-          </a:xfrm>
-          <a:prstGeom prst="rect">
-            <a:avLst/>
-          </a:prstGeom>
-          <a:noFill/>
-          <a:ln/>
-        </p:spPr>
-        <p:txBody>
-          <a:bodyPr wrap="square" lIns="0" tIns="0" rIns="0" bIns="0" rtlCol="0" anchor="ctr"/>
-          <a:lstStyle/>
-          <a:p>
-            <a:pPr algn="l" indent="0" marL="0">
-              <a:buNone/>
-            </a:pPr>
-            <a:r>
-              <a:rPr lang="en-US" sz="2400" b="1" dirty="0">
-                <a:solidFill>
-                  <a:schemeClr val="tx2"/>
-                </a:solidFill>
-              </a:rPr>
-              <a:t>Who withdraws, by type and mix</a:t>
-            </a:r>
-            <a:endParaRPr lang="en-US" sz="2400" dirty="0"/>
-          </a:p>
-        </p:txBody>
-      </p:sp>
-      <p:pic>
-        <p:nvPicPr>
-          <p:cNvPr id="3" name="e06" descr="Share who withdraw by individualist share, three panels by lambda pair: collectivists above individualists at every mixed share for the two wide gaps.">    </p:cNvPr>
-          <p:cNvPicPr>
-            <a:picLocks noChangeAspect="1"/>
-          </p:cNvPicPr>
-          <p:nvPr/>
-        </p:nvPicPr>
-        <p:blipFill>
-          <a:blip r:embed="rId1"/>
-          <a:stretch>
-            <a:fillRect/>
-          </a:stretch>
-        </p:blipFill>
-        <p:spPr>
-          <a:xfrm>
-            <a:off x="512064" y="1051560"/>
-            <a:ext cx="8119872" cy="3383280"/>
-          </a:xfrm>
-          <a:prstGeom prst="rect">
-            <a:avLst/>
-          </a:prstGeom>
-        </p:spPr>
-      </p:pic>
-      <p:sp>
-        <p:nvSpPr>
-          <p:cNvPr id="4" name="caption"/>
-          <p:cNvSpPr txBox="1"/>
-          <p:nvPr/>
-        </p:nvSpPr>
-        <p:spPr>
-          <a:xfrm>
-            <a:off x="457200" y="4480560"/>
-            <a:ext cx="8229600" cy="274320"/>
-          </a:xfrm>
-          <a:prstGeom prst="rect">
-            <a:avLst/>
-          </a:prstGeom>
-          <a:noFill/>
-          <a:ln/>
-        </p:spPr>
-        <p:txBody>
-          <a:bodyPr wrap="square" lIns="0" tIns="0" rIns="0" bIns="0" rtlCol="0" anchor="ctr"/>
-          <a:lstStyle/>
-          <a:p>
-            <a:pPr indent="0" marL="0">
-              <a:buNone/>
-            </a:pPr>
-            <a:r>
-              <a:rPr lang="en-US" sz="1000" i="1" dirty="0">
-                <a:solidFill>
-                  <a:schemeClr val="accent3"/>
-                </a:solidFill>
-              </a:rPr>
-              <a:t>Share who withdraw by individualist share μ, one panel per λ pair; orange individualists, blue collectivists, with CIs.</a:t>
-            </a:r>
-            <a:endParaRPr lang="en-US" sz="1000" dirty="0"/>
-          </a:p>
-        </p:txBody>
-      </p:sp>
-      <p:sp>
-        <p:nvSpPr>
-          <p:cNvPr id="25" name="Slide Number Placeholder 0"/>
-          <p:cNvSpPr>
-            <a:spLocks noGrp="1"/>
-          </p:cNvSpPr>
-          <p:nvPr>
-            <p:ph type="sldNum" sz="quarter" idx="4294967295"/>
-          </p:nvPr>
-        </p:nvSpPr>
-        <p:spPr>
-          <a:xfrm>
-            <a:off x="8321040" y="4754880"/>
-            <a:ext cx="457200" cy="274320"/>
-          </a:xfrm>
-          <a:prstGeom prst="rect">
-            <a:avLst/>
-          </a:prstGeom>
-          <a:extLst>
-            <a:ext uri="{C572A759-6A51-4108-AA02-DFA0A04FC94B}">
-              <ma14:wrappingTextBoxFlag xmlns:ma14="http://schemas.microsoft.com/office/mac/drawingml/2011/main" val="0"/>
-            </a:ext>
-          </a:extLst>
-        </p:spPr>
-        <p:txBody>
-          <a:bodyPr/>
-          <a:lstStyle>
-            <a:lvl1pPr>
-              <a:defRPr sz="900">
-                <a:solidFill>
-                  <a:srgbClr val="6B7280"/>
-                </a:solidFill>
-              </a:defRPr>
-            </a:lvl1pPr>
-          </a:lstStyle>
-          <a:p>
-            <a:pPr algn="r"/>
-            <a:fld id="{F7021451-1387-4CA6-816F-3879F97B5CBC}" type="slidenum">
-              <a:rPr b="0" lang="en-US"/>
-              <a:t>16</a:t>
-            </a:fld>
-            <a:endParaRPr lang="en-US"/>
-          </a:p>
-        </p:txBody>
-      </p:sp>
-    </p:spTree>
-  </p:cSld>
-  <p:clrMapOvr>
-    <a:masterClrMapping/>
-  </p:clrMapOvr>
-</p:sld>
-</file>
-
-<file path=ppt/slides/slide17.xml><?xml version="1.0" encoding="utf-8"?>
-<p:sld xmlns:a="http://schemas.openxmlformats.org/drawingml/2006/main" xmlns:r="http://schemas.openxmlformats.org/officeDocument/2006/relationships" xmlns:p="http://schemas.openxmlformats.org/presentationml/2006/main">
-  <p:cSld name="Slide 17">
-    <p:spTree>
-      <p:nvGrpSpPr>
-        <p:cNvPr id="1" name=""/>
-        <p:cNvGrpSpPr/>
-        <p:nvPr/>
-      </p:nvGrpSpPr>
-      <p:grpSpPr>
-        <a:xfrm>
-          <a:off x="0" y="0"/>
-          <a:ext cx="0" cy="0"/>
-          <a:chOff x="0" y="0"/>
-          <a:chExt cx="0" cy="0"/>
-        </a:xfrm>
-      </p:grpSpPr>
-      <p:sp>
-        <p:nvSpPr>
-          <p:cNvPr id="2" name="Text 0"/>
-          <p:cNvSpPr/>
-          <p:nvPr>
-            <p:ph idx="100" type="title" hasCustomPrompt="1"/>
-          </p:nvPr>
-        </p:nvSpPr>
-        <p:spPr>
-          <a:xfrm>
-            <a:off x="457200" y="274320"/>
-            <a:ext cx="8229600" cy="685800"/>
-          </a:xfrm>
-          <a:prstGeom prst="rect">
-            <a:avLst/>
-          </a:prstGeom>
-          <a:noFill/>
-          <a:ln/>
-        </p:spPr>
-        <p:txBody>
-          <a:bodyPr wrap="square" lIns="0" tIns="0" rIns="0" bIns="0" rtlCol="0" anchor="ctr"/>
-          <a:lstStyle/>
-          <a:p>
-            <a:pPr algn="l" indent="0" marL="0">
-              <a:buNone/>
-            </a:pPr>
-            <a:r>
-              <a:rPr lang="en-US" sz="2400" b="1" dirty="0">
-                <a:solidFill>
-                  <a:schemeClr val="tx2"/>
-                </a:solidFill>
-              </a:rPr>
-              <a:t>Which channel carries culture</a:t>
-            </a:r>
-            <a:endParaRPr lang="en-US" sz="2400" dirty="0"/>
-          </a:p>
-        </p:txBody>
-      </p:sp>
-      <p:pic>
-        <p:nvPicPr>
-          <p:cNvPr id="3" name="e09" descr="Who runs in failed runs with optimistic news when lambda applies only to the neighbour blend, only to the news blend, or both: positive, negative, small positive.">    </p:cNvPr>
-          <p:cNvPicPr>
-            <a:picLocks noChangeAspect="1"/>
-          </p:cNvPicPr>
-          <p:nvPr/>
-        </p:nvPicPr>
-        <p:blipFill>
-          <a:blip r:embed="rId1"/>
-          <a:stretch>
-            <a:fillRect/>
-          </a:stretch>
-        </p:blipFill>
-        <p:spPr>
-          <a:xfrm>
-            <a:off x="1547348" y="1051560"/>
-            <a:ext cx="6049305" cy="3383280"/>
-          </a:xfrm>
-          <a:prstGeom prst="rect">
-            <a:avLst/>
-          </a:prstGeom>
-        </p:spPr>
-      </p:pic>
-      <p:sp>
-        <p:nvSpPr>
-          <p:cNvPr id="4" name="caption"/>
-          <p:cNvSpPr txBox="1"/>
-          <p:nvPr/>
-        </p:nvSpPr>
-        <p:spPr>
-          <a:xfrm>
-            <a:off x="457200" y="4480560"/>
-            <a:ext cx="8229600" cy="274320"/>
-          </a:xfrm>
-          <a:prstGeom prst="rect">
-            <a:avLst/>
-          </a:prstGeom>
-          <a:noFill/>
-          <a:ln/>
-        </p:spPr>
-        <p:txBody>
-          <a:bodyPr wrap="square" lIns="0" tIns="0" rIns="0" bIns="0" rtlCol="0" anchor="ctr"/>
-          <a:lstStyle/>
-          <a:p>
-            <a:pPr indent="0" marL="0">
-              <a:buNone/>
-            </a:pPr>
-            <a:r>
-              <a:rPr lang="en-US" sz="1000" i="1" dirty="0">
-                <a:solidFill>
-                  <a:schemeClr val="accent3"/>
-                </a:solidFill>
-              </a:rPr>
-              <a:t>D in failed runs with optimistic news, when λ weights only the neighbour blend, only the news blend, or both (the model). θ-blend only +0.14; head-count only −0.07; both +0.02.</a:t>
-            </a:r>
-            <a:endParaRPr lang="en-US" sz="1000" dirty="0"/>
-          </a:p>
-        </p:txBody>
-      </p:sp>
-      <p:sp>
-        <p:nvSpPr>
-          <p:cNvPr id="25" name="Slide Number Placeholder 0"/>
-          <p:cNvSpPr>
-            <a:spLocks noGrp="1"/>
-          </p:cNvSpPr>
-          <p:nvPr>
-            <p:ph type="sldNum" sz="quarter" idx="4294967295"/>
-          </p:nvPr>
-        </p:nvSpPr>
-        <p:spPr>
-          <a:xfrm>
-            <a:off x="8321040" y="4754880"/>
-            <a:ext cx="457200" cy="274320"/>
-          </a:xfrm>
-          <a:prstGeom prst="rect">
-            <a:avLst/>
-          </a:prstGeom>
-          <a:extLst>
-            <a:ext uri="{C572A759-6A51-4108-AA02-DFA0A04FC94B}">
-              <ma14:wrappingTextBoxFlag xmlns:ma14="http://schemas.microsoft.com/office/mac/drawingml/2011/main" val="0"/>
-            </a:ext>
-          </a:extLst>
-        </p:spPr>
-        <p:txBody>
-          <a:bodyPr/>
-          <a:lstStyle>
-            <a:lvl1pPr>
-              <a:defRPr sz="900">
-                <a:solidFill>
-                  <a:srgbClr val="6B7280"/>
-                </a:solidFill>
-              </a:defRPr>
-            </a:lvl1pPr>
-          </a:lstStyle>
-          <a:p>
-            <a:pPr algn="r"/>
-            <a:fld id="{F7021451-1387-4CA6-816F-3879F97B5CBC}" type="slidenum">
-              <a:rPr b="0" lang="en-US"/>
-              <a:t>17</a:t>
             </a:fld>
             <a:endParaRPr lang="en-US"/>
           </a:p>

</xml_diff>

<commit_message>
Deck: ODD overview redrawn from a script (delta for the discount, D and d_i for deposits, 1% cap, Newman-Watts)
Co-Authored-By: Claude Fable 5.1 <noreply@anthropic.com>
</commit_message>
<xml_diff>
--- a/docs/deck_2026-10-26_seminar.pptx
+++ b/docs/deck_2026-10-26_seminar.pptx
@@ -120,7 +120,7 @@
   <p:extLst>
     <p:ext uri="{521415D9-36F7-43E2-AB2F-B90AF26B5E84}">
       <p14:sectionLst xmlns:p14="http://schemas.microsoft.com/office/powerpoint/2010/main">
-        <p14:section name="Opening" id="{55747bc9-fbff-27bd-8aa5-5a4fae069394}">
+        <p14:section name="Opening" id="{396bd14a-a39d-e6f2-f9f5-0628e9fb9461}">
           <p14:sldIdLst>
             <p14:sldId id="256"/>
             <p14:sldId id="257"/>
@@ -130,13 +130,13 @@
             <p14:sldId id="261"/>
           </p14:sldIdLst>
         </p14:section>
-        <p14:section name="The model" id="{9d0c14df-bb4b-d725-5f23-c886e55d2248}">
+        <p14:section name="The model" id="{260780b1-eda7-6696-3496-b5072fee71e6}">
           <p14:sldIdLst>
             <p14:sldId id="262"/>
             <p14:sldId id="263"/>
           </p14:sldIdLst>
         </p14:section>
-        <p14:section name="Results" id="{2d66c5e5-8eab-8a04-4be3-89b73e6948d4}">
+        <p14:section name="Results" id="{3fe9e14b-c449-ebcb-e3cb-ecaf6b6eb562}">
           <p14:sldIdLst>
             <p14:sldId id="264"/>
             <p14:sldId id="265"/>
@@ -144,12 +144,12 @@
             <p14:sldId id="267"/>
           </p14:sldIdLst>
         </p14:section>
-        <p14:section name="Validation" id="{512177da-e3e1-33b4-f7ac-30aa9211fc0b}">
+        <p14:section name="Validation" id="{bd234241-c11c-d2f9-d706-b94b13808ece}">
           <p14:sldIdLst>
             <p14:sldId id="268"/>
           </p14:sldIdLst>
         </p14:section>
-        <p14:section name="Close" id="{c984a01f-8343-fd6a-056e-d8b13e51c458}">
+        <p14:section name="Close" id="{e05ab89a-db4b-2e47-913e-ccc4b4be4d1a}">
           <p14:sldIdLst>
             <p14:sldId id="269"/>
           </p14:sldIdLst>
@@ -7846,7 +7846,7 @@
         <p:spPr>
           <a:xfrm>
             <a:off x="457200" y="1051560"/>
-            <a:ext cx="3467633" cy="3520440"/>
+            <a:ext cx="3495797" cy="3520440"/>
           </a:xfrm>
           <a:prstGeom prst="rect">
             <a:avLst/>
@@ -7861,8 +7861,8 @@
         </p:nvSpPr>
         <p:spPr>
           <a:xfrm>
-            <a:off x="4244873" y="1051560"/>
-            <a:ext cx="2152383" cy="960120"/>
+            <a:off x="4273037" y="1051560"/>
+            <a:ext cx="2138302" cy="960120"/>
           </a:xfrm>
           <a:prstGeom prst="roundRect">
             <a:avLst>
@@ -7888,8 +7888,8 @@
         </p:nvSpPr>
         <p:spPr>
           <a:xfrm>
-            <a:off x="4382033" y="1124712"/>
-            <a:ext cx="1878063" cy="457200"/>
+            <a:off x="4410197" y="1124712"/>
+            <a:ext cx="1863982" cy="457200"/>
           </a:xfrm>
           <a:prstGeom prst="rect">
             <a:avLst/>
@@ -7927,8 +7927,8 @@
         </p:nvSpPr>
         <p:spPr>
           <a:xfrm>
-            <a:off x="4382033" y="1600200"/>
-            <a:ext cx="1878063" cy="356616"/>
+            <a:off x="4410197" y="1600200"/>
+            <a:ext cx="1863982" cy="356616"/>
           </a:xfrm>
           <a:prstGeom prst="rect">
             <a:avLst/>
@@ -7963,8 +7963,8 @@
         </p:nvSpPr>
         <p:spPr>
           <a:xfrm>
-            <a:off x="6534417" y="1051560"/>
-            <a:ext cx="2152383" cy="960120"/>
+            <a:off x="6548498" y="1051560"/>
+            <a:ext cx="2138302" cy="960120"/>
           </a:xfrm>
           <a:prstGeom prst="roundRect">
             <a:avLst>
@@ -7990,8 +7990,8 @@
         </p:nvSpPr>
         <p:spPr>
           <a:xfrm>
-            <a:off x="6671577" y="1124712"/>
-            <a:ext cx="1878063" cy="457200"/>
+            <a:off x="6685658" y="1124712"/>
+            <a:ext cx="1863982" cy="457200"/>
           </a:xfrm>
           <a:prstGeom prst="rect">
             <a:avLst/>
@@ -8029,8 +8029,8 @@
         </p:nvSpPr>
         <p:spPr>
           <a:xfrm>
-            <a:off x="6671577" y="1600200"/>
-            <a:ext cx="1878063" cy="356616"/>
+            <a:off x="6685658" y="1600200"/>
+            <a:ext cx="1863982" cy="356616"/>
           </a:xfrm>
           <a:prstGeom prst="rect">
             <a:avLst/>
@@ -8065,8 +8065,8 @@
         </p:nvSpPr>
         <p:spPr>
           <a:xfrm>
-            <a:off x="4244873" y="2148840"/>
-            <a:ext cx="2152383" cy="960120"/>
+            <a:off x="4273037" y="2148840"/>
+            <a:ext cx="2138302" cy="960120"/>
           </a:xfrm>
           <a:prstGeom prst="roundRect">
             <a:avLst>
@@ -8092,8 +8092,8 @@
         </p:nvSpPr>
         <p:spPr>
           <a:xfrm>
-            <a:off x="4382033" y="2221992"/>
-            <a:ext cx="1878063" cy="457200"/>
+            <a:off x="4410197" y="2221992"/>
+            <a:ext cx="1863982" cy="457200"/>
           </a:xfrm>
           <a:prstGeom prst="rect">
             <a:avLst/>
@@ -8131,8 +8131,8 @@
         </p:nvSpPr>
         <p:spPr>
           <a:xfrm>
-            <a:off x="4382033" y="2697480"/>
-            <a:ext cx="1878063" cy="356616"/>
+            <a:off x="4410197" y="2697480"/>
+            <a:ext cx="1863982" cy="356616"/>
           </a:xfrm>
           <a:prstGeom prst="rect">
             <a:avLst/>
@@ -8167,8 +8167,8 @@
         </p:nvSpPr>
         <p:spPr>
           <a:xfrm>
-            <a:off x="6534417" y="2148840"/>
-            <a:ext cx="2152383" cy="960120"/>
+            <a:off x="6548498" y="2148840"/>
+            <a:ext cx="2138302" cy="960120"/>
           </a:xfrm>
           <a:prstGeom prst="roundRect">
             <a:avLst>
@@ -8194,8 +8194,8 @@
         </p:nvSpPr>
         <p:spPr>
           <a:xfrm>
-            <a:off x="6671577" y="2221992"/>
-            <a:ext cx="1878063" cy="457200"/>
+            <a:off x="6685658" y="2221992"/>
+            <a:ext cx="1863982" cy="457200"/>
           </a:xfrm>
           <a:prstGeom prst="rect">
             <a:avLst/>
@@ -8233,8 +8233,8 @@
         </p:nvSpPr>
         <p:spPr>
           <a:xfrm>
-            <a:off x="6671577" y="2697480"/>
-            <a:ext cx="1878063" cy="356616"/>
+            <a:off x="6685658" y="2697480"/>
+            <a:ext cx="1863982" cy="356616"/>
           </a:xfrm>
           <a:prstGeom prst="rect">
             <a:avLst/>
@@ -8269,8 +8269,8 @@
         </p:nvSpPr>
         <p:spPr>
           <a:xfrm>
-            <a:off x="4244873" y="3200400"/>
-            <a:ext cx="4441927" cy="1371600"/>
+            <a:off x="4273037" y="3200400"/>
+            <a:ext cx="4413763" cy="1371600"/>
           </a:xfrm>
           <a:prstGeom prst="rect">
             <a:avLst/>

</xml_diff>

<commit_message>
Deck: slide 7 is the ODD diagram alone, redrawn landscape with larger type; stat cards and bullets dropped
Co-Authored-By: Claude Fable 5.1 <noreply@anthropic.com>
</commit_message>
<xml_diff>
--- a/docs/deck_2026-10-26_seminar.pptx
+++ b/docs/deck_2026-10-26_seminar.pptx
@@ -120,7 +120,7 @@
   <p:extLst>
     <p:ext uri="{521415D9-36F7-43E2-AB2F-B90AF26B5E84}">
       <p14:sectionLst xmlns:p14="http://schemas.microsoft.com/office/powerpoint/2010/main">
-        <p14:section name="Opening" id="{396bd14a-a39d-e6f2-f9f5-0628e9fb9461}">
+        <p14:section name="Opening" id="{1f7eaf38-7217-63af-858d-04223ebb9ab6}">
           <p14:sldIdLst>
             <p14:sldId id="256"/>
             <p14:sldId id="257"/>
@@ -130,13 +130,13 @@
             <p14:sldId id="261"/>
           </p14:sldIdLst>
         </p14:section>
-        <p14:section name="The model" id="{260780b1-eda7-6696-3496-b5072fee71e6}">
+        <p14:section name="The model" id="{07e11f8b-ebfc-e6b7-cc2f-af456474f78b}">
           <p14:sldIdLst>
             <p14:sldId id="262"/>
             <p14:sldId id="263"/>
           </p14:sldIdLst>
         </p14:section>
-        <p14:section name="Results" id="{3fe9e14b-c449-ebcb-e3cb-ecaf6b6eb562}">
+        <p14:section name="Results" id="{3dcd6eb8-4a11-1cb3-fb35-50729516d630}">
           <p14:sldIdLst>
             <p14:sldId id="264"/>
             <p14:sldId id="265"/>
@@ -144,12 +144,12 @@
             <p14:sldId id="267"/>
           </p14:sldIdLst>
         </p14:section>
-        <p14:section name="Validation" id="{bd234241-c11c-d2f9-d706-b94b13808ece}">
+        <p14:section name="Validation" id="{3d995789-02a4-a703-7336-379116b19253}">
           <p14:sldIdLst>
             <p14:sldId id="268"/>
           </p14:sldIdLst>
         </p14:section>
-        <p14:section name="Close" id="{e05ab89a-db4b-2e47-913e-ccc4b4be4d1a}">
+        <p14:section name="Close" id="{58a945bc-9831-3746-1dc1-5d7114cef8ee}">
           <p14:sldIdLst>
             <p14:sldId id="269"/>
           </p14:sldIdLst>
@@ -1526,7 +1526,7 @@
           <a:p>
             <a:r>
               <a:rPr lang="en-US" dirty="0"/>
-              <a:t>~2 min. N = 1,000 depositors on a small-world network; one bank that sells assets at a discount when cash runs short (fire-sale bank). Each tick a depositor sees neighbours' withdrawals and the public news, blends them with a private signal, and withdraws if that pays. Reference bank: deposits log-normal (sigma 2.5), each capped at 1% of the total; CARA 0.1; partial withdrawals allowed. The diagram is the technical ODD overview: walk the right-hand column (warm-up, world, shock, tick loop) and skip the formulas.</a:t>
+              <a:t>~2 min. Talk through the diagram. Left: N = 1,000 depositors, deposits log-normal (sigma 2.5) capped at 1% of the total (Celsius's largest account); types I and C from the warm-up; a Newman-Watts network; the fire-sale bank (reserves rD in cash, the rest plus equity in a long asset sold at a 60% haircut if cash runs short; it fails at period 2 if cash plus the asset at R(theta) is below its promises); theta uniform per run and a public signal that is absent, accurate or stale. Middle and right: warm-up, draw the world, shock, then the tick loop: observe neighbours and the news, blend each with your own information using lambda, value staying against withdrawing (a fraction, partial withdrawals allowed) by Monte Carlo, act. 25 initialisations x 10 draws per cell. Outcomes: D = individualists' minus collectivists' withdrawal share among those not hit by the shock; P(fail) = share of runs that fail. Risk aversion is in the model (CARA) but not on the slide.</a:t>
             </a:r>
             <a:endParaRPr lang="en-US" dirty="0"/>
           </a:p>
@@ -7831,7 +7831,7 @@
       </p:sp>
       <p:pic>
         <p:nvPicPr>
-          <p:cNvPr id="3" name="odd" descr="Model overview: depositors on a social network with a bank; each run draws fundamentals and signals, a shock hits, then depositors observe neighbours and news, form beliefs, and decide whether to withdraw, tick by tick.">    </p:cNvPr>
+          <p:cNvPr id="3" name="odd" descr="Model overview in three columns. Entities: depositors with log-normal deposits capped at 1% of the total, a type and a private signal; a Newman–Watts network; a bank with reserves, a long asset that sells at a discount when cash runs short, and a return that rises with the fundamental; the environment draws the fundamental and a public signal. Schedule: cultural warm-up, draw the run’s world, an exogenous shock, then a tick loop in which each banked depositor observes neighbours and the public signal, forms beliefs with weight λ on the social side, values staying against withdrawing by Monte Carlo, and acts; then period 2 settles the bank and the run is recorded.">    </p:cNvPr>
           <p:cNvPicPr>
             <a:picLocks noChangeAspect="1"/>
           </p:cNvPicPr>
@@ -7845,516 +7845,14 @@
         </p:blipFill>
         <p:spPr>
           <a:xfrm>
-            <a:off x="457200" y="1051560"/>
-            <a:ext cx="3495797" cy="3520440"/>
+            <a:off x="755294" y="960120"/>
+            <a:ext cx="7633411" cy="3657600"/>
           </a:xfrm>
           <a:prstGeom prst="rect">
             <a:avLst/>
           </a:prstGeom>
         </p:spPr>
       </p:pic>
-      <p:sp>
-        <p:nvSpPr>
-          <p:cNvPr id="4" name="stat-depositors on a smal"/>
-          <p:cNvSpPr/>
-          <p:nvPr/>
-        </p:nvSpPr>
-        <p:spPr>
-          <a:xfrm>
-            <a:off x="4273037" y="1051560"/>
-            <a:ext cx="2138302" cy="960120"/>
-          </a:xfrm>
-          <a:prstGeom prst="roundRect">
-            <a:avLst>
-              <a:gd name="adj" fmla="val 7619"/>
-            </a:avLst>
-          </a:prstGeom>
-          <a:solidFill>
-            <a:schemeClr val="bg2"/>
-          </a:solidFill>
-          <a:ln w="12700">
-            <a:solidFill>
-              <a:schemeClr val="bg2"/>
-            </a:solidFill>
-            <a:prstDash val="solid"/>
-          </a:ln>
-        </p:spPr>
-      </p:sp>
-      <p:sp>
-        <p:nvSpPr>
-          <p:cNvPr id="5" name="stat-big"/>
-          <p:cNvSpPr txBox="1"/>
-          <p:nvPr/>
-        </p:nvSpPr>
-        <p:spPr>
-          <a:xfrm>
-            <a:off x="4410197" y="1124712"/>
-            <a:ext cx="1863982" cy="457200"/>
-          </a:xfrm>
-          <a:prstGeom prst="rect">
-            <a:avLst/>
-          </a:prstGeom>
-          <a:noFill/>
-          <a:ln/>
-        </p:spPr>
-        <p:txBody>
-          <a:bodyPr wrap="square" lIns="0" tIns="0" rIns="0" bIns="0" rtlCol="0" anchor="ctr"/>
-          <a:lstStyle/>
-          <a:p>
-            <a:pPr indent="0" marL="0">
-              <a:buNone/>
-            </a:pPr>
-            <a:r>
-              <a:rPr lang="en-US" sz="2600" b="1" dirty="0">
-                <a:solidFill>
-                  <a:schemeClr val="accent1"/>
-                </a:solidFill>
-                <a:latin typeface="Cambria" pitchFamily="34" charset="0"/>
-                <a:ea typeface="Cambria" pitchFamily="34" charset="-122"/>
-                <a:cs typeface="Cambria" pitchFamily="34" charset="-120"/>
-              </a:rPr>
-              <a:t>1,000</a:t>
-            </a:r>
-            <a:endParaRPr lang="en-US" sz="2600" dirty="0"/>
-          </a:p>
-        </p:txBody>
-      </p:sp>
-      <p:sp>
-        <p:nvSpPr>
-          <p:cNvPr id="6" name="stat-label"/>
-          <p:cNvSpPr txBox="1"/>
-          <p:nvPr/>
-        </p:nvSpPr>
-        <p:spPr>
-          <a:xfrm>
-            <a:off x="4410197" y="1600200"/>
-            <a:ext cx="1863982" cy="356616"/>
-          </a:xfrm>
-          <a:prstGeom prst="rect">
-            <a:avLst/>
-          </a:prstGeom>
-          <a:noFill/>
-          <a:ln/>
-        </p:spPr>
-        <p:txBody>
-          <a:bodyPr wrap="square" lIns="0" tIns="0" rIns="0" bIns="0" rtlCol="0" anchor="t"/>
-          <a:lstStyle/>
-          <a:p>
-            <a:pPr indent="0" marL="0">
-              <a:buNone/>
-            </a:pPr>
-            <a:r>
-              <a:rPr lang="en-US" sz="1100" dirty="0">
-                <a:solidFill>
-                  <a:schemeClr val="accent3"/>
-                </a:solidFill>
-              </a:rPr>
-              <a:t>depositors on a small-world network, one bank</a:t>
-            </a:r>
-            <a:endParaRPr lang="en-US" sz="1100" dirty="0"/>
-          </a:p>
-        </p:txBody>
-      </p:sp>
-      <p:sp>
-        <p:nvSpPr>
-          <p:cNvPr id="7" name="stat-cap on any one depos"/>
-          <p:cNvSpPr/>
-          <p:nvPr/>
-        </p:nvSpPr>
-        <p:spPr>
-          <a:xfrm>
-            <a:off x="6548498" y="1051560"/>
-            <a:ext cx="2138302" cy="960120"/>
-          </a:xfrm>
-          <a:prstGeom prst="roundRect">
-            <a:avLst>
-              <a:gd name="adj" fmla="val 7619"/>
-            </a:avLst>
-          </a:prstGeom>
-          <a:solidFill>
-            <a:schemeClr val="bg2"/>
-          </a:solidFill>
-          <a:ln w="12700">
-            <a:solidFill>
-              <a:schemeClr val="bg2"/>
-            </a:solidFill>
-            <a:prstDash val="solid"/>
-          </a:ln>
-        </p:spPr>
-      </p:sp>
-      <p:sp>
-        <p:nvSpPr>
-          <p:cNvPr id="8" name="stat-big"/>
-          <p:cNvSpPr txBox="1"/>
-          <p:nvPr/>
-        </p:nvSpPr>
-        <p:spPr>
-          <a:xfrm>
-            <a:off x="6685658" y="1124712"/>
-            <a:ext cx="1863982" cy="457200"/>
-          </a:xfrm>
-          <a:prstGeom prst="rect">
-            <a:avLst/>
-          </a:prstGeom>
-          <a:noFill/>
-          <a:ln/>
-        </p:spPr>
-        <p:txBody>
-          <a:bodyPr wrap="square" lIns="0" tIns="0" rIns="0" bIns="0" rtlCol="0" anchor="ctr"/>
-          <a:lstStyle/>
-          <a:p>
-            <a:pPr indent="0" marL="0">
-              <a:buNone/>
-            </a:pPr>
-            <a:r>
-              <a:rPr lang="en-US" sz="2600" b="1" dirty="0">
-                <a:solidFill>
-                  <a:schemeClr val="accent1"/>
-                </a:solidFill>
-                <a:latin typeface="Cambria" pitchFamily="34" charset="0"/>
-                <a:ea typeface="Cambria" pitchFamily="34" charset="-122"/>
-                <a:cs typeface="Cambria" pitchFamily="34" charset="-120"/>
-              </a:rPr>
-              <a:t>1%</a:t>
-            </a:r>
-            <a:endParaRPr lang="en-US" sz="2600" dirty="0"/>
-          </a:p>
-        </p:txBody>
-      </p:sp>
-      <p:sp>
-        <p:nvSpPr>
-          <p:cNvPr id="9" name="stat-label"/>
-          <p:cNvSpPr txBox="1"/>
-          <p:nvPr/>
-        </p:nvSpPr>
-        <p:spPr>
-          <a:xfrm>
-            <a:off x="6685658" y="1600200"/>
-            <a:ext cx="1863982" cy="356616"/>
-          </a:xfrm>
-          <a:prstGeom prst="rect">
-            <a:avLst/>
-          </a:prstGeom>
-          <a:noFill/>
-          <a:ln/>
-        </p:spPr>
-        <p:txBody>
-          <a:bodyPr wrap="square" lIns="0" tIns="0" rIns="0" bIns="0" rtlCol="0" anchor="t"/>
-          <a:lstStyle/>
-          <a:p>
-            <a:pPr indent="0" marL="0">
-              <a:buNone/>
-            </a:pPr>
-            <a:r>
-              <a:rPr lang="en-US" sz="1100" dirty="0">
-                <a:solidFill>
-                  <a:schemeClr val="accent3"/>
-                </a:solidFill>
-              </a:rPr>
-              <a:t>cap on any one deposit; sizes log-normal (σ 2.5) below it</a:t>
-            </a:r>
-            <a:endParaRPr lang="en-US" sz="1100" dirty="0"/>
-          </a:p>
-        </p:txBody>
-      </p:sp>
-      <p:sp>
-        <p:nvSpPr>
-          <p:cNvPr id="10" name="stat-risk aversion; parti"/>
-          <p:cNvSpPr/>
-          <p:nvPr/>
-        </p:nvSpPr>
-        <p:spPr>
-          <a:xfrm>
-            <a:off x="4273037" y="2148840"/>
-            <a:ext cx="2138302" cy="960120"/>
-          </a:xfrm>
-          <a:prstGeom prst="roundRect">
-            <a:avLst>
-              <a:gd name="adj" fmla="val 7619"/>
-            </a:avLst>
-          </a:prstGeom>
-          <a:solidFill>
-            <a:schemeClr val="bg2"/>
-          </a:solidFill>
-          <a:ln w="12700">
-            <a:solidFill>
-              <a:schemeClr val="bg2"/>
-            </a:solidFill>
-            <a:prstDash val="solid"/>
-          </a:ln>
-        </p:spPr>
-      </p:sp>
-      <p:sp>
-        <p:nvSpPr>
-          <p:cNvPr id="11" name="stat-big"/>
-          <p:cNvSpPr txBox="1"/>
-          <p:nvPr/>
-        </p:nvSpPr>
-        <p:spPr>
-          <a:xfrm>
-            <a:off x="4410197" y="2221992"/>
-            <a:ext cx="1863982" cy="457200"/>
-          </a:xfrm>
-          <a:prstGeom prst="rect">
-            <a:avLst/>
-          </a:prstGeom>
-          <a:noFill/>
-          <a:ln/>
-        </p:spPr>
-        <p:txBody>
-          <a:bodyPr wrap="square" lIns="0" tIns="0" rIns="0" bIns="0" rtlCol="0" anchor="ctr"/>
-          <a:lstStyle/>
-          <a:p>
-            <a:pPr indent="0" marL="0">
-              <a:buNone/>
-            </a:pPr>
-            <a:r>
-              <a:rPr lang="en-US" sz="2200" b="1" dirty="0">
-                <a:solidFill>
-                  <a:schemeClr val="accent1"/>
-                </a:solidFill>
-                <a:latin typeface="Cambria" pitchFamily="34" charset="0"/>
-                <a:ea typeface="Cambria" pitchFamily="34" charset="-122"/>
-                <a:cs typeface="Cambria" pitchFamily="34" charset="-120"/>
-              </a:rPr>
-              <a:t>CARA 0.1</a:t>
-            </a:r>
-            <a:endParaRPr lang="en-US" sz="2200" dirty="0"/>
-          </a:p>
-        </p:txBody>
-      </p:sp>
-      <p:sp>
-        <p:nvSpPr>
-          <p:cNvPr id="12" name="stat-label"/>
-          <p:cNvSpPr txBox="1"/>
-          <p:nvPr/>
-        </p:nvSpPr>
-        <p:spPr>
-          <a:xfrm>
-            <a:off x="4410197" y="2697480"/>
-            <a:ext cx="1863982" cy="356616"/>
-          </a:xfrm>
-          <a:prstGeom prst="rect">
-            <a:avLst/>
-          </a:prstGeom>
-          <a:noFill/>
-          <a:ln/>
-        </p:spPr>
-        <p:txBody>
-          <a:bodyPr wrap="square" lIns="0" tIns="0" rIns="0" bIns="0" rtlCol="0" anchor="t"/>
-          <a:lstStyle/>
-          <a:p>
-            <a:pPr indent="0" marL="0">
-              <a:buNone/>
-            </a:pPr>
-            <a:r>
-              <a:rPr lang="en-US" sz="1100" dirty="0">
-                <a:solidFill>
-                  <a:schemeClr val="accent3"/>
-                </a:solidFill>
-              </a:rPr>
-              <a:t>risk aversion; partial withdrawals allowed</a:t>
-            </a:r>
-            <a:endParaRPr lang="en-US" sz="1100" dirty="0"/>
-          </a:p>
-        </p:txBody>
-      </p:sp>
-      <p:sp>
-        <p:nvSpPr>
-          <p:cNvPr id="13" name="stat-runs per cell: 25 in"/>
-          <p:cNvSpPr/>
-          <p:nvPr/>
-        </p:nvSpPr>
-        <p:spPr>
-          <a:xfrm>
-            <a:off x="6548498" y="2148840"/>
-            <a:ext cx="2138302" cy="960120"/>
-          </a:xfrm>
-          <a:prstGeom prst="roundRect">
-            <a:avLst>
-              <a:gd name="adj" fmla="val 7619"/>
-            </a:avLst>
-          </a:prstGeom>
-          <a:solidFill>
-            <a:schemeClr val="bg2"/>
-          </a:solidFill>
-          <a:ln w="12700">
-            <a:solidFill>
-              <a:schemeClr val="bg2"/>
-            </a:solidFill>
-            <a:prstDash val="solid"/>
-          </a:ln>
-        </p:spPr>
-      </p:sp>
-      <p:sp>
-        <p:nvSpPr>
-          <p:cNvPr id="14" name="stat-big"/>
-          <p:cNvSpPr txBox="1"/>
-          <p:nvPr/>
-        </p:nvSpPr>
-        <p:spPr>
-          <a:xfrm>
-            <a:off x="6685658" y="2221992"/>
-            <a:ext cx="1863982" cy="457200"/>
-          </a:xfrm>
-          <a:prstGeom prst="rect">
-            <a:avLst/>
-          </a:prstGeom>
-          <a:noFill/>
-          <a:ln/>
-        </p:spPr>
-        <p:txBody>
-          <a:bodyPr wrap="square" lIns="0" tIns="0" rIns="0" bIns="0" rtlCol="0" anchor="ctr"/>
-          <a:lstStyle/>
-          <a:p>
-            <a:pPr indent="0" marL="0">
-              <a:buNone/>
-            </a:pPr>
-            <a:r>
-              <a:rPr lang="en-US" sz="2600" b="1" dirty="0">
-                <a:solidFill>
-                  <a:schemeClr val="accent1"/>
-                </a:solidFill>
-                <a:latin typeface="Cambria" pitchFamily="34" charset="0"/>
-                <a:ea typeface="Cambria" pitchFamily="34" charset="-122"/>
-                <a:cs typeface="Cambria" pitchFamily="34" charset="-120"/>
-              </a:rPr>
-              <a:t>250</a:t>
-            </a:r>
-            <a:endParaRPr lang="en-US" sz="2600" dirty="0"/>
-          </a:p>
-        </p:txBody>
-      </p:sp>
-      <p:sp>
-        <p:nvSpPr>
-          <p:cNvPr id="15" name="stat-label"/>
-          <p:cNvSpPr txBox="1"/>
-          <p:nvPr/>
-        </p:nvSpPr>
-        <p:spPr>
-          <a:xfrm>
-            <a:off x="6685658" y="2697480"/>
-            <a:ext cx="1863982" cy="356616"/>
-          </a:xfrm>
-          <a:prstGeom prst="rect">
-            <a:avLst/>
-          </a:prstGeom>
-          <a:noFill/>
-          <a:ln/>
-        </p:spPr>
-        <p:txBody>
-          <a:bodyPr wrap="square" lIns="0" tIns="0" rIns="0" bIns="0" rtlCol="0" anchor="t"/>
-          <a:lstStyle/>
-          <a:p>
-            <a:pPr indent="0" marL="0">
-              <a:buNone/>
-            </a:pPr>
-            <a:r>
-              <a:rPr lang="en-US" sz="1100" dirty="0">
-                <a:solidFill>
-                  <a:schemeClr val="accent3"/>
-                </a:solidFill>
-              </a:rPr>
-              <a:t>runs per cell: 25 initialisations × 10 draws</a:t>
-            </a:r>
-            <a:endParaRPr lang="en-US" sz="1100" dirty="0"/>
-          </a:p>
-        </p:txBody>
-      </p:sp>
-      <p:sp>
-        <p:nvSpPr>
-          <p:cNvPr id="16" name="bullets"/>
-          <p:cNvSpPr txBox="1"/>
-          <p:nvPr/>
-        </p:nvSpPr>
-        <p:spPr>
-          <a:xfrm>
-            <a:off x="4273037" y="3200400"/>
-            <a:ext cx="4413763" cy="1371600"/>
-          </a:xfrm>
-          <a:prstGeom prst="rect">
-            <a:avLst/>
-          </a:prstGeom>
-          <a:noFill/>
-          <a:ln/>
-        </p:spPr>
-        <p:txBody>
-          <a:bodyPr wrap="square" lIns="0" tIns="0" rIns="0" bIns="0" rtlCol="0" anchor="t"/>
-          <a:lstStyle/>
-          <a:p>
-            <a:pPr marL="177800" indent="-177800">
-              <a:spcAft>
-                <a:spcPts val="400"/>
-              </a:spcAft>
-              <a:buSzPct val="100000"/>
-              <a:buChar char="•"/>
-            </a:pPr>
-            <a:r>
-              <a:rPr lang="en-US" sz="1150" dirty="0">
-                <a:solidFill>
-                  <a:schemeClr val="tx1"/>
-                </a:solidFill>
-              </a:rPr>
-              <a:t>One bank that sells its long asset at a discount when cash runs short (a fire-sale bank)</a:t>
-            </a:r>
-            <a:endParaRPr lang="en-US" sz="1150" dirty="0"/>
-          </a:p>
-          <a:p>
-            <a:pPr marL="177800" indent="-177800">
-              <a:spcAft>
-                <a:spcPts val="400"/>
-              </a:spcAft>
-              <a:buSzPct val="100000"/>
-              <a:buChar char="•"/>
-            </a:pPr>
-            <a:r>
-              <a:rPr lang="en-US" sz="1150" dirty="0">
-                <a:solidFill>
-                  <a:schemeClr val="tx1"/>
-                </a:solidFill>
-              </a:rPr>
-              <a:t>Each tick a depositor sees neighbours’ withdrawals and the public news, blends them with a private signal, and withdraws if that pays</a:t>
-            </a:r>
-            <a:endParaRPr lang="en-US" sz="1150" dirty="0"/>
-          </a:p>
-          <a:p>
-            <a:pPr marL="177800" indent="-177800">
-              <a:spcAft>
-                <a:spcPts val="400"/>
-              </a:spcAft>
-              <a:buSzPct val="100000"/>
-              <a:buChar char="•"/>
-            </a:pPr>
-            <a:r>
-              <a:rPr lang="en-US" sz="1150" dirty="0">
-                <a:solidFill>
-                  <a:schemeClr val="tx1"/>
-                </a:solidFill>
-              </a:rPr>
-              <a:t>A public signal can be absent, accurate, or outdated</a:t>
-            </a:r>
-            <a:endParaRPr lang="en-US" sz="1150" dirty="0"/>
-          </a:p>
-          <a:p>
-            <a:pPr marL="177800" indent="-177800">
-              <a:spcAft>
-                <a:spcPts val="400"/>
-              </a:spcAft>
-              <a:buSzPct val="100000"/>
-              <a:buChar char="•"/>
-            </a:pPr>
-            <a:r>
-              <a:rPr lang="en-US" sz="1150" dirty="0">
-                <a:solidFill>
-                  <a:schemeClr val="tx1"/>
-                </a:solidFill>
-              </a:rPr>
-              <a:t>Outcomes: D = individualists’ minus collectivists’ withdrawal share (those not hit by the shock); P(fail) = share of runs that fail</a:t>
-            </a:r>
-            <a:endParaRPr lang="en-US" sz="1150" dirty="0"/>
-          </a:p>
-        </p:txBody>
-      </p:sp>
       <p:sp>
         <p:nvSpPr>
           <p:cNvPr id="25" name="Slide Number Placeholder 0"/>

</xml_diff>

<commit_message>
Deck: capping slide is the figure alone
Co-Authored-By: Claude Fable 5.1 <noreply@anthropic.com>
</commit_message>
<xml_diff>
--- a/docs/deck_2026-10-26_seminar.pptx
+++ b/docs/deck_2026-10-26_seminar.pptx
@@ -120,7 +120,7 @@
   <p:extLst>
     <p:ext uri="{521415D9-36F7-43E2-AB2F-B90AF26B5E84}">
       <p14:sectionLst xmlns:p14="http://schemas.microsoft.com/office/powerpoint/2010/main">
-        <p14:section name="Opening" id="{1f7eaf38-7217-63af-858d-04223ebb9ab6}">
+        <p14:section name="Opening" id="{94242ec3-5a4e-0bfd-3107-9536b985bfbc}">
           <p14:sldIdLst>
             <p14:sldId id="256"/>
             <p14:sldId id="257"/>
@@ -130,13 +130,13 @@
             <p14:sldId id="261"/>
           </p14:sldIdLst>
         </p14:section>
-        <p14:section name="The model" id="{07e11f8b-ebfc-e6b7-cc2f-af456474f78b}">
+        <p14:section name="The model" id="{668a035d-92bc-cde4-60fa-8794ddf3d63f}">
           <p14:sldIdLst>
             <p14:sldId id="262"/>
             <p14:sldId id="263"/>
           </p14:sldIdLst>
         </p14:section>
-        <p14:section name="Results" id="{3dcd6eb8-4a11-1cb3-fb35-50729516d630}">
+        <p14:section name="Results" id="{66109033-2af5-4de4-7573-55bbf8b23061}">
           <p14:sldIdLst>
             <p14:sldId id="264"/>
             <p14:sldId id="265"/>
@@ -144,12 +144,12 @@
             <p14:sldId id="267"/>
           </p14:sldIdLst>
         </p14:section>
-        <p14:section name="Validation" id="{3d995789-02a4-a703-7336-379116b19253}">
+        <p14:section name="Validation" id="{2163cee4-4da1-3543-2a88-0a2c5bac8ebd}">
           <p14:sldIdLst>
             <p14:sldId id="268"/>
           </p14:sldIdLst>
         </p14:section>
-        <p14:section name="Close" id="{58a945bc-9831-3746-1dc1-5d7114cef8ee}">
+        <p14:section name="Close" id="{9eaa7b34-87ce-a7a6-6bca-c3e988ac2b06}">
           <p14:sldIdLst>
             <p14:sldId id="269"/>
           </p14:sldIdLst>
@@ -3690,8 +3690,8 @@
         </p:blipFill>
         <p:spPr>
           <a:xfrm>
-            <a:off x="457200" y="1051560"/>
-            <a:ext cx="4941052" cy="3291840"/>
+            <a:off x="1998536" y="1005840"/>
+            <a:ext cx="5146929" cy="3429000"/>
           </a:xfrm>
           <a:prstGeom prst="rect">
             <a:avLst/>
@@ -3706,8 +3706,8 @@
         </p:nvSpPr>
         <p:spPr>
           <a:xfrm>
-            <a:off x="457200" y="4389120"/>
-            <a:ext cx="5486400" cy="274320"/>
+            <a:off x="1998536" y="4480560"/>
+            <a:ext cx="5146929" cy="274320"/>
           </a:xfrm>
           <a:prstGeom prst="rect">
             <a:avLst/>
@@ -3731,312 +3731,6 @@
               <a:t>Chance the bank fails by share of individualists, for three deposit-size distributions. λ pairs pooled.</a:t>
             </a:r>
             <a:endParaRPr lang="en-US" sz="1000" dirty="0"/>
-          </a:p>
-        </p:txBody>
-      </p:sp>
-      <p:sp>
-        <p:nvSpPr>
-          <p:cNvPr id="5" name="stat-uncapped: a few very"/>
-          <p:cNvSpPr/>
-          <p:nvPr/>
-        </p:nvSpPr>
-        <p:spPr>
-          <a:xfrm>
-            <a:off x="6217920" y="1051560"/>
-            <a:ext cx="2468880" cy="1005840"/>
-          </a:xfrm>
-          <a:prstGeom prst="roundRect">
-            <a:avLst>
-              <a:gd name="adj" fmla="val 7273"/>
-            </a:avLst>
-          </a:prstGeom>
-          <a:solidFill>
-            <a:schemeClr val="bg2"/>
-          </a:solidFill>
-          <a:ln w="12700">
-            <a:solidFill>
-              <a:schemeClr val="bg2"/>
-            </a:solidFill>
-            <a:prstDash val="solid"/>
-          </a:ln>
-        </p:spPr>
-      </p:sp>
-      <p:sp>
-        <p:nvSpPr>
-          <p:cNvPr id="6" name="stat-big"/>
-          <p:cNvSpPr txBox="1"/>
-          <p:nvPr/>
-        </p:nvSpPr>
-        <p:spPr>
-          <a:xfrm>
-            <a:off x="6355080" y="1124712"/>
-            <a:ext cx="2194560" cy="457200"/>
-          </a:xfrm>
-          <a:prstGeom prst="rect">
-            <a:avLst/>
-          </a:prstGeom>
-          <a:noFill/>
-          <a:ln/>
-        </p:spPr>
-        <p:txBody>
-          <a:bodyPr wrap="square" lIns="0" tIns="0" rIns="0" bIns="0" rtlCol="0" anchor="ctr"/>
-          <a:lstStyle/>
-          <a:p>
-            <a:pPr indent="0" marL="0">
-              <a:buNone/>
-            </a:pPr>
-            <a:r>
-              <a:rPr lang="en-US" sz="2200" b="1" dirty="0">
-                <a:solidFill>
-                  <a:schemeClr val="accent2"/>
-                </a:solidFill>
-                <a:latin typeface="Cambria" pitchFamily="34" charset="0"/>
-                <a:ea typeface="Cambria" pitchFamily="34" charset="-122"/>
-                <a:cs typeface="Cambria" pitchFamily="34" charset="-120"/>
-              </a:rPr>
-              <a:t>0.61 to 0.11</a:t>
-            </a:r>
-            <a:endParaRPr lang="en-US" sz="2200" dirty="0"/>
-          </a:p>
-        </p:txBody>
-      </p:sp>
-      <p:sp>
-        <p:nvSpPr>
-          <p:cNvPr id="7" name="stat-label"/>
-          <p:cNvSpPr txBox="1"/>
-          <p:nvPr/>
-        </p:nvSpPr>
-        <p:spPr>
-          <a:xfrm>
-            <a:off x="6355080" y="1600200"/>
-            <a:ext cx="2194560" cy="402336"/>
-          </a:xfrm>
-          <a:prstGeom prst="rect">
-            <a:avLst/>
-          </a:prstGeom>
-          <a:noFill/>
-          <a:ln/>
-        </p:spPr>
-        <p:txBody>
-          <a:bodyPr wrap="square" lIns="0" tIns="0" rIns="0" bIns="0" rtlCol="0" anchor="t"/>
-          <a:lstStyle/>
-          <a:p>
-            <a:pPr indent="0" marL="0">
-              <a:buNone/>
-            </a:pPr>
-            <a:r>
-              <a:rPr lang="en-US" sz="1100" dirty="0">
-                <a:solidFill>
-                  <a:schemeClr val="accent3"/>
-                </a:solidFill>
-              </a:rPr>
-              <a:t>uncapped: a few very large deposits (σ 2.5)</a:t>
-            </a:r>
-            <a:endParaRPr lang="en-US" sz="1100" dirty="0"/>
-          </a:p>
-        </p:txBody>
-      </p:sp>
-      <p:sp>
-        <p:nvSpPr>
-          <p:cNvPr id="8" name="stat-capped: no deposit a"/>
-          <p:cNvSpPr/>
-          <p:nvPr/>
-        </p:nvSpPr>
-        <p:spPr>
-          <a:xfrm>
-            <a:off x="6217920" y="2194560"/>
-            <a:ext cx="2468880" cy="1005840"/>
-          </a:xfrm>
-          <a:prstGeom prst="roundRect">
-            <a:avLst>
-              <a:gd name="adj" fmla="val 7273"/>
-            </a:avLst>
-          </a:prstGeom>
-          <a:solidFill>
-            <a:schemeClr val="bg2"/>
-          </a:solidFill>
-          <a:ln w="12700">
-            <a:solidFill>
-              <a:schemeClr val="bg2"/>
-            </a:solidFill>
-            <a:prstDash val="solid"/>
-          </a:ln>
-        </p:spPr>
-      </p:sp>
-      <p:sp>
-        <p:nvSpPr>
-          <p:cNvPr id="9" name="stat-big"/>
-          <p:cNvSpPr txBox="1"/>
-          <p:nvPr/>
-        </p:nvSpPr>
-        <p:spPr>
-          <a:xfrm>
-            <a:off x="6355080" y="2267712"/>
-            <a:ext cx="2194560" cy="457200"/>
-          </a:xfrm>
-          <a:prstGeom prst="rect">
-            <a:avLst/>
-          </a:prstGeom>
-          <a:noFill/>
-          <a:ln/>
-        </p:spPr>
-        <p:txBody>
-          <a:bodyPr wrap="square" lIns="0" tIns="0" rIns="0" bIns="0" rtlCol="0" anchor="ctr"/>
-          <a:lstStyle/>
-          <a:p>
-            <a:pPr indent="0" marL="0">
-              <a:buNone/>
-            </a:pPr>
-            <a:r>
-              <a:rPr lang="en-US" sz="2200" b="1" dirty="0">
-                <a:solidFill>
-                  <a:schemeClr val="accent1"/>
-                </a:solidFill>
-                <a:latin typeface="Cambria" pitchFamily="34" charset="0"/>
-                <a:ea typeface="Cambria" pitchFamily="34" charset="-122"/>
-                <a:cs typeface="Cambria" pitchFamily="34" charset="-120"/>
-              </a:rPr>
-              <a:t>0.51 to 0.08</a:t>
-            </a:r>
-            <a:endParaRPr lang="en-US" sz="2200" dirty="0"/>
-          </a:p>
-        </p:txBody>
-      </p:sp>
-      <p:sp>
-        <p:nvSpPr>
-          <p:cNvPr id="10" name="stat-label"/>
-          <p:cNvSpPr txBox="1"/>
-          <p:nvPr/>
-        </p:nvSpPr>
-        <p:spPr>
-          <a:xfrm>
-            <a:off x="6355080" y="2743200"/>
-            <a:ext cx="2194560" cy="402336"/>
-          </a:xfrm>
-          <a:prstGeom prst="rect">
-            <a:avLst/>
-          </a:prstGeom>
-          <a:noFill/>
-          <a:ln/>
-        </p:spPr>
-        <p:txBody>
-          <a:bodyPr wrap="square" lIns="0" tIns="0" rIns="0" bIns="0" rtlCol="0" anchor="t"/>
-          <a:lstStyle/>
-          <a:p>
-            <a:pPr indent="0" marL="0">
-              <a:buNone/>
-            </a:pPr>
-            <a:r>
-              <a:rPr lang="en-US" sz="1100" dirty="0">
-                <a:solidFill>
-                  <a:schemeClr val="accent3"/>
-                </a:solidFill>
-              </a:rPr>
-              <a:t>capped: no deposit above 1% of the total (the reference bank)</a:t>
-            </a:r>
-            <a:endParaRPr lang="en-US" sz="1100" dirty="0"/>
-          </a:p>
-        </p:txBody>
-      </p:sp>
-      <p:sp>
-        <p:nvSpPr>
-          <p:cNvPr id="11" name="stat-similar sizes (σ 1)."/>
-          <p:cNvSpPr/>
-          <p:nvPr/>
-        </p:nvSpPr>
-        <p:spPr>
-          <a:xfrm>
-            <a:off x="6217920" y="3337560"/>
-            <a:ext cx="2468880" cy="1097280"/>
-          </a:xfrm>
-          <a:prstGeom prst="roundRect">
-            <a:avLst>
-              <a:gd name="adj" fmla="val 6667"/>
-            </a:avLst>
-          </a:prstGeom>
-          <a:solidFill>
-            <a:schemeClr val="bg2"/>
-          </a:solidFill>
-          <a:ln w="12700">
-            <a:solidFill>
-              <a:schemeClr val="bg2"/>
-            </a:solidFill>
-            <a:prstDash val="solid"/>
-          </a:ln>
-        </p:spPr>
-      </p:sp>
-      <p:sp>
-        <p:nvSpPr>
-          <p:cNvPr id="12" name="stat-big"/>
-          <p:cNvSpPr txBox="1"/>
-          <p:nvPr/>
-        </p:nvSpPr>
-        <p:spPr>
-          <a:xfrm>
-            <a:off x="6355080" y="3410712"/>
-            <a:ext cx="2194560" cy="457200"/>
-          </a:xfrm>
-          <a:prstGeom prst="rect">
-            <a:avLst/>
-          </a:prstGeom>
-          <a:noFill/>
-          <a:ln/>
-        </p:spPr>
-        <p:txBody>
-          <a:bodyPr wrap="square" lIns="0" tIns="0" rIns="0" bIns="0" rtlCol="0" anchor="ctr"/>
-          <a:lstStyle/>
-          <a:p>
-            <a:pPr indent="0" marL="0">
-              <a:buNone/>
-            </a:pPr>
-            <a:r>
-              <a:rPr lang="en-US" sz="2200" b="1" dirty="0">
-                <a:solidFill>
-                  <a:schemeClr val="accent3"/>
-                </a:solidFill>
-                <a:latin typeface="Cambria" pitchFamily="34" charset="0"/>
-                <a:ea typeface="Cambria" pitchFamily="34" charset="-122"/>
-                <a:cs typeface="Cambria" pitchFamily="34" charset="-120"/>
-              </a:rPr>
-              <a:t>0.50 to 0.08</a:t>
-            </a:r>
-            <a:endParaRPr lang="en-US" sz="2200" dirty="0"/>
-          </a:p>
-        </p:txBody>
-      </p:sp>
-      <p:sp>
-        <p:nvSpPr>
-          <p:cNvPr id="13" name="stat-label"/>
-          <p:cNvSpPr txBox="1"/>
-          <p:nvPr/>
-        </p:nvSpPr>
-        <p:spPr>
-          <a:xfrm>
-            <a:off x="6355080" y="3886200"/>
-            <a:ext cx="2194560" cy="493776"/>
-          </a:xfrm>
-          <a:prstGeom prst="rect">
-            <a:avLst/>
-          </a:prstGeom>
-          <a:noFill/>
-          <a:ln/>
-        </p:spPr>
-        <p:txBody>
-          <a:bodyPr wrap="square" lIns="0" tIns="0" rIns="0" bIns="0" rtlCol="0" anchor="t"/>
-          <a:lstStyle/>
-          <a:p>
-            <a:pPr indent="0" marL="0">
-              <a:buNone/>
-            </a:pPr>
-            <a:r>
-              <a:rPr lang="en-US" sz="1100" dirty="0">
-                <a:solidFill>
-                  <a:schemeClr val="accent3"/>
-                </a:solidFill>
-              </a:rPr>
-              <a:t>similar sizes (σ 1). The μ gradient is the same in all three.</a:t>
-            </a:r>
-            <a:endParaRPr lang="en-US" sz="1100" dirty="0"/>
           </a:p>
         </p:txBody>
       </p:sp>

</xml_diff>

<commit_message>
Deck: slide 12 retitled Varying the deposit-size distribution; caption dropped
Co-Authored-By: Claude Fable 5.1 <noreply@anthropic.com>
</commit_message>
<xml_diff>
--- a/docs/deck_2026-10-26_seminar.pptx
+++ b/docs/deck_2026-10-26_seminar.pptx
@@ -120,7 +120,7 @@
   <p:extLst>
     <p:ext uri="{521415D9-36F7-43E2-AB2F-B90AF26B5E84}">
       <p14:sectionLst xmlns:p14="http://schemas.microsoft.com/office/powerpoint/2010/main">
-        <p14:section name="Opening" id="{94242ec3-5a4e-0bfd-3107-9536b985bfbc}">
+        <p14:section name="Opening" id="{adb55f74-1e4f-cafe-c236-ec8495150dba}">
           <p14:sldIdLst>
             <p14:sldId id="256"/>
             <p14:sldId id="257"/>
@@ -130,13 +130,13 @@
             <p14:sldId id="261"/>
           </p14:sldIdLst>
         </p14:section>
-        <p14:section name="The model" id="{668a035d-92bc-cde4-60fa-8794ddf3d63f}">
+        <p14:section name="The model" id="{538e7ede-8c99-7bf3-0909-8a0d8c8da669}">
           <p14:sldIdLst>
             <p14:sldId id="262"/>
             <p14:sldId id="263"/>
           </p14:sldIdLst>
         </p14:section>
-        <p14:section name="Results" id="{66109033-2af5-4de4-7573-55bbf8b23061}">
+        <p14:section name="Results" id="{b7c4e30d-a625-7c84-1c1c-518b911ddeec}">
           <p14:sldIdLst>
             <p14:sldId id="264"/>
             <p14:sldId id="265"/>
@@ -144,12 +144,12 @@
             <p14:sldId id="267"/>
           </p14:sldIdLst>
         </p14:section>
-        <p14:section name="Validation" id="{2163cee4-4da1-3543-2a88-0a2c5bac8ebd}">
+        <p14:section name="Validation" id="{3227f0ef-a8eb-06f1-9804-e50fd6c2cf70}">
           <p14:sldIdLst>
             <p14:sldId id="268"/>
           </p14:sldIdLst>
         </p14:section>
-        <p14:section name="Close" id="{9eaa7b34-87ce-a7a6-6bca-c3e988ac2b06}">
+        <p14:section name="Close" id="{184ce1ae-7332-6520-8422-fcaa1b221e28}">
           <p14:sldIdLst>
             <p14:sldId id="269"/>
           </p14:sldIdLst>
@@ -3668,7 +3668,7 @@
                   <a:schemeClr val="tx2"/>
                 </a:solidFill>
               </a:rPr>
-              <a:t>Capping the largest deposits</a:t>
+              <a:t>Varying the deposit-size distribution</a:t>
             </a:r>
             <a:endParaRPr lang="en-US" sz="2400" dirty="0"/>
           </a:p>
@@ -3690,50 +3690,14 @@
         </p:blipFill>
         <p:spPr>
           <a:xfrm>
-            <a:off x="1998536" y="1005840"/>
-            <a:ext cx="5146929" cy="3429000"/>
+            <a:off x="1861284" y="1005840"/>
+            <a:ext cx="5421432" cy="3611880"/>
           </a:xfrm>
           <a:prstGeom prst="rect">
             <a:avLst/>
           </a:prstGeom>
         </p:spPr>
       </p:pic>
-      <p:sp>
-        <p:nvSpPr>
-          <p:cNvPr id="4" name="caption"/>
-          <p:cNvSpPr txBox="1"/>
-          <p:nvPr/>
-        </p:nvSpPr>
-        <p:spPr>
-          <a:xfrm>
-            <a:off x="1998536" y="4480560"/>
-            <a:ext cx="5146929" cy="274320"/>
-          </a:xfrm>
-          <a:prstGeom prst="rect">
-            <a:avLst/>
-          </a:prstGeom>
-          <a:noFill/>
-          <a:ln/>
-        </p:spPr>
-        <p:txBody>
-          <a:bodyPr wrap="square" lIns="0" tIns="0" rIns="0" bIns="0" rtlCol="0" anchor="ctr"/>
-          <a:lstStyle/>
-          <a:p>
-            <a:pPr indent="0" marL="0">
-              <a:buNone/>
-            </a:pPr>
-            <a:r>
-              <a:rPr lang="en-US" sz="1000" i="1" dirty="0">
-                <a:solidFill>
-                  <a:schemeClr val="accent3"/>
-                </a:solidFill>
-              </a:rPr>
-              <a:t>Chance the bank fails by share of individualists, for three deposit-size distributions. λ pairs pooled.</a:t>
-            </a:r>
-            <a:endParaRPr lang="en-US" sz="1000" dirty="0"/>
-          </a:p>
-        </p:txBody>
-      </p:sp>
       <p:sp>
         <p:nvSpPr>
           <p:cNvPr id="25" name="Slide Number Placeholder 0"/>

</xml_diff>

<commit_message>
Deck: legend shows the λ pairs (Large (λ 0.1, 0.9) etc.) on e01/e05/e08; slide 11 is the figure alone; fig_deck.py SIZE updated for the next HPC run
Co-Authored-By: Claude Fable 5.1 <noreply@anthropic.com>
</commit_message>
<xml_diff>
--- a/docs/deck_2026-10-26_seminar.pptx
+++ b/docs/deck_2026-10-26_seminar.pptx
@@ -120,7 +120,7 @@
   <p:extLst>
     <p:ext uri="{521415D9-36F7-43E2-AB2F-B90AF26B5E84}">
       <p14:sectionLst xmlns:p14="http://schemas.microsoft.com/office/powerpoint/2010/main">
-        <p14:section name="Opening" id="{adb55f74-1e4f-cafe-c236-ec8495150dba}">
+        <p14:section name="Opening" id="{b6b0f83b-c9cc-eb6c-f883-e98e432d065c}">
           <p14:sldIdLst>
             <p14:sldId id="256"/>
             <p14:sldId id="257"/>
@@ -130,13 +130,13 @@
             <p14:sldId id="261"/>
           </p14:sldIdLst>
         </p14:section>
-        <p14:section name="The model" id="{538e7ede-8c99-7bf3-0909-8a0d8c8da669}">
+        <p14:section name="The model" id="{4842ef48-cbd9-2872-84c1-38994a200d3b}">
           <p14:sldIdLst>
             <p14:sldId id="262"/>
             <p14:sldId id="263"/>
           </p14:sldIdLst>
         </p14:section>
-        <p14:section name="Results" id="{b7c4e30d-a625-7c84-1c1c-518b911ddeec}">
+        <p14:section name="Results" id="{ddddc7ac-7fb3-17d7-e516-de499f8e14e9}">
           <p14:sldIdLst>
             <p14:sldId id="264"/>
             <p14:sldId id="265"/>
@@ -144,12 +144,12 @@
             <p14:sldId id="267"/>
           </p14:sldIdLst>
         </p14:section>
-        <p14:section name="Validation" id="{3227f0ef-a8eb-06f1-9804-e50fd6c2cf70}">
+        <p14:section name="Validation" id="{dd639afe-7e13-d3c9-d089-bf8162965392}">
           <p14:sldIdLst>
             <p14:sldId id="268"/>
           </p14:sldIdLst>
         </p14:section>
-        <p14:section name="Close" id="{184ce1ae-7332-6520-8422-fcaa1b221e28}">
+        <p14:section name="Close" id="{1ff97b49-e8ba-070e-4b4c-6be4435de0d1}">
           <p14:sldIdLst>
             <p14:sldId id="269"/>
           </p14:sldIdLst>
@@ -2644,7 +2644,7 @@
         <p:spPr>
           <a:xfrm>
             <a:off x="457200" y="1051560"/>
-            <a:ext cx="4941052" cy="3291840"/>
+            <a:ext cx="5013472" cy="3291840"/>
           </a:xfrm>
           <a:prstGeom prst="rect">
             <a:avLst/>
@@ -3114,458 +3114,14 @@
         </p:blipFill>
         <p:spPr>
           <a:xfrm>
-            <a:off x="457200" y="1051560"/>
-            <a:ext cx="5486400" cy="2607605"/>
+            <a:off x="730766" y="1005840"/>
+            <a:ext cx="7682469" cy="3611880"/>
           </a:xfrm>
           <a:prstGeom prst="rect">
             <a:avLst/>
           </a:prstGeom>
         </p:spPr>
       </p:pic>
-      <p:sp>
-        <p:nvSpPr>
-          <p:cNvPr id="4" name="caption"/>
-          <p:cNvSpPr txBox="1"/>
-          <p:nvPr/>
-        </p:nvSpPr>
-        <p:spPr>
-          <a:xfrm>
-            <a:off x="457200" y="3704885"/>
-            <a:ext cx="5486400" cy="274320"/>
-          </a:xfrm>
-          <a:prstGeom prst="rect">
-            <a:avLst/>
-          </a:prstGeom>
-          <a:noFill/>
-          <a:ln/>
-        </p:spPr>
-        <p:txBody>
-          <a:bodyPr wrap="square" lIns="0" tIns="0" rIns="0" bIns="0" rtlCol="0" anchor="ctr"/>
-          <a:lstStyle/>
-          <a:p>
-            <a:pPr indent="0" marL="0">
-              <a:buNone/>
-            </a:pPr>
-            <a:r>
-              <a:rPr lang="en-US" sz="1000" i="1" dirty="0">
-                <a:solidFill>
-                  <a:schemeClr val="accent3"/>
-                </a:solidFill>
-              </a:rPr>
-              <a:t>Chance the bank fails, by the kind of public news, dot and CI per λ pair. All mixes μ. Numbers at right: wide λ gap.</a:t>
-            </a:r>
-            <a:endParaRPr lang="en-US" sz="1000" dirty="0"/>
-          </a:p>
-        </p:txBody>
-      </p:sp>
-      <p:sp>
-        <p:nvSpPr>
-          <p:cNvPr id="5" name="stat-outdated, pessimisti"/>
-          <p:cNvSpPr/>
-          <p:nvPr/>
-        </p:nvSpPr>
-        <p:spPr>
-          <a:xfrm>
-            <a:off x="6217920" y="1051560"/>
-            <a:ext cx="2468880" cy="777240"/>
-          </a:xfrm>
-          <a:prstGeom prst="roundRect">
-            <a:avLst>
-              <a:gd name="adj" fmla="val 9412"/>
-            </a:avLst>
-          </a:prstGeom>
-          <a:solidFill>
-            <a:schemeClr val="bg2"/>
-          </a:solidFill>
-          <a:ln w="12700">
-            <a:solidFill>
-              <a:schemeClr val="bg2"/>
-            </a:solidFill>
-            <a:prstDash val="solid"/>
-          </a:ln>
-        </p:spPr>
-      </p:sp>
-      <p:sp>
-        <p:nvSpPr>
-          <p:cNvPr id="6" name="stat-big"/>
-          <p:cNvSpPr txBox="1"/>
-          <p:nvPr/>
-        </p:nvSpPr>
-        <p:spPr>
-          <a:xfrm>
-            <a:off x="6355080" y="1124712"/>
-            <a:ext cx="2194560" cy="365760"/>
-          </a:xfrm>
-          <a:prstGeom prst="rect">
-            <a:avLst/>
-          </a:prstGeom>
-          <a:noFill/>
-          <a:ln/>
-        </p:spPr>
-        <p:txBody>
-          <a:bodyPr wrap="square" lIns="0" tIns="0" rIns="0" bIns="0" rtlCol="0" anchor="ctr"/>
-          <a:lstStyle/>
-          <a:p>
-            <a:pPr indent="0" marL="0">
-              <a:buNone/>
-            </a:pPr>
-            <a:r>
-              <a:rPr lang="en-US" sz="2200" b="1" dirty="0">
-                <a:solidFill>
-                  <a:schemeClr val="accent2"/>
-                </a:solidFill>
-                <a:latin typeface="Cambria" pitchFamily="34" charset="0"/>
-                <a:ea typeface="Cambria" pitchFamily="34" charset="-122"/>
-                <a:cs typeface="Cambria" pitchFamily="34" charset="-120"/>
-              </a:rPr>
-              <a:t>0.48</a:t>
-            </a:r>
-            <a:endParaRPr lang="en-US" sz="2200" dirty="0"/>
-          </a:p>
-        </p:txBody>
-      </p:sp>
-      <p:sp>
-        <p:nvSpPr>
-          <p:cNvPr id="7" name="stat-label"/>
-          <p:cNvSpPr txBox="1"/>
-          <p:nvPr/>
-        </p:nvSpPr>
-        <p:spPr>
-          <a:xfrm>
-            <a:off x="6355080" y="1508760"/>
-            <a:ext cx="2194560" cy="265176"/>
-          </a:xfrm>
-          <a:prstGeom prst="rect">
-            <a:avLst/>
-          </a:prstGeom>
-          <a:noFill/>
-          <a:ln/>
-        </p:spPr>
-        <p:txBody>
-          <a:bodyPr wrap="square" lIns="0" tIns="0" rIns="0" bIns="0" rtlCol="0" anchor="t"/>
-          <a:lstStyle/>
-          <a:p>
-            <a:pPr indent="0" marL="0">
-              <a:buNone/>
-            </a:pPr>
-            <a:r>
-              <a:rPr lang="en-US" sz="1100" dirty="0">
-                <a:solidFill>
-                  <a:schemeClr val="accent3"/>
-                </a:solidFill>
-              </a:rPr>
-              <a:t>outdated, pessimistic news</a:t>
-            </a:r>
-            <a:endParaRPr lang="en-US" sz="1100" dirty="0"/>
-          </a:p>
-        </p:txBody>
-      </p:sp>
-      <p:sp>
-        <p:nvSpPr>
-          <p:cNvPr id="8" name="stat-no public news"/>
-          <p:cNvSpPr/>
-          <p:nvPr/>
-        </p:nvSpPr>
-        <p:spPr>
-          <a:xfrm>
-            <a:off x="6217920" y="1938528"/>
-            <a:ext cx="2468880" cy="777240"/>
-          </a:xfrm>
-          <a:prstGeom prst="roundRect">
-            <a:avLst>
-              <a:gd name="adj" fmla="val 9412"/>
-            </a:avLst>
-          </a:prstGeom>
-          <a:solidFill>
-            <a:schemeClr val="bg2"/>
-          </a:solidFill>
-          <a:ln w="12700">
-            <a:solidFill>
-              <a:schemeClr val="bg2"/>
-            </a:solidFill>
-            <a:prstDash val="solid"/>
-          </a:ln>
-        </p:spPr>
-      </p:sp>
-      <p:sp>
-        <p:nvSpPr>
-          <p:cNvPr id="9" name="stat-big"/>
-          <p:cNvSpPr txBox="1"/>
-          <p:nvPr/>
-        </p:nvSpPr>
-        <p:spPr>
-          <a:xfrm>
-            <a:off x="6355080" y="2011680"/>
-            <a:ext cx="2194560" cy="365760"/>
-          </a:xfrm>
-          <a:prstGeom prst="rect">
-            <a:avLst/>
-          </a:prstGeom>
-          <a:noFill/>
-          <a:ln/>
-        </p:spPr>
-        <p:txBody>
-          <a:bodyPr wrap="square" lIns="0" tIns="0" rIns="0" bIns="0" rtlCol="0" anchor="ctr"/>
-          <a:lstStyle/>
-          <a:p>
-            <a:pPr indent="0" marL="0">
-              <a:buNone/>
-            </a:pPr>
-            <a:r>
-              <a:rPr lang="en-US" sz="2200" b="1" dirty="0">
-                <a:solidFill>
-                  <a:schemeClr val="accent1"/>
-                </a:solidFill>
-                <a:latin typeface="Cambria" pitchFamily="34" charset="0"/>
-                <a:ea typeface="Cambria" pitchFamily="34" charset="-122"/>
-                <a:cs typeface="Cambria" pitchFamily="34" charset="-120"/>
-              </a:rPr>
-              <a:t>0.31</a:t>
-            </a:r>
-            <a:endParaRPr lang="en-US" sz="2200" dirty="0"/>
-          </a:p>
-        </p:txBody>
-      </p:sp>
-      <p:sp>
-        <p:nvSpPr>
-          <p:cNvPr id="10" name="stat-label"/>
-          <p:cNvSpPr txBox="1"/>
-          <p:nvPr/>
-        </p:nvSpPr>
-        <p:spPr>
-          <a:xfrm>
-            <a:off x="6355080" y="2395728"/>
-            <a:ext cx="2194560" cy="265176"/>
-          </a:xfrm>
-          <a:prstGeom prst="rect">
-            <a:avLst/>
-          </a:prstGeom>
-          <a:noFill/>
-          <a:ln/>
-        </p:spPr>
-        <p:txBody>
-          <a:bodyPr wrap="square" lIns="0" tIns="0" rIns="0" bIns="0" rtlCol="0" anchor="t"/>
-          <a:lstStyle/>
-          <a:p>
-            <a:pPr indent="0" marL="0">
-              <a:buNone/>
-            </a:pPr>
-            <a:r>
-              <a:rPr lang="en-US" sz="1100" dirty="0">
-                <a:solidFill>
-                  <a:schemeClr val="accent3"/>
-                </a:solidFill>
-              </a:rPr>
-              <a:t>no public news</a:t>
-            </a:r>
-            <a:endParaRPr lang="en-US" sz="1100" dirty="0"/>
-          </a:p>
-        </p:txBody>
-      </p:sp>
-      <p:sp>
-        <p:nvSpPr>
-          <p:cNvPr id="11" name="stat-accurate news"/>
-          <p:cNvSpPr/>
-          <p:nvPr/>
-        </p:nvSpPr>
-        <p:spPr>
-          <a:xfrm>
-            <a:off x="6217920" y="2825496"/>
-            <a:ext cx="2468880" cy="777240"/>
-          </a:xfrm>
-          <a:prstGeom prst="roundRect">
-            <a:avLst>
-              <a:gd name="adj" fmla="val 9412"/>
-            </a:avLst>
-          </a:prstGeom>
-          <a:solidFill>
-            <a:schemeClr val="bg2"/>
-          </a:solidFill>
-          <a:ln w="12700">
-            <a:solidFill>
-              <a:schemeClr val="bg2"/>
-            </a:solidFill>
-            <a:prstDash val="solid"/>
-          </a:ln>
-        </p:spPr>
-      </p:sp>
-      <p:sp>
-        <p:nvSpPr>
-          <p:cNvPr id="12" name="stat-big"/>
-          <p:cNvSpPr txBox="1"/>
-          <p:nvPr/>
-        </p:nvSpPr>
-        <p:spPr>
-          <a:xfrm>
-            <a:off x="6355080" y="2898648"/>
-            <a:ext cx="2194560" cy="365760"/>
-          </a:xfrm>
-          <a:prstGeom prst="rect">
-            <a:avLst/>
-          </a:prstGeom>
-          <a:noFill/>
-          <a:ln/>
-        </p:spPr>
-        <p:txBody>
-          <a:bodyPr wrap="square" lIns="0" tIns="0" rIns="0" bIns="0" rtlCol="0" anchor="ctr"/>
-          <a:lstStyle/>
-          <a:p>
-            <a:pPr indent="0" marL="0">
-              <a:buNone/>
-            </a:pPr>
-            <a:r>
-              <a:rPr lang="en-US" sz="2200" b="1" dirty="0">
-                <a:solidFill>
-                  <a:schemeClr val="accent1"/>
-                </a:solidFill>
-                <a:latin typeface="Cambria" pitchFamily="34" charset="0"/>
-                <a:ea typeface="Cambria" pitchFamily="34" charset="-122"/>
-                <a:cs typeface="Cambria" pitchFamily="34" charset="-120"/>
-              </a:rPr>
-              <a:t>0.29</a:t>
-            </a:r>
-            <a:endParaRPr lang="en-US" sz="2200" dirty="0"/>
-          </a:p>
-        </p:txBody>
-      </p:sp>
-      <p:sp>
-        <p:nvSpPr>
-          <p:cNvPr id="13" name="stat-label"/>
-          <p:cNvSpPr txBox="1"/>
-          <p:nvPr/>
-        </p:nvSpPr>
-        <p:spPr>
-          <a:xfrm>
-            <a:off x="6355080" y="3282696"/>
-            <a:ext cx="2194560" cy="265176"/>
-          </a:xfrm>
-          <a:prstGeom prst="rect">
-            <a:avLst/>
-          </a:prstGeom>
-          <a:noFill/>
-          <a:ln/>
-        </p:spPr>
-        <p:txBody>
-          <a:bodyPr wrap="square" lIns="0" tIns="0" rIns="0" bIns="0" rtlCol="0" anchor="t"/>
-          <a:lstStyle/>
-          <a:p>
-            <a:pPr indent="0" marL="0">
-              <a:buNone/>
-            </a:pPr>
-            <a:r>
-              <a:rPr lang="en-US" sz="1100" dirty="0">
-                <a:solidFill>
-                  <a:schemeClr val="accent3"/>
-                </a:solidFill>
-              </a:rPr>
-              <a:t>accurate news</a:t>
-            </a:r>
-            <a:endParaRPr lang="en-US" sz="1100" dirty="0"/>
-          </a:p>
-        </p:txBody>
-      </p:sp>
-      <p:sp>
-        <p:nvSpPr>
-          <p:cNvPr id="14" name="stat-outdated, optimistic"/>
-          <p:cNvSpPr/>
-          <p:nvPr/>
-        </p:nvSpPr>
-        <p:spPr>
-          <a:xfrm>
-            <a:off x="6217920" y="3712464"/>
-            <a:ext cx="2468880" cy="777240"/>
-          </a:xfrm>
-          <a:prstGeom prst="roundRect">
-            <a:avLst>
-              <a:gd name="adj" fmla="val 9412"/>
-            </a:avLst>
-          </a:prstGeom>
-          <a:solidFill>
-            <a:schemeClr val="bg2"/>
-          </a:solidFill>
-          <a:ln w="12700">
-            <a:solidFill>
-              <a:schemeClr val="bg2"/>
-            </a:solidFill>
-            <a:prstDash val="solid"/>
-          </a:ln>
-        </p:spPr>
-      </p:sp>
-      <p:sp>
-        <p:nvSpPr>
-          <p:cNvPr id="15" name="stat-big"/>
-          <p:cNvSpPr txBox="1"/>
-          <p:nvPr/>
-        </p:nvSpPr>
-        <p:spPr>
-          <a:xfrm>
-            <a:off x="6355080" y="3785616"/>
-            <a:ext cx="2194560" cy="365760"/>
-          </a:xfrm>
-          <a:prstGeom prst="rect">
-            <a:avLst/>
-          </a:prstGeom>
-          <a:noFill/>
-          <a:ln/>
-        </p:spPr>
-        <p:txBody>
-          <a:bodyPr wrap="square" lIns="0" tIns="0" rIns="0" bIns="0" rtlCol="0" anchor="ctr"/>
-          <a:lstStyle/>
-          <a:p>
-            <a:pPr indent="0" marL="0">
-              <a:buNone/>
-            </a:pPr>
-            <a:r>
-              <a:rPr lang="en-US" sz="2200" b="1" dirty="0">
-                <a:solidFill>
-                  <a:schemeClr val="accent5"/>
-                </a:solidFill>
-                <a:latin typeface="Cambria" pitchFamily="34" charset="0"/>
-                <a:ea typeface="Cambria" pitchFamily="34" charset="-122"/>
-                <a:cs typeface="Cambria" pitchFamily="34" charset="-120"/>
-              </a:rPr>
-              <a:t>0.16</a:t>
-            </a:r>
-            <a:endParaRPr lang="en-US" sz="2200" dirty="0"/>
-          </a:p>
-        </p:txBody>
-      </p:sp>
-      <p:sp>
-        <p:nvSpPr>
-          <p:cNvPr id="16" name="stat-label"/>
-          <p:cNvSpPr txBox="1"/>
-          <p:nvPr/>
-        </p:nvSpPr>
-        <p:spPr>
-          <a:xfrm>
-            <a:off x="6355080" y="4169664"/>
-            <a:ext cx="2194560" cy="265176"/>
-          </a:xfrm>
-          <a:prstGeom prst="rect">
-            <a:avLst/>
-          </a:prstGeom>
-          <a:noFill/>
-          <a:ln/>
-        </p:spPr>
-        <p:txBody>
-          <a:bodyPr wrap="square" lIns="0" tIns="0" rIns="0" bIns="0" rtlCol="0" anchor="t"/>
-          <a:lstStyle/>
-          <a:p>
-            <a:pPr indent="0" marL="0">
-              <a:buNone/>
-            </a:pPr>
-            <a:r>
-              <a:rPr lang="en-US" sz="1100" dirty="0">
-                <a:solidFill>
-                  <a:schemeClr val="accent3"/>
-                </a:solidFill>
-              </a:rPr>
-              <a:t>outdated, optimistic news</a:t>
-            </a:r>
-            <a:endParaRPr lang="en-US" sz="1100" dirty="0"/>
-          </a:p>
-        </p:txBody>
-      </p:sp>
       <p:sp>
         <p:nvSpPr>
           <p:cNvPr id="25" name="Slide Number Placeholder 0"/>
@@ -3823,7 +3379,7 @@
         <p:spPr>
           <a:xfrm>
             <a:off x="457200" y="1051560"/>
-            <a:ext cx="5145146" cy="3291840"/>
+            <a:ext cx="5214275" cy="3291840"/>
           </a:xfrm>
           <a:prstGeom prst="rect">
             <a:avLst/>

</xml_diff>

<commit_message>
Deck: herding and failure-by-mix slides are the figures alone
Co-Authored-By: Claude Fable 5.1 <noreply@anthropic.com>
</commit_message>
<xml_diff>
--- a/docs/deck_2026-10-26_seminar.pptx
+++ b/docs/deck_2026-10-26_seminar.pptx
@@ -120,7 +120,7 @@
   <p:extLst>
     <p:ext uri="{521415D9-36F7-43E2-AB2F-B90AF26B5E84}">
       <p14:sectionLst xmlns:p14="http://schemas.microsoft.com/office/powerpoint/2010/main">
-        <p14:section name="Opening" id="{b6b0f83b-c9cc-eb6c-f883-e98e432d065c}">
+        <p14:section name="Opening" id="{2608034c-f592-06ab-d20e-d0bf15f8d299}">
           <p14:sldIdLst>
             <p14:sldId id="256"/>
             <p14:sldId id="257"/>
@@ -130,13 +130,13 @@
             <p14:sldId id="261"/>
           </p14:sldIdLst>
         </p14:section>
-        <p14:section name="The model" id="{4842ef48-cbd9-2872-84c1-38994a200d3b}">
+        <p14:section name="The model" id="{38c95e52-69c0-e73b-e8dc-383ebdaba2b0}">
           <p14:sldIdLst>
             <p14:sldId id="262"/>
             <p14:sldId id="263"/>
           </p14:sldIdLst>
         </p14:section>
-        <p14:section name="Results" id="{ddddc7ac-7fb3-17d7-e516-de499f8e14e9}">
+        <p14:section name="Results" id="{82fd25da-2328-2403-d222-b621f0b68152}">
           <p14:sldIdLst>
             <p14:sldId id="264"/>
             <p14:sldId id="265"/>
@@ -144,12 +144,12 @@
             <p14:sldId id="267"/>
           </p14:sldIdLst>
         </p14:section>
-        <p14:section name="Validation" id="{dd639afe-7e13-d3c9-d089-bf8162965392}">
+        <p14:section name="Validation" id="{b42d5292-5795-11d3-ecd3-b831e5972654}">
           <p14:sldIdLst>
             <p14:sldId id="268"/>
           </p14:sldIdLst>
         </p14:section>
-        <p14:section name="Close" id="{1ff97b49-e8ba-070e-4b4c-6be4435de0d1}">
+        <p14:section name="Close" id="{0413a2d1-648d-303b-806e-53efe1fe319a}">
           <p14:sldIdLst>
             <p14:sldId id="269"/>
           </p14:sldIdLst>
@@ -2643,8 +2643,8 @@
         </p:blipFill>
         <p:spPr>
           <a:xfrm>
-            <a:off x="457200" y="1051560"/>
-            <a:ext cx="5013472" cy="3291840"/>
+            <a:off x="1821553" y="1005840"/>
+            <a:ext cx="5500893" cy="3611880"/>
           </a:xfrm>
           <a:prstGeom prst="rect">
             <a:avLst/>
@@ -2653,54 +2653,18 @@
       </p:pic>
       <p:sp>
         <p:nvSpPr>
-          <p:cNvPr id="4" name="caption"/>
-          <p:cNvSpPr txBox="1"/>
-          <p:nvPr/>
-        </p:nvSpPr>
-        <p:spPr>
-          <a:xfrm>
-            <a:off x="457200" y="4389120"/>
-            <a:ext cx="5486400" cy="274320"/>
-          </a:xfrm>
-          <a:prstGeom prst="rect">
-            <a:avLst/>
-          </a:prstGeom>
-          <a:noFill/>
-          <a:ln/>
-        </p:spPr>
-        <p:txBody>
-          <a:bodyPr wrap="square" lIns="0" tIns="0" rIns="0" bIns="0" rtlCol="0" anchor="ctr"/>
-          <a:lstStyle/>
-          <a:p>
-            <a:pPr indent="0" marL="0">
-              <a:buNone/>
-            </a:pPr>
-            <a:r>
-              <a:rPr lang="en-US" sz="1000" i="1" dirty="0">
-                <a:solidFill>
-                  <a:schemeClr val="accent3"/>
-                </a:solidFill>
-              </a:rPr>
-              <a:t>Chance the bank fails, by share of individualists μ, one line per λ pair. Includes the pure populations (μ 0 and 1).</a:t>
-            </a:r>
-            <a:endParaRPr lang="en-US" sz="1000" dirty="0"/>
-          </a:p>
-        </p:txBody>
-      </p:sp>
-      <p:sp>
-        <p:nvSpPr>
-          <p:cNvPr id="5" name="stat-P(fail) from no indi"/>
+          <p:cNvPr id="4" name="card-Monotone"/>
           <p:cNvSpPr/>
           <p:nvPr/>
         </p:nvSpPr>
         <p:spPr>
           <a:xfrm>
-            <a:off x="6217920" y="1051560"/>
-            <a:ext cx="2468880" cy="1005840"/>
+            <a:off x="6217920" y="3337560"/>
+            <a:ext cx="2468880" cy="1097280"/>
           </a:xfrm>
           <a:prstGeom prst="roundRect">
             <a:avLst>
-              <a:gd name="adj" fmla="val 7273"/>
+              <a:gd name="adj" fmla="val 6667"/>
             </a:avLst>
           </a:prstGeom>
           <a:solidFill>
@@ -2716,14 +2680,14 @@
       </p:sp>
       <p:sp>
         <p:nvSpPr>
-          <p:cNvPr id="6" name="stat-big"/>
+          <p:cNvPr id="5" name="card-head"/>
           <p:cNvSpPr txBox="1"/>
           <p:nvPr/>
         </p:nvSpPr>
         <p:spPr>
           <a:xfrm>
-            <a:off x="6355080" y="1124712"/>
-            <a:ext cx="2194560" cy="457200"/>
+            <a:off x="6355080" y="3429000"/>
+            <a:ext cx="2194560" cy="292608"/>
           </a:xfrm>
           <a:prstGeom prst="rect">
             <a:avLst/>
@@ -2739,210 +2703,6 @@
               <a:buNone/>
             </a:pPr>
             <a:r>
-              <a:rPr lang="en-US" sz="2200" b="1" dirty="0">
-                <a:solidFill>
-                  <a:schemeClr val="accent1"/>
-                </a:solidFill>
-                <a:latin typeface="Cambria" pitchFamily="34" charset="0"/>
-                <a:ea typeface="Cambria" pitchFamily="34" charset="-122"/>
-                <a:cs typeface="Cambria" pitchFamily="34" charset="-120"/>
-              </a:rPr>
-              <a:t>0.67 to 0.08</a:t>
-            </a:r>
-            <a:endParaRPr lang="en-US" sz="2200" dirty="0"/>
-          </a:p>
-        </p:txBody>
-      </p:sp>
-      <p:sp>
-        <p:nvSpPr>
-          <p:cNvPr id="7" name="stat-label"/>
-          <p:cNvSpPr txBox="1"/>
-          <p:nvPr/>
-        </p:nvSpPr>
-        <p:spPr>
-          <a:xfrm>
-            <a:off x="6355080" y="1600200"/>
-            <a:ext cx="2194560" cy="402336"/>
-          </a:xfrm>
-          <a:prstGeom prst="rect">
-            <a:avLst/>
-          </a:prstGeom>
-          <a:noFill/>
-          <a:ln/>
-        </p:spPr>
-        <p:txBody>
-          <a:bodyPr wrap="square" lIns="0" tIns="0" rIns="0" bIns="0" rtlCol="0" anchor="t"/>
-          <a:lstStyle/>
-          <a:p>
-            <a:pPr indent="0" marL="0">
-              <a:buNone/>
-            </a:pPr>
-            <a:r>
-              <a:rPr lang="en-US" sz="1100" dirty="0">
-                <a:solidFill>
-                  <a:schemeClr val="accent3"/>
-                </a:solidFill>
-              </a:rPr>
-              <a:t>P(fail) from no individualists to all, wide λ gap</a:t>
-            </a:r>
-            <a:endParaRPr lang="en-US" sz="1100" dirty="0"/>
-          </a:p>
-        </p:txBody>
-      </p:sp>
-      <p:sp>
-        <p:nvSpPr>
-          <p:cNvPr id="8" name="stat-the same, narrow λ g"/>
-          <p:cNvSpPr/>
-          <p:nvPr/>
-        </p:nvSpPr>
-        <p:spPr>
-          <a:xfrm>
-            <a:off x="6217920" y="2194560"/>
-            <a:ext cx="2468880" cy="1005840"/>
-          </a:xfrm>
-          <a:prstGeom prst="roundRect">
-            <a:avLst>
-              <a:gd name="adj" fmla="val 7273"/>
-            </a:avLst>
-          </a:prstGeom>
-          <a:solidFill>
-            <a:schemeClr val="bg2"/>
-          </a:solidFill>
-          <a:ln w="12700">
-            <a:solidFill>
-              <a:schemeClr val="bg2"/>
-            </a:solidFill>
-            <a:prstDash val="solid"/>
-          </a:ln>
-        </p:spPr>
-      </p:sp>
-      <p:sp>
-        <p:nvSpPr>
-          <p:cNvPr id="9" name="stat-big"/>
-          <p:cNvSpPr txBox="1"/>
-          <p:nvPr/>
-        </p:nvSpPr>
-        <p:spPr>
-          <a:xfrm>
-            <a:off x="6355080" y="2267712"/>
-            <a:ext cx="2194560" cy="457200"/>
-          </a:xfrm>
-          <a:prstGeom prst="rect">
-            <a:avLst/>
-          </a:prstGeom>
-          <a:noFill/>
-          <a:ln/>
-        </p:spPr>
-        <p:txBody>
-          <a:bodyPr wrap="square" lIns="0" tIns="0" rIns="0" bIns="0" rtlCol="0" anchor="ctr"/>
-          <a:lstStyle/>
-          <a:p>
-            <a:pPr indent="0" marL="0">
-              <a:buNone/>
-            </a:pPr>
-            <a:r>
-              <a:rPr lang="en-US" sz="2200" b="1" dirty="0">
-                <a:solidFill>
-                  <a:schemeClr val="accent1"/>
-                </a:solidFill>
-                <a:latin typeface="Cambria" pitchFamily="34" charset="0"/>
-                <a:ea typeface="Cambria" pitchFamily="34" charset="-122"/>
-                <a:cs typeface="Cambria" pitchFamily="34" charset="-120"/>
-              </a:rPr>
-              <a:t>0.25 to 0.09</a:t>
-            </a:r>
-            <a:endParaRPr lang="en-US" sz="2200" dirty="0"/>
-          </a:p>
-        </p:txBody>
-      </p:sp>
-      <p:sp>
-        <p:nvSpPr>
-          <p:cNvPr id="10" name="stat-label"/>
-          <p:cNvSpPr txBox="1"/>
-          <p:nvPr/>
-        </p:nvSpPr>
-        <p:spPr>
-          <a:xfrm>
-            <a:off x="6355080" y="2743200"/>
-            <a:ext cx="2194560" cy="402336"/>
-          </a:xfrm>
-          <a:prstGeom prst="rect">
-            <a:avLst/>
-          </a:prstGeom>
-          <a:noFill/>
-          <a:ln/>
-        </p:spPr>
-        <p:txBody>
-          <a:bodyPr wrap="square" lIns="0" tIns="0" rIns="0" bIns="0" rtlCol="0" anchor="t"/>
-          <a:lstStyle/>
-          <a:p>
-            <a:pPr indent="0" marL="0">
-              <a:buNone/>
-            </a:pPr>
-            <a:r>
-              <a:rPr lang="en-US" sz="1100" dirty="0">
-                <a:solidFill>
-                  <a:schemeClr val="accent3"/>
-                </a:solidFill>
-              </a:rPr>
-              <a:t>the same, narrow λ gap: it matters most when collectivists dominate</a:t>
-            </a:r>
-            <a:endParaRPr lang="en-US" sz="1100" dirty="0"/>
-          </a:p>
-        </p:txBody>
-      </p:sp>
-      <p:sp>
-        <p:nvSpPr>
-          <p:cNvPr id="11" name="card-Monotone"/>
-          <p:cNvSpPr/>
-          <p:nvPr/>
-        </p:nvSpPr>
-        <p:spPr>
-          <a:xfrm>
-            <a:off x="6217920" y="3337560"/>
-            <a:ext cx="2468880" cy="1097280"/>
-          </a:xfrm>
-          <a:prstGeom prst="roundRect">
-            <a:avLst>
-              <a:gd name="adj" fmla="val 6667"/>
-            </a:avLst>
-          </a:prstGeom>
-          <a:solidFill>
-            <a:schemeClr val="bg2"/>
-          </a:solidFill>
-          <a:ln w="12700">
-            <a:solidFill>
-              <a:schemeClr val="bg2"/>
-            </a:solidFill>
-            <a:prstDash val="solid"/>
-          </a:ln>
-        </p:spPr>
-      </p:sp>
-      <p:sp>
-        <p:nvSpPr>
-          <p:cNvPr id="12" name="card-head"/>
-          <p:cNvSpPr txBox="1"/>
-          <p:nvPr/>
-        </p:nvSpPr>
-        <p:spPr>
-          <a:xfrm>
-            <a:off x="6355080" y="3429000"/>
-            <a:ext cx="2194560" cy="292608"/>
-          </a:xfrm>
-          <a:prstGeom prst="rect">
-            <a:avLst/>
-          </a:prstGeom>
-          <a:noFill/>
-          <a:ln/>
-        </p:spPr>
-        <p:txBody>
-          <a:bodyPr wrap="square" lIns="0" tIns="0" rIns="0" bIns="0" rtlCol="0" anchor="ctr"/>
-          <a:lstStyle/>
-          <a:p>
-            <a:pPr indent="0" marL="0">
-              <a:buNone/>
-            </a:pPr>
-            <a:r>
               <a:rPr lang="en-US" sz="1300" b="1" dirty="0">
                 <a:solidFill>
                   <a:schemeClr val="tx2"/>
@@ -2956,7 +2716,7 @@
       </p:sp>
       <p:sp>
         <p:nvSpPr>
-          <p:cNvPr id="13" name="card-body"/>
+          <p:cNvPr id="6" name="card-body"/>
           <p:cNvSpPr txBox="1"/>
           <p:nvPr/>
         </p:nvSpPr>
@@ -8035,356 +7795,14 @@
         </p:blipFill>
         <p:spPr>
           <a:xfrm>
-            <a:off x="457200" y="1051560"/>
-            <a:ext cx="5164897" cy="3291840"/>
+            <a:off x="1738480" y="1005840"/>
+            <a:ext cx="5667040" cy="3611880"/>
           </a:xfrm>
           <a:prstGeom prst="rect">
             <a:avLst/>
           </a:prstGeom>
         </p:spPr>
       </p:pic>
-      <p:sp>
-        <p:nvSpPr>
-          <p:cNvPr id="4" name="caption"/>
-          <p:cNvSpPr txBox="1"/>
-          <p:nvPr/>
-        </p:nvSpPr>
-        <p:spPr>
-          <a:xfrm>
-            <a:off x="457200" y="4389120"/>
-            <a:ext cx="5486400" cy="274320"/>
-          </a:xfrm>
-          <a:prstGeom prst="rect">
-            <a:avLst/>
-          </a:prstGeom>
-          <a:noFill/>
-          <a:ln/>
-        </p:spPr>
-        <p:txBody>
-          <a:bodyPr wrap="square" lIns="0" tIns="0" rIns="0" bIns="0" rtlCol="0" anchor="ctr"/>
-          <a:lstStyle/>
-          <a:p>
-            <a:pPr indent="0" marL="0">
-              <a:buNone/>
-            </a:pPr>
-            <a:r>
-              <a:rPr lang="en-US" sz="1000" i="1" dirty="0">
-                <a:solidFill>
-                  <a:schemeClr val="accent3"/>
-                </a:solidFill>
-              </a:rPr>
-              <a:t>Chance of withdrawing, given the share of a depositor’s neighbours who have already withdrawn. λ pairs pooled; reference bank.</a:t>
-            </a:r>
-            <a:endParaRPr lang="en-US" sz="1000" dirty="0"/>
-          </a:p>
-        </p:txBody>
-      </p:sp>
-      <p:sp>
-        <p:nvSpPr>
-          <p:cNvPr id="5" name="stat-collectivists, once "/>
-          <p:cNvSpPr/>
-          <p:nvPr/>
-        </p:nvSpPr>
-        <p:spPr>
-          <a:xfrm>
-            <a:off x="6217920" y="1051560"/>
-            <a:ext cx="2468880" cy="1005840"/>
-          </a:xfrm>
-          <a:prstGeom prst="roundRect">
-            <a:avLst>
-              <a:gd name="adj" fmla="val 7273"/>
-            </a:avLst>
-          </a:prstGeom>
-          <a:solidFill>
-            <a:schemeClr val="bg2"/>
-          </a:solidFill>
-          <a:ln w="12700">
-            <a:solidFill>
-              <a:schemeClr val="bg2"/>
-            </a:solidFill>
-            <a:prstDash val="solid"/>
-          </a:ln>
-        </p:spPr>
-      </p:sp>
-      <p:sp>
-        <p:nvSpPr>
-          <p:cNvPr id="6" name="stat-big"/>
-          <p:cNvSpPr txBox="1"/>
-          <p:nvPr/>
-        </p:nvSpPr>
-        <p:spPr>
-          <a:xfrm>
-            <a:off x="6355080" y="1124712"/>
-            <a:ext cx="2194560" cy="457200"/>
-          </a:xfrm>
-          <a:prstGeom prst="rect">
-            <a:avLst/>
-          </a:prstGeom>
-          <a:noFill/>
-          <a:ln/>
-        </p:spPr>
-        <p:txBody>
-          <a:bodyPr wrap="square" lIns="0" tIns="0" rIns="0" bIns="0" rtlCol="0" anchor="ctr"/>
-          <a:lstStyle/>
-          <a:p>
-            <a:pPr indent="0" marL="0">
-              <a:buNone/>
-            </a:pPr>
-            <a:r>
-              <a:rPr lang="en-US" sz="2200" b="1" dirty="0">
-                <a:solidFill>
-                  <a:srgbClr val="2A78D6"/>
-                </a:solidFill>
-                <a:latin typeface="Cambria" pitchFamily="34" charset="0"/>
-                <a:ea typeface="Cambria" pitchFamily="34" charset="-122"/>
-                <a:cs typeface="Cambria" pitchFamily="34" charset="-120"/>
-              </a:rPr>
-              <a:t>0.15 to 0.93</a:t>
-            </a:r>
-            <a:endParaRPr lang="en-US" sz="2200" dirty="0"/>
-          </a:p>
-        </p:txBody>
-      </p:sp>
-      <p:sp>
-        <p:nvSpPr>
-          <p:cNvPr id="7" name="stat-label"/>
-          <p:cNvSpPr txBox="1"/>
-          <p:nvPr/>
-        </p:nvSpPr>
-        <p:spPr>
-          <a:xfrm>
-            <a:off x="6355080" y="1600200"/>
-            <a:ext cx="2194560" cy="402336"/>
-          </a:xfrm>
-          <a:prstGeom prst="rect">
-            <a:avLst/>
-          </a:prstGeom>
-          <a:noFill/>
-          <a:ln/>
-        </p:spPr>
-        <p:txBody>
-          <a:bodyPr wrap="square" lIns="0" tIns="0" rIns="0" bIns="0" rtlCol="0" anchor="t"/>
-          <a:lstStyle/>
-          <a:p>
-            <a:pPr indent="0" marL="0">
-              <a:buNone/>
-            </a:pPr>
-            <a:r>
-              <a:rPr lang="en-US" sz="1100" dirty="0">
-                <a:solidFill>
-                  <a:schemeClr val="accent3"/>
-                </a:solidFill>
-              </a:rPr>
-              <a:t>collectivists, once 20–35% of their neighbours are out</a:t>
-            </a:r>
-            <a:endParaRPr lang="en-US" sz="1100" dirty="0"/>
-          </a:p>
-        </p:txBody>
-      </p:sp>
-      <p:sp>
-        <p:nvSpPr>
-          <p:cNvPr id="8" name="stat-where individualists"/>
-          <p:cNvSpPr/>
-          <p:nvPr/>
-        </p:nvSpPr>
-        <p:spPr>
-          <a:xfrm>
-            <a:off x="6217920" y="2194560"/>
-            <a:ext cx="2468880" cy="1005840"/>
-          </a:xfrm>
-          <a:prstGeom prst="roundRect">
-            <a:avLst>
-              <a:gd name="adj" fmla="val 7273"/>
-            </a:avLst>
-          </a:prstGeom>
-          <a:solidFill>
-            <a:schemeClr val="bg2"/>
-          </a:solidFill>
-          <a:ln w="12700">
-            <a:solidFill>
-              <a:schemeClr val="bg2"/>
-            </a:solidFill>
-            <a:prstDash val="solid"/>
-          </a:ln>
-        </p:spPr>
-      </p:sp>
-      <p:sp>
-        <p:nvSpPr>
-          <p:cNvPr id="9" name="stat-big"/>
-          <p:cNvSpPr txBox="1"/>
-          <p:nvPr/>
-        </p:nvSpPr>
-        <p:spPr>
-          <a:xfrm>
-            <a:off x="6355080" y="2267712"/>
-            <a:ext cx="2194560" cy="457200"/>
-          </a:xfrm>
-          <a:prstGeom prst="rect">
-            <a:avLst/>
-          </a:prstGeom>
-          <a:noFill/>
-          <a:ln/>
-        </p:spPr>
-        <p:txBody>
-          <a:bodyPr wrap="square" lIns="0" tIns="0" rIns="0" bIns="0" rtlCol="0" anchor="ctr"/>
-          <a:lstStyle/>
-          <a:p>
-            <a:pPr indent="0" marL="0">
-              <a:buNone/>
-            </a:pPr>
-            <a:r>
-              <a:rPr lang="en-US" sz="2200" b="1" dirty="0">
-                <a:solidFill>
-                  <a:srgbClr val="EB6834"/>
-                </a:solidFill>
-                <a:latin typeface="Cambria" pitchFamily="34" charset="0"/>
-                <a:ea typeface="Cambria" pitchFamily="34" charset="-122"/>
-                <a:cs typeface="Cambria" pitchFamily="34" charset="-120"/>
-              </a:rPr>
-              <a:t>0.25 to 0.30</a:t>
-            </a:r>
-            <a:endParaRPr lang="en-US" sz="2200" dirty="0"/>
-          </a:p>
-        </p:txBody>
-      </p:sp>
-      <p:sp>
-        <p:nvSpPr>
-          <p:cNvPr id="10" name="stat-label"/>
-          <p:cNvSpPr txBox="1"/>
-          <p:nvPr/>
-        </p:nvSpPr>
-        <p:spPr>
-          <a:xfrm>
-            <a:off x="6355080" y="2743200"/>
-            <a:ext cx="2194560" cy="402336"/>
-          </a:xfrm>
-          <a:prstGeom prst="rect">
-            <a:avLst/>
-          </a:prstGeom>
-          <a:noFill/>
-          <a:ln/>
-        </p:spPr>
-        <p:txBody>
-          <a:bodyPr wrap="square" lIns="0" tIns="0" rIns="0" bIns="0" rtlCol="0" anchor="t"/>
-          <a:lstStyle/>
-          <a:p>
-            <a:pPr indent="0" marL="0">
-              <a:buNone/>
-            </a:pPr>
-            <a:r>
-              <a:rPr lang="en-US" sz="1100" dirty="0">
-                <a:solidFill>
-                  <a:schemeClr val="accent3"/>
-                </a:solidFill>
-              </a:rPr>
-              <a:t>where individualists level off, whatever their neighbours do</a:t>
-            </a:r>
-            <a:endParaRPr lang="en-US" sz="1100" dirty="0"/>
-          </a:p>
-        </p:txBody>
-      </p:sp>
-      <p:sp>
-        <p:nvSpPr>
-          <p:cNvPr id="11" name="stat-difference in slopes"/>
-          <p:cNvSpPr/>
-          <p:nvPr/>
-        </p:nvSpPr>
-        <p:spPr>
-          <a:xfrm>
-            <a:off x="6217920" y="3337560"/>
-            <a:ext cx="2468880" cy="1097280"/>
-          </a:xfrm>
-          <a:prstGeom prst="roundRect">
-            <a:avLst>
-              <a:gd name="adj" fmla="val 6667"/>
-            </a:avLst>
-          </a:prstGeom>
-          <a:solidFill>
-            <a:schemeClr val="bg2"/>
-          </a:solidFill>
-          <a:ln w="12700">
-            <a:solidFill>
-              <a:schemeClr val="bg2"/>
-            </a:solidFill>
-            <a:prstDash val="solid"/>
-          </a:ln>
-        </p:spPr>
-      </p:sp>
-      <p:sp>
-        <p:nvSpPr>
-          <p:cNvPr id="12" name="stat-big"/>
-          <p:cNvSpPr txBox="1"/>
-          <p:nvPr/>
-        </p:nvSpPr>
-        <p:spPr>
-          <a:xfrm>
-            <a:off x="6355080" y="3410712"/>
-            <a:ext cx="2194560" cy="457200"/>
-          </a:xfrm>
-          <a:prstGeom prst="rect">
-            <a:avLst/>
-          </a:prstGeom>
-          <a:noFill/>
-          <a:ln/>
-        </p:spPr>
-        <p:txBody>
-          <a:bodyPr wrap="square" lIns="0" tIns="0" rIns="0" bIns="0" rtlCol="0" anchor="ctr"/>
-          <a:lstStyle/>
-          <a:p>
-            <a:pPr indent="0" marL="0">
-              <a:buNone/>
-            </a:pPr>
-            <a:r>
-              <a:rPr lang="en-US" sz="2600" b="1" dirty="0">
-                <a:solidFill>
-                  <a:schemeClr val="accent1"/>
-                </a:solidFill>
-                <a:latin typeface="Cambria" pitchFamily="34" charset="0"/>
-                <a:ea typeface="Cambria" pitchFamily="34" charset="-122"/>
-                <a:cs typeface="Cambria" pitchFamily="34" charset="-120"/>
-              </a:rPr>
-              <a:t>+0.58</a:t>
-            </a:r>
-            <a:endParaRPr lang="en-US" sz="2600" dirty="0"/>
-          </a:p>
-        </p:txBody>
-      </p:sp>
-      <p:sp>
-        <p:nvSpPr>
-          <p:cNvPr id="13" name="stat-label"/>
-          <p:cNvSpPr txBox="1"/>
-          <p:nvPr/>
-        </p:nvSpPr>
-        <p:spPr>
-          <a:xfrm>
-            <a:off x="6355080" y="3886200"/>
-            <a:ext cx="2194560" cy="493776"/>
-          </a:xfrm>
-          <a:prstGeom prst="rect">
-            <a:avLst/>
-          </a:prstGeom>
-          <a:noFill/>
-          <a:ln/>
-        </p:spPr>
-        <p:txBody>
-          <a:bodyPr wrap="square" lIns="0" tIns="0" rIns="0" bIns="0" rtlCol="0" anchor="t"/>
-          <a:lstStyle/>
-          <a:p>
-            <a:pPr indent="0" marL="0">
-              <a:buNone/>
-            </a:pPr>
-            <a:r>
-              <a:rPr lang="en-US" sz="1100" dirty="0">
-                <a:solidFill>
-                  <a:schemeClr val="accent3"/>
-                </a:solidFill>
-              </a:rPr>
-              <a:t>difference in slopes (collectivists 0.80, individualists 0.22), t = 16.7</a:t>
-            </a:r>
-            <a:endParaRPr lang="en-US" sz="1100" dirty="0"/>
-          </a:p>
-        </p:txBody>
-      </p:sp>
       <p:sp>
         <p:nvSpPr>
           <p:cNvPr id="25" name="Slide Number Placeholder 0"/>

</xml_diff>

<commit_message>
Deck: Monotone card dropped from the failure-by-mix slide
Co-Authored-By: Claude Fable 5.1 <noreply@anthropic.com>
</commit_message>
<xml_diff>
--- a/docs/deck_2026-10-26_seminar.pptx
+++ b/docs/deck_2026-10-26_seminar.pptx
@@ -120,7 +120,7 @@
   <p:extLst>
     <p:ext uri="{521415D9-36F7-43E2-AB2F-B90AF26B5E84}">
       <p14:sectionLst xmlns:p14="http://schemas.microsoft.com/office/powerpoint/2010/main">
-        <p14:section name="Opening" id="{2608034c-f592-06ab-d20e-d0bf15f8d299}">
+        <p14:section name="Opening" id="{44391919-9fcc-e48e-4148-b200cdee47b1}">
           <p14:sldIdLst>
             <p14:sldId id="256"/>
             <p14:sldId id="257"/>
@@ -130,13 +130,13 @@
             <p14:sldId id="261"/>
           </p14:sldIdLst>
         </p14:section>
-        <p14:section name="The model" id="{38c95e52-69c0-e73b-e8dc-383ebdaba2b0}">
+        <p14:section name="The model" id="{a2d97d17-a860-ed0c-b5db-4c8c7c436921}">
           <p14:sldIdLst>
             <p14:sldId id="262"/>
             <p14:sldId id="263"/>
           </p14:sldIdLst>
         </p14:section>
-        <p14:section name="Results" id="{82fd25da-2328-2403-d222-b621f0b68152}">
+        <p14:section name="Results" id="{57d6db16-59c6-fe38-bf59-3ea97d0f0ac8}">
           <p14:sldIdLst>
             <p14:sldId id="264"/>
             <p14:sldId id="265"/>
@@ -144,12 +144,12 @@
             <p14:sldId id="267"/>
           </p14:sldIdLst>
         </p14:section>
-        <p14:section name="Validation" id="{b42d5292-5795-11d3-ecd3-b831e5972654}">
+        <p14:section name="Validation" id="{bbeb5f1c-807a-14b3-a341-0d597cde811e}">
           <p14:sldIdLst>
             <p14:sldId id="268"/>
           </p14:sldIdLst>
         </p14:section>
-        <p14:section name="Close" id="{0413a2d1-648d-303b-806e-53efe1fe319a}">
+        <p14:section name="Close" id="{9c6f72a4-c463-7586-fe7c-888f471380be}">
           <p14:sldIdLst>
             <p14:sldId id="269"/>
           </p14:sldIdLst>
@@ -2651,105 +2651,6 @@
           </a:prstGeom>
         </p:spPr>
       </p:pic>
-      <p:sp>
-        <p:nvSpPr>
-          <p:cNvPr id="4" name="card-Monotone"/>
-          <p:cNvSpPr/>
-          <p:nvPr/>
-        </p:nvSpPr>
-        <p:spPr>
-          <a:xfrm>
-            <a:off x="6217920" y="3337560"/>
-            <a:ext cx="2468880" cy="1097280"/>
-          </a:xfrm>
-          <a:prstGeom prst="roundRect">
-            <a:avLst>
-              <a:gd name="adj" fmla="val 6667"/>
-            </a:avLst>
-          </a:prstGeom>
-          <a:solidFill>
-            <a:schemeClr val="bg2"/>
-          </a:solidFill>
-          <a:ln w="12700">
-            <a:solidFill>
-              <a:schemeClr val="bg2"/>
-            </a:solidFill>
-            <a:prstDash val="solid"/>
-          </a:ln>
-        </p:spPr>
-      </p:sp>
-      <p:sp>
-        <p:nvSpPr>
-          <p:cNvPr id="5" name="card-head"/>
-          <p:cNvSpPr txBox="1"/>
-          <p:nvPr/>
-        </p:nvSpPr>
-        <p:spPr>
-          <a:xfrm>
-            <a:off x="6355080" y="3429000"/>
-            <a:ext cx="2194560" cy="292608"/>
-          </a:xfrm>
-          <a:prstGeom prst="rect">
-            <a:avLst/>
-          </a:prstGeom>
-          <a:noFill/>
-          <a:ln/>
-        </p:spPr>
-        <p:txBody>
-          <a:bodyPr wrap="square" lIns="0" tIns="0" rIns="0" bIns="0" rtlCol="0" anchor="ctr"/>
-          <a:lstStyle/>
-          <a:p>
-            <a:pPr indent="0" marL="0">
-              <a:buNone/>
-            </a:pPr>
-            <a:r>
-              <a:rPr lang="en-US" sz="1300" b="1" dirty="0">
-                <a:solidFill>
-                  <a:schemeClr val="tx2"/>
-                </a:solidFill>
-              </a:rPr>
-              <a:t>Monotone</a:t>
-            </a:r>
-            <a:endParaRPr lang="en-US" sz="1300" dirty="0"/>
-          </a:p>
-        </p:txBody>
-      </p:sp>
-      <p:sp>
-        <p:nvSpPr>
-          <p:cNvPr id="6" name="card-body"/>
-          <p:cNvSpPr txBox="1"/>
-          <p:nvPr/>
-        </p:nvSpPr>
-        <p:spPr>
-          <a:xfrm>
-            <a:off x="6355080" y="3749040"/>
-            <a:ext cx="2194560" cy="594360"/>
-          </a:xfrm>
-          <a:prstGeom prst="rect">
-            <a:avLst/>
-          </a:prstGeom>
-          <a:noFill/>
-          <a:ln/>
-        </p:spPr>
-        <p:txBody>
-          <a:bodyPr wrap="square" lIns="0" tIns="0" rIns="0" bIns="0" rtlCol="0" anchor="t"/>
-          <a:lstStyle/>
-          <a:p>
-            <a:pPr indent="0" marL="0">
-              <a:buNone/>
-            </a:pPr>
-            <a:r>
-              <a:rPr lang="en-US" sz="1150" dirty="0">
-                <a:solidFill>
-                  <a:schemeClr val="tx1"/>
-                </a:solidFill>
-              </a:rPr>
-              <a:t>No interior peak at any mix. The lines converge once individualists are 75% or more.</a:t>
-            </a:r>
-            <a:endParaRPr lang="en-US" sz="1150" dirty="0"/>
-          </a:p>
-        </p:txBody>
-      </p:sp>
       <p:sp>
         <p:nvSpPr>
           <p:cNvPr id="25" name="Slide Number Placeholder 0"/>

</xml_diff>

<commit_message>
Deck: tests slide is the figure alone; titles centred on every layout
Co-Authored-By: Claude Fable 5.1 <noreply@anthropic.com>
</commit_message>
<xml_diff>
--- a/docs/deck_2026-10-26_seminar.pptx
+++ b/docs/deck_2026-10-26_seminar.pptx
@@ -120,7 +120,7 @@
   <p:extLst>
     <p:ext uri="{521415D9-36F7-43E2-AB2F-B90AF26B5E84}">
       <p14:sectionLst xmlns:p14="http://schemas.microsoft.com/office/powerpoint/2010/main">
-        <p14:section name="Opening" id="{44391919-9fcc-e48e-4148-b200cdee47b1}">
+        <p14:section name="Opening" id="{f74dc821-8093-4557-6100-8267c8f72c7b}">
           <p14:sldIdLst>
             <p14:sldId id="256"/>
             <p14:sldId id="257"/>
@@ -130,13 +130,13 @@
             <p14:sldId id="261"/>
           </p14:sldIdLst>
         </p14:section>
-        <p14:section name="The model" id="{a2d97d17-a860-ed0c-b5db-4c8c7c436921}">
+        <p14:section name="The model" id="{3dbc78c5-c894-8079-f20a-0b095a8322de}">
           <p14:sldIdLst>
             <p14:sldId id="262"/>
             <p14:sldId id="263"/>
           </p14:sldIdLst>
         </p14:section>
-        <p14:section name="Results" id="{57d6db16-59c6-fe38-bf59-3ea97d0f0ac8}">
+        <p14:section name="Results" id="{52f79486-cf45-3327-b8f9-944bd37c0efd}">
           <p14:sldIdLst>
             <p14:sldId id="264"/>
             <p14:sldId id="265"/>
@@ -144,12 +144,12 @@
             <p14:sldId id="267"/>
           </p14:sldIdLst>
         </p14:section>
-        <p14:section name="Validation" id="{bbeb5f1c-807a-14b3-a341-0d597cde811e}">
+        <p14:section name="Validation" id="{3ff624ca-f151-8928-2d1e-c1e0231df7af}">
           <p14:sldIdLst>
             <p14:sldId id="268"/>
           </p14:sldIdLst>
         </p14:section>
-        <p14:section name="Close" id="{9c6f72a4-c463-7586-fe7c-888f471380be}">
+        <p14:section name="Close" id="{ef47ef8c-0395-b0a5-0ecc-5eeaa9adb85e}">
           <p14:sldIdLst>
             <p14:sldId id="269"/>
           </p14:sldIdLst>
@@ -1820,7 +1820,7 @@
         <p:txBody>
           <a:bodyPr wrap="square" rtlCol="0"/>
           <a:lstStyle>
-            <a:lvl1pPr algn="l" indent="0" marL="0">
+            <a:lvl1pPr algn="ctr" indent="0" marL="0">
               <a:buNone/>
               <a:defRPr lang="en-US" sz="3400" b="1" dirty="0">
                 <a:solidFill>
@@ -1830,7 +1830,7 @@
             </a:lvl1pPr>
           </a:lstStyle>
           <a:p>
-            <a:pPr algn="l" indent="0" marL="0">
+            <a:pPr algn="ctr" indent="0" marL="0">
               <a:buNone/>
             </a:pPr>
             <a:endParaRPr lang="en-US" sz="3400" dirty="0"/>
@@ -1930,7 +1930,7 @@
         <p:txBody>
           <a:bodyPr wrap="square" rtlCol="0"/>
           <a:lstStyle>
-            <a:lvl1pPr algn="l" indent="0" marL="0">
+            <a:lvl1pPr algn="ctr" indent="0" marL="0">
               <a:buNone/>
               <a:defRPr lang="en-US" sz="2400" b="1" dirty="0">
                 <a:solidFill>
@@ -1940,7 +1940,7 @@
             </a:lvl1pPr>
           </a:lstStyle>
           <a:p>
-            <a:pPr algn="l" indent="0" marL="0">
+            <a:pPr algn="ctr" indent="0" marL="0">
               <a:buNone/>
             </a:pPr>
             <a:endParaRPr lang="en-US" sz="2400" dirty="0"/>
@@ -2082,7 +2082,7 @@
         <p:txBody>
           <a:bodyPr wrap="square" rtlCol="0"/>
           <a:lstStyle>
-            <a:lvl1pPr algn="l" indent="0" marL="0">
+            <a:lvl1pPr algn="ctr" indent="0" marL="0">
               <a:buNone/>
               <a:defRPr lang="en-US" sz="3200" b="1" dirty="0">
                 <a:solidFill>
@@ -2092,7 +2092,7 @@
             </a:lvl1pPr>
           </a:lstStyle>
           <a:p>
-            <a:pPr algn="l" indent="0" marL="0">
+            <a:pPr algn="ctr" indent="0" marL="0">
               <a:buNone/>
             </a:pPr>
             <a:endParaRPr lang="en-US" sz="3200" dirty="0"/>
@@ -2511,7 +2511,7 @@
           <a:bodyPr wrap="square" lIns="0" tIns="0" rIns="0" bIns="0" rtlCol="0" anchor="b"/>
           <a:lstStyle/>
           <a:p>
-            <a:pPr algn="l" indent="0" marL="0">
+            <a:pPr algn="ctr" indent="0" marL="0">
               <a:buNone/>
             </a:pPr>
             <a:r>
@@ -2612,7 +2612,7 @@
           <a:bodyPr wrap="square" lIns="0" tIns="0" rIns="0" bIns="0" rtlCol="0" anchor="ctr"/>
           <a:lstStyle/>
           <a:p>
-            <a:pPr algn="l" indent="0" marL="0">
+            <a:pPr algn="ctr" indent="0" marL="0">
               <a:buNone/>
             </a:pPr>
             <a:r>
@@ -2744,7 +2744,7 @@
           <a:bodyPr wrap="square" lIns="0" tIns="0" rIns="0" bIns="0" rtlCol="0" anchor="ctr"/>
           <a:lstStyle/>
           <a:p>
-            <a:pPr algn="l" indent="0" marL="0">
+            <a:pPr algn="ctr" indent="0" marL="0">
               <a:buNone/>
             </a:pPr>
             <a:r>
@@ -2876,7 +2876,7 @@
           <a:bodyPr wrap="square" lIns="0" tIns="0" rIns="0" bIns="0" rtlCol="0" anchor="ctr"/>
           <a:lstStyle/>
           <a:p>
-            <a:pPr algn="l" indent="0" marL="0">
+            <a:pPr algn="ctr" indent="0" marL="0">
               <a:buNone/>
             </a:pPr>
             <a:r>
@@ -3008,7 +3008,7 @@
           <a:bodyPr wrap="square" lIns="0" tIns="0" rIns="0" bIns="0" rtlCol="0" anchor="ctr"/>
           <a:lstStyle/>
           <a:p>
-            <a:pPr algn="l" indent="0" marL="0">
+            <a:pPr algn="ctr" indent="0" marL="0">
               <a:buNone/>
             </a:pPr>
             <a:r>
@@ -3039,283 +3039,14 @@
         </p:blipFill>
         <p:spPr>
           <a:xfrm>
-            <a:off x="457200" y="1051560"/>
-            <a:ext cx="5214275" cy="3291840"/>
+            <a:off x="1711391" y="1005840"/>
+            <a:ext cx="5721218" cy="3611880"/>
           </a:xfrm>
           <a:prstGeom prst="rect">
             <a:avLst/>
           </a:prstGeom>
         </p:spPr>
       </p:pic>
-      <p:sp>
-        <p:nvSpPr>
-          <p:cNvPr id="4" name="caption"/>
-          <p:cNvSpPr txBox="1"/>
-          <p:nvPr/>
-        </p:nvSpPr>
-        <p:spPr>
-          <a:xfrm>
-            <a:off x="457200" y="4389120"/>
-            <a:ext cx="5486400" cy="274320"/>
-          </a:xfrm>
-          <a:prstGeom prst="rect">
-            <a:avLst/>
-          </a:prstGeom>
-          <a:noFill/>
-          <a:ln/>
-        </p:spPr>
-        <p:txBody>
-          <a:bodyPr wrap="square" lIns="0" tIns="0" rIns="0" bIns="0" rtlCol="0" anchor="ctr"/>
-          <a:lstStyle/>
-          <a:p>
-            <a:pPr indent="0" marL="0">
-              <a:buNone/>
-            </a:pPr>
-            <a:r>
-              <a:rPr lang="en-US" sz="1000" i="1" dirty="0">
-                <a:solidFill>
-                  <a:schemeClr val="accent3"/>
-                </a:solidFill>
-              </a:rPr>
-              <a:t>D relative to no news, against how far the public news sits from the truth. Shaded: where the theory predicts the sign.</a:t>
-            </a:r>
-            <a:endParaRPr lang="en-US" sz="1000" dirty="0"/>
-          </a:p>
-        </p:txBody>
-      </p:sp>
-      <p:sp>
-        <p:nvSpPr>
-          <p:cNvPr id="5" name="tests"/>
-          <p:cNvSpPr/>
-          <p:nvPr/>
-        </p:nvSpPr>
-        <p:spPr>
-          <a:xfrm>
-            <a:off x="6217920" y="1051560"/>
-            <a:ext cx="2468880" cy="2103120"/>
-          </a:xfrm>
-          <a:prstGeom prst="roundRect">
-            <a:avLst>
-              <a:gd name="adj" fmla="val 3478"/>
-            </a:avLst>
-          </a:prstGeom>
-          <a:solidFill>
-            <a:schemeClr val="bg2"/>
-          </a:solidFill>
-          <a:ln w="12700">
-            <a:solidFill>
-              <a:schemeClr val="bg2"/>
-            </a:solidFill>
-            <a:prstDash val="solid"/>
-          </a:ln>
-        </p:spPr>
-      </p:sp>
-      <p:sp>
-        <p:nvSpPr>
-          <p:cNvPr id="6" name="tests-text"/>
-          <p:cNvSpPr txBox="1"/>
-          <p:nvPr/>
-        </p:nvSpPr>
-        <p:spPr>
-          <a:xfrm>
-            <a:off x="6355080" y="1143000"/>
-            <a:ext cx="2194560" cy="1920240"/>
-          </a:xfrm>
-          <a:prstGeom prst="rect">
-            <a:avLst/>
-          </a:prstGeom>
-          <a:noFill/>
-          <a:ln/>
-        </p:spPr>
-        <p:txBody>
-          <a:bodyPr wrap="square" lIns="0" tIns="0" rIns="0" bIns="0" rtlCol="0" anchor="t"/>
-          <a:lstStyle/>
-          <a:p>
-            <a:pPr indent="0" marL="0">
-              <a:spcAft>
-                <a:spcPts val="600"/>
-              </a:spcAft>
-              <a:buNone/>
-            </a:pPr>
-            <a:r>
-              <a:rPr lang="en-US" sz="1300" b="1" dirty="0">
-                <a:solidFill>
-                  <a:schemeClr val="tx2"/>
-                </a:solidFill>
-              </a:rPr>
-              <a:t>Pre-registered tests</a:t>
-            </a:r>
-            <a:endParaRPr lang="en-US" sz="1050" dirty="0"/>
-          </a:p>
-          <a:p>
-            <a:pPr indent="0" marL="0">
-              <a:spcAft>
-                <a:spcPts val="300"/>
-              </a:spcAft>
-              <a:buNone/>
-            </a:pPr>
-            <a:r>
-              <a:rPr lang="en-US" sz="1050" dirty="0">
-                <a:solidFill>
-                  <a:schemeClr val="tx1"/>
-                </a:solidFill>
-              </a:rPr>
-              <a:t>G1′  optimistic news: individualists run more   +0.033</a:t>
-            </a:r>
-            <a:endParaRPr lang="en-US" sz="1050" dirty="0"/>
-          </a:p>
-          <a:p>
-            <a:pPr indent="0" marL="0">
-              <a:spcAft>
-                <a:spcPts val="300"/>
-              </a:spcAft>
-              <a:buNone/>
-            </a:pPr>
-            <a:r>
-              <a:rPr lang="en-US" sz="1050" dirty="0">
-                <a:solidFill>
-                  <a:schemeClr val="tx1"/>
-                </a:solidFill>
-              </a:rPr>
-              <a:t>G4′  pessimistic news: collectivists run more   −0.031</a:t>
-            </a:r>
-            <a:endParaRPr lang="en-US" sz="1050" dirty="0"/>
-          </a:p>
-          <a:p>
-            <a:pPr indent="0" marL="0">
-              <a:spcAft>
-                <a:spcPts val="300"/>
-              </a:spcAft>
-              <a:buNone/>
-            </a:pPr>
-            <a:r>
-              <a:rPr lang="en-US" sz="1050" dirty="0">
-                <a:solidFill>
-                  <a:schemeClr val="tx1"/>
-                </a:solidFill>
-              </a:rPr>
-              <a:t>G2a′  the effect grows with the λ gap   +0.093</a:t>
-            </a:r>
-            <a:endParaRPr lang="en-US" sz="1050" dirty="0"/>
-          </a:p>
-          <a:p>
-            <a:pPr indent="0" marL="0">
-              <a:buNone/>
-            </a:pPr>
-            <a:r>
-              <a:rPr lang="en-US" sz="1050" dirty="0">
-                <a:solidFill>
-                  <a:schemeClr val="accent2"/>
-                </a:solidFill>
-              </a:rPr>
-              <a:t>G3  sorting with no news: counts against (one pair wrong-signed)</a:t>
-            </a:r>
-            <a:endParaRPr lang="en-US" sz="1050" dirty="0"/>
-          </a:p>
-        </p:txBody>
-      </p:sp>
-      <p:sp>
-        <p:nvSpPr>
-          <p:cNvPr id="7" name="stat-confirmatory tests s"/>
-          <p:cNvSpPr/>
-          <p:nvPr/>
-        </p:nvSpPr>
-        <p:spPr>
-          <a:xfrm>
-            <a:off x="6217920" y="3291840"/>
-            <a:ext cx="2468880" cy="1143000"/>
-          </a:xfrm>
-          <a:prstGeom prst="roundRect">
-            <a:avLst>
-              <a:gd name="adj" fmla="val 6400"/>
-            </a:avLst>
-          </a:prstGeom>
-          <a:solidFill>
-            <a:schemeClr val="bg2"/>
-          </a:solidFill>
-          <a:ln w="12700">
-            <a:solidFill>
-              <a:schemeClr val="bg2"/>
-            </a:solidFill>
-            <a:prstDash val="solid"/>
-          </a:ln>
-        </p:spPr>
-      </p:sp>
-      <p:sp>
-        <p:nvSpPr>
-          <p:cNvPr id="8" name="stat-big"/>
-          <p:cNvSpPr txBox="1"/>
-          <p:nvPr/>
-        </p:nvSpPr>
-        <p:spPr>
-          <a:xfrm>
-            <a:off x="6355080" y="3364992"/>
-            <a:ext cx="2194560" cy="457200"/>
-          </a:xfrm>
-          <a:prstGeom prst="rect">
-            <a:avLst/>
-          </a:prstGeom>
-          <a:noFill/>
-          <a:ln/>
-        </p:spPr>
-        <p:txBody>
-          <a:bodyPr wrap="square" lIns="0" tIns="0" rIns="0" bIns="0" rtlCol="0" anchor="ctr"/>
-          <a:lstStyle/>
-          <a:p>
-            <a:pPr indent="0" marL="0">
-              <a:buNone/>
-            </a:pPr>
-            <a:r>
-              <a:rPr lang="en-US" sz="2600" b="1" dirty="0">
-                <a:solidFill>
-                  <a:schemeClr val="accent1"/>
-                </a:solidFill>
-                <a:latin typeface="Cambria" pitchFamily="34" charset="0"/>
-                <a:ea typeface="Cambria" pitchFamily="34" charset="-122"/>
-                <a:cs typeface="Cambria" pitchFamily="34" charset="-120"/>
-              </a:rPr>
-              <a:t>3 of 4</a:t>
-            </a:r>
-            <a:endParaRPr lang="en-US" sz="2600" dirty="0"/>
-          </a:p>
-        </p:txBody>
-      </p:sp>
-      <p:sp>
-        <p:nvSpPr>
-          <p:cNvPr id="9" name="stat-label"/>
-          <p:cNvSpPr txBox="1"/>
-          <p:nvPr/>
-        </p:nvSpPr>
-        <p:spPr>
-          <a:xfrm>
-            <a:off x="6355080" y="3840480"/>
-            <a:ext cx="2194560" cy="539496"/>
-          </a:xfrm>
-          <a:prstGeom prst="rect">
-            <a:avLst/>
-          </a:prstGeom>
-          <a:noFill/>
-          <a:ln/>
-        </p:spPr>
-        <p:txBody>
-          <a:bodyPr wrap="square" lIns="0" tIns="0" rIns="0" bIns="0" rtlCol="0" anchor="t"/>
-          <a:lstStyle/>
-          <a:p>
-            <a:pPr indent="0" marL="0">
-              <a:buNone/>
-            </a:pPr>
-            <a:r>
-              <a:rPr lang="en-US" sz="1100" dirty="0">
-                <a:solidFill>
-                  <a:schemeClr val="accent3"/>
-                </a:solidFill>
-              </a:rPr>
-              <a:t>confirmatory tests support the theory, on all three versions of the bank</a:t>
-            </a:r>
-            <a:endParaRPr lang="en-US" sz="1100" dirty="0"/>
-          </a:p>
-        </p:txBody>
-      </p:sp>
       <p:sp>
         <p:nvSpPr>
           <p:cNvPr id="25" name="Slide Number Placeholder 0"/>
@@ -3409,7 +3140,7 @@
           <a:bodyPr wrap="square" lIns="0" tIns="0" rIns="0" bIns="0" rtlCol="0" anchor="ctr"/>
           <a:lstStyle/>
           <a:p>
-            <a:pPr algn="l" indent="0" marL="0">
+            <a:pPr algn="ctr" indent="0" marL="0">
               <a:buNone/>
             </a:pPr>
             <a:r>
@@ -4664,7 +4395,7 @@
           <a:bodyPr wrap="square" lIns="0" tIns="0" rIns="0" bIns="0" rtlCol="0" anchor="ctr"/>
           <a:lstStyle/>
           <a:p>
-            <a:pPr algn="l" indent="0" marL="0">
+            <a:pPr algn="ctr" indent="0" marL="0">
               <a:buNone/>
             </a:pPr>
             <a:r>
@@ -4832,7 +4563,7 @@
           <a:bodyPr wrap="square" lIns="0" tIns="0" rIns="0" bIns="0" rtlCol="0" anchor="ctr"/>
           <a:lstStyle/>
           <a:p>
-            <a:pPr algn="l" indent="0" marL="0">
+            <a:pPr algn="ctr" indent="0" marL="0">
               <a:buNone/>
             </a:pPr>
             <a:r>
@@ -5236,7 +4967,7 @@
           <a:bodyPr wrap="square" lIns="0" tIns="0" rIns="0" bIns="0" rtlCol="0" anchor="ctr"/>
           <a:lstStyle/>
           <a:p>
-            <a:pPr algn="l" indent="0" marL="0">
+            <a:pPr algn="ctr" indent="0" marL="0">
               <a:buNone/>
             </a:pPr>
             <a:r>
@@ -5440,7 +5171,7 @@
           <a:bodyPr wrap="square" lIns="0" tIns="0" rIns="0" bIns="0" rtlCol="0" anchor="ctr"/>
           <a:lstStyle/>
           <a:p>
-            <a:pPr algn="l" indent="0" marL="0">
+            <a:pPr algn="ctr" indent="0" marL="0">
               <a:buNone/>
             </a:pPr>
             <a:r>
@@ -5702,7 +5433,7 @@
           <a:bodyPr wrap="square" lIns="0" tIns="0" rIns="0" bIns="0" rtlCol="0" anchor="ctr"/>
           <a:lstStyle/>
           <a:p>
-            <a:pPr algn="l" indent="0" marL="0">
+            <a:pPr algn="ctr" indent="0" marL="0">
               <a:buNone/>
             </a:pPr>
             <a:r>
@@ -6689,7 +6420,7 @@
           <a:bodyPr wrap="square" lIns="0" tIns="0" rIns="0" bIns="0" rtlCol="0" anchor="ctr"/>
           <a:lstStyle/>
           <a:p>
-            <a:pPr algn="l" indent="0" marL="0">
+            <a:pPr algn="ctr" indent="0" marL="0">
               <a:buNone/>
             </a:pPr>
             <a:r>
@@ -6821,7 +6552,7 @@
           <a:bodyPr wrap="square" lIns="0" tIns="0" rIns="0" bIns="0" rtlCol="0" anchor="ctr"/>
           <a:lstStyle/>
           <a:p>
-            <a:pPr algn="l" indent="0" marL="0">
+            <a:pPr algn="ctr" indent="0" marL="0">
               <a:buNone/>
             </a:pPr>
             <a:r>
@@ -7665,7 +7396,7 @@
           <a:bodyPr wrap="square" lIns="0" tIns="0" rIns="0" bIns="0" rtlCol="0" anchor="ctr"/>
           <a:lstStyle/>
           <a:p>
-            <a:pPr algn="l" indent="0" marL="0">
+            <a:pPr algn="ctr" indent="0" marL="0">
               <a:buNone/>
             </a:pPr>
             <a:r>

</xml_diff>

<commit_message>
Deck: title-slide and section body lines centred too
Co-Authored-By: Claude Fable 5.1 <noreply@anthropic.com>
</commit_message>
<xml_diff>
--- a/docs/deck_2026-10-26_seminar.pptx
+++ b/docs/deck_2026-10-26_seminar.pptx
@@ -120,7 +120,7 @@
   <p:extLst>
     <p:ext uri="{521415D9-36F7-43E2-AB2F-B90AF26B5E84}">
       <p14:sectionLst xmlns:p14="http://schemas.microsoft.com/office/powerpoint/2010/main">
-        <p14:section name="Opening" id="{f74dc821-8093-4557-6100-8267c8f72c7b}">
+        <p14:section name="Opening" id="{66232072-5ce4-fc8d-724d-12034e6c9281}">
           <p14:sldIdLst>
             <p14:sldId id="256"/>
             <p14:sldId id="257"/>
@@ -130,13 +130,13 @@
             <p14:sldId id="261"/>
           </p14:sldIdLst>
         </p14:section>
-        <p14:section name="The model" id="{3dbc78c5-c894-8079-f20a-0b095a8322de}">
+        <p14:section name="The model" id="{d7cb94e2-5df4-89f5-6685-eb87c59aafa0}">
           <p14:sldIdLst>
             <p14:sldId id="262"/>
             <p14:sldId id="263"/>
           </p14:sldIdLst>
         </p14:section>
-        <p14:section name="Results" id="{52f79486-cf45-3327-b8f9-944bd37c0efd}">
+        <p14:section name="Results" id="{364aee76-b905-e268-56f7-081d18027cb5}">
           <p14:sldIdLst>
             <p14:sldId id="264"/>
             <p14:sldId id="265"/>
@@ -144,12 +144,12 @@
             <p14:sldId id="267"/>
           </p14:sldIdLst>
         </p14:section>
-        <p14:section name="Validation" id="{3ff624ca-f151-8928-2d1e-c1e0231df7af}">
+        <p14:section name="Validation" id="{997b9967-b4e6-de0c-9ffe-0857759d3860}">
           <p14:sldIdLst>
             <p14:sldId id="268"/>
           </p14:sldIdLst>
         </p14:section>
-        <p14:section name="Close" id="{ef47ef8c-0395-b0a5-0ecc-5eeaa9adb85e}">
+        <p14:section name="Close" id="{f940eb86-0f47-7546-2ea4-cc08e2c6a39a}">
           <p14:sldIdLst>
             <p14:sldId id="269"/>
           </p14:sldIdLst>
@@ -1859,7 +1859,7 @@
         <p:txBody>
           <a:bodyPr wrap="square" rtlCol="0"/>
           <a:lstStyle>
-            <a:lvl1pPr indent="0" marL="0">
+            <a:lvl1pPr algn="ctr" indent="0" marL="0">
               <a:buNone/>
               <a:defRPr lang="en-US" sz="1800" dirty="0">
                 <a:solidFill>
@@ -1869,7 +1869,7 @@
             </a:lvl1pPr>
           </a:lstStyle>
           <a:p>
-            <a:pPr indent="0" marL="0">
+            <a:pPr algn="ctr" indent="0" marL="0">
               <a:buNone/>
             </a:pPr>
             <a:endParaRPr lang="en-US" sz="1800" dirty="0"/>
@@ -2121,7 +2121,7 @@
         <p:txBody>
           <a:bodyPr wrap="square" rtlCol="0"/>
           <a:lstStyle>
-            <a:lvl1pPr indent="0" marL="0">
+            <a:lvl1pPr algn="ctr" indent="0" marL="0">
               <a:buNone/>
               <a:defRPr lang="en-US" sz="1600" dirty="0">
                 <a:solidFill>
@@ -2131,7 +2131,7 @@
             </a:lvl1pPr>
           </a:lstStyle>
           <a:p>
-            <a:pPr indent="0" marL="0">
+            <a:pPr algn="ctr" indent="0" marL="0">
               <a:buNone/>
             </a:pPr>
             <a:endParaRPr lang="en-US" sz="1600" dirty="0"/>
@@ -2549,7 +2549,7 @@
           <a:bodyPr wrap="square" lIns="0" tIns="0" rIns="0" bIns="0" rtlCol="0" anchor="t"/>
           <a:lstStyle/>
           <a:p>
-            <a:pPr indent="0" marL="0">
+            <a:pPr algn="ctr" indent="0" marL="0">
               <a:buNone/>
             </a:pPr>
             <a:r>

</xml_diff>

<commit_message>
Deck: slide 4 titled Who runs? Variation in interpretation
Co-Authored-By: Claude Fable 5.1 <noreply@anthropic.com>
</commit_message>
<xml_diff>
--- a/docs/deck_2026-10-26_seminar.pptx
+++ b/docs/deck_2026-10-26_seminar.pptx
@@ -120,7 +120,7 @@
   <p:extLst>
     <p:ext uri="{521415D9-36F7-43E2-AB2F-B90AF26B5E84}">
       <p14:sectionLst xmlns:p14="http://schemas.microsoft.com/office/powerpoint/2010/main">
-        <p14:section name="Opening" id="{66232072-5ce4-fc8d-724d-12034e6c9281}">
+        <p14:section name="Opening" id="{b3036143-0614-3c46-bf62-ec9af268fe5d}">
           <p14:sldIdLst>
             <p14:sldId id="256"/>
             <p14:sldId id="257"/>
@@ -130,13 +130,13 @@
             <p14:sldId id="261"/>
           </p14:sldIdLst>
         </p14:section>
-        <p14:section name="The model" id="{d7cb94e2-5df4-89f5-6685-eb87c59aafa0}">
+        <p14:section name="The model" id="{43417378-c602-8ba3-0a7f-452f30f7e1e7}">
           <p14:sldIdLst>
             <p14:sldId id="262"/>
             <p14:sldId id="263"/>
           </p14:sldIdLst>
         </p14:section>
-        <p14:section name="Results" id="{364aee76-b905-e268-56f7-081d18027cb5}">
+        <p14:section name="Results" id="{71db07c4-e67e-e358-943e-965b0b2daefe}">
           <p14:sldIdLst>
             <p14:sldId id="264"/>
             <p14:sldId id="265"/>
@@ -144,12 +144,12 @@
             <p14:sldId id="267"/>
           </p14:sldIdLst>
         </p14:section>
-        <p14:section name="Validation" id="{997b9967-b4e6-de0c-9ffe-0857759d3860}">
+        <p14:section name="Validation" id="{4089247c-afd4-ecb0-0708-96d26b089efc}">
           <p14:sldIdLst>
             <p14:sldId id="268"/>
           </p14:sldIdLst>
         </p14:section>
-        <p14:section name="Close" id="{f940eb86-0f47-7546-2ea4-cc08e2c6a39a}">
+        <p14:section name="Close" id="{89048555-bdaa-8ff0-84d9-d74506216e4c}">
           <p14:sldIdLst>
             <p14:sldId id="269"/>
           </p14:sldIdLst>
@@ -4976,7 +4976,7 @@
                   <a:schemeClr val="tx2"/>
                 </a:solidFill>
               </a:rPr>
-              <a:t>Variation in interpretation</a:t>
+              <a:t>Who runs? Variation in interpretation</a:t>
             </a:r>
             <a:endParaRPr lang="en-US" sz="2400" dirty="0"/>
           </a:p>

</xml_diff>

<commit_message>
Deck: equation slide stripped to the formula and the wedge line
Co-Authored-By: Claude Fable 5.1 <noreply@anthropic.com>
</commit_message>
<xml_diff>
--- a/docs/deck_2026-10-26_seminar.pptx
+++ b/docs/deck_2026-10-26_seminar.pptx
@@ -120,7 +120,7 @@
   <p:extLst>
     <p:ext uri="{521415D9-36F7-43E2-AB2F-B90AF26B5E84}">
       <p14:sectionLst xmlns:p14="http://schemas.microsoft.com/office/powerpoint/2010/main">
-        <p14:section name="Opening" id="{b3036143-0614-3c46-bf62-ec9af268fe5d}">
+        <p14:section name="Opening" id="{73d3a8d4-57fe-0bbe-d4aa-2b6454c48607}">
           <p14:sldIdLst>
             <p14:sldId id="256"/>
             <p14:sldId id="257"/>
@@ -130,13 +130,13 @@
             <p14:sldId id="261"/>
           </p14:sldIdLst>
         </p14:section>
-        <p14:section name="The model" id="{43417378-c602-8ba3-0a7f-452f30f7e1e7}">
+        <p14:section name="The model" id="{d28270cd-b6b6-5513-8b00-6b6d52f7d89e}">
           <p14:sldIdLst>
             <p14:sldId id="262"/>
             <p14:sldId id="263"/>
           </p14:sldIdLst>
         </p14:section>
-        <p14:section name="Results" id="{71db07c4-e67e-e358-943e-965b0b2daefe}">
+        <p14:section name="Results" id="{e7b0b13f-a173-4d8d-40de-b16682c38755}">
           <p14:sldIdLst>
             <p14:sldId id="264"/>
             <p14:sldId id="265"/>
@@ -144,12 +144,12 @@
             <p14:sldId id="267"/>
           </p14:sldIdLst>
         </p14:section>
-        <p14:section name="Validation" id="{4089247c-afd4-ecb0-0708-96d26b089efc}">
+        <p14:section name="Validation" id="{4f732cc8-e8ee-206b-b417-45ddd17b6918}">
           <p14:sldIdLst>
             <p14:sldId id="268"/>
           </p14:sldIdLst>
         </p14:section>
-        <p14:section name="Close" id="{89048555-bdaa-8ff0-84d9-d74506216e4c}">
+        <p14:section name="Close" id="{f643f2dc-3ac9-6137-0b4a-b23a5b1347cd}">
           <p14:sldIdLst>
             <p14:sldId id="269"/>
           </p14:sldIdLst>
@@ -5450,40 +5450,13 @@
       </p:sp>
       <p:sp>
         <p:nvSpPr>
-          <p:cNvPr id="3" name="eq-card"/>
-          <p:cNvSpPr/>
-          <p:nvPr/>
-        </p:nvSpPr>
-        <p:spPr>
-          <a:xfrm>
-            <a:off x="457200" y="1051560"/>
-            <a:ext cx="8229600" cy="1143000"/>
-          </a:xfrm>
-          <a:prstGeom prst="roundRect">
-            <a:avLst>
-              <a:gd name="adj" fmla="val 6400"/>
-            </a:avLst>
-          </a:prstGeom>
-          <a:solidFill>
-            <a:schemeClr val="accent4"/>
-          </a:solidFill>
-          <a:ln w="12700">
-            <a:solidFill>
-              <a:schemeClr val="accent4"/>
-            </a:solidFill>
-            <a:prstDash val="solid"/>
-          </a:ln>
-        </p:spPr>
-      </p:sp>
-      <p:sp>
-        <p:nvSpPr>
-          <p:cNvPr id="4" name="eq"/>
+          <p:cNvPr id="3" name="eq"/>
           <p:cNvSpPr txBox="1"/>
           <p:nvPr/>
         </p:nvSpPr>
         <p:spPr>
           <a:xfrm>
-            <a:off x="640080" y="1097280"/>
+            <a:off x="640080" y="1371600"/>
             <a:ext cx="7863840" cy="685800"/>
           </a:xfrm>
           <a:prstGeom prst="rect">
@@ -5656,13 +5629,13 @@
       </p:sp>
       <p:sp>
         <p:nvSpPr>
-          <p:cNvPr id="5" name="eq-sub"/>
+          <p:cNvPr id="4" name="eq-sub"/>
           <p:cNvSpPr txBox="1"/>
           <p:nvPr/>
         </p:nvSpPr>
         <p:spPr>
           <a:xfrm>
-            <a:off x="640080" y="1783080"/>
+            <a:off x="640080" y="2103120"/>
             <a:ext cx="7863840" cy="320040"/>
           </a:xfrm>
           <a:prstGeom prst="rect">
@@ -5692,41 +5665,14 @@
       </p:sp>
       <p:sp>
         <p:nvSpPr>
-          <p:cNvPr id="6" name="term-0"/>
-          <p:cNvSpPr/>
-          <p:nvPr/>
-        </p:nvSpPr>
-        <p:spPr>
-          <a:xfrm>
-            <a:off x="457200" y="2331720"/>
-            <a:ext cx="2651760" cy="1188720"/>
-          </a:xfrm>
-          <a:prstGeom prst="roundRect">
-            <a:avLst>
-              <a:gd name="adj" fmla="val 6154"/>
-            </a:avLst>
-          </a:prstGeom>
-          <a:solidFill>
-            <a:schemeClr val="bg2"/>
-          </a:solidFill>
-          <a:ln w="12700">
-            <a:solidFill>
-              <a:schemeClr val="bg2"/>
-            </a:solidFill>
-            <a:prstDash val="solid"/>
-          </a:ln>
-        </p:spPr>
-      </p:sp>
-      <p:sp>
-        <p:nvSpPr>
-          <p:cNvPr id="7" name="term-head"/>
+          <p:cNvPr id="5" name="wedge"/>
           <p:cNvSpPr txBox="1"/>
           <p:nvPr/>
         </p:nvSpPr>
         <p:spPr>
           <a:xfrm>
-            <a:off x="594360" y="2377440"/>
-            <a:ext cx="2423160" cy="457200"/>
+            <a:off x="457200" y="3017520"/>
+            <a:ext cx="8229600" cy="777240"/>
           </a:xfrm>
           <a:prstGeom prst="rect">
             <a:avLst/>
@@ -5735,595 +5681,252 @@
           <a:ln/>
         </p:spPr>
         <p:txBody>
-          <a:bodyPr wrap="square" lIns="0" tIns="0" rIns="0" bIns="0" rtlCol="0" anchor="ctr"/>
-          <a:lstStyle/>
-          <a:p>
-            <a:pPr indent="0" marL="0">
-              <a:buNone/>
-            </a:pPr>
-            <a:r>
-              <a:rPr lang="en-US" sz="2200" i="1" dirty="0">
+          <a:bodyPr wrap="square" lIns="0" tIns="0" rIns="0" bIns="0" rtlCol="0" anchor="t"/>
+          <a:lstStyle/>
+          <a:p>
+            <a:pPr algn="ctr" indent="0" marL="0">
+              <a:buNone/>
+            </a:pPr>
+            <a:r>
+              <a:rPr lang="en-US" sz="1400" b="1" dirty="0">
+                <a:solidFill>
+                  <a:srgbClr val="EB6834"/>
+                </a:solidFill>
+              </a:rPr>
+              <a:t>Individualists </a:t>
+            </a:r>
+            <a:pPr algn="ctr" indent="0" marL="0">
+              <a:buNone/>
+            </a:pPr>
+            <a:r>
+              <a:rPr lang="en-US" sz="1400" dirty="0">
+                <a:solidFill>
+                  <a:schemeClr val="tx1"/>
+                </a:solidFill>
+              </a:rPr>
+              <a:t>λ</a:t>
+            </a:r>
+            <a:pPr algn="ctr" indent="0" marL="0">
+              <a:buNone/>
+            </a:pPr>
+            <a:r>
+              <a:rPr lang="en-US" sz="1400" baseline="-40000" dirty="0">
+                <a:solidFill>
+                  <a:schemeClr val="tx1"/>
+                </a:solidFill>
+              </a:rPr>
+              <a:t>I</a:t>
+            </a:r>
+            <a:pPr algn="ctr" indent="0" marL="0">
+              <a:buNone/>
+            </a:pPr>
+            <a:r>
+              <a:rPr lang="en-US" sz="1400" dirty="0">
+                <a:solidFill>
+                  <a:schemeClr val="tx1"/>
+                </a:solidFill>
+              </a:rPr>
+              <a:t>  &lt;  λ</a:t>
+            </a:r>
+            <a:pPr algn="ctr" indent="0" marL="0">
+              <a:buNone/>
+            </a:pPr>
+            <a:r>
+              <a:rPr lang="en-US" sz="1400" baseline="-40000" dirty="0">
+                <a:solidFill>
+                  <a:schemeClr val="tx1"/>
+                </a:solidFill>
+              </a:rPr>
+              <a:t>C</a:t>
+            </a:r>
+            <a:pPr algn="ctr" indent="0" marL="0">
+              <a:buNone/>
+            </a:pPr>
+            <a:r>
+              <a:rPr lang="en-US" sz="1400" b="1" dirty="0">
+                <a:solidFill>
+                  <a:srgbClr val="2A78D6"/>
+                </a:solidFill>
+              </a:rPr>
+              <a:t> collectivists</a:t>
+            </a:r>
+            <a:pPr algn="ctr" indent="0" marL="0">
+              <a:buNone/>
+            </a:pPr>
+            <a:r>
+              <a:rPr lang="en-US" sz="1400" dirty="0">
+                <a:solidFill>
+                  <a:schemeClr val="tx1"/>
+                </a:solidFill>
+              </a:rPr>
+              <a:t>.  Same two signals, different estimates: </a:t>
+            </a:r>
+            <a:pPr algn="ctr" indent="0" marL="0">
+              <a:buNone/>
+            </a:pPr>
+            <a:r>
+              <a:rPr lang="en-US" sz="1400" i="1" dirty="0">
+                <a:solidFill>
+                  <a:schemeClr val="tx1"/>
+                </a:solidFill>
+              </a:rPr>
+              <a:t>ŝ</a:t>
+            </a:r>
+            <a:pPr algn="ctr" indent="0" marL="0">
+              <a:buNone/>
+            </a:pPr>
+            <a:r>
+              <a:rPr lang="en-US" sz="1400" baseline="-40000" dirty="0">
+                <a:solidFill>
+                  <a:schemeClr val="tx1"/>
+                </a:solidFill>
+              </a:rPr>
+              <a:t>I</a:t>
+            </a:r>
+            <a:pPr algn="ctr" indent="0" marL="0">
+              <a:buNone/>
+            </a:pPr>
+            <a:r>
+              <a:rPr lang="en-US" sz="1400" dirty="0">
+                <a:solidFill>
+                  <a:schemeClr val="tx1"/>
+                </a:solidFill>
+              </a:rPr>
+              <a:t> − </a:t>
+            </a:r>
+            <a:pPr algn="ctr" indent="0" marL="0">
+              <a:buNone/>
+            </a:pPr>
+            <a:r>
+              <a:rPr lang="en-US" sz="1400" i="1" dirty="0">
+                <a:solidFill>
+                  <a:schemeClr val="tx1"/>
+                </a:solidFill>
+              </a:rPr>
+              <a:t>ŝ</a:t>
+            </a:r>
+            <a:pPr algn="ctr" indent="0" marL="0">
+              <a:buNone/>
+            </a:pPr>
+            <a:r>
+              <a:rPr lang="en-US" sz="1400" baseline="-40000" dirty="0">
+                <a:solidFill>
+                  <a:schemeClr val="tx1"/>
+                </a:solidFill>
+              </a:rPr>
+              <a:t>C</a:t>
+            </a:r>
+            <a:pPr algn="ctr" indent="0" marL="0">
+              <a:buNone/>
+            </a:pPr>
+            <a:r>
+              <a:rPr lang="en-US" sz="1400" dirty="0">
+                <a:solidFill>
+                  <a:schemeClr val="tx1"/>
+                </a:solidFill>
+              </a:rPr>
+              <a:t> = (λ</a:t>
+            </a:r>
+            <a:pPr algn="ctr" indent="0" marL="0">
+              <a:buNone/>
+            </a:pPr>
+            <a:r>
+              <a:rPr lang="en-US" sz="1400" baseline="-40000" dirty="0">
+                <a:solidFill>
+                  <a:schemeClr val="tx1"/>
+                </a:solidFill>
+              </a:rPr>
+              <a:t>C</a:t>
+            </a:r>
+            <a:pPr algn="ctr" indent="0" marL="0">
+              <a:buNone/>
+            </a:pPr>
+            <a:r>
+              <a:rPr lang="en-US" sz="1400" dirty="0">
+                <a:solidFill>
+                  <a:schemeClr val="tx1"/>
+                </a:solidFill>
+              </a:rPr>
+              <a:t> − λ</a:t>
+            </a:r>
+            <a:pPr algn="ctr" indent="0" marL="0">
+              <a:buNone/>
+            </a:pPr>
+            <a:r>
+              <a:rPr lang="en-US" sz="1400" baseline="-40000" dirty="0">
+                <a:solidFill>
+                  <a:schemeClr val="tx1"/>
+                </a:solidFill>
+              </a:rPr>
+              <a:t>I</a:t>
+            </a:r>
+            <a:pPr algn="ctr" indent="0" marL="0">
+              <a:buNone/>
+            </a:pPr>
+            <a:r>
+              <a:rPr lang="en-US" sz="1400" dirty="0">
+                <a:solidFill>
+                  <a:schemeClr val="tx1"/>
+                </a:solidFill>
+              </a:rPr>
+              <a:t>)(</a:t>
+            </a:r>
+            <a:pPr algn="ctr" indent="0" marL="0">
+              <a:buNone/>
+            </a:pPr>
+            <a:r>
+              <a:rPr lang="en-US" sz="1400" i="1" dirty="0">
+                <a:solidFill>
+                  <a:schemeClr val="tx1"/>
+                </a:solidFill>
+              </a:rPr>
+              <a:t>x</a:t>
+            </a:r>
+            <a:pPr algn="ctr" indent="0" marL="0">
+              <a:buNone/>
+            </a:pPr>
+            <a:r>
+              <a:rPr lang="en-US" sz="1400" dirty="0">
+                <a:solidFill>
+                  <a:schemeClr val="tx1"/>
+                </a:solidFill>
+              </a:rPr>
+              <a:t> − </a:t>
+            </a:r>
+            <a:pPr algn="ctr" indent="0" marL="0">
+              <a:buNone/>
+            </a:pPr>
+            <a:r>
+              <a:rPr lang="en-US" sz="1400" i="1" dirty="0">
+                <a:solidFill>
+                  <a:schemeClr val="tx1"/>
+                </a:solidFill>
+              </a:rPr>
+              <a:t>y</a:t>
+            </a:r>
+            <a:pPr algn="ctr" indent="0" marL="0">
+              <a:buNone/>
+            </a:pPr>
+            <a:r>
+              <a:rPr lang="en-US" sz="1400" dirty="0">
+                <a:solidFill>
+                  <a:schemeClr val="tx1"/>
+                </a:solidFill>
+              </a:rPr>
+              <a:t>). </a:t>
+            </a:r>
+            <a:pPr algn="ctr" indent="0" marL="0">
+              <a:buNone/>
+            </a:pPr>
+            <a:r>
+              <a:rPr lang="en-US" sz="1400" b="1" dirty="0">
                 <a:solidFill>
                   <a:schemeClr val="tx2"/>
                 </a:solidFill>
-                <a:latin typeface="Cambria" pitchFamily="34" charset="0"/>
-                <a:ea typeface="Cambria" pitchFamily="34" charset="-122"/>
-                <a:cs typeface="Cambria" pitchFamily="34" charset="-120"/>
-              </a:rPr>
-              <a:t>x</a:t>
-            </a:r>
-            <a:pPr indent="0" marL="0">
-              <a:buNone/>
-            </a:pPr>
-            <a:r>
-              <a:rPr lang="en-US" sz="2200" i="1" baseline="-40000" dirty="0">
-                <a:solidFill>
-                  <a:schemeClr val="tx2"/>
-                </a:solidFill>
-                <a:latin typeface="Cambria" pitchFamily="34" charset="0"/>
-                <a:ea typeface="Cambria" pitchFamily="34" charset="-122"/>
-                <a:cs typeface="Cambria" pitchFamily="34" charset="-120"/>
-              </a:rPr>
-              <a:t>i</a:t>
-            </a:r>
-            <a:pPr indent="0" marL="0">
-              <a:buNone/>
-            </a:pPr>
-            <a:r>
-              <a:rPr lang="en-US" sz="1250" b="1" dirty="0">
-                <a:solidFill>
-                  <a:schemeClr val="tx1"/>
-                </a:solidFill>
-              </a:rPr>
-              <a:t>   what the depositor sees</a:t>
-            </a:r>
-            <a:endParaRPr lang="en-US" sz="2200" dirty="0"/>
-          </a:p>
-        </p:txBody>
-      </p:sp>
-      <p:sp>
-        <p:nvSpPr>
-          <p:cNvPr id="8" name="term-body"/>
-          <p:cNvSpPr txBox="1"/>
-          <p:nvPr/>
-        </p:nvSpPr>
-        <p:spPr>
-          <a:xfrm>
-            <a:off x="594360" y="2834640"/>
-            <a:ext cx="2423160" cy="640080"/>
-          </a:xfrm>
-          <a:prstGeom prst="rect">
-            <a:avLst/>
-          </a:prstGeom>
-          <a:noFill/>
-          <a:ln/>
-        </p:spPr>
-        <p:txBody>
-          <a:bodyPr wrap="square" lIns="0" tIns="0" rIns="0" bIns="0" rtlCol="0" anchor="t"/>
-          <a:lstStyle/>
-          <a:p>
-            <a:pPr indent="0" marL="0">
-              <a:buNone/>
-            </a:pPr>
-            <a:r>
-              <a:rPr lang="en-US" sz="1150" dirty="0">
-                <a:solidFill>
-                  <a:schemeClr val="accent3"/>
-                </a:solidFill>
-              </a:rPr>
-              <a:t>a private signal of the fundamental, one noisy draw each</a:t>
-            </a:r>
-            <a:endParaRPr lang="en-US" sz="1150" dirty="0"/>
-          </a:p>
-        </p:txBody>
-      </p:sp>
-      <p:sp>
-        <p:nvSpPr>
-          <p:cNvPr id="9" name="term-1"/>
-          <p:cNvSpPr/>
-          <p:nvPr/>
-        </p:nvSpPr>
-        <p:spPr>
-          <a:xfrm>
-            <a:off x="3246120" y="2331720"/>
-            <a:ext cx="2651760" cy="1188720"/>
-          </a:xfrm>
-          <a:prstGeom prst="roundRect">
-            <a:avLst>
-              <a:gd name="adj" fmla="val 6154"/>
-            </a:avLst>
-          </a:prstGeom>
-          <a:solidFill>
-            <a:schemeClr val="bg2"/>
-          </a:solidFill>
-          <a:ln w="12700">
-            <a:solidFill>
-              <a:schemeClr val="bg2"/>
-            </a:solidFill>
-            <a:prstDash val="solid"/>
-          </a:ln>
-        </p:spPr>
-      </p:sp>
-      <p:sp>
-        <p:nvSpPr>
-          <p:cNvPr id="10" name="term-head"/>
-          <p:cNvSpPr txBox="1"/>
-          <p:nvPr/>
-        </p:nvSpPr>
-        <p:spPr>
-          <a:xfrm>
-            <a:off x="3383280" y="2377440"/>
-            <a:ext cx="2423160" cy="457200"/>
-          </a:xfrm>
-          <a:prstGeom prst="rect">
-            <a:avLst/>
-          </a:prstGeom>
-          <a:noFill/>
-          <a:ln/>
-        </p:spPr>
-        <p:txBody>
-          <a:bodyPr wrap="square" lIns="0" tIns="0" rIns="0" bIns="0" rtlCol="0" anchor="ctr"/>
-          <a:lstStyle/>
-          <a:p>
-            <a:pPr indent="0" marL="0">
-              <a:buNone/>
-            </a:pPr>
-            <a:r>
-              <a:rPr lang="en-US" sz="2200" i="1" dirty="0">
-                <a:solidFill>
-                  <a:schemeClr val="accent3"/>
-                </a:solidFill>
-                <a:latin typeface="Cambria" pitchFamily="34" charset="0"/>
-                <a:ea typeface="Cambria" pitchFamily="34" charset="-122"/>
-                <a:cs typeface="Cambria" pitchFamily="34" charset="-120"/>
-              </a:rPr>
-              <a:t>y</a:t>
-            </a:r>
-            <a:pPr indent="0" marL="0">
-              <a:buNone/>
-            </a:pPr>
-            <a:pPr indent="0" marL="0">
-              <a:buNone/>
-            </a:pPr>
-            <a:r>
-              <a:rPr lang="en-US" sz="1250" b="1" dirty="0">
-                <a:solidFill>
-                  <a:schemeClr val="tx1"/>
-                </a:solidFill>
-              </a:rPr>
-              <a:t>   what the depositor is told</a:t>
-            </a:r>
-            <a:endParaRPr lang="en-US" sz="2200" dirty="0"/>
-          </a:p>
-        </p:txBody>
-      </p:sp>
-      <p:sp>
-        <p:nvSpPr>
-          <p:cNvPr id="11" name="term-body"/>
-          <p:cNvSpPr txBox="1"/>
-          <p:nvPr/>
-        </p:nvSpPr>
-        <p:spPr>
-          <a:xfrm>
-            <a:off x="3383280" y="2834640"/>
-            <a:ext cx="2423160" cy="640080"/>
-          </a:xfrm>
-          <a:prstGeom prst="rect">
-            <a:avLst/>
-          </a:prstGeom>
-          <a:noFill/>
-          <a:ln/>
-        </p:spPr>
-        <p:txBody>
-          <a:bodyPr wrap="square" lIns="0" tIns="0" rIns="0" bIns="0" rtlCol="0" anchor="t"/>
-          <a:lstStyle/>
-          <a:p>
-            <a:pPr indent="0" marL="0">
-              <a:buNone/>
-            </a:pPr>
-            <a:r>
-              <a:rPr lang="en-US" sz="1150" dirty="0">
-                <a:solidFill>
-                  <a:schemeClr val="accent3"/>
-                </a:solidFill>
-              </a:rPr>
-              <a:t>a public signal, common to all, which can be stale</a:t>
-            </a:r>
-            <a:endParaRPr lang="en-US" sz="1150" dirty="0"/>
-          </a:p>
-        </p:txBody>
-      </p:sp>
-      <p:sp>
-        <p:nvSpPr>
-          <p:cNvPr id="12" name="term-2"/>
-          <p:cNvSpPr/>
-          <p:nvPr/>
-        </p:nvSpPr>
-        <p:spPr>
-          <a:xfrm>
-            <a:off x="6035040" y="2331720"/>
-            <a:ext cx="2651760" cy="1188720"/>
-          </a:xfrm>
-          <a:prstGeom prst="roundRect">
-            <a:avLst>
-              <a:gd name="adj" fmla="val 6154"/>
-            </a:avLst>
-          </a:prstGeom>
-          <a:solidFill>
-            <a:schemeClr val="bg2"/>
-          </a:solidFill>
-          <a:ln w="12700">
-            <a:solidFill>
-              <a:schemeClr val="bg2"/>
-            </a:solidFill>
-            <a:prstDash val="solid"/>
-          </a:ln>
-        </p:spPr>
-      </p:sp>
-      <p:sp>
-        <p:nvSpPr>
-          <p:cNvPr id="13" name="term-head"/>
-          <p:cNvSpPr txBox="1"/>
-          <p:nvPr/>
-        </p:nvSpPr>
-        <p:spPr>
-          <a:xfrm>
-            <a:off x="6172200" y="2377440"/>
-            <a:ext cx="2423160" cy="457200"/>
-          </a:xfrm>
-          <a:prstGeom prst="rect">
-            <a:avLst/>
-          </a:prstGeom>
-          <a:noFill/>
-          <a:ln/>
-        </p:spPr>
-        <p:txBody>
-          <a:bodyPr wrap="square" lIns="0" tIns="0" rIns="0" bIns="0" rtlCol="0" anchor="ctr"/>
-          <a:lstStyle/>
-          <a:p>
-            <a:pPr indent="0" marL="0">
-              <a:buNone/>
-            </a:pPr>
-            <a:r>
-              <a:rPr lang="en-US" sz="2200" i="1" dirty="0">
-                <a:solidFill>
-                  <a:schemeClr val="accent1"/>
-                </a:solidFill>
-                <a:latin typeface="Cambria" pitchFamily="34" charset="0"/>
-                <a:ea typeface="Cambria" pitchFamily="34" charset="-122"/>
-                <a:cs typeface="Cambria" pitchFamily="34" charset="-120"/>
-              </a:rPr>
-              <a:t>λ</a:t>
-            </a:r>
-            <a:pPr indent="0" marL="0">
-              <a:buNone/>
-            </a:pPr>
-            <a:r>
-              <a:rPr lang="en-US" sz="2200" i="1" baseline="-40000" dirty="0">
-                <a:solidFill>
-                  <a:schemeClr val="accent1"/>
-                </a:solidFill>
-                <a:latin typeface="Cambria" pitchFamily="34" charset="0"/>
-                <a:ea typeface="Cambria" pitchFamily="34" charset="-122"/>
-                <a:cs typeface="Cambria" pitchFamily="34" charset="-120"/>
-              </a:rPr>
-              <a:t>i</a:t>
-            </a:r>
-            <a:pPr indent="0" marL="0">
-              <a:buNone/>
-            </a:pPr>
-            <a:r>
-              <a:rPr lang="en-US" sz="1250" b="1" dirty="0">
-                <a:solidFill>
-                  <a:schemeClr val="tx1"/>
-                </a:solidFill>
-              </a:rPr>
-              <a:t>   weight on the public line</a:t>
-            </a:r>
-            <a:endParaRPr lang="en-US" sz="2200" dirty="0"/>
-          </a:p>
-        </p:txBody>
-      </p:sp>
-      <p:sp>
-        <p:nvSpPr>
-          <p:cNvPr id="14" name="term-body"/>
-          <p:cNvSpPr txBox="1"/>
-          <p:nvPr/>
-        </p:nvSpPr>
-        <p:spPr>
-          <a:xfrm>
-            <a:off x="6172200" y="2834640"/>
-            <a:ext cx="2423160" cy="640080"/>
-          </a:xfrm>
-          <a:prstGeom prst="rect">
-            <a:avLst/>
-          </a:prstGeom>
-          <a:noFill/>
-          <a:ln/>
-        </p:spPr>
-        <p:txBody>
-          <a:bodyPr wrap="square" lIns="0" tIns="0" rIns="0" bIns="0" rtlCol="0" anchor="t"/>
-          <a:lstStyle/>
-          <a:p>
-            <a:pPr indent="0" marL="0">
-              <a:buNone/>
-            </a:pPr>
-            <a:r>
-              <a:rPr lang="en-US" sz="1150" dirty="0">
-                <a:solidFill>
-                  <a:schemeClr val="accent3"/>
-                </a:solidFill>
-              </a:rPr>
-              <a:t>a disposition set before the run; culture is its source</a:t>
-            </a:r>
-            <a:endParaRPr lang="en-US" sz="1150" dirty="0"/>
-          </a:p>
-        </p:txBody>
-      </p:sp>
-      <p:sp>
-        <p:nvSpPr>
-          <p:cNvPr id="15" name="wedge"/>
-          <p:cNvSpPr txBox="1"/>
-          <p:nvPr/>
-        </p:nvSpPr>
-        <p:spPr>
-          <a:xfrm>
-            <a:off x="457200" y="3657600"/>
-            <a:ext cx="8229600" cy="777240"/>
-          </a:xfrm>
-          <a:prstGeom prst="rect">
-            <a:avLst/>
-          </a:prstGeom>
-          <a:noFill/>
-          <a:ln/>
-        </p:spPr>
-        <p:txBody>
-          <a:bodyPr wrap="square" lIns="0" tIns="0" rIns="0" bIns="0" rtlCol="0" anchor="t"/>
-          <a:lstStyle/>
-          <a:p>
-            <a:pPr indent="0" marL="0">
-              <a:buNone/>
-            </a:pPr>
-            <a:r>
-              <a:rPr lang="en-US" sz="1300" b="1" dirty="0">
-                <a:solidFill>
-                  <a:srgbClr val="EB6834"/>
-                </a:solidFill>
-              </a:rPr>
-              <a:t>Individualists </a:t>
-            </a:r>
-            <a:pPr indent="0" marL="0">
-              <a:buNone/>
-            </a:pPr>
-            <a:r>
-              <a:rPr lang="en-US" sz="1300" dirty="0">
-                <a:solidFill>
-                  <a:schemeClr val="tx1"/>
-                </a:solidFill>
-              </a:rPr>
-              <a:t>λ</a:t>
-            </a:r>
-            <a:pPr indent="0" marL="0">
-              <a:buNone/>
-            </a:pPr>
-            <a:r>
-              <a:rPr lang="en-US" sz="1300" baseline="-40000" dirty="0">
-                <a:solidFill>
-                  <a:schemeClr val="tx1"/>
-                </a:solidFill>
-              </a:rPr>
-              <a:t>I</a:t>
-            </a:r>
-            <a:pPr indent="0" marL="0">
-              <a:buNone/>
-            </a:pPr>
-            <a:r>
-              <a:rPr lang="en-US" sz="1300" dirty="0">
-                <a:solidFill>
-                  <a:schemeClr val="tx1"/>
-                </a:solidFill>
-              </a:rPr>
-              <a:t>  &lt;  λ</a:t>
-            </a:r>
-            <a:pPr indent="0" marL="0">
-              <a:buNone/>
-            </a:pPr>
-            <a:r>
-              <a:rPr lang="en-US" sz="1300" baseline="-40000" dirty="0">
-                <a:solidFill>
-                  <a:schemeClr val="tx1"/>
-                </a:solidFill>
-              </a:rPr>
-              <a:t>C</a:t>
-            </a:r>
-            <a:pPr indent="0" marL="0">
-              <a:buNone/>
-            </a:pPr>
-            <a:r>
-              <a:rPr lang="en-US" sz="1300" b="1" dirty="0">
-                <a:solidFill>
-                  <a:srgbClr val="2A78D6"/>
-                </a:solidFill>
-              </a:rPr>
-              <a:t> collectivists</a:t>
-            </a:r>
-            <a:pPr indent="0" marL="0">
-              <a:buNone/>
-            </a:pPr>
-            <a:r>
-              <a:rPr lang="en-US" sz="1300" dirty="0">
-                <a:solidFill>
-                  <a:schemeClr val="tx1"/>
-                </a:solidFill>
-              </a:rPr>
-              <a:t>.  Same two signals, different estimates: </a:t>
-            </a:r>
-            <a:pPr indent="0" marL="0">
-              <a:buNone/>
-            </a:pPr>
-            <a:r>
-              <a:rPr lang="en-US" sz="1300" i="1" dirty="0">
-                <a:solidFill>
-                  <a:schemeClr val="tx1"/>
-                </a:solidFill>
-              </a:rPr>
-              <a:t>ŝ</a:t>
-            </a:r>
-            <a:pPr indent="0" marL="0">
-              <a:buNone/>
-            </a:pPr>
-            <a:r>
-              <a:rPr lang="en-US" sz="1300" baseline="-40000" dirty="0">
-                <a:solidFill>
-                  <a:schemeClr val="tx1"/>
-                </a:solidFill>
-              </a:rPr>
-              <a:t>I</a:t>
-            </a:r>
-            <a:pPr indent="0" marL="0">
-              <a:buNone/>
-            </a:pPr>
-            <a:r>
-              <a:rPr lang="en-US" sz="1300" dirty="0">
-                <a:solidFill>
-                  <a:schemeClr val="tx1"/>
-                </a:solidFill>
-              </a:rPr>
-              <a:t> − </a:t>
-            </a:r>
-            <a:pPr indent="0" marL="0">
-              <a:buNone/>
-            </a:pPr>
-            <a:r>
-              <a:rPr lang="en-US" sz="1300" i="1" dirty="0">
-                <a:solidFill>
-                  <a:schemeClr val="tx1"/>
-                </a:solidFill>
-              </a:rPr>
-              <a:t>ŝ</a:t>
-            </a:r>
-            <a:pPr indent="0" marL="0">
-              <a:buNone/>
-            </a:pPr>
-            <a:r>
-              <a:rPr lang="en-US" sz="1300" baseline="-40000" dirty="0">
-                <a:solidFill>
-                  <a:schemeClr val="tx1"/>
-                </a:solidFill>
-              </a:rPr>
-              <a:t>C</a:t>
-            </a:r>
-            <a:pPr indent="0" marL="0">
-              <a:buNone/>
-            </a:pPr>
-            <a:r>
-              <a:rPr lang="en-US" sz="1300" dirty="0">
-                <a:solidFill>
-                  <a:schemeClr val="tx1"/>
-                </a:solidFill>
-              </a:rPr>
-              <a:t> = (λ</a:t>
-            </a:r>
-            <a:pPr indent="0" marL="0">
-              <a:buNone/>
-            </a:pPr>
-            <a:r>
-              <a:rPr lang="en-US" sz="1300" baseline="-40000" dirty="0">
-                <a:solidFill>
-                  <a:schemeClr val="tx1"/>
-                </a:solidFill>
-              </a:rPr>
-              <a:t>C</a:t>
-            </a:r>
-            <a:pPr indent="0" marL="0">
-              <a:buNone/>
-            </a:pPr>
-            <a:r>
-              <a:rPr lang="en-US" sz="1300" dirty="0">
-                <a:solidFill>
-                  <a:schemeClr val="tx1"/>
-                </a:solidFill>
-              </a:rPr>
-              <a:t> − λ</a:t>
-            </a:r>
-            <a:pPr indent="0" marL="0">
-              <a:buNone/>
-            </a:pPr>
-            <a:r>
-              <a:rPr lang="en-US" sz="1300" baseline="-40000" dirty="0">
-                <a:solidFill>
-                  <a:schemeClr val="tx1"/>
-                </a:solidFill>
-              </a:rPr>
-              <a:t>I</a:t>
-            </a:r>
-            <a:pPr indent="0" marL="0">
-              <a:buNone/>
-            </a:pPr>
-            <a:r>
-              <a:rPr lang="en-US" sz="1300" dirty="0">
-                <a:solidFill>
-                  <a:schemeClr val="tx1"/>
-                </a:solidFill>
-              </a:rPr>
-              <a:t>)(</a:t>
-            </a:r>
-            <a:pPr indent="0" marL="0">
-              <a:buNone/>
-            </a:pPr>
-            <a:r>
-              <a:rPr lang="en-US" sz="1300" i="1" dirty="0">
-                <a:solidFill>
-                  <a:schemeClr val="tx1"/>
-                </a:solidFill>
-              </a:rPr>
-              <a:t>x</a:t>
-            </a:r>
-            <a:pPr indent="0" marL="0">
-              <a:buNone/>
-            </a:pPr>
-            <a:r>
-              <a:rPr lang="en-US" sz="1300" dirty="0">
-                <a:solidFill>
-                  <a:schemeClr val="tx1"/>
-                </a:solidFill>
-              </a:rPr>
-              <a:t> − </a:t>
-            </a:r>
-            <a:pPr indent="0" marL="0">
-              <a:buNone/>
-            </a:pPr>
-            <a:r>
-              <a:rPr lang="en-US" sz="1300" i="1" dirty="0">
-                <a:solidFill>
-                  <a:schemeClr val="tx1"/>
-                </a:solidFill>
-              </a:rPr>
-              <a:t>y</a:t>
-            </a:r>
-            <a:pPr indent="0" marL="0">
-              <a:buNone/>
-            </a:pPr>
-            <a:r>
-              <a:rPr lang="en-US" sz="1300" dirty="0">
-                <a:solidFill>
-                  <a:schemeClr val="tx1"/>
-                </a:solidFill>
-              </a:rPr>
-              <a:t>). </a:t>
-            </a:r>
-            <a:pPr indent="0" marL="0">
-              <a:buNone/>
-            </a:pPr>
-            <a:r>
-              <a:rPr lang="en-US" sz="1300" b="1" dirty="0">
-                <a:solidFill>
-                  <a:schemeClr val="tx2"/>
-                </a:solidFill>
               </a:rPr>
               <a:t>Who runs is sorted by the weight, and the order flips with the sign of the public error.</a:t>
             </a:r>
-            <a:endParaRPr lang="en-US" sz="1300" dirty="0"/>
+            <a:endParaRPr lang="en-US" sz="1400" dirty="0"/>
           </a:p>
         </p:txBody>
       </p:sp>

</xml_diff>

<commit_message>
Deck: wedge line says which type runs more under optimistic vs pessimistic news
Co-Authored-By: Claude Fable 5.1 <noreply@anthropic.com>
</commit_message>
<xml_diff>
--- a/docs/deck_2026-10-26_seminar.pptx
+++ b/docs/deck_2026-10-26_seminar.pptx
@@ -120,7 +120,7 @@
   <p:extLst>
     <p:ext uri="{521415D9-36F7-43E2-AB2F-B90AF26B5E84}">
       <p14:sectionLst xmlns:p14="http://schemas.microsoft.com/office/powerpoint/2010/main">
-        <p14:section name="Opening" id="{73d3a8d4-57fe-0bbe-d4aa-2b6454c48607}">
+        <p14:section name="Opening" id="{323d20d6-e695-9e15-752b-5ddd667d8f45}">
           <p14:sldIdLst>
             <p14:sldId id="256"/>
             <p14:sldId id="257"/>
@@ -130,13 +130,13 @@
             <p14:sldId id="261"/>
           </p14:sldIdLst>
         </p14:section>
-        <p14:section name="The model" id="{d28270cd-b6b6-5513-8b00-6b6d52f7d89e}">
+        <p14:section name="The model" id="{6d5348b0-1b8b-fec1-10fd-5c57a3f13f00}">
           <p14:sldIdLst>
             <p14:sldId id="262"/>
             <p14:sldId id="263"/>
           </p14:sldIdLst>
         </p14:section>
-        <p14:section name="Results" id="{e7b0b13f-a173-4d8d-40de-b16682c38755}">
+        <p14:section name="Results" id="{97cfc799-ce7f-f93a-c311-a0a6d52329ae}">
           <p14:sldIdLst>
             <p14:sldId id="264"/>
             <p14:sldId id="265"/>
@@ -144,12 +144,12 @@
             <p14:sldId id="267"/>
           </p14:sldIdLst>
         </p14:section>
-        <p14:section name="Validation" id="{4f732cc8-e8ee-206b-b417-45ddd17b6918}">
+        <p14:section name="Validation" id="{dbd01375-bfb5-6f0c-ad03-c4cab584aaff}">
           <p14:sldIdLst>
             <p14:sldId id="268"/>
           </p14:sldIdLst>
         </p14:section>
-        <p14:section name="Close" id="{f643f2dc-3ac9-6137-0b4a-b23a5b1347cd}">
+        <p14:section name="Close" id="{dae37f5b-7041-83ff-1ce6-d3ac39617de2}">
           <p14:sldIdLst>
             <p14:sldId id="269"/>
           </p14:sldIdLst>
@@ -5671,8 +5671,8 @@
         </p:nvSpPr>
         <p:spPr>
           <a:xfrm>
-            <a:off x="457200" y="3017520"/>
-            <a:ext cx="8229600" cy="777240"/>
+            <a:off x="457200" y="2926080"/>
+            <a:ext cx="8229600" cy="1005840"/>
           </a:xfrm>
           <a:prstGeom prst="rect">
             <a:avLst/>
@@ -5924,7 +5924,7 @@
                   <a:schemeClr val="tx2"/>
                 </a:solidFill>
               </a:rPr>
-              <a:t>Who runs is sorted by the weight, and the order flips with the sign of the public error.</a:t>
+              <a:t>Which type runs more depends on which way the public line is wrong: too optimistic, individualists; too pessimistic, collectivists.</a:t>
             </a:r>
             <a:endParaRPr lang="en-US" sz="1400" dirty="0"/>
           </a:p>

</xml_diff>

<commit_message>
Deck: slide 6 is two equations, the type ordering between them, the which-type-runs sentence dropped
Co-Authored-By: Claude Fable 5.1 <noreply@anthropic.com>
</commit_message>
<xml_diff>
--- a/docs/deck_2026-10-26_seminar.pptx
+++ b/docs/deck_2026-10-26_seminar.pptx
@@ -120,7 +120,7 @@
   <p:extLst>
     <p:ext uri="{521415D9-36F7-43E2-AB2F-B90AF26B5E84}">
       <p14:sectionLst xmlns:p14="http://schemas.microsoft.com/office/powerpoint/2010/main">
-        <p14:section name="Opening" id="{323d20d6-e695-9e15-752b-5ddd667d8f45}">
+        <p14:section name="Opening" id="{e8d106ef-29f7-f7f3-a2b9-524ca082942b}">
           <p14:sldIdLst>
             <p14:sldId id="256"/>
             <p14:sldId id="257"/>
@@ -130,13 +130,13 @@
             <p14:sldId id="261"/>
           </p14:sldIdLst>
         </p14:section>
-        <p14:section name="The model" id="{6d5348b0-1b8b-fec1-10fd-5c57a3f13f00}">
+        <p14:section name="The model" id="{9b56c753-34b1-43c1-d0c9-371c72d9d2a8}">
           <p14:sldIdLst>
             <p14:sldId id="262"/>
             <p14:sldId id="263"/>
           </p14:sldIdLst>
         </p14:section>
-        <p14:section name="Results" id="{97cfc799-ce7f-f93a-c311-a0a6d52329ae}">
+        <p14:section name="Results" id="{ad2fb228-debd-565c-9452-6bdc6685c404}">
           <p14:sldIdLst>
             <p14:sldId id="264"/>
             <p14:sldId id="265"/>
@@ -144,12 +144,12 @@
             <p14:sldId id="267"/>
           </p14:sldIdLst>
         </p14:section>
-        <p14:section name="Validation" id="{dbd01375-bfb5-6f0c-ad03-c4cab584aaff}">
+        <p14:section name="Validation" id="{f1c3482c-3ea1-8f51-0634-0281b6ee2845}">
           <p14:sldIdLst>
             <p14:sldId id="268"/>
           </p14:sldIdLst>
         </p14:section>
-        <p14:section name="Close" id="{dae37f5b-7041-83ff-1ce6-d3ac39617de2}">
+        <p14:section name="Close" id="{77450113-6f20-144f-7834-f8030bbf41bf}">
           <p14:sldIdLst>
             <p14:sldId id="269"/>
           </p14:sldIdLst>
@@ -5456,7 +5456,7 @@
         </p:nvSpPr>
         <p:spPr>
           <a:xfrm>
-            <a:off x="640080" y="1371600"/>
+            <a:off x="640080" y="1097280"/>
             <a:ext cx="7863840" cy="685800"/>
           </a:xfrm>
           <a:prstGeom prst="rect">
@@ -5635,7 +5635,7 @@
         </p:nvSpPr>
         <p:spPr>
           <a:xfrm>
-            <a:off x="640080" y="2103120"/>
+            <a:off x="640080" y="1828800"/>
             <a:ext cx="7863840" cy="320040"/>
           </a:xfrm>
           <a:prstGeom prst="rect">
@@ -5665,14 +5665,14 @@
       </p:sp>
       <p:sp>
         <p:nvSpPr>
-          <p:cNvPr id="5" name="wedge"/>
+          <p:cNvPr id="5" name="types"/>
           <p:cNvSpPr txBox="1"/>
           <p:nvPr/>
         </p:nvSpPr>
         <p:spPr>
           <a:xfrm>
-            <a:off x="457200" y="2926080"/>
-            <a:ext cx="8229600" cy="1005840"/>
+            <a:off x="457200" y="2286000"/>
+            <a:ext cx="8229600" cy="411480"/>
           </a:xfrm>
           <a:prstGeom prst="rect">
             <a:avLst/>
@@ -5681,14 +5681,14 @@
           <a:ln/>
         </p:spPr>
         <p:txBody>
-          <a:bodyPr wrap="square" lIns="0" tIns="0" rIns="0" bIns="0" rtlCol="0" anchor="t"/>
+          <a:bodyPr wrap="square" lIns="0" tIns="0" rIns="0" bIns="0" rtlCol="0" anchor="ctr"/>
           <a:lstStyle/>
           <a:p>
             <a:pPr algn="ctr" indent="0" marL="0">
               <a:buNone/>
             </a:pPr>
             <a:r>
-              <a:rPr lang="en-US" sz="1400" b="1" dirty="0">
+              <a:rPr lang="en-US" sz="1600" b="1" dirty="0">
                 <a:solidFill>
                   <a:srgbClr val="EB6834"/>
                 </a:solidFill>
@@ -5699,7 +5699,7 @@
               <a:buNone/>
             </a:pPr>
             <a:r>
-              <a:rPr lang="en-US" sz="1400" dirty="0">
+              <a:rPr lang="en-US" sz="1600" dirty="0">
                 <a:solidFill>
                   <a:schemeClr val="tx1"/>
                 </a:solidFill>
@@ -5710,7 +5710,7 @@
               <a:buNone/>
             </a:pPr>
             <a:r>
-              <a:rPr lang="en-US" sz="1400" baseline="-40000" dirty="0">
+              <a:rPr lang="en-US" sz="1600" baseline="-40000" dirty="0">
                 <a:solidFill>
                   <a:schemeClr val="tx1"/>
                 </a:solidFill>
@@ -5721,7 +5721,7 @@
               <a:buNone/>
             </a:pPr>
             <a:r>
-              <a:rPr lang="en-US" sz="1400" dirty="0">
+              <a:rPr lang="en-US" sz="1600" dirty="0">
                 <a:solidFill>
                   <a:schemeClr val="tx1"/>
                 </a:solidFill>
@@ -5732,7 +5732,7 @@
               <a:buNone/>
             </a:pPr>
             <a:r>
-              <a:rPr lang="en-US" sz="1400" baseline="-40000" dirty="0">
+              <a:rPr lang="en-US" sz="1600" baseline="-40000" dirty="0">
                 <a:solidFill>
                   <a:schemeClr val="tx1"/>
                 </a:solidFill>
@@ -5743,32 +5743,91 @@
               <a:buNone/>
             </a:pPr>
             <a:r>
-              <a:rPr lang="en-US" sz="1400" b="1" dirty="0">
+              <a:rPr lang="en-US" sz="1600" b="1" dirty="0">
                 <a:solidFill>
                   <a:srgbClr val="2A78D6"/>
                 </a:solidFill>
               </a:rPr>
               <a:t> collectivists</a:t>
             </a:r>
+            <a:endParaRPr lang="en-US" sz="1600" dirty="0"/>
+          </a:p>
+        </p:txBody>
+      </p:sp>
+      <p:sp>
+        <p:nvSpPr>
+          <p:cNvPr id="6" name="eq2"/>
+          <p:cNvSpPr txBox="1"/>
+          <p:nvPr/>
+        </p:nvSpPr>
+        <p:spPr>
+          <a:xfrm>
+            <a:off x="640080" y="2834640"/>
+            <a:ext cx="7863840" cy="685800"/>
+          </a:xfrm>
+          <a:prstGeom prst="rect">
+            <a:avLst/>
+          </a:prstGeom>
+          <a:noFill/>
+          <a:ln/>
+        </p:spPr>
+        <p:txBody>
+          <a:bodyPr wrap="square" lIns="0" tIns="0" rIns="0" bIns="0" rtlCol="0" anchor="ctr"/>
+          <a:lstStyle/>
+          <a:p>
             <a:pPr algn="ctr" indent="0" marL="0">
               <a:buNone/>
             </a:pPr>
             <a:r>
-              <a:rPr lang="en-US" sz="1400" dirty="0">
-                <a:solidFill>
-                  <a:schemeClr val="tx1"/>
-                </a:solidFill>
-              </a:rPr>
-              <a:t>.  Same two signals, different estimates: </a:t>
+              <a:rPr lang="en-US" sz="3000" i="1" dirty="0">
+                <a:solidFill>
+                  <a:schemeClr val="tx2"/>
+                </a:solidFill>
+                <a:latin typeface="Cambria" pitchFamily="34" charset="0"/>
+                <a:ea typeface="Cambria" pitchFamily="34" charset="-122"/>
+                <a:cs typeface="Cambria" pitchFamily="34" charset="-120"/>
+              </a:rPr>
+              <a:t>ŝ</a:t>
             </a:r>
             <a:pPr algn="ctr" indent="0" marL="0">
               <a:buNone/>
             </a:pPr>
             <a:r>
-              <a:rPr lang="en-US" sz="1400" i="1" dirty="0">
-                <a:solidFill>
-                  <a:schemeClr val="tx1"/>
-                </a:solidFill>
+              <a:rPr lang="en-US" sz="3000" baseline="-40000" dirty="0">
+                <a:solidFill>
+                  <a:schemeClr val="tx2"/>
+                </a:solidFill>
+                <a:latin typeface="Cambria" pitchFamily="34" charset="0"/>
+                <a:ea typeface="Cambria" pitchFamily="34" charset="-122"/>
+                <a:cs typeface="Cambria" pitchFamily="34" charset="-120"/>
+              </a:rPr>
+              <a:t>I</a:t>
+            </a:r>
+            <a:pPr algn="ctr" indent="0" marL="0">
+              <a:buNone/>
+            </a:pPr>
+            <a:r>
+              <a:rPr lang="en-US" sz="3000" dirty="0">
+                <a:solidFill>
+                  <a:schemeClr val="tx2"/>
+                </a:solidFill>
+                <a:latin typeface="Cambria" pitchFamily="34" charset="0"/>
+                <a:ea typeface="Cambria" pitchFamily="34" charset="-122"/>
+                <a:cs typeface="Cambria" pitchFamily="34" charset="-120"/>
+              </a:rPr>
+              <a:t>  −  </a:t>
+            </a:r>
+            <a:pPr algn="ctr" indent="0" marL="0">
+              <a:buNone/>
+            </a:pPr>
+            <a:r>
+              <a:rPr lang="en-US" sz="3000" i="1" dirty="0">
+                <a:solidFill>
+                  <a:schemeClr val="tx2"/>
+                </a:solidFill>
+                <a:latin typeface="Cambria" pitchFamily="34" charset="0"/>
+                <a:ea typeface="Cambria" pitchFamily="34" charset="-122"/>
+                <a:cs typeface="Cambria" pitchFamily="34" charset="-120"/>
               </a:rPr>
               <a:t>ŝ</a:t>
             </a:r>
@@ -5776,10 +5835,69 @@
               <a:buNone/>
             </a:pPr>
             <a:r>
-              <a:rPr lang="en-US" sz="1400" baseline="-40000" dirty="0">
-                <a:solidFill>
-                  <a:schemeClr val="tx1"/>
-                </a:solidFill>
+              <a:rPr lang="en-US" sz="3000" baseline="-40000" dirty="0">
+                <a:solidFill>
+                  <a:schemeClr val="tx2"/>
+                </a:solidFill>
+                <a:latin typeface="Cambria" pitchFamily="34" charset="0"/>
+                <a:ea typeface="Cambria" pitchFamily="34" charset="-122"/>
+                <a:cs typeface="Cambria" pitchFamily="34" charset="-120"/>
+              </a:rPr>
+              <a:t>C</a:t>
+            </a:r>
+            <a:pPr algn="ctr" indent="0" marL="0">
+              <a:buNone/>
+            </a:pPr>
+            <a:r>
+              <a:rPr lang="en-US" sz="3000" dirty="0">
+                <a:solidFill>
+                  <a:schemeClr val="tx2"/>
+                </a:solidFill>
+                <a:latin typeface="Cambria" pitchFamily="34" charset="0"/>
+                <a:ea typeface="Cambria" pitchFamily="34" charset="-122"/>
+                <a:cs typeface="Cambria" pitchFamily="34" charset="-120"/>
+              </a:rPr>
+              <a:t>  =  (λ</a:t>
+            </a:r>
+            <a:pPr algn="ctr" indent="0" marL="0">
+              <a:buNone/>
+            </a:pPr>
+            <a:r>
+              <a:rPr lang="en-US" sz="3000" baseline="-40000" dirty="0">
+                <a:solidFill>
+                  <a:schemeClr val="tx2"/>
+                </a:solidFill>
+                <a:latin typeface="Cambria" pitchFamily="34" charset="0"/>
+                <a:ea typeface="Cambria" pitchFamily="34" charset="-122"/>
+                <a:cs typeface="Cambria" pitchFamily="34" charset="-120"/>
+              </a:rPr>
+              <a:t>C</a:t>
+            </a:r>
+            <a:pPr algn="ctr" indent="0" marL="0">
+              <a:buNone/>
+            </a:pPr>
+            <a:r>
+              <a:rPr lang="en-US" sz="3000" dirty="0">
+                <a:solidFill>
+                  <a:schemeClr val="tx2"/>
+                </a:solidFill>
+                <a:latin typeface="Cambria" pitchFamily="34" charset="0"/>
+                <a:ea typeface="Cambria" pitchFamily="34" charset="-122"/>
+                <a:cs typeface="Cambria" pitchFamily="34" charset="-120"/>
+              </a:rPr>
+              <a:t> − λ</a:t>
+            </a:r>
+            <a:pPr algn="ctr" indent="0" marL="0">
+              <a:buNone/>
+            </a:pPr>
+            <a:r>
+              <a:rPr lang="en-US" sz="3000" baseline="-40000" dirty="0">
+                <a:solidFill>
+                  <a:schemeClr val="tx2"/>
+                </a:solidFill>
+                <a:latin typeface="Cambria" pitchFamily="34" charset="0"/>
+                <a:ea typeface="Cambria" pitchFamily="34" charset="-122"/>
+                <a:cs typeface="Cambria" pitchFamily="34" charset="-120"/>
               </a:rPr>
               <a:t>I</a:t>
             </a:r>
@@ -5787,10 +5905,41 @@
               <a:buNone/>
             </a:pPr>
             <a:r>
-              <a:rPr lang="en-US" sz="1400" dirty="0">
-                <a:solidFill>
-                  <a:schemeClr val="tx1"/>
-                </a:solidFill>
+              <a:rPr lang="en-US" sz="3000" dirty="0">
+                <a:solidFill>
+                  <a:schemeClr val="tx2"/>
+                </a:solidFill>
+                <a:latin typeface="Cambria" pitchFamily="34" charset="0"/>
+                <a:ea typeface="Cambria" pitchFamily="34" charset="-122"/>
+                <a:cs typeface="Cambria" pitchFamily="34" charset="-120"/>
+              </a:rPr>
+              <a:t>) · (</a:t>
+            </a:r>
+            <a:pPr algn="ctr" indent="0" marL="0">
+              <a:buNone/>
+            </a:pPr>
+            <a:r>
+              <a:rPr lang="en-US" sz="3000" i="1" dirty="0">
+                <a:solidFill>
+                  <a:schemeClr val="tx2"/>
+                </a:solidFill>
+                <a:latin typeface="Cambria" pitchFamily="34" charset="0"/>
+                <a:ea typeface="Cambria" pitchFamily="34" charset="-122"/>
+                <a:cs typeface="Cambria" pitchFamily="34" charset="-120"/>
+              </a:rPr>
+              <a:t>x</a:t>
+            </a:r>
+            <a:pPr algn="ctr" indent="0" marL="0">
+              <a:buNone/>
+            </a:pPr>
+            <a:r>
+              <a:rPr lang="en-US" sz="3000" dirty="0">
+                <a:solidFill>
+                  <a:schemeClr val="tx2"/>
+                </a:solidFill>
+                <a:latin typeface="Cambria" pitchFamily="34" charset="0"/>
+                <a:ea typeface="Cambria" pitchFamily="34" charset="-122"/>
+                <a:cs typeface="Cambria" pitchFamily="34" charset="-120"/>
               </a:rPr>
               <a:t> − </a:t>
             </a:r>
@@ -5798,135 +5947,67 @@
               <a:buNone/>
             </a:pPr>
             <a:r>
-              <a:rPr lang="en-US" sz="1400" i="1" dirty="0">
-                <a:solidFill>
-                  <a:schemeClr val="tx1"/>
-                </a:solidFill>
-              </a:rPr>
-              <a:t>ŝ</a:t>
+              <a:rPr lang="en-US" sz="3000" i="1" dirty="0">
+                <a:solidFill>
+                  <a:schemeClr val="tx2"/>
+                </a:solidFill>
+                <a:latin typeface="Cambria" pitchFamily="34" charset="0"/>
+                <a:ea typeface="Cambria" pitchFamily="34" charset="-122"/>
+                <a:cs typeface="Cambria" pitchFamily="34" charset="-120"/>
+              </a:rPr>
+              <a:t>y</a:t>
             </a:r>
             <a:pPr algn="ctr" indent="0" marL="0">
               <a:buNone/>
             </a:pPr>
             <a:r>
-              <a:rPr lang="en-US" sz="1400" baseline="-40000" dirty="0">
-                <a:solidFill>
-                  <a:schemeClr val="tx1"/>
-                </a:solidFill>
-              </a:rPr>
-              <a:t>C</a:t>
-            </a:r>
+              <a:rPr lang="en-US" sz="3000" dirty="0">
+                <a:solidFill>
+                  <a:schemeClr val="tx2"/>
+                </a:solidFill>
+                <a:latin typeface="Cambria" pitchFamily="34" charset="0"/>
+                <a:ea typeface="Cambria" pitchFamily="34" charset="-122"/>
+                <a:cs typeface="Cambria" pitchFamily="34" charset="-120"/>
+              </a:rPr>
+              <a:t>)</a:t>
+            </a:r>
+            <a:endParaRPr lang="en-US" sz="3000" dirty="0"/>
+          </a:p>
+        </p:txBody>
+      </p:sp>
+      <p:sp>
+        <p:nvSpPr>
+          <p:cNvPr id="7" name="eq2-sub"/>
+          <p:cNvSpPr txBox="1"/>
+          <p:nvPr/>
+        </p:nvSpPr>
+        <p:spPr>
+          <a:xfrm>
+            <a:off x="640080" y="3566160"/>
+            <a:ext cx="7863840" cy="320040"/>
+          </a:xfrm>
+          <a:prstGeom prst="rect">
+            <a:avLst/>
+          </a:prstGeom>
+          <a:noFill/>
+          <a:ln/>
+        </p:spPr>
+        <p:txBody>
+          <a:bodyPr wrap="square" lIns="0" tIns="0" rIns="0" bIns="0" rtlCol="0" anchor="ctr"/>
+          <a:lstStyle/>
+          <a:p>
             <a:pPr algn="ctr" indent="0" marL="0">
               <a:buNone/>
             </a:pPr>
             <a:r>
-              <a:rPr lang="en-US" sz="1400" dirty="0">
-                <a:solidFill>
-                  <a:schemeClr val="tx1"/>
-                </a:solidFill>
-              </a:rPr>
-              <a:t> = (λ</a:t>
-            </a:r>
-            <a:pPr algn="ctr" indent="0" marL="0">
-              <a:buNone/>
-            </a:pPr>
-            <a:r>
-              <a:rPr lang="en-US" sz="1400" baseline="-40000" dirty="0">
-                <a:solidFill>
-                  <a:schemeClr val="tx1"/>
-                </a:solidFill>
-              </a:rPr>
-              <a:t>C</a:t>
-            </a:r>
-            <a:pPr algn="ctr" indent="0" marL="0">
-              <a:buNone/>
-            </a:pPr>
-            <a:r>
-              <a:rPr lang="en-US" sz="1400" dirty="0">
-                <a:solidFill>
-                  <a:schemeClr val="tx1"/>
-                </a:solidFill>
-              </a:rPr>
-              <a:t> − λ</a:t>
-            </a:r>
-            <a:pPr algn="ctr" indent="0" marL="0">
-              <a:buNone/>
-            </a:pPr>
-            <a:r>
-              <a:rPr lang="en-US" sz="1400" baseline="-40000" dirty="0">
-                <a:solidFill>
-                  <a:schemeClr val="tx1"/>
-                </a:solidFill>
-              </a:rPr>
-              <a:t>I</a:t>
-            </a:r>
-            <a:pPr algn="ctr" indent="0" marL="0">
-              <a:buNone/>
-            </a:pPr>
-            <a:r>
-              <a:rPr lang="en-US" sz="1400" dirty="0">
-                <a:solidFill>
-                  <a:schemeClr val="tx1"/>
-                </a:solidFill>
-              </a:rPr>
-              <a:t>)(</a:t>
-            </a:r>
-            <a:pPr algn="ctr" indent="0" marL="0">
-              <a:buNone/>
-            </a:pPr>
-            <a:r>
-              <a:rPr lang="en-US" sz="1400" i="1" dirty="0">
-                <a:solidFill>
-                  <a:schemeClr val="tx1"/>
-                </a:solidFill>
-              </a:rPr>
-              <a:t>x</a:t>
-            </a:r>
-            <a:pPr algn="ctr" indent="0" marL="0">
-              <a:buNone/>
-            </a:pPr>
-            <a:r>
-              <a:rPr lang="en-US" sz="1400" dirty="0">
-                <a:solidFill>
-                  <a:schemeClr val="tx1"/>
-                </a:solidFill>
-              </a:rPr>
-              <a:t> − </a:t>
-            </a:r>
-            <a:pPr algn="ctr" indent="0" marL="0">
-              <a:buNone/>
-            </a:pPr>
-            <a:r>
-              <a:rPr lang="en-US" sz="1400" i="1" dirty="0">
-                <a:solidFill>
-                  <a:schemeClr val="tx1"/>
-                </a:solidFill>
-              </a:rPr>
-              <a:t>y</a:t>
-            </a:r>
-            <a:pPr algn="ctr" indent="0" marL="0">
-              <a:buNone/>
-            </a:pPr>
-            <a:r>
-              <a:rPr lang="en-US" sz="1400" dirty="0">
-                <a:solidFill>
-                  <a:schemeClr val="tx1"/>
-                </a:solidFill>
-              </a:rPr>
-              <a:t>). </a:t>
-            </a:r>
-            <a:pPr algn="ctr" indent="0" marL="0">
-              <a:buNone/>
-            </a:pPr>
-            <a:r>
-              <a:rPr lang="en-US" sz="1400" b="1" dirty="0">
-                <a:solidFill>
-                  <a:schemeClr val="tx2"/>
-                </a:solidFill>
-              </a:rPr>
-              <a:t>Which type runs more depends on which way the public line is wrong: too optimistic, individualists; too pessimistic, collectivists.</a:t>
-            </a:r>
-            <a:endParaRPr lang="en-US" sz="1400" dirty="0"/>
+              <a:rPr lang="en-US" sz="1200" i="1" dirty="0">
+                <a:solidFill>
+                  <a:schemeClr val="accent3"/>
+                </a:solidFill>
+              </a:rPr>
+              <a:t>same two signals, different estimates</a:t>
+            </a:r>
+            <a:endParaRPr lang="en-US" sz="1200" dirty="0"/>
           </a:p>
         </p:txBody>
       </p:sp>

</xml_diff>

<commit_message>
Deck: slide 6 sublines dropped; type-ordering line at equation size
Co-Authored-By: Claude Fable 5.1 <noreply@anthropic.com>
</commit_message>
<xml_diff>
--- a/docs/deck_2026-10-26_seminar.pptx
+++ b/docs/deck_2026-10-26_seminar.pptx
@@ -120,7 +120,7 @@
   <p:extLst>
     <p:ext uri="{521415D9-36F7-43E2-AB2F-B90AF26B5E84}">
       <p14:sectionLst xmlns:p14="http://schemas.microsoft.com/office/powerpoint/2010/main">
-        <p14:section name="Opening" id="{e8d106ef-29f7-f7f3-a2b9-524ca082942b}">
+        <p14:section name="Opening" id="{49df280b-01d8-0f12-4d4d-7672fd3be63a}">
           <p14:sldIdLst>
             <p14:sldId id="256"/>
             <p14:sldId id="257"/>
@@ -130,13 +130,13 @@
             <p14:sldId id="261"/>
           </p14:sldIdLst>
         </p14:section>
-        <p14:section name="The model" id="{9b56c753-34b1-43c1-d0c9-371c72d9d2a8}">
+        <p14:section name="The model" id="{591384eb-cd13-34df-b1d7-096e405a2b84}">
           <p14:sldIdLst>
             <p14:sldId id="262"/>
             <p14:sldId id="263"/>
           </p14:sldIdLst>
         </p14:section>
-        <p14:section name="Results" id="{ad2fb228-debd-565c-9452-6bdc6685c404}">
+        <p14:section name="Results" id="{3422793d-8c54-fc48-2ab6-4bcb7c212aa3}">
           <p14:sldIdLst>
             <p14:sldId id="264"/>
             <p14:sldId id="265"/>
@@ -144,12 +144,12 @@
             <p14:sldId id="267"/>
           </p14:sldIdLst>
         </p14:section>
-        <p14:section name="Validation" id="{f1c3482c-3ea1-8f51-0634-0281b6ee2845}">
+        <p14:section name="Validation" id="{82488de2-729d-546c-d210-319fb61ce12e}">
           <p14:sldIdLst>
             <p14:sldId id="268"/>
           </p14:sldIdLst>
         </p14:section>
-        <p14:section name="Close" id="{77450113-6f20-144f-7834-f8030bbf41bf}">
+        <p14:section name="Close" id="{64a6d4dd-9fe1-9f16-e9f5-8c8c2d898f39}">
           <p14:sldIdLst>
             <p14:sldId id="269"/>
           </p14:sldIdLst>
@@ -5456,7 +5456,7 @@
         </p:nvSpPr>
         <p:spPr>
           <a:xfrm>
-            <a:off x="640080" y="1097280"/>
+            <a:off x="640080" y="1234440"/>
             <a:ext cx="7863840" cy="685800"/>
           </a:xfrm>
           <a:prstGeom prst="rect">
@@ -5629,14 +5629,14 @@
       </p:sp>
       <p:sp>
         <p:nvSpPr>
-          <p:cNvPr id="4" name="eq-sub"/>
+          <p:cNvPr id="4" name="types"/>
           <p:cNvSpPr txBox="1"/>
           <p:nvPr/>
         </p:nvSpPr>
         <p:spPr>
           <a:xfrm>
-            <a:off x="640080" y="1828800"/>
-            <a:ext cx="7863840" cy="320040"/>
+            <a:off x="457200" y="2240280"/>
+            <a:ext cx="8229600" cy="685800"/>
           </a:xfrm>
           <a:prstGeom prst="rect">
             <a:avLst/>
@@ -5652,148 +5652,21 @@
               <a:buNone/>
             </a:pPr>
             <a:r>
-              <a:rPr lang="en-US" sz="1200" i="1" dirty="0">
-                <a:solidFill>
-                  <a:schemeClr val="accent3"/>
-                </a:solidFill>
-              </a:rPr>
-              <a:t>the depositor’s estimate of the bank, compared with a threshold: run if it falls below</a:t>
-            </a:r>
-            <a:endParaRPr lang="en-US" sz="1200" dirty="0"/>
-          </a:p>
-        </p:txBody>
-      </p:sp>
-      <p:sp>
-        <p:nvSpPr>
-          <p:cNvPr id="5" name="types"/>
-          <p:cNvSpPr txBox="1"/>
-          <p:nvPr/>
-        </p:nvSpPr>
-        <p:spPr>
-          <a:xfrm>
-            <a:off x="457200" y="2286000"/>
-            <a:ext cx="8229600" cy="411480"/>
-          </a:xfrm>
-          <a:prstGeom prst="rect">
-            <a:avLst/>
-          </a:prstGeom>
-          <a:noFill/>
-          <a:ln/>
-        </p:spPr>
-        <p:txBody>
-          <a:bodyPr wrap="square" lIns="0" tIns="0" rIns="0" bIns="0" rtlCol="0" anchor="ctr"/>
-          <a:lstStyle/>
-          <a:p>
-            <a:pPr algn="ctr" indent="0" marL="0">
-              <a:buNone/>
-            </a:pPr>
-            <a:r>
-              <a:rPr lang="en-US" sz="1600" b="1" dirty="0">
+              <a:rPr lang="en-US" sz="3000" b="1" dirty="0">
                 <a:solidFill>
                   <a:srgbClr val="EB6834"/>
-                </a:solidFill>
-              </a:rPr>
-              <a:t>Individualists </a:t>
-            </a:r>
-            <a:pPr algn="ctr" indent="0" marL="0">
-              <a:buNone/>
-            </a:pPr>
-            <a:r>
-              <a:rPr lang="en-US" sz="1600" dirty="0">
-                <a:solidFill>
-                  <a:schemeClr val="tx1"/>
-                </a:solidFill>
-              </a:rPr>
-              <a:t>λ</a:t>
-            </a:r>
-            <a:pPr algn="ctr" indent="0" marL="0">
-              <a:buNone/>
-            </a:pPr>
-            <a:r>
-              <a:rPr lang="en-US" sz="1600" baseline="-40000" dirty="0">
-                <a:solidFill>
-                  <a:schemeClr val="tx1"/>
-                </a:solidFill>
-              </a:rPr>
-              <a:t>I</a:t>
-            </a:r>
-            <a:pPr algn="ctr" indent="0" marL="0">
-              <a:buNone/>
-            </a:pPr>
-            <a:r>
-              <a:rPr lang="en-US" sz="1600" dirty="0">
-                <a:solidFill>
-                  <a:schemeClr val="tx1"/>
-                </a:solidFill>
-              </a:rPr>
-              <a:t>  &lt;  λ</a:t>
-            </a:r>
-            <a:pPr algn="ctr" indent="0" marL="0">
-              <a:buNone/>
-            </a:pPr>
-            <a:r>
-              <a:rPr lang="en-US" sz="1600" baseline="-40000" dirty="0">
-                <a:solidFill>
-                  <a:schemeClr val="tx1"/>
-                </a:solidFill>
-              </a:rPr>
-              <a:t>C</a:t>
-            </a:r>
-            <a:pPr algn="ctr" indent="0" marL="0">
-              <a:buNone/>
-            </a:pPr>
-            <a:r>
-              <a:rPr lang="en-US" sz="1600" b="1" dirty="0">
-                <a:solidFill>
-                  <a:srgbClr val="2A78D6"/>
-                </a:solidFill>
-              </a:rPr>
-              <a:t> collectivists</a:t>
-            </a:r>
-            <a:endParaRPr lang="en-US" sz="1600" dirty="0"/>
-          </a:p>
-        </p:txBody>
-      </p:sp>
-      <p:sp>
-        <p:nvSpPr>
-          <p:cNvPr id="6" name="eq2"/>
-          <p:cNvSpPr txBox="1"/>
-          <p:nvPr/>
-        </p:nvSpPr>
-        <p:spPr>
-          <a:xfrm>
-            <a:off x="640080" y="2834640"/>
-            <a:ext cx="7863840" cy="685800"/>
-          </a:xfrm>
-          <a:prstGeom prst="rect">
-            <a:avLst/>
-          </a:prstGeom>
-          <a:noFill/>
-          <a:ln/>
-        </p:spPr>
-        <p:txBody>
-          <a:bodyPr wrap="square" lIns="0" tIns="0" rIns="0" bIns="0" rtlCol="0" anchor="ctr"/>
-          <a:lstStyle/>
-          <a:p>
-            <a:pPr algn="ctr" indent="0" marL="0">
-              <a:buNone/>
-            </a:pPr>
-            <a:r>
-              <a:rPr lang="en-US" sz="3000" i="1" dirty="0">
-                <a:solidFill>
-                  <a:schemeClr val="tx2"/>
                 </a:solidFill>
                 <a:latin typeface="Cambria" pitchFamily="34" charset="0"/>
                 <a:ea typeface="Cambria" pitchFamily="34" charset="-122"/>
                 <a:cs typeface="Cambria" pitchFamily="34" charset="-120"/>
               </a:rPr>
-              <a:t>ŝ</a:t>
+              <a:t>Individualists </a:t>
             </a:r>
             <a:pPr algn="ctr" indent="0" marL="0">
               <a:buNone/>
             </a:pPr>
             <a:r>
-              <a:rPr lang="en-US" sz="3000" baseline="-40000" dirty="0">
+              <a:rPr lang="en-US" sz="3000" dirty="0">
                 <a:solidFill>
                   <a:schemeClr val="tx2"/>
                 </a:solidFill>
@@ -5801,13 +5674,13 @@
                 <a:ea typeface="Cambria" pitchFamily="34" charset="-122"/>
                 <a:cs typeface="Cambria" pitchFamily="34" charset="-120"/>
               </a:rPr>
-              <a:t>I</a:t>
+              <a:t>λ</a:t>
             </a:r>
             <a:pPr algn="ctr" indent="0" marL="0">
               <a:buNone/>
             </a:pPr>
             <a:r>
-              <a:rPr lang="en-US" sz="3000" dirty="0">
+              <a:rPr lang="en-US" sz="3000" baseline="-40000" dirty="0">
                 <a:solidFill>
                   <a:schemeClr val="tx2"/>
                 </a:solidFill>
@@ -5815,13 +5688,13 @@
                 <a:ea typeface="Cambria" pitchFamily="34" charset="-122"/>
                 <a:cs typeface="Cambria" pitchFamily="34" charset="-120"/>
               </a:rPr>
-              <a:t>  −  </a:t>
+              <a:t>I</a:t>
             </a:r>
             <a:pPr algn="ctr" indent="0" marL="0">
               <a:buNone/>
             </a:pPr>
             <a:r>
-              <a:rPr lang="en-US" sz="3000" i="1" dirty="0">
+              <a:rPr lang="en-US" sz="3000" dirty="0">
                 <a:solidFill>
                   <a:schemeClr val="tx2"/>
                 </a:solidFill>
@@ -5829,7 +5702,7 @@
                 <a:ea typeface="Cambria" pitchFamily="34" charset="-122"/>
                 <a:cs typeface="Cambria" pitchFamily="34" charset="-120"/>
               </a:rPr>
-              <a:t>ŝ</a:t>
+              <a:t>  &lt;  λ</a:t>
             </a:r>
             <a:pPr algn="ctr" indent="0" marL="0">
               <a:buNone/>
@@ -5849,21 +5722,46 @@
               <a:buNone/>
             </a:pPr>
             <a:r>
-              <a:rPr lang="en-US" sz="3000" dirty="0">
-                <a:solidFill>
-                  <a:schemeClr val="tx2"/>
+              <a:rPr lang="en-US" sz="3000" b="1" dirty="0">
+                <a:solidFill>
+                  <a:srgbClr val="2A78D6"/>
                 </a:solidFill>
                 <a:latin typeface="Cambria" pitchFamily="34" charset="0"/>
                 <a:ea typeface="Cambria" pitchFamily="34" charset="-122"/>
                 <a:cs typeface="Cambria" pitchFamily="34" charset="-120"/>
               </a:rPr>
-              <a:t>  =  (λ</a:t>
-            </a:r>
+              <a:t> collectivists</a:t>
+            </a:r>
+            <a:endParaRPr lang="en-US" sz="3000" dirty="0"/>
+          </a:p>
+        </p:txBody>
+      </p:sp>
+      <p:sp>
+        <p:nvSpPr>
+          <p:cNvPr id="5" name="eq2"/>
+          <p:cNvSpPr txBox="1"/>
+          <p:nvPr/>
+        </p:nvSpPr>
+        <p:spPr>
+          <a:xfrm>
+            <a:off x="640080" y="3246120"/>
+            <a:ext cx="7863840" cy="685800"/>
+          </a:xfrm>
+          <a:prstGeom prst="rect">
+            <a:avLst/>
+          </a:prstGeom>
+          <a:noFill/>
+          <a:ln/>
+        </p:spPr>
+        <p:txBody>
+          <a:bodyPr wrap="square" lIns="0" tIns="0" rIns="0" bIns="0" rtlCol="0" anchor="ctr"/>
+          <a:lstStyle/>
+          <a:p>
             <a:pPr algn="ctr" indent="0" marL="0">
               <a:buNone/>
             </a:pPr>
             <a:r>
-              <a:rPr lang="en-US" sz="3000" baseline="-40000" dirty="0">
+              <a:rPr lang="en-US" sz="3000" i="1" dirty="0">
                 <a:solidFill>
                   <a:schemeClr val="tx2"/>
                 </a:solidFill>
@@ -5871,13 +5769,13 @@
                 <a:ea typeface="Cambria" pitchFamily="34" charset="-122"/>
                 <a:cs typeface="Cambria" pitchFamily="34" charset="-120"/>
               </a:rPr>
-              <a:t>C</a:t>
+              <a:t>ŝ</a:t>
             </a:r>
             <a:pPr algn="ctr" indent="0" marL="0">
               <a:buNone/>
             </a:pPr>
             <a:r>
-              <a:rPr lang="en-US" sz="3000" dirty="0">
+              <a:rPr lang="en-US" sz="3000" baseline="-40000" dirty="0">
                 <a:solidFill>
                   <a:schemeClr val="tx2"/>
                 </a:solidFill>
@@ -5885,13 +5783,13 @@
                 <a:ea typeface="Cambria" pitchFamily="34" charset="-122"/>
                 <a:cs typeface="Cambria" pitchFamily="34" charset="-120"/>
               </a:rPr>
-              <a:t> − λ</a:t>
+              <a:t>I</a:t>
             </a:r>
             <a:pPr algn="ctr" indent="0" marL="0">
               <a:buNone/>
             </a:pPr>
             <a:r>
-              <a:rPr lang="en-US" sz="3000" baseline="-40000" dirty="0">
+              <a:rPr lang="en-US" sz="3000" dirty="0">
                 <a:solidFill>
                   <a:schemeClr val="tx2"/>
                 </a:solidFill>
@@ -5899,13 +5797,13 @@
                 <a:ea typeface="Cambria" pitchFamily="34" charset="-122"/>
                 <a:cs typeface="Cambria" pitchFamily="34" charset="-120"/>
               </a:rPr>
-              <a:t>I</a:t>
+              <a:t>  −  </a:t>
             </a:r>
             <a:pPr algn="ctr" indent="0" marL="0">
               <a:buNone/>
             </a:pPr>
             <a:r>
-              <a:rPr lang="en-US" sz="3000" dirty="0">
+              <a:rPr lang="en-US" sz="3000" i="1" dirty="0">
                 <a:solidFill>
                   <a:schemeClr val="tx2"/>
                 </a:solidFill>
@@ -5913,13 +5811,13 @@
                 <a:ea typeface="Cambria" pitchFamily="34" charset="-122"/>
                 <a:cs typeface="Cambria" pitchFamily="34" charset="-120"/>
               </a:rPr>
-              <a:t>) · (</a:t>
+              <a:t>ŝ</a:t>
             </a:r>
             <a:pPr algn="ctr" indent="0" marL="0">
               <a:buNone/>
             </a:pPr>
             <a:r>
-              <a:rPr lang="en-US" sz="3000" i="1" dirty="0">
+              <a:rPr lang="en-US" sz="3000" baseline="-40000" dirty="0">
                 <a:solidFill>
                   <a:schemeClr val="tx2"/>
                 </a:solidFill>
@@ -5927,7 +5825,7 @@
                 <a:ea typeface="Cambria" pitchFamily="34" charset="-122"/>
                 <a:cs typeface="Cambria" pitchFamily="34" charset="-120"/>
               </a:rPr>
-              <a:t>x</a:t>
+              <a:t>C</a:t>
             </a:r>
             <a:pPr algn="ctr" indent="0" marL="0">
               <a:buNone/>
@@ -5941,13 +5839,13 @@
                 <a:ea typeface="Cambria" pitchFamily="34" charset="-122"/>
                 <a:cs typeface="Cambria" pitchFamily="34" charset="-120"/>
               </a:rPr>
-              <a:t> − </a:t>
+              <a:t>  =  (λ</a:t>
             </a:r>
             <a:pPr algn="ctr" indent="0" marL="0">
               <a:buNone/>
             </a:pPr>
             <a:r>
-              <a:rPr lang="en-US" sz="3000" i="1" dirty="0">
+              <a:rPr lang="en-US" sz="3000" baseline="-40000" dirty="0">
                 <a:solidFill>
                   <a:schemeClr val="tx2"/>
                 </a:solidFill>
@@ -5955,7 +5853,7 @@
                 <a:ea typeface="Cambria" pitchFamily="34" charset="-122"/>
                 <a:cs typeface="Cambria" pitchFamily="34" charset="-120"/>
               </a:rPr>
-              <a:t>y</a:t>
+              <a:t>C</a:t>
             </a:r>
             <a:pPr algn="ctr" indent="0" marL="0">
               <a:buNone/>
@@ -5969,45 +5867,93 @@
                 <a:ea typeface="Cambria" pitchFamily="34" charset="-122"/>
                 <a:cs typeface="Cambria" pitchFamily="34" charset="-120"/>
               </a:rPr>
+              <a:t> − λ</a:t>
+            </a:r>
+            <a:pPr algn="ctr" indent="0" marL="0">
+              <a:buNone/>
+            </a:pPr>
+            <a:r>
+              <a:rPr lang="en-US" sz="3000" baseline="-40000" dirty="0">
+                <a:solidFill>
+                  <a:schemeClr val="tx2"/>
+                </a:solidFill>
+                <a:latin typeface="Cambria" pitchFamily="34" charset="0"/>
+                <a:ea typeface="Cambria" pitchFamily="34" charset="-122"/>
+                <a:cs typeface="Cambria" pitchFamily="34" charset="-120"/>
+              </a:rPr>
+              <a:t>I</a:t>
+            </a:r>
+            <a:pPr algn="ctr" indent="0" marL="0">
+              <a:buNone/>
+            </a:pPr>
+            <a:r>
+              <a:rPr lang="en-US" sz="3000" dirty="0">
+                <a:solidFill>
+                  <a:schemeClr val="tx2"/>
+                </a:solidFill>
+                <a:latin typeface="Cambria" pitchFamily="34" charset="0"/>
+                <a:ea typeface="Cambria" pitchFamily="34" charset="-122"/>
+                <a:cs typeface="Cambria" pitchFamily="34" charset="-120"/>
+              </a:rPr>
+              <a:t>) · (</a:t>
+            </a:r>
+            <a:pPr algn="ctr" indent="0" marL="0">
+              <a:buNone/>
+            </a:pPr>
+            <a:r>
+              <a:rPr lang="en-US" sz="3000" i="1" dirty="0">
+                <a:solidFill>
+                  <a:schemeClr val="tx2"/>
+                </a:solidFill>
+                <a:latin typeface="Cambria" pitchFamily="34" charset="0"/>
+                <a:ea typeface="Cambria" pitchFamily="34" charset="-122"/>
+                <a:cs typeface="Cambria" pitchFamily="34" charset="-120"/>
+              </a:rPr>
+              <a:t>x</a:t>
+            </a:r>
+            <a:pPr algn="ctr" indent="0" marL="0">
+              <a:buNone/>
+            </a:pPr>
+            <a:r>
+              <a:rPr lang="en-US" sz="3000" dirty="0">
+                <a:solidFill>
+                  <a:schemeClr val="tx2"/>
+                </a:solidFill>
+                <a:latin typeface="Cambria" pitchFamily="34" charset="0"/>
+                <a:ea typeface="Cambria" pitchFamily="34" charset="-122"/>
+                <a:cs typeface="Cambria" pitchFamily="34" charset="-120"/>
+              </a:rPr>
+              <a:t> − </a:t>
+            </a:r>
+            <a:pPr algn="ctr" indent="0" marL="0">
+              <a:buNone/>
+            </a:pPr>
+            <a:r>
+              <a:rPr lang="en-US" sz="3000" i="1" dirty="0">
+                <a:solidFill>
+                  <a:schemeClr val="tx2"/>
+                </a:solidFill>
+                <a:latin typeface="Cambria" pitchFamily="34" charset="0"/>
+                <a:ea typeface="Cambria" pitchFamily="34" charset="-122"/>
+                <a:cs typeface="Cambria" pitchFamily="34" charset="-120"/>
+              </a:rPr>
+              <a:t>y</a:t>
+            </a:r>
+            <a:pPr algn="ctr" indent="0" marL="0">
+              <a:buNone/>
+            </a:pPr>
+            <a:r>
+              <a:rPr lang="en-US" sz="3000" dirty="0">
+                <a:solidFill>
+                  <a:schemeClr val="tx2"/>
+                </a:solidFill>
+                <a:latin typeface="Cambria" pitchFamily="34" charset="0"/>
+                <a:ea typeface="Cambria" pitchFamily="34" charset="-122"/>
+                <a:cs typeface="Cambria" pitchFamily="34" charset="-120"/>
+              </a:rPr>
               <a:t>)</a:t>
             </a:r>
             <a:endParaRPr lang="en-US" sz="3000" dirty="0"/>
-          </a:p>
-        </p:txBody>
-      </p:sp>
-      <p:sp>
-        <p:nvSpPr>
-          <p:cNvPr id="7" name="eq2-sub"/>
-          <p:cNvSpPr txBox="1"/>
-          <p:nvPr/>
-        </p:nvSpPr>
-        <p:spPr>
-          <a:xfrm>
-            <a:off x="640080" y="3566160"/>
-            <a:ext cx="7863840" cy="320040"/>
-          </a:xfrm>
-          <a:prstGeom prst="rect">
-            <a:avLst/>
-          </a:prstGeom>
-          <a:noFill/>
-          <a:ln/>
-        </p:spPr>
-        <p:txBody>
-          <a:bodyPr wrap="square" lIns="0" tIns="0" rIns="0" bIns="0" rtlCol="0" anchor="ctr"/>
-          <a:lstStyle/>
-          <a:p>
-            <a:pPr algn="ctr" indent="0" marL="0">
-              <a:buNone/>
-            </a:pPr>
-            <a:r>
-              <a:rPr lang="en-US" sz="1200" i="1" dirty="0">
-                <a:solidFill>
-                  <a:schemeClr val="accent3"/>
-                </a:solidFill>
-              </a:rPr>
-              <a:t>same two signals, different estimates</a:t>
-            </a:r>
-            <a:endParaRPr lang="en-US" sz="1200" dirty="0"/>
           </a:p>
         </p:txBody>
       </p:sp>

</xml_diff>

<commit_message>
Deck: ODD diagram names the estimate s-hat_i in the form-beliefs step
Co-Authored-By: Claude Fable 5.1 <noreply@anthropic.com>
</commit_message>
<xml_diff>
--- a/docs/deck_2026-10-26_seminar.pptx
+++ b/docs/deck_2026-10-26_seminar.pptx
@@ -120,7 +120,7 @@
   <p:extLst>
     <p:ext uri="{521415D9-36F7-43E2-AB2F-B90AF26B5E84}">
       <p14:sectionLst xmlns:p14="http://schemas.microsoft.com/office/powerpoint/2010/main">
-        <p14:section name="Opening" id="{49df280b-01d8-0f12-4d4d-7672fd3be63a}">
+        <p14:section name="Opening" id="{531b4b43-cc7b-a765-080a-d9a077638ad3}">
           <p14:sldIdLst>
             <p14:sldId id="256"/>
             <p14:sldId id="257"/>
@@ -130,13 +130,13 @@
             <p14:sldId id="261"/>
           </p14:sldIdLst>
         </p14:section>
-        <p14:section name="The model" id="{591384eb-cd13-34df-b1d7-096e405a2b84}">
+        <p14:section name="The model" id="{faf00e54-99fc-53f9-bf89-6aa0b06ea64b}">
           <p14:sldIdLst>
             <p14:sldId id="262"/>
             <p14:sldId id="263"/>
           </p14:sldIdLst>
         </p14:section>
-        <p14:section name="Results" id="{3422793d-8c54-fc48-2ab6-4bcb7c212aa3}">
+        <p14:section name="Results" id="{894820f3-bf2a-f6b6-9132-e67141ad8e4b}">
           <p14:sldIdLst>
             <p14:sldId id="264"/>
             <p14:sldId id="265"/>
@@ -144,12 +144,12 @@
             <p14:sldId id="267"/>
           </p14:sldIdLst>
         </p14:section>
-        <p14:section name="Validation" id="{82488de2-729d-546c-d210-319fb61ce12e}">
+        <p14:section name="Validation" id="{036d2c08-b55b-bd46-5cac-90c69a365efd}">
           <p14:sldIdLst>
             <p14:sldId id="268"/>
           </p14:sldIdLst>
         </p14:section>
-        <p14:section name="Close" id="{64a6d4dd-9fe1-9f16-e9f5-8c8c2d898f39}">
+        <p14:section name="Close" id="{a489903a-90e9-33d8-223f-0f1c5356b2eb}">
           <p14:sldIdLst>
             <p14:sldId id="269"/>
           </p14:sldIdLst>

</xml_diff>

<commit_message>
Deck: types slide without cards or the mu note; gap chips centred under a Signal interpretation gap label
Co-Authored-By: Claude Fable 5.1 <noreply@anthropic.com>
</commit_message>
<xml_diff>
--- a/docs/deck_2026-10-26_seminar.pptx
+++ b/docs/deck_2026-10-26_seminar.pptx
@@ -120,7 +120,7 @@
   <p:extLst>
     <p:ext uri="{521415D9-36F7-43E2-AB2F-B90AF26B5E84}">
       <p14:sectionLst xmlns:p14="http://schemas.microsoft.com/office/powerpoint/2010/main">
-        <p14:section name="Opening" id="{531b4b43-cc7b-a765-080a-d9a077638ad3}">
+        <p14:section name="Opening" id="{376d669b-be17-14be-b237-fc8624411091}">
           <p14:sldIdLst>
             <p14:sldId id="256"/>
             <p14:sldId id="257"/>
@@ -130,13 +130,13 @@
             <p14:sldId id="261"/>
           </p14:sldIdLst>
         </p14:section>
-        <p14:section name="The model" id="{faf00e54-99fc-53f9-bf89-6aa0b06ea64b}">
+        <p14:section name="The model" id="{4e19ce85-378f-2703-8add-2ec3e159bc38}">
           <p14:sldIdLst>
             <p14:sldId id="262"/>
             <p14:sldId id="263"/>
           </p14:sldIdLst>
         </p14:section>
-        <p14:section name="Results" id="{894820f3-bf2a-f6b6-9132-e67141ad8e4b}">
+        <p14:section name="Results" id="{baa68e76-972d-5be2-2929-34dfd650adf7}">
           <p14:sldIdLst>
             <p14:sldId id="264"/>
             <p14:sldId id="265"/>
@@ -144,12 +144,12 @@
             <p14:sldId id="267"/>
           </p14:sldIdLst>
         </p14:section>
-        <p14:section name="Validation" id="{036d2c08-b55b-bd46-5cac-90c69a365efd}">
+        <p14:section name="Validation" id="{d1fa0da2-20d4-9998-bf3f-4179fb7ed91d}">
           <p14:sldIdLst>
             <p14:sldId id="268"/>
           </p14:sldIdLst>
         </p14:section>
-        <p14:section name="Close" id="{a489903a-90e9-33d8-223f-0f1c5356b2eb}">
+        <p14:section name="Close" id="{b668a685-14da-8823-5c90-bc5822d0e324}">
           <p14:sldIdLst>
             <p14:sldId id="269"/>
           </p14:sldIdLst>
@@ -6199,34 +6199,7 @@
       </p:sp>
       <p:sp>
         <p:nvSpPr>
-          <p:cNvPr id="3" name="type-Individualists"/>
-          <p:cNvSpPr/>
-          <p:nvPr/>
-        </p:nvSpPr>
-        <p:spPr>
-          <a:xfrm>
-            <a:off x="457200" y="1051560"/>
-            <a:ext cx="4023360" cy="2377440"/>
-          </a:xfrm>
-          <a:prstGeom prst="roundRect">
-            <a:avLst>
-              <a:gd name="adj" fmla="val 3077"/>
-            </a:avLst>
-          </a:prstGeom>
-          <a:solidFill>
-            <a:schemeClr val="bg2"/>
-          </a:solidFill>
-          <a:ln w="12700">
-            <a:solidFill>
-              <a:schemeClr val="bg2"/>
-            </a:solidFill>
-            <a:prstDash val="solid"/>
-          </a:ln>
-        </p:spPr>
-      </p:sp>
-      <p:sp>
-        <p:nvSpPr>
-          <p:cNvPr id="4" name="type-head"/>
+          <p:cNvPr id="3" name="type-head"/>
           <p:cNvSpPr txBox="1"/>
           <p:nvPr/>
         </p:nvSpPr>
@@ -6262,7 +6235,7 @@
       </p:sp>
       <p:sp>
         <p:nvSpPr>
-          <p:cNvPr id="5" name="bullets"/>
+          <p:cNvPr id="4" name="bullets"/>
           <p:cNvSpPr txBox="1"/>
           <p:nvPr/>
         </p:nvSpPr>
@@ -6356,34 +6329,7 @@
       </p:sp>
       <p:sp>
         <p:nvSpPr>
-          <p:cNvPr id="6" name="type-Collectivists"/>
-          <p:cNvSpPr/>
-          <p:nvPr/>
-        </p:nvSpPr>
-        <p:spPr>
-          <a:xfrm>
-            <a:off x="4663440" y="1051560"/>
-            <a:ext cx="4023360" cy="2377440"/>
-          </a:xfrm>
-          <a:prstGeom prst="roundRect">
-            <a:avLst>
-              <a:gd name="adj" fmla="val 3077"/>
-            </a:avLst>
-          </a:prstGeom>
-          <a:solidFill>
-            <a:schemeClr val="bg2"/>
-          </a:solidFill>
-          <a:ln w="12700">
-            <a:solidFill>
-              <a:schemeClr val="bg2"/>
-            </a:solidFill>
-            <a:prstDash val="solid"/>
-          </a:ln>
-        </p:spPr>
-      </p:sp>
-      <p:sp>
-        <p:nvSpPr>
-          <p:cNvPr id="7" name="type-head"/>
+          <p:cNvPr id="5" name="type-head"/>
           <p:cNvSpPr txBox="1"/>
           <p:nvPr/>
         </p:nvSpPr>
@@ -6419,7 +6365,7 @@
       </p:sp>
       <p:sp>
         <p:nvSpPr>
-          <p:cNvPr id="8" name="bullets"/>
+          <p:cNvPr id="6" name="bullets"/>
           <p:cNvSpPr txBox="1"/>
           <p:nvPr/>
         </p:nvSpPr>
@@ -6513,14 +6459,14 @@
       </p:sp>
       <p:sp>
         <p:nvSpPr>
-          <p:cNvPr id="9" name="pairs-head"/>
+          <p:cNvPr id="7" name="pairs-head"/>
           <p:cNvSpPr txBox="1"/>
           <p:nvPr/>
         </p:nvSpPr>
         <p:spPr>
           <a:xfrm>
-            <a:off x="457200" y="3611880"/>
-            <a:ext cx="4572000" cy="274320"/>
+            <a:off x="914400" y="3749040"/>
+            <a:ext cx="2103120" cy="329184"/>
           </a:xfrm>
           <a:prstGeom prst="rect">
             <a:avLst/>
@@ -6536,26 +6482,26 @@
               <a:buNone/>
             </a:pPr>
             <a:r>
-              <a:rPr lang="en-US" sz="1100" b="1" dirty="0">
-                <a:solidFill>
-                  <a:schemeClr val="accent3"/>
-                </a:solidFill>
-              </a:rPr>
-              <a:t>Three pairs (λ individualist, λ collectivist) in the figures</a:t>
-            </a:r>
-            <a:endParaRPr lang="en-US" sz="1100" dirty="0"/>
-          </a:p>
-        </p:txBody>
-      </p:sp>
-      <p:sp>
-        <p:nvSpPr>
-          <p:cNvPr id="10" name="chip"/>
+              <a:rPr lang="en-US" sz="1300" b="1" dirty="0">
+                <a:solidFill>
+                  <a:schemeClr val="tx2"/>
+                </a:solidFill>
+              </a:rPr>
+              <a:t>Signal interpretation gap</a:t>
+            </a:r>
+            <a:endParaRPr lang="en-US" sz="1300" dirty="0"/>
+          </a:p>
+        </p:txBody>
+      </p:sp>
+      <p:sp>
+        <p:nvSpPr>
+          <p:cNvPr id="8" name="chip"/>
           <p:cNvSpPr/>
           <p:nvPr/>
         </p:nvSpPr>
         <p:spPr>
           <a:xfrm>
-            <a:off x="457200" y="3931920"/>
+            <a:off x="3108960" y="3749040"/>
             <a:ext cx="914400" cy="329184"/>
           </a:xfrm>
           <a:prstGeom prst="roundRect">
@@ -6576,13 +6522,13 @@
       </p:sp>
       <p:sp>
         <p:nvSpPr>
-          <p:cNvPr id="11" name="chip-label"/>
+          <p:cNvPr id="9" name="chip-label"/>
           <p:cNvSpPr txBox="1"/>
           <p:nvPr/>
         </p:nvSpPr>
         <p:spPr>
           <a:xfrm>
-            <a:off x="457200" y="3931920"/>
+            <a:off x="3108960" y="3749040"/>
             <a:ext cx="914400" cy="329184"/>
           </a:xfrm>
           <a:prstGeom prst="rect">
@@ -6615,14 +6561,14 @@
       </p:sp>
       <p:sp>
         <p:nvSpPr>
-          <p:cNvPr id="12" name="pair-label"/>
+          <p:cNvPr id="10" name="pair-label"/>
           <p:cNvSpPr txBox="1"/>
           <p:nvPr/>
         </p:nvSpPr>
         <p:spPr>
           <a:xfrm>
-            <a:off x="1417320" y="3931920"/>
-            <a:ext cx="640080" cy="329184"/>
+            <a:off x="4069080" y="3749040"/>
+            <a:ext cx="777240" cy="329184"/>
           </a:xfrm>
           <a:prstGeom prst="rect">
             <a:avLst/>
@@ -6638,26 +6584,26 @@
               <a:buNone/>
             </a:pPr>
             <a:r>
-              <a:rPr lang="en-US" sz="1100" dirty="0">
+              <a:rPr lang="en-US" sz="1200" dirty="0">
                 <a:solidFill>
                   <a:schemeClr val="accent3"/>
                 </a:solidFill>
               </a:rPr>
               <a:t>wide gap</a:t>
             </a:r>
-            <a:endParaRPr lang="en-US" sz="1100" dirty="0"/>
-          </a:p>
-        </p:txBody>
-      </p:sp>
-      <p:sp>
-        <p:nvSpPr>
-          <p:cNvPr id="13" name="chip"/>
+            <a:endParaRPr lang="en-US" sz="1200" dirty="0"/>
+          </a:p>
+        </p:txBody>
+      </p:sp>
+      <p:sp>
+        <p:nvSpPr>
+          <p:cNvPr id="11" name="chip"/>
           <p:cNvSpPr/>
           <p:nvPr/>
         </p:nvSpPr>
         <p:spPr>
           <a:xfrm>
-            <a:off x="2057400" y="3931920"/>
+            <a:off x="4846320" y="3749040"/>
             <a:ext cx="914400" cy="329184"/>
           </a:xfrm>
           <a:prstGeom prst="roundRect">
@@ -6678,13 +6624,13 @@
       </p:sp>
       <p:sp>
         <p:nvSpPr>
-          <p:cNvPr id="14" name="chip-label"/>
+          <p:cNvPr id="12" name="chip-label"/>
           <p:cNvSpPr txBox="1"/>
           <p:nvPr/>
         </p:nvSpPr>
         <p:spPr>
           <a:xfrm>
-            <a:off x="2057400" y="3931920"/>
+            <a:off x="4846320" y="3749040"/>
             <a:ext cx="914400" cy="329184"/>
           </a:xfrm>
           <a:prstGeom prst="rect">
@@ -6717,14 +6663,14 @@
       </p:sp>
       <p:sp>
         <p:nvSpPr>
-          <p:cNvPr id="15" name="pair-label"/>
+          <p:cNvPr id="13" name="pair-label"/>
           <p:cNvSpPr txBox="1"/>
           <p:nvPr/>
         </p:nvSpPr>
         <p:spPr>
           <a:xfrm>
-            <a:off x="3017520" y="3931920"/>
-            <a:ext cx="640080" cy="329184"/>
+            <a:off x="5806440" y="3749040"/>
+            <a:ext cx="777240" cy="329184"/>
           </a:xfrm>
           <a:prstGeom prst="rect">
             <a:avLst/>
@@ -6740,26 +6686,26 @@
               <a:buNone/>
             </a:pPr>
             <a:r>
-              <a:rPr lang="en-US" sz="1100" dirty="0">
+              <a:rPr lang="en-US" sz="1200" dirty="0">
                 <a:solidFill>
                   <a:schemeClr val="accent3"/>
                 </a:solidFill>
               </a:rPr>
               <a:t>medium</a:t>
             </a:r>
-            <a:endParaRPr lang="en-US" sz="1100" dirty="0"/>
-          </a:p>
-        </p:txBody>
-      </p:sp>
-      <p:sp>
-        <p:nvSpPr>
-          <p:cNvPr id="16" name="chip"/>
+            <a:endParaRPr lang="en-US" sz="1200" dirty="0"/>
+          </a:p>
+        </p:txBody>
+      </p:sp>
+      <p:sp>
+        <p:nvSpPr>
+          <p:cNvPr id="14" name="chip"/>
           <p:cNvSpPr/>
           <p:nvPr/>
         </p:nvSpPr>
         <p:spPr>
           <a:xfrm>
-            <a:off x="3657600" y="3931920"/>
+            <a:off x="6583680" y="3749040"/>
             <a:ext cx="914400" cy="329184"/>
           </a:xfrm>
           <a:prstGeom prst="roundRect">
@@ -6780,13 +6726,13 @@
       </p:sp>
       <p:sp>
         <p:nvSpPr>
-          <p:cNvPr id="17" name="chip-label"/>
+          <p:cNvPr id="15" name="chip-label"/>
           <p:cNvSpPr txBox="1"/>
           <p:nvPr/>
         </p:nvSpPr>
         <p:spPr>
           <a:xfrm>
-            <a:off x="3657600" y="3931920"/>
+            <a:off x="6583680" y="3749040"/>
             <a:ext cx="914400" cy="329184"/>
           </a:xfrm>
           <a:prstGeom prst="rect">
@@ -6819,14 +6765,14 @@
       </p:sp>
       <p:sp>
         <p:nvSpPr>
-          <p:cNvPr id="18" name="pair-label"/>
+          <p:cNvPr id="16" name="pair-label"/>
           <p:cNvSpPr txBox="1"/>
           <p:nvPr/>
         </p:nvSpPr>
         <p:spPr>
           <a:xfrm>
-            <a:off x="4617720" y="3931920"/>
-            <a:ext cx="640080" cy="329184"/>
+            <a:off x="7543800" y="3749040"/>
+            <a:ext cx="777240" cy="329184"/>
           </a:xfrm>
           <a:prstGeom prst="rect">
             <a:avLst/>
@@ -6842,94 +6788,14 @@
               <a:buNone/>
             </a:pPr>
             <a:r>
-              <a:rPr lang="en-US" sz="1100" dirty="0">
+              <a:rPr lang="en-US" sz="1200" dirty="0">
                 <a:solidFill>
                   <a:schemeClr val="accent3"/>
                 </a:solidFill>
               </a:rPr>
               <a:t>narrow</a:t>
             </a:r>
-            <a:endParaRPr lang="en-US" sz="1100" dirty="0"/>
-          </a:p>
-        </p:txBody>
-      </p:sp>
-      <p:sp>
-        <p:nvSpPr>
-          <p:cNvPr id="19" name="mu-note"/>
-          <p:cNvSpPr txBox="1"/>
-          <p:nvPr/>
-        </p:nvSpPr>
-        <p:spPr>
-          <a:xfrm>
-            <a:off x="5303520" y="3611880"/>
-            <a:ext cx="3383280" cy="822960"/>
-          </a:xfrm>
-          <a:prstGeom prst="rect">
-            <a:avLst/>
-          </a:prstGeom>
-          <a:noFill/>
-          <a:ln/>
-        </p:spPr>
-        <p:txBody>
-          <a:bodyPr wrap="square" lIns="0" tIns="0" rIns="0" bIns="0" rtlCol="0" anchor="t"/>
-          <a:lstStyle/>
-          <a:p>
-            <a:pPr indent="0" marL="0">
-              <a:buNone/>
-            </a:pPr>
-            <a:r>
-              <a:rPr lang="en-US" sz="1100" dirty="0">
-                <a:solidFill>
-                  <a:schemeClr val="accent3"/>
-                </a:solidFill>
-              </a:rPr>
-              <a:t>The share of individualists μ is set by a cultural warm-up on the network. </a:t>
-            </a:r>
-            <a:pPr indent="0" marL="0">
-              <a:buNone/>
-            </a:pPr>
-            <a:r>
-              <a:rPr lang="en-US" sz="1100" b="1" dirty="0">
-                <a:solidFill>
-                  <a:srgbClr val="EB6834"/>
-                </a:solidFill>
-              </a:rPr>
-              <a:t>Orange = individualists</a:t>
-            </a:r>
-            <a:pPr indent="0" marL="0">
-              <a:buNone/>
-            </a:pPr>
-            <a:r>
-              <a:rPr lang="en-US" sz="1100" dirty="0">
-                <a:solidFill>
-                  <a:schemeClr val="accent3"/>
-                </a:solidFill>
-              </a:rPr>
-              <a:t>, </a:t>
-            </a:r>
-            <a:pPr indent="0" marL="0">
-              <a:buNone/>
-            </a:pPr>
-            <a:r>
-              <a:rPr lang="en-US" sz="1100" b="1" dirty="0">
-                <a:solidFill>
-                  <a:srgbClr val="2A78D6"/>
-                </a:solidFill>
-              </a:rPr>
-              <a:t>blue = collectivists</a:t>
-            </a:r>
-            <a:pPr indent="0" marL="0">
-              <a:buNone/>
-            </a:pPr>
-            <a:r>
-              <a:rPr lang="en-US" sz="1100" dirty="0">
-                <a:solidFill>
-                  <a:schemeClr val="accent3"/>
-                </a:solidFill>
-              </a:rPr>
-              <a:t> throughout.</a:t>
-            </a:r>
-            <a:endParaRPr lang="en-US" sz="1100" dirty="0"/>
+            <a:endParaRPr lang="en-US" sz="1200" dirty="0"/>
           </a:p>
         </p:txBody>
       </p:sp>

</xml_diff>

<commit_message>
Deck: gap chips centred on slide 8 with the label beneath them
Co-Authored-By: Claude Fable 5.1 <noreply@anthropic.com>
</commit_message>
<xml_diff>
--- a/docs/deck_2026-10-26_seminar.pptx
+++ b/docs/deck_2026-10-26_seminar.pptx
@@ -120,7 +120,7 @@
   <p:extLst>
     <p:ext uri="{521415D9-36F7-43E2-AB2F-B90AF26B5E84}">
       <p14:sectionLst xmlns:p14="http://schemas.microsoft.com/office/powerpoint/2010/main">
-        <p14:section name="Opening" id="{376d669b-be17-14be-b237-fc8624411091}">
+        <p14:section name="Opening" id="{49c422ad-505d-8dcf-c12d-ff605d9aaaa0}">
           <p14:sldIdLst>
             <p14:sldId id="256"/>
             <p14:sldId id="257"/>
@@ -130,13 +130,13 @@
             <p14:sldId id="261"/>
           </p14:sldIdLst>
         </p14:section>
-        <p14:section name="The model" id="{4e19ce85-378f-2703-8add-2ec3e159bc38}">
+        <p14:section name="The model" id="{481503f5-a1b7-8bef-c57a-44ace5cec1e5}">
           <p14:sldIdLst>
             <p14:sldId id="262"/>
             <p14:sldId id="263"/>
           </p14:sldIdLst>
         </p14:section>
-        <p14:section name="Results" id="{baa68e76-972d-5be2-2929-34dfd650adf7}">
+        <p14:section name="Results" id="{85901ff1-6875-5771-133d-a9a628aed2a5}">
           <p14:sldIdLst>
             <p14:sldId id="264"/>
             <p14:sldId id="265"/>
@@ -144,12 +144,12 @@
             <p14:sldId id="267"/>
           </p14:sldIdLst>
         </p14:section>
-        <p14:section name="Validation" id="{d1fa0da2-20d4-9998-bf3f-4179fb7ed91d}">
+        <p14:section name="Validation" id="{f9368fb3-0c9c-652b-9c95-3431d06c4de7}">
           <p14:sldIdLst>
             <p14:sldId id="268"/>
           </p14:sldIdLst>
         </p14:section>
-        <p14:section name="Close" id="{b668a685-14da-8823-5c90-bc5822d0e324}">
+        <p14:section name="Close" id="{4898beb8-f625-c9f1-f85a-50d2d4d3b4f7}">
           <p14:sldIdLst>
             <p14:sldId id="269"/>
           </p14:sldIdLst>
@@ -6465,8 +6465,8 @@
         </p:nvSpPr>
         <p:spPr>
           <a:xfrm>
-            <a:off x="914400" y="3749040"/>
-            <a:ext cx="2103120" cy="329184"/>
+            <a:off x="457200" y="3886200"/>
+            <a:ext cx="8229600" cy="329184"/>
           </a:xfrm>
           <a:prstGeom prst="rect">
             <a:avLst/>
@@ -6478,7 +6478,7 @@
           <a:bodyPr wrap="square" lIns="0" tIns="0" rIns="0" bIns="0" rtlCol="0" anchor="ctr"/>
           <a:lstStyle/>
           <a:p>
-            <a:pPr indent="0" marL="0">
+            <a:pPr algn="ctr" indent="0" marL="0">
               <a:buNone/>
             </a:pPr>
             <a:r>
@@ -6501,7 +6501,7 @@
         </p:nvSpPr>
         <p:spPr>
           <a:xfrm>
-            <a:off x="3108960" y="3749040"/>
+            <a:off x="2057400" y="3429000"/>
             <a:ext cx="914400" cy="329184"/>
           </a:xfrm>
           <a:prstGeom prst="roundRect">
@@ -6528,7 +6528,7 @@
         </p:nvSpPr>
         <p:spPr>
           <a:xfrm>
-            <a:off x="3108960" y="3749040"/>
+            <a:off x="2057400" y="3429000"/>
             <a:ext cx="914400" cy="329184"/>
           </a:xfrm>
           <a:prstGeom prst="rect">
@@ -6567,7 +6567,7 @@
         </p:nvSpPr>
         <p:spPr>
           <a:xfrm>
-            <a:off x="4069080" y="3749040"/>
+            <a:off x="3017520" y="3429000"/>
             <a:ext cx="777240" cy="329184"/>
           </a:xfrm>
           <a:prstGeom prst="rect">
@@ -6603,7 +6603,7 @@
         </p:nvSpPr>
         <p:spPr>
           <a:xfrm>
-            <a:off x="4846320" y="3749040"/>
+            <a:off x="3794760" y="3429000"/>
             <a:ext cx="914400" cy="329184"/>
           </a:xfrm>
           <a:prstGeom prst="roundRect">
@@ -6630,7 +6630,7 @@
         </p:nvSpPr>
         <p:spPr>
           <a:xfrm>
-            <a:off x="4846320" y="3749040"/>
+            <a:off x="3794760" y="3429000"/>
             <a:ext cx="914400" cy="329184"/>
           </a:xfrm>
           <a:prstGeom prst="rect">
@@ -6669,7 +6669,7 @@
         </p:nvSpPr>
         <p:spPr>
           <a:xfrm>
-            <a:off x="5806440" y="3749040"/>
+            <a:off x="4754880" y="3429000"/>
             <a:ext cx="777240" cy="329184"/>
           </a:xfrm>
           <a:prstGeom prst="rect">
@@ -6705,7 +6705,7 @@
         </p:nvSpPr>
         <p:spPr>
           <a:xfrm>
-            <a:off x="6583680" y="3749040"/>
+            <a:off x="5532120" y="3429000"/>
             <a:ext cx="914400" cy="329184"/>
           </a:xfrm>
           <a:prstGeom prst="roundRect">
@@ -6732,7 +6732,7 @@
         </p:nvSpPr>
         <p:spPr>
           <a:xfrm>
-            <a:off x="6583680" y="3749040"/>
+            <a:off x="5532120" y="3429000"/>
             <a:ext cx="914400" cy="329184"/>
           </a:xfrm>
           <a:prstGeom prst="rect">
@@ -6771,7 +6771,7 @@
         </p:nvSpPr>
         <p:spPr>
           <a:xfrm>
-            <a:off x="7543800" y="3749040"/>
+            <a:off x="6492240" y="3429000"/>
             <a:ext cx="777240" cy="329184"/>
           </a:xfrm>
           <a:prstGeom prst="rect">

</xml_diff>

<commit_message>
Deck: takeaways as six numbered lines, no cards or chips; next-steps box dropped; wording trimmed
Co-Authored-By: Claude Fable 5.1 <noreply@anthropic.com>
</commit_message>
<xml_diff>
--- a/docs/deck_2026-10-26_seminar.pptx
+++ b/docs/deck_2026-10-26_seminar.pptx
@@ -120,7 +120,7 @@
   <p:extLst>
     <p:ext uri="{521415D9-36F7-43E2-AB2F-B90AF26B5E84}">
       <p14:sectionLst xmlns:p14="http://schemas.microsoft.com/office/powerpoint/2010/main">
-        <p14:section name="Opening" id="{49c422ad-505d-8dcf-c12d-ff605d9aaaa0}">
+        <p14:section name="Opening" id="{3c0f1e0c-7c18-eb01-bf6a-11c8510f56ac}">
           <p14:sldIdLst>
             <p14:sldId id="256"/>
             <p14:sldId id="257"/>
@@ -130,13 +130,13 @@
             <p14:sldId id="261"/>
           </p14:sldIdLst>
         </p14:section>
-        <p14:section name="The model" id="{481503f5-a1b7-8bef-c57a-44ace5cec1e5}">
+        <p14:section name="The model" id="{5c1b3cfd-5638-9a33-58d5-7f895a2e268f}">
           <p14:sldIdLst>
             <p14:sldId id="262"/>
             <p14:sldId id="263"/>
           </p14:sldIdLst>
         </p14:section>
-        <p14:section name="Results" id="{85901ff1-6875-5771-133d-a9a628aed2a5}">
+        <p14:section name="Results" id="{bff05c9e-5350-fc9e-a1bc-a5ca9e23503c}">
           <p14:sldIdLst>
             <p14:sldId id="264"/>
             <p14:sldId id="265"/>
@@ -144,12 +144,12 @@
             <p14:sldId id="267"/>
           </p14:sldIdLst>
         </p14:section>
-        <p14:section name="Validation" id="{f9368fb3-0c9c-652b-9c95-3431d06c4de7}">
+        <p14:section name="Validation" id="{e569a8c1-abeb-152c-bec6-dd04644ace26}">
           <p14:sldIdLst>
             <p14:sldId id="268"/>
           </p14:sldIdLst>
         </p14:section>
-        <p14:section name="Close" id="{4898beb8-f625-c9f1-f85a-50d2d4d3b4f7}">
+        <p14:section name="Close" id="{b73275a0-fad0-4d42-c4db-b551958915af}">
           <p14:sldIdLst>
             <p14:sldId id="269"/>
           </p14:sldIdLst>
@@ -3157,68 +3157,14 @@
       </p:sp>
       <p:sp>
         <p:nvSpPr>
-          <p:cNvPr id="3" name="take-0"/>
-          <p:cNvSpPr/>
-          <p:nvPr/>
-        </p:nvSpPr>
-        <p:spPr>
-          <a:xfrm>
-            <a:off x="457200" y="1051560"/>
-            <a:ext cx="5760720" cy="512064"/>
-          </a:xfrm>
-          <a:prstGeom prst="roundRect">
-            <a:avLst>
-              <a:gd name="adj" fmla="val 14286"/>
-            </a:avLst>
-          </a:prstGeom>
-          <a:solidFill>
-            <a:schemeClr val="bg2"/>
-          </a:solidFill>
-          <a:ln w="12700">
-            <a:solidFill>
-              <a:schemeClr val="bg2"/>
-            </a:solidFill>
-            <a:prstDash val="solid"/>
-          </a:ln>
-        </p:spPr>
-      </p:sp>
-      <p:sp>
-        <p:nvSpPr>
-          <p:cNvPr id="4" name="chip"/>
-          <p:cNvSpPr/>
-          <p:nvPr/>
-        </p:nvSpPr>
-        <p:spPr>
-          <a:xfrm>
-            <a:off x="548640" y="1143000"/>
-            <a:ext cx="329184" cy="329184"/>
-          </a:xfrm>
-          <a:prstGeom prst="roundRect">
-            <a:avLst>
-              <a:gd name="adj" fmla="val 16667"/>
-            </a:avLst>
-          </a:prstGeom>
-          <a:solidFill>
-            <a:schemeClr val="accent1"/>
-          </a:solidFill>
-          <a:ln w="12700">
-            <a:solidFill>
-              <a:schemeClr val="accent1"/>
-            </a:solidFill>
-            <a:prstDash val="solid"/>
-          </a:ln>
-        </p:spPr>
-      </p:sp>
-      <p:sp>
-        <p:nvSpPr>
-          <p:cNvPr id="5" name="chip-label"/>
+          <p:cNvPr id="3" name="take-head"/>
           <p:cNvSpPr txBox="1"/>
           <p:nvPr/>
         </p:nvSpPr>
         <p:spPr>
           <a:xfrm>
-            <a:off x="548640" y="1143000"/>
-            <a:ext cx="329184" cy="329184"/>
+            <a:off x="457200" y="1051560"/>
+            <a:ext cx="2743200" cy="530352"/>
           </a:xfrm>
           <a:prstGeom prst="rect">
             <a:avLst/>
@@ -3230,34 +3176,42 @@
           <a:bodyPr wrap="square" lIns="0" tIns="0" rIns="0" bIns="0" rtlCol="0" anchor="ctr"/>
           <a:lstStyle/>
           <a:p>
-            <a:pPr algn="ctr" indent="0" marL="0">
-              <a:buNone/>
-            </a:pPr>
-            <a:r>
-              <a:rPr lang="en-US" sz="1100" b="1" dirty="0">
-                <a:solidFill>
-                  <a:schemeClr val="bg1"/>
-                </a:solidFill>
-                <a:latin typeface="Cambria" pitchFamily="34" charset="0"/>
-                <a:ea typeface="Cambria" pitchFamily="34" charset="-122"/>
-                <a:cs typeface="Cambria" pitchFamily="34" charset="-120"/>
-              </a:rPr>
-              <a:t>1</a:t>
-            </a:r>
-            <a:endParaRPr lang="en-US" sz="1100" dirty="0"/>
-          </a:p>
-        </p:txBody>
-      </p:sp>
-      <p:sp>
-        <p:nvSpPr>
-          <p:cNvPr id="6" name="take-head"/>
+            <a:pPr indent="0" marL="0">
+              <a:buNone/>
+            </a:pPr>
+            <a:r>
+              <a:rPr lang="en-US" sz="1300" b="1" dirty="0">
+                <a:solidFill>
+                  <a:schemeClr val="accent1"/>
+                </a:solidFill>
+              </a:rPr>
+              <a:t>1:  </a:t>
+            </a:r>
+            <a:pPr indent="0" marL="0">
+              <a:buNone/>
+            </a:pPr>
+            <a:r>
+              <a:rPr lang="en-US" sz="1300" b="1" dirty="0">
+                <a:solidFill>
+                  <a:schemeClr val="tx2"/>
+                </a:solidFill>
+              </a:rPr>
+              <a:t>Sorting follows the news</a:t>
+            </a:r>
+            <a:endParaRPr lang="en-US" sz="1300" dirty="0"/>
+          </a:p>
+        </p:txBody>
+      </p:sp>
+      <p:sp>
+        <p:nvSpPr>
+          <p:cNvPr id="4" name="take-body"/>
           <p:cNvSpPr txBox="1"/>
           <p:nvPr/>
         </p:nvSpPr>
         <p:spPr>
           <a:xfrm>
-            <a:off x="987552" y="1088136"/>
-            <a:ext cx="1600200" cy="438912"/>
+            <a:off x="3291840" y="1051560"/>
+            <a:ext cx="5394960" cy="530352"/>
           </a:xfrm>
           <a:prstGeom prst="rect">
             <a:avLst/>
@@ -3273,27 +3227,27 @@
               <a:buNone/>
             </a:pPr>
             <a:r>
-              <a:rPr lang="en-US" sz="1100" b="1" dirty="0">
-                <a:solidFill>
-                  <a:schemeClr val="tx2"/>
-                </a:solidFill>
-              </a:rPr>
-              <a:t>Sorting follows the news</a:t>
-            </a:r>
-            <a:endParaRPr lang="en-US" sz="1100" dirty="0"/>
-          </a:p>
-        </p:txBody>
-      </p:sp>
-      <p:sp>
-        <p:nvSpPr>
-          <p:cNvPr id="7" name="take-body"/>
+              <a:rPr lang="en-US" sz="1200" dirty="0">
+                <a:solidFill>
+                  <a:schemeClr val="tx1"/>
+                </a:solidFill>
+              </a:rPr>
+              <a:t>Optimistic public news makes individualists run relatively more; pessimistic news, collectivists.</a:t>
+            </a:r>
+            <a:endParaRPr lang="en-US" sz="1200" dirty="0"/>
+          </a:p>
+        </p:txBody>
+      </p:sp>
+      <p:sp>
+        <p:nvSpPr>
+          <p:cNvPr id="5" name="take-head"/>
           <p:cNvSpPr txBox="1"/>
           <p:nvPr/>
         </p:nvSpPr>
         <p:spPr>
           <a:xfrm>
-            <a:off x="2651760" y="1088136"/>
-            <a:ext cx="3474720" cy="438912"/>
+            <a:off x="457200" y="1627632"/>
+            <a:ext cx="2743200" cy="530352"/>
           </a:xfrm>
           <a:prstGeom prst="rect">
             <a:avLst/>
@@ -3309,81 +3263,38 @@
               <a:buNone/>
             </a:pPr>
             <a:r>
-              <a:rPr lang="en-US" sz="1000" dirty="0">
-                <a:solidFill>
-                  <a:schemeClr val="tx1"/>
-                </a:solidFill>
-              </a:rPr>
-              <a:t>Optimistic public news makes individualists run relatively more; pessimistic news, collectivists. 3 of 4 pre-registered tests pass, in all three bank versions.</a:t>
-            </a:r>
-            <a:endParaRPr lang="en-US" sz="1000" dirty="0"/>
-          </a:p>
-        </p:txBody>
-      </p:sp>
-      <p:sp>
-        <p:nvSpPr>
-          <p:cNvPr id="8" name="take-1"/>
-          <p:cNvSpPr/>
-          <p:nvPr/>
-        </p:nvSpPr>
-        <p:spPr>
-          <a:xfrm>
-            <a:off x="457200" y="1636776"/>
-            <a:ext cx="5760720" cy="512064"/>
-          </a:xfrm>
-          <a:prstGeom prst="roundRect">
-            <a:avLst>
-              <a:gd name="adj" fmla="val 14286"/>
-            </a:avLst>
-          </a:prstGeom>
-          <a:solidFill>
-            <a:schemeClr val="bg2"/>
-          </a:solidFill>
-          <a:ln w="12700">
-            <a:solidFill>
-              <a:schemeClr val="bg2"/>
-            </a:solidFill>
-            <a:prstDash val="solid"/>
-          </a:ln>
-        </p:spPr>
-      </p:sp>
-      <p:sp>
-        <p:nvSpPr>
-          <p:cNvPr id="9" name="chip"/>
-          <p:cNvSpPr/>
-          <p:nvPr/>
-        </p:nvSpPr>
-        <p:spPr>
-          <a:xfrm>
-            <a:off x="548640" y="1728216"/>
-            <a:ext cx="329184" cy="329184"/>
-          </a:xfrm>
-          <a:prstGeom prst="roundRect">
-            <a:avLst>
-              <a:gd name="adj" fmla="val 16667"/>
-            </a:avLst>
-          </a:prstGeom>
-          <a:solidFill>
-            <a:schemeClr val="accent1"/>
-          </a:solidFill>
-          <a:ln w="12700">
-            <a:solidFill>
-              <a:schemeClr val="accent1"/>
-            </a:solidFill>
-            <a:prstDash val="solid"/>
-          </a:ln>
-        </p:spPr>
-      </p:sp>
-      <p:sp>
-        <p:nvSpPr>
-          <p:cNvPr id="10" name="chip-label"/>
+              <a:rPr lang="en-US" sz="1300" b="1" dirty="0">
+                <a:solidFill>
+                  <a:schemeClr val="accent1"/>
+                </a:solidFill>
+              </a:rPr>
+              <a:t>2:  </a:t>
+            </a:r>
+            <a:pPr indent="0" marL="0">
+              <a:buNone/>
+            </a:pPr>
+            <a:r>
+              <a:rPr lang="en-US" sz="1300" b="1" dirty="0">
+                <a:solidFill>
+                  <a:schemeClr val="tx2"/>
+                </a:solidFill>
+              </a:rPr>
+              <a:t>Collectivists herd</a:t>
+            </a:r>
+            <a:endParaRPr lang="en-US" sz="1300" dirty="0"/>
+          </a:p>
+        </p:txBody>
+      </p:sp>
+      <p:sp>
+        <p:nvSpPr>
+          <p:cNvPr id="6" name="take-body"/>
           <p:cNvSpPr txBox="1"/>
           <p:nvPr/>
         </p:nvSpPr>
         <p:spPr>
           <a:xfrm>
-            <a:off x="548640" y="1728216"/>
-            <a:ext cx="329184" cy="329184"/>
+            <a:off x="3291840" y="1627632"/>
+            <a:ext cx="5394960" cy="530352"/>
           </a:xfrm>
           <a:prstGeom prst="rect">
             <a:avLst/>
@@ -3395,21 +3306,184 @@
           <a:bodyPr wrap="square" lIns="0" tIns="0" rIns="0" bIns="0" rtlCol="0" anchor="ctr"/>
           <a:lstStyle/>
           <a:p>
-            <a:pPr algn="ctr" indent="0" marL="0">
-              <a:buNone/>
-            </a:pPr>
-            <a:r>
-              <a:rPr lang="en-US" sz="1100" b="1" dirty="0">
-                <a:solidFill>
-                  <a:schemeClr val="bg1"/>
-                </a:solidFill>
-                <a:latin typeface="Cambria" pitchFamily="34" charset="0"/>
-                <a:ea typeface="Cambria" pitchFamily="34" charset="-122"/>
-                <a:cs typeface="Cambria" pitchFamily="34" charset="-120"/>
-              </a:rPr>
-              <a:t>2</a:t>
-            </a:r>
-            <a:endParaRPr lang="en-US" sz="1100" dirty="0"/>
+            <a:pPr indent="0" marL="0">
+              <a:buNone/>
+            </a:pPr>
+            <a:r>
+              <a:rPr lang="en-US" sz="1200" dirty="0">
+                <a:solidFill>
+                  <a:schemeClr val="tx1"/>
+                </a:solidFill>
+              </a:rPr>
+              <a:t>Their chance of withdrawing jumps from 0.15 to 0.93 once 20–35% of neighbours are out; individualists level off near 0.3.</a:t>
+            </a:r>
+            <a:endParaRPr lang="en-US" sz="1200" dirty="0"/>
+          </a:p>
+        </p:txBody>
+      </p:sp>
+      <p:sp>
+        <p:nvSpPr>
+          <p:cNvPr id="7" name="take-head"/>
+          <p:cNvSpPr txBox="1"/>
+          <p:nvPr/>
+        </p:nvSpPr>
+        <p:spPr>
+          <a:xfrm>
+            <a:off x="457200" y="2203704"/>
+            <a:ext cx="2743200" cy="530352"/>
+          </a:xfrm>
+          <a:prstGeom prst="rect">
+            <a:avLst/>
+          </a:prstGeom>
+          <a:noFill/>
+          <a:ln/>
+        </p:spPr>
+        <p:txBody>
+          <a:bodyPr wrap="square" lIns="0" tIns="0" rIns="0" bIns="0" rtlCol="0" anchor="ctr"/>
+          <a:lstStyle/>
+          <a:p>
+            <a:pPr indent="0" marL="0">
+              <a:buNone/>
+            </a:pPr>
+            <a:r>
+              <a:rPr lang="en-US" sz="1300" b="1" dirty="0">
+                <a:solidFill>
+                  <a:schemeClr val="accent1"/>
+                </a:solidFill>
+              </a:rPr>
+              <a:t>3:  </a:t>
+            </a:r>
+            <a:pPr indent="0" marL="0">
+              <a:buNone/>
+            </a:pPr>
+            <a:r>
+              <a:rPr lang="en-US" sz="1300" b="1" dirty="0">
+                <a:solidFill>
+                  <a:schemeClr val="tx2"/>
+                </a:solidFill>
+              </a:rPr>
+              <a:t>More individualists, fewer failures</a:t>
+            </a:r>
+            <a:endParaRPr lang="en-US" sz="1300" dirty="0"/>
+          </a:p>
+        </p:txBody>
+      </p:sp>
+      <p:sp>
+        <p:nvSpPr>
+          <p:cNvPr id="8" name="take-body"/>
+          <p:cNvSpPr txBox="1"/>
+          <p:nvPr/>
+        </p:nvSpPr>
+        <p:spPr>
+          <a:xfrm>
+            <a:off x="3291840" y="2203704"/>
+            <a:ext cx="5394960" cy="530352"/>
+          </a:xfrm>
+          <a:prstGeom prst="rect">
+            <a:avLst/>
+          </a:prstGeom>
+          <a:noFill/>
+          <a:ln/>
+        </p:spPr>
+        <p:txBody>
+          <a:bodyPr wrap="square" lIns="0" tIns="0" rIns="0" bIns="0" rtlCol="0" anchor="ctr"/>
+          <a:lstStyle/>
+          <a:p>
+            <a:pPr indent="0" marL="0">
+              <a:buNone/>
+            </a:pPr>
+            <a:r>
+              <a:rPr lang="en-US" sz="1200" dirty="0">
+                <a:solidFill>
+                  <a:schemeClr val="tx1"/>
+                </a:solidFill>
+              </a:rPr>
+              <a:t>P(fail) falls from 0.67 to 0.08 as the individualist share goes from 0 to 1.</a:t>
+            </a:r>
+            <a:endParaRPr lang="en-US" sz="1200" dirty="0"/>
+          </a:p>
+        </p:txBody>
+      </p:sp>
+      <p:sp>
+        <p:nvSpPr>
+          <p:cNvPr id="9" name="take-head"/>
+          <p:cNvSpPr txBox="1"/>
+          <p:nvPr/>
+        </p:nvSpPr>
+        <p:spPr>
+          <a:xfrm>
+            <a:off x="457200" y="2779776"/>
+            <a:ext cx="2743200" cy="530352"/>
+          </a:xfrm>
+          <a:prstGeom prst="rect">
+            <a:avLst/>
+          </a:prstGeom>
+          <a:noFill/>
+          <a:ln/>
+        </p:spPr>
+        <p:txBody>
+          <a:bodyPr wrap="square" lIns="0" tIns="0" rIns="0" bIns="0" rtlCol="0" anchor="ctr"/>
+          <a:lstStyle/>
+          <a:p>
+            <a:pPr indent="0" marL="0">
+              <a:buNone/>
+            </a:pPr>
+            <a:r>
+              <a:rPr lang="en-US" sz="1300" b="1" dirty="0">
+                <a:solidFill>
+                  <a:schemeClr val="accent1"/>
+                </a:solidFill>
+              </a:rPr>
+              <a:t>4:  </a:t>
+            </a:r>
+            <a:pPr indent="0" marL="0">
+              <a:buNone/>
+            </a:pPr>
+            <a:r>
+              <a:rPr lang="en-US" sz="1300" b="1" dirty="0">
+                <a:solidFill>
+                  <a:schemeClr val="tx2"/>
+                </a:solidFill>
+              </a:rPr>
+              <a:t>Stale news cuts both ways</a:t>
+            </a:r>
+            <a:endParaRPr lang="en-US" sz="1300" dirty="0"/>
+          </a:p>
+        </p:txBody>
+      </p:sp>
+      <p:sp>
+        <p:nvSpPr>
+          <p:cNvPr id="10" name="take-body"/>
+          <p:cNvSpPr txBox="1"/>
+          <p:nvPr/>
+        </p:nvSpPr>
+        <p:spPr>
+          <a:xfrm>
+            <a:off x="3291840" y="2779776"/>
+            <a:ext cx="5394960" cy="530352"/>
+          </a:xfrm>
+          <a:prstGeom prst="rect">
+            <a:avLst/>
+          </a:prstGeom>
+          <a:noFill/>
+          <a:ln/>
+        </p:spPr>
+        <p:txBody>
+          <a:bodyPr wrap="square" lIns="0" tIns="0" rIns="0" bIns="0" rtlCol="0" anchor="ctr"/>
+          <a:lstStyle/>
+          <a:p>
+            <a:pPr indent="0" marL="0">
+              <a:buNone/>
+            </a:pPr>
+            <a:r>
+              <a:rPr lang="en-US" sz="1200" dirty="0">
+                <a:solidFill>
+                  <a:schemeClr val="tx1"/>
+                </a:solidFill>
+              </a:rPr>
+              <a:t>A stale optimistic signal halves failure, a stale pessimistic one raises it by half. Accurate news barely moves it.</a:t>
+            </a:r>
+            <a:endParaRPr lang="en-US" sz="1200" dirty="0"/>
           </a:p>
         </p:txBody>
       </p:sp>
@@ -3421,8 +3495,8 @@
         </p:nvSpPr>
         <p:spPr>
           <a:xfrm>
-            <a:off x="987552" y="1673352"/>
-            <a:ext cx="1600200" cy="438912"/>
+            <a:off x="457200" y="3355848"/>
+            <a:ext cx="2743200" cy="530352"/>
           </a:xfrm>
           <a:prstGeom prst="rect">
             <a:avLst/>
@@ -3438,14 +3512,25 @@
               <a:buNone/>
             </a:pPr>
             <a:r>
-              <a:rPr lang="en-US" sz="1100" b="1" dirty="0">
+              <a:rPr lang="en-US" sz="1300" b="1" dirty="0">
+                <a:solidFill>
+                  <a:schemeClr val="accent1"/>
+                </a:solidFill>
+              </a:rPr>
+              <a:t>5:  </a:t>
+            </a:r>
+            <a:pPr indent="0" marL="0">
+              <a:buNone/>
+            </a:pPr>
+            <a:r>
+              <a:rPr lang="en-US" sz="1300" b="1" dirty="0">
                 <a:solidFill>
                   <a:schemeClr val="tx2"/>
                 </a:solidFill>
               </a:rPr>
-              <a:t>Collectivists herd</a:t>
-            </a:r>
-            <a:endParaRPr lang="en-US" sz="1100" dirty="0"/>
+              <a:t>Capping the largest deposits</a:t>
+            </a:r>
+            <a:endParaRPr lang="en-US" sz="1300" dirty="0"/>
           </a:p>
         </p:txBody>
       </p:sp>
@@ -3457,8 +3542,8 @@
         </p:nvSpPr>
         <p:spPr>
           <a:xfrm>
-            <a:off x="2651760" y="1673352"/>
-            <a:ext cx="3474720" cy="438912"/>
+            <a:off x="3291840" y="3355848"/>
+            <a:ext cx="5394960" cy="530352"/>
           </a:xfrm>
           <a:prstGeom prst="rect">
             <a:avLst/>
@@ -3474,81 +3559,27 @@
               <a:buNone/>
             </a:pPr>
             <a:r>
-              <a:rPr lang="en-US" sz="1000" dirty="0">
+              <a:rPr lang="en-US" sz="1200" dirty="0">
                 <a:solidFill>
                   <a:schemeClr val="tx1"/>
                 </a:solidFill>
               </a:rPr>
-              <a:t>Their chance of withdrawing jumps from 0.15 to 0.93 once 20–35% of neighbours are out; individualists level off near 0.3.</a:t>
-            </a:r>
-            <a:endParaRPr lang="en-US" sz="1000" dirty="0"/>
-          </a:p>
-        </p:txBody>
-      </p:sp>
-      <p:sp>
-        <p:nvSpPr>
-          <p:cNvPr id="13" name="take-2"/>
-          <p:cNvSpPr/>
-          <p:nvPr/>
-        </p:nvSpPr>
-        <p:spPr>
-          <a:xfrm>
-            <a:off x="457200" y="2221992"/>
-            <a:ext cx="5760720" cy="512064"/>
-          </a:xfrm>
-          <a:prstGeom prst="roundRect">
-            <a:avLst>
-              <a:gd name="adj" fmla="val 14286"/>
-            </a:avLst>
-          </a:prstGeom>
-          <a:solidFill>
-            <a:schemeClr val="bg2"/>
-          </a:solidFill>
-          <a:ln w="12700">
-            <a:solidFill>
-              <a:schemeClr val="bg2"/>
-            </a:solidFill>
-            <a:prstDash val="solid"/>
-          </a:ln>
-        </p:spPr>
-      </p:sp>
-      <p:sp>
-        <p:nvSpPr>
-          <p:cNvPr id="14" name="chip"/>
-          <p:cNvSpPr/>
-          <p:nvPr/>
-        </p:nvSpPr>
-        <p:spPr>
-          <a:xfrm>
-            <a:off x="548640" y="2313432"/>
-            <a:ext cx="329184" cy="329184"/>
-          </a:xfrm>
-          <a:prstGeom prst="roundRect">
-            <a:avLst>
-              <a:gd name="adj" fmla="val 16667"/>
-            </a:avLst>
-          </a:prstGeom>
-          <a:solidFill>
-            <a:schemeClr val="accent1"/>
-          </a:solidFill>
-          <a:ln w="12700">
-            <a:solidFill>
-              <a:schemeClr val="accent1"/>
-            </a:solidFill>
-            <a:prstDash val="solid"/>
-          </a:ln>
-        </p:spPr>
-      </p:sp>
-      <p:sp>
-        <p:nvSpPr>
-          <p:cNvPr id="15" name="chip-label"/>
+              <a:t>A 1% cap brings failure down to the no-concentration bank’s level; the culture gradient is unchanged.</a:t>
+            </a:r>
+            <a:endParaRPr lang="en-US" sz="1200" dirty="0"/>
+          </a:p>
+        </p:txBody>
+      </p:sp>
+      <p:sp>
+        <p:nvSpPr>
+          <p:cNvPr id="13" name="take-head"/>
           <p:cNvSpPr txBox="1"/>
           <p:nvPr/>
         </p:nvSpPr>
         <p:spPr>
           <a:xfrm>
-            <a:off x="548640" y="2313432"/>
-            <a:ext cx="329184" cy="329184"/>
+            <a:off x="457200" y="3931920"/>
+            <a:ext cx="2743200" cy="530352"/>
           </a:xfrm>
           <a:prstGeom prst="rect">
             <a:avLst/>
@@ -3560,34 +3591,42 @@
           <a:bodyPr wrap="square" lIns="0" tIns="0" rIns="0" bIns="0" rtlCol="0" anchor="ctr"/>
           <a:lstStyle/>
           <a:p>
-            <a:pPr algn="ctr" indent="0" marL="0">
-              <a:buNone/>
-            </a:pPr>
-            <a:r>
-              <a:rPr lang="en-US" sz="1100" b="1" dirty="0">
-                <a:solidFill>
-                  <a:schemeClr val="bg1"/>
-                </a:solidFill>
-                <a:latin typeface="Cambria" pitchFamily="34" charset="0"/>
-                <a:ea typeface="Cambria" pitchFamily="34" charset="-122"/>
-                <a:cs typeface="Cambria" pitchFamily="34" charset="-120"/>
-              </a:rPr>
-              <a:t>3</a:t>
-            </a:r>
-            <a:endParaRPr lang="en-US" sz="1100" dirty="0"/>
-          </a:p>
-        </p:txBody>
-      </p:sp>
-      <p:sp>
-        <p:nvSpPr>
-          <p:cNvPr id="16" name="take-head"/>
+            <a:pPr indent="0" marL="0">
+              <a:buNone/>
+            </a:pPr>
+            <a:r>
+              <a:rPr lang="en-US" sz="1300" b="1" dirty="0">
+                <a:solidFill>
+                  <a:schemeClr val="accent1"/>
+                </a:solidFill>
+              </a:rPr>
+              <a:t>6:  </a:t>
+            </a:r>
+            <a:pPr indent="0" marL="0">
+              <a:buNone/>
+            </a:pPr>
+            <a:r>
+              <a:rPr lang="en-US" sz="1300" b="1" dirty="0">
+                <a:solidFill>
+                  <a:schemeClr val="tx2"/>
+                </a:solidFill>
+              </a:rPr>
+              <a:t>Not yet matched</a:t>
+            </a:r>
+            <a:endParaRPr lang="en-US" sz="1300" dirty="0"/>
+          </a:p>
+        </p:txBody>
+      </p:sp>
+      <p:sp>
+        <p:nvSpPr>
+          <p:cNvPr id="14" name="take-body"/>
           <p:cNvSpPr txBox="1"/>
           <p:nvPr/>
         </p:nvSpPr>
         <p:spPr>
           <a:xfrm>
-            <a:off x="987552" y="2258568"/>
-            <a:ext cx="1600200" cy="438912"/>
+            <a:off x="3291840" y="3931920"/>
+            <a:ext cx="5394960" cy="530352"/>
           </a:xfrm>
           <a:prstGeom prst="rect">
             <a:avLst/>
@@ -3603,702 +3642,14 @@
               <a:buNone/>
             </a:pPr>
             <a:r>
-              <a:rPr lang="en-US" sz="1100" b="1" dirty="0">
-                <a:solidFill>
-                  <a:schemeClr val="tx2"/>
-                </a:solidFill>
-              </a:rPr>
-              <a:t>More individualists, fewer failures</a:t>
-            </a:r>
-            <a:endParaRPr lang="en-US" sz="1100" dirty="0"/>
-          </a:p>
-        </p:txBody>
-      </p:sp>
-      <p:sp>
-        <p:nvSpPr>
-          <p:cNvPr id="17" name="take-body"/>
-          <p:cNvSpPr txBox="1"/>
-          <p:nvPr/>
-        </p:nvSpPr>
-        <p:spPr>
-          <a:xfrm>
-            <a:off x="2651760" y="2258568"/>
-            <a:ext cx="3474720" cy="438912"/>
-          </a:xfrm>
-          <a:prstGeom prst="rect">
-            <a:avLst/>
-          </a:prstGeom>
-          <a:noFill/>
-          <a:ln/>
-        </p:spPr>
-        <p:txBody>
-          <a:bodyPr wrap="square" lIns="0" tIns="0" rIns="0" bIns="0" rtlCol="0" anchor="ctr"/>
-          <a:lstStyle/>
-          <a:p>
-            <a:pPr indent="0" marL="0">
-              <a:buNone/>
-            </a:pPr>
-            <a:r>
-              <a:rPr lang="en-US" sz="1000" dirty="0">
+              <a:rPr lang="en-US" sz="1200" dirty="0">
                 <a:solidFill>
                   <a:schemeClr val="tx1"/>
                 </a:solidFill>
               </a:rPr>
-              <a:t>P(fail) falls from 0.67 to 0.08 as the individualist share goes from 0 to 1. Monotone; no interior peak.</a:t>
-            </a:r>
-            <a:endParaRPr lang="en-US" sz="1000" dirty="0"/>
-          </a:p>
-        </p:txBody>
-      </p:sp>
-      <p:sp>
-        <p:nvSpPr>
-          <p:cNvPr id="18" name="take-3"/>
-          <p:cNvSpPr/>
-          <p:nvPr/>
-        </p:nvSpPr>
-        <p:spPr>
-          <a:xfrm>
-            <a:off x="457200" y="2807208"/>
-            <a:ext cx="5760720" cy="512064"/>
-          </a:xfrm>
-          <a:prstGeom prst="roundRect">
-            <a:avLst>
-              <a:gd name="adj" fmla="val 14286"/>
-            </a:avLst>
-          </a:prstGeom>
-          <a:solidFill>
-            <a:schemeClr val="bg2"/>
-          </a:solidFill>
-          <a:ln w="12700">
-            <a:solidFill>
-              <a:schemeClr val="bg2"/>
-            </a:solidFill>
-            <a:prstDash val="solid"/>
-          </a:ln>
-        </p:spPr>
-      </p:sp>
-      <p:sp>
-        <p:nvSpPr>
-          <p:cNvPr id="19" name="chip"/>
-          <p:cNvSpPr/>
-          <p:nvPr/>
-        </p:nvSpPr>
-        <p:spPr>
-          <a:xfrm>
-            <a:off x="548640" y="2898648"/>
-            <a:ext cx="329184" cy="329184"/>
-          </a:xfrm>
-          <a:prstGeom prst="roundRect">
-            <a:avLst>
-              <a:gd name="adj" fmla="val 16667"/>
-            </a:avLst>
-          </a:prstGeom>
-          <a:solidFill>
-            <a:schemeClr val="accent1"/>
-          </a:solidFill>
-          <a:ln w="12700">
-            <a:solidFill>
-              <a:schemeClr val="accent1"/>
-            </a:solidFill>
-            <a:prstDash val="solid"/>
-          </a:ln>
-        </p:spPr>
-      </p:sp>
-      <p:sp>
-        <p:nvSpPr>
-          <p:cNvPr id="20" name="chip-label"/>
-          <p:cNvSpPr txBox="1"/>
-          <p:nvPr/>
-        </p:nvSpPr>
-        <p:spPr>
-          <a:xfrm>
-            <a:off x="548640" y="2898648"/>
-            <a:ext cx="329184" cy="329184"/>
-          </a:xfrm>
-          <a:prstGeom prst="rect">
-            <a:avLst/>
-          </a:prstGeom>
-          <a:noFill/>
-          <a:ln/>
-        </p:spPr>
-        <p:txBody>
-          <a:bodyPr wrap="square" lIns="0" tIns="0" rIns="0" bIns="0" rtlCol="0" anchor="ctr"/>
-          <a:lstStyle/>
-          <a:p>
-            <a:pPr algn="ctr" indent="0" marL="0">
-              <a:buNone/>
-            </a:pPr>
-            <a:r>
-              <a:rPr lang="en-US" sz="1100" b="1" dirty="0">
-                <a:solidFill>
-                  <a:schemeClr val="bg1"/>
-                </a:solidFill>
-                <a:latin typeface="Cambria" pitchFamily="34" charset="0"/>
-                <a:ea typeface="Cambria" pitchFamily="34" charset="-122"/>
-                <a:cs typeface="Cambria" pitchFamily="34" charset="-120"/>
-              </a:rPr>
-              <a:t>4</a:t>
-            </a:r>
-            <a:endParaRPr lang="en-US" sz="1100" dirty="0"/>
-          </a:p>
-        </p:txBody>
-      </p:sp>
-      <p:sp>
-        <p:nvSpPr>
-          <p:cNvPr id="21" name="take-head"/>
-          <p:cNvSpPr txBox="1"/>
-          <p:nvPr/>
-        </p:nvSpPr>
-        <p:spPr>
-          <a:xfrm>
-            <a:off x="987552" y="2843784"/>
-            <a:ext cx="1600200" cy="438912"/>
-          </a:xfrm>
-          <a:prstGeom prst="rect">
-            <a:avLst/>
-          </a:prstGeom>
-          <a:noFill/>
-          <a:ln/>
-        </p:spPr>
-        <p:txBody>
-          <a:bodyPr wrap="square" lIns="0" tIns="0" rIns="0" bIns="0" rtlCol="0" anchor="ctr"/>
-          <a:lstStyle/>
-          <a:p>
-            <a:pPr indent="0" marL="0">
-              <a:buNone/>
-            </a:pPr>
-            <a:r>
-              <a:rPr lang="en-US" sz="1100" b="1" dirty="0">
-                <a:solidFill>
-                  <a:schemeClr val="tx2"/>
-                </a:solidFill>
-              </a:rPr>
-              <a:t>Stale news cuts both ways</a:t>
-            </a:r>
-            <a:endParaRPr lang="en-US" sz="1100" dirty="0"/>
-          </a:p>
-        </p:txBody>
-      </p:sp>
-      <p:sp>
-        <p:nvSpPr>
-          <p:cNvPr id="22" name="take-body"/>
-          <p:cNvSpPr txBox="1"/>
-          <p:nvPr/>
-        </p:nvSpPr>
-        <p:spPr>
-          <a:xfrm>
-            <a:off x="2651760" y="2843784"/>
-            <a:ext cx="3474720" cy="438912"/>
-          </a:xfrm>
-          <a:prstGeom prst="rect">
-            <a:avLst/>
-          </a:prstGeom>
-          <a:noFill/>
-          <a:ln/>
-        </p:spPr>
-        <p:txBody>
-          <a:bodyPr wrap="square" lIns="0" tIns="0" rIns="0" bIns="0" rtlCol="0" anchor="ctr"/>
-          <a:lstStyle/>
-          <a:p>
-            <a:pPr indent="0" marL="0">
-              <a:buNone/>
-            </a:pPr>
-            <a:r>
-              <a:rPr lang="en-US" sz="1000" dirty="0">
-                <a:solidFill>
-                  <a:schemeClr val="tx1"/>
-                </a:solidFill>
-              </a:rPr>
-              <a:t>A stale optimistic signal halves failure, a stale pessimistic one raises it by half. Accurate news barely moves it.</a:t>
-            </a:r>
-            <a:endParaRPr lang="en-US" sz="1000" dirty="0"/>
-          </a:p>
-        </p:txBody>
-      </p:sp>
-      <p:sp>
-        <p:nvSpPr>
-          <p:cNvPr id="23" name="take-4"/>
-          <p:cNvSpPr/>
-          <p:nvPr/>
-        </p:nvSpPr>
-        <p:spPr>
-          <a:xfrm>
-            <a:off x="457200" y="3392424"/>
-            <a:ext cx="5760720" cy="512064"/>
-          </a:xfrm>
-          <a:prstGeom prst="roundRect">
-            <a:avLst>
-              <a:gd name="adj" fmla="val 14286"/>
-            </a:avLst>
-          </a:prstGeom>
-          <a:solidFill>
-            <a:schemeClr val="bg2"/>
-          </a:solidFill>
-          <a:ln w="12700">
-            <a:solidFill>
-              <a:schemeClr val="bg2"/>
-            </a:solidFill>
-            <a:prstDash val="solid"/>
-          </a:ln>
-        </p:spPr>
-      </p:sp>
-      <p:sp>
-        <p:nvSpPr>
-          <p:cNvPr id="24" name="chip"/>
-          <p:cNvSpPr/>
-          <p:nvPr/>
-        </p:nvSpPr>
-        <p:spPr>
-          <a:xfrm>
-            <a:off x="548640" y="3483864"/>
-            <a:ext cx="329184" cy="329184"/>
-          </a:xfrm>
-          <a:prstGeom prst="roundRect">
-            <a:avLst>
-              <a:gd name="adj" fmla="val 16667"/>
-            </a:avLst>
-          </a:prstGeom>
-          <a:solidFill>
-            <a:schemeClr val="accent1"/>
-          </a:solidFill>
-          <a:ln w="12700">
-            <a:solidFill>
-              <a:schemeClr val="accent1"/>
-            </a:solidFill>
-            <a:prstDash val="solid"/>
-          </a:ln>
-        </p:spPr>
-      </p:sp>
-      <p:sp>
-        <p:nvSpPr>
-          <p:cNvPr id="25" name="chip-label"/>
-          <p:cNvSpPr txBox="1"/>
-          <p:nvPr/>
-        </p:nvSpPr>
-        <p:spPr>
-          <a:xfrm>
-            <a:off x="548640" y="3483864"/>
-            <a:ext cx="329184" cy="329184"/>
-          </a:xfrm>
-          <a:prstGeom prst="rect">
-            <a:avLst/>
-          </a:prstGeom>
-          <a:noFill/>
-          <a:ln/>
-        </p:spPr>
-        <p:txBody>
-          <a:bodyPr wrap="square" lIns="0" tIns="0" rIns="0" bIns="0" rtlCol="0" anchor="ctr"/>
-          <a:lstStyle/>
-          <a:p>
-            <a:pPr algn="ctr" indent="0" marL="0">
-              <a:buNone/>
-            </a:pPr>
-            <a:r>
-              <a:rPr lang="en-US" sz="1100" b="1" dirty="0">
-                <a:solidFill>
-                  <a:schemeClr val="bg1"/>
-                </a:solidFill>
-                <a:latin typeface="Cambria" pitchFamily="34" charset="0"/>
-                <a:ea typeface="Cambria" pitchFamily="34" charset="-122"/>
-                <a:cs typeface="Cambria" pitchFamily="34" charset="-120"/>
-              </a:rPr>
-              <a:t>5</a:t>
-            </a:r>
-            <a:endParaRPr lang="en-US" sz="1100" dirty="0"/>
-          </a:p>
-        </p:txBody>
-      </p:sp>
-      <p:sp>
-        <p:nvSpPr>
-          <p:cNvPr id="26" name="take-head"/>
-          <p:cNvSpPr txBox="1"/>
-          <p:nvPr/>
-        </p:nvSpPr>
-        <p:spPr>
-          <a:xfrm>
-            <a:off x="987552" y="3429000"/>
-            <a:ext cx="1600200" cy="438912"/>
-          </a:xfrm>
-          <a:prstGeom prst="rect">
-            <a:avLst/>
-          </a:prstGeom>
-          <a:noFill/>
-          <a:ln/>
-        </p:spPr>
-        <p:txBody>
-          <a:bodyPr wrap="square" lIns="0" tIns="0" rIns="0" bIns="0" rtlCol="0" anchor="ctr"/>
-          <a:lstStyle/>
-          <a:p>
-            <a:pPr indent="0" marL="0">
-              <a:buNone/>
-            </a:pPr>
-            <a:r>
-              <a:rPr lang="en-US" sz="1100" b="1" dirty="0">
-                <a:solidFill>
-                  <a:schemeClr val="tx2"/>
-                </a:solidFill>
-              </a:rPr>
-              <a:t>Capping the largest deposits</a:t>
-            </a:r>
-            <a:endParaRPr lang="en-US" sz="1100" dirty="0"/>
-          </a:p>
-        </p:txBody>
-      </p:sp>
-      <p:sp>
-        <p:nvSpPr>
-          <p:cNvPr id="27" name="take-body"/>
-          <p:cNvSpPr txBox="1"/>
-          <p:nvPr/>
-        </p:nvSpPr>
-        <p:spPr>
-          <a:xfrm>
-            <a:off x="2651760" y="3429000"/>
-            <a:ext cx="3474720" cy="438912"/>
-          </a:xfrm>
-          <a:prstGeom prst="rect">
-            <a:avLst/>
-          </a:prstGeom>
-          <a:noFill/>
-          <a:ln/>
-        </p:spPr>
-        <p:txBody>
-          <a:bodyPr wrap="square" lIns="0" tIns="0" rIns="0" bIns="0" rtlCol="0" anchor="ctr"/>
-          <a:lstStyle/>
-          <a:p>
-            <a:pPr indent="0" marL="0">
-              <a:buNone/>
-            </a:pPr>
-            <a:r>
-              <a:rPr lang="en-US" sz="1000" dirty="0">
-                <a:solidFill>
-                  <a:schemeClr val="tx1"/>
-                </a:solidFill>
-              </a:rPr>
-              <a:t>A 1% cap brings failure down to the no-concentration bank’s level; the culture gradient is unchanged.</a:t>
-            </a:r>
-            <a:endParaRPr lang="en-US" sz="1000" dirty="0"/>
-          </a:p>
-        </p:txBody>
-      </p:sp>
-      <p:sp>
-        <p:nvSpPr>
-          <p:cNvPr id="28" name="take-5"/>
-          <p:cNvSpPr/>
-          <p:nvPr/>
-        </p:nvSpPr>
-        <p:spPr>
-          <a:xfrm>
-            <a:off x="457200" y="3977640"/>
-            <a:ext cx="5760720" cy="512064"/>
-          </a:xfrm>
-          <a:prstGeom prst="roundRect">
-            <a:avLst>
-              <a:gd name="adj" fmla="val 14286"/>
-            </a:avLst>
-          </a:prstGeom>
-          <a:solidFill>
-            <a:schemeClr val="accent4"/>
-          </a:solidFill>
-          <a:ln w="12700">
-            <a:solidFill>
-              <a:schemeClr val="accent4"/>
-            </a:solidFill>
-            <a:prstDash val="solid"/>
-          </a:ln>
-        </p:spPr>
-      </p:sp>
-      <p:sp>
-        <p:nvSpPr>
-          <p:cNvPr id="29" name="chip"/>
-          <p:cNvSpPr/>
-          <p:nvPr/>
-        </p:nvSpPr>
-        <p:spPr>
-          <a:xfrm>
-            <a:off x="548640" y="4069080"/>
-            <a:ext cx="329184" cy="329184"/>
-          </a:xfrm>
-          <a:prstGeom prst="roundRect">
-            <a:avLst>
-              <a:gd name="adj" fmla="val 16667"/>
-            </a:avLst>
-          </a:prstGeom>
-          <a:solidFill>
-            <a:schemeClr val="accent2"/>
-          </a:solidFill>
-          <a:ln w="12700">
-            <a:solidFill>
-              <a:schemeClr val="accent2"/>
-            </a:solidFill>
-            <a:prstDash val="solid"/>
-          </a:ln>
-        </p:spPr>
-      </p:sp>
-      <p:sp>
-        <p:nvSpPr>
-          <p:cNvPr id="30" name="chip-label"/>
-          <p:cNvSpPr txBox="1"/>
-          <p:nvPr/>
-        </p:nvSpPr>
-        <p:spPr>
-          <a:xfrm>
-            <a:off x="548640" y="4069080"/>
-            <a:ext cx="329184" cy="329184"/>
-          </a:xfrm>
-          <a:prstGeom prst="rect">
-            <a:avLst/>
-          </a:prstGeom>
-          <a:noFill/>
-          <a:ln/>
-        </p:spPr>
-        <p:txBody>
-          <a:bodyPr wrap="square" lIns="0" tIns="0" rIns="0" bIns="0" rtlCol="0" anchor="ctr"/>
-          <a:lstStyle/>
-          <a:p>
-            <a:pPr algn="ctr" indent="0" marL="0">
-              <a:buNone/>
-            </a:pPr>
-            <a:r>
-              <a:rPr lang="en-US" sz="1100" b="1" dirty="0">
-                <a:solidFill>
-                  <a:schemeClr val="bg1"/>
-                </a:solidFill>
-                <a:latin typeface="Cambria" pitchFamily="34" charset="0"/>
-                <a:ea typeface="Cambria" pitchFamily="34" charset="-122"/>
-                <a:cs typeface="Cambria" pitchFamily="34" charset="-120"/>
-              </a:rPr>
-              <a:t>6</a:t>
-            </a:r>
-            <a:endParaRPr lang="en-US" sz="1100" dirty="0"/>
-          </a:p>
-        </p:txBody>
-      </p:sp>
-      <p:sp>
-        <p:nvSpPr>
-          <p:cNvPr id="31" name="take-head"/>
-          <p:cNvSpPr txBox="1"/>
-          <p:nvPr/>
-        </p:nvSpPr>
-        <p:spPr>
-          <a:xfrm>
-            <a:off x="987552" y="4014216"/>
-            <a:ext cx="1600200" cy="438912"/>
-          </a:xfrm>
-          <a:prstGeom prst="rect">
-            <a:avLst/>
-          </a:prstGeom>
-          <a:noFill/>
-          <a:ln/>
-        </p:spPr>
-        <p:txBody>
-          <a:bodyPr wrap="square" lIns="0" tIns="0" rIns="0" bIns="0" rtlCol="0" anchor="ctr"/>
-          <a:lstStyle/>
-          <a:p>
-            <a:pPr indent="0" marL="0">
-              <a:buNone/>
-            </a:pPr>
-            <a:r>
-              <a:rPr lang="en-US" sz="1100" b="1" dirty="0">
-                <a:solidFill>
-                  <a:schemeClr val="tx2"/>
-                </a:solidFill>
-              </a:rPr>
-              <a:t>Not yet matched</a:t>
-            </a:r>
-            <a:endParaRPr lang="en-US" sz="1100" dirty="0"/>
-          </a:p>
-        </p:txBody>
-      </p:sp>
-      <p:sp>
-        <p:nvSpPr>
-          <p:cNvPr id="32" name="take-body"/>
-          <p:cNvSpPr txBox="1"/>
-          <p:nvPr/>
-        </p:nvSpPr>
-        <p:spPr>
-          <a:xfrm>
-            <a:off x="2651760" y="4014216"/>
-            <a:ext cx="3474720" cy="438912"/>
-          </a:xfrm>
-          <a:prstGeom prst="rect">
-            <a:avLst/>
-          </a:prstGeom>
-          <a:noFill/>
-          <a:ln/>
-        </p:spPr>
-        <p:txBody>
-          <a:bodyPr wrap="square" lIns="0" tIns="0" rIns="0" bIns="0" rtlCol="0" anchor="ctr"/>
-          <a:lstStyle/>
-          <a:p>
-            <a:pPr indent="0" marL="0">
-              <a:buNone/>
-            </a:pPr>
-            <a:r>
-              <a:rPr lang="en-US" sz="1000" dirty="0">
-                <a:solidFill>
-                  <a:schemeClr val="tx1"/>
-                </a:solidFill>
-              </a:rPr>
-              <a:t>How Celsius’s largest depositors exit: one-shot share 0.35 there, 0.93 or more in the model.</a:t>
-            </a:r>
-            <a:endParaRPr lang="en-US" sz="1000" dirty="0"/>
-          </a:p>
-        </p:txBody>
-      </p:sp>
-      <p:sp>
-        <p:nvSpPr>
-          <p:cNvPr id="33" name="next"/>
-          <p:cNvSpPr/>
-          <p:nvPr/>
-        </p:nvSpPr>
-        <p:spPr>
-          <a:xfrm>
-            <a:off x="6400800" y="1051560"/>
-            <a:ext cx="2286000" cy="3438144"/>
-          </a:xfrm>
-          <a:prstGeom prst="roundRect">
-            <a:avLst>
-              <a:gd name="adj" fmla="val 3200"/>
-            </a:avLst>
-          </a:prstGeom>
-          <a:solidFill>
-            <a:schemeClr val="bg2"/>
-          </a:solidFill>
-          <a:ln w="12700">
-            <a:solidFill>
-              <a:schemeClr val="bg2"/>
-            </a:solidFill>
-            <a:prstDash val="solid"/>
-          </a:ln>
-        </p:spPr>
-      </p:sp>
-      <p:sp>
-        <p:nvSpPr>
-          <p:cNvPr id="34" name="next-head"/>
-          <p:cNvSpPr txBox="1"/>
-          <p:nvPr/>
-        </p:nvSpPr>
-        <p:spPr>
-          <a:xfrm>
-            <a:off x="6537960" y="1143000"/>
-            <a:ext cx="2011680" cy="320040"/>
-          </a:xfrm>
-          <a:prstGeom prst="rect">
-            <a:avLst/>
-          </a:prstGeom>
-          <a:noFill/>
-          <a:ln/>
-        </p:spPr>
-        <p:txBody>
-          <a:bodyPr wrap="square" lIns="0" tIns="0" rIns="0" bIns="0" rtlCol="0" anchor="ctr"/>
-          <a:lstStyle/>
-          <a:p>
-            <a:pPr indent="0" marL="0">
-              <a:buNone/>
-            </a:pPr>
-            <a:r>
-              <a:rPr lang="en-US" sz="1300" b="1" dirty="0">
-                <a:solidFill>
-                  <a:schemeClr val="tx2"/>
-                </a:solidFill>
-              </a:rPr>
-              <a:t>Next steps</a:t>
-            </a:r>
-            <a:endParaRPr lang="en-US" sz="1300" dirty="0"/>
-          </a:p>
-        </p:txBody>
-      </p:sp>
-      <p:sp>
-        <p:nvSpPr>
-          <p:cNvPr id="35" name="bullets"/>
-          <p:cNvSpPr txBox="1"/>
-          <p:nvPr/>
-        </p:nvSpPr>
-        <p:spPr>
-          <a:xfrm>
-            <a:off x="6537960" y="1508760"/>
-            <a:ext cx="2011680" cy="2926080"/>
-          </a:xfrm>
-          <a:prstGeom prst="rect">
-            <a:avLst/>
-          </a:prstGeom>
-          <a:noFill/>
-          <a:ln/>
-        </p:spPr>
-        <p:txBody>
-          <a:bodyPr wrap="square" lIns="0" tIns="0" rIns="0" bIns="0" rtlCol="0" anchor="t"/>
-          <a:lstStyle/>
-          <a:p>
-            <a:pPr marL="177800" indent="-177800">
-              <a:spcAft>
-                <a:spcPts val="700"/>
-              </a:spcAft>
-              <a:buSzPct val="100000"/>
-              <a:buChar char="•"/>
-            </a:pPr>
-            <a:r>
-              <a:rPr lang="en-US" sz="1100" dirty="0">
-                <a:solidFill>
-                  <a:schemeClr val="tx1"/>
-                </a:solidFill>
-              </a:rPr>
-              <a:t>Super-individuals, to match how the largest depositors exited Celsius</a:t>
-            </a:r>
-            <a:endParaRPr lang="en-US" sz="1100" dirty="0"/>
-          </a:p>
-          <a:p>
-            <a:pPr marL="177800" indent="-177800">
-              <a:spcAft>
-                <a:spcPts val="700"/>
-              </a:spcAft>
-              <a:buSzPct val="100000"/>
-              <a:buChar char="•"/>
-            </a:pPr>
-            <a:r>
-              <a:rPr lang="en-US" sz="1100" dirty="0">
-                <a:solidFill>
-                  <a:schemeClr val="tx1"/>
-                </a:solidFill>
-              </a:rPr>
-              <a:t>Deposit insurance and the reserve ratio on the fire-sale bank</a:t>
-            </a:r>
-            <a:endParaRPr lang="en-US" sz="1100" dirty="0"/>
-          </a:p>
-          <a:p>
-            <a:pPr marL="177800" indent="-177800">
-              <a:spcAft>
-                <a:spcPts val="700"/>
-              </a:spcAft>
-              <a:buSzPct val="100000"/>
-              <a:buChar char="•"/>
-            </a:pPr>
-            <a:r>
-              <a:rPr lang="en-US" sz="1100" dirty="0">
-                <a:solidFill>
-                  <a:schemeClr val="tx1"/>
-                </a:solidFill>
-              </a:rPr>
-              <a:t>Network topology and learning</a:t>
-            </a:r>
-            <a:endParaRPr lang="en-US" sz="1100" dirty="0"/>
-          </a:p>
-          <a:p>
-            <a:pPr marL="177800" indent="-177800">
-              <a:spcAft>
-                <a:spcPts val="700"/>
-              </a:spcAft>
-              <a:buSzPct val="100000"/>
-              <a:buChar char="•"/>
-            </a:pPr>
-            <a:r>
-              <a:rPr lang="en-US" sz="1100" dirty="0">
-                <a:solidFill>
-                  <a:schemeClr val="tx1"/>
-                </a:solidFill>
-              </a:rPr>
-              <a:t>Full sweep: stale public signal plus no-signal baseline, CARA 0.1, σ reported</a:t>
-            </a:r>
-            <a:endParaRPr lang="en-US" sz="1100" dirty="0"/>
+              <a:t>How large depositors exit in real runs: one-shot share about 0.35 there, 0.93 or more in the model.</a:t>
+            </a:r>
+            <a:endParaRPr lang="en-US" sz="1200" dirty="0"/>
           </a:p>
         </p:txBody>
       </p:sp>

</xml_diff>

<commit_message>
Deck: takeaway 6 without the one-shot numbers
Co-Authored-By: Claude Fable 5.1 <noreply@anthropic.com>
</commit_message>
<xml_diff>
--- a/docs/deck_2026-10-26_seminar.pptx
+++ b/docs/deck_2026-10-26_seminar.pptx
@@ -120,7 +120,7 @@
   <p:extLst>
     <p:ext uri="{521415D9-36F7-43E2-AB2F-B90AF26B5E84}">
       <p14:sectionLst xmlns:p14="http://schemas.microsoft.com/office/powerpoint/2010/main">
-        <p14:section name="Opening" id="{3c0f1e0c-7c18-eb01-bf6a-11c8510f56ac}">
+        <p14:section name="Opening" id="{b281086f-10c5-245c-420f-c960da7f8fbc}">
           <p14:sldIdLst>
             <p14:sldId id="256"/>
             <p14:sldId id="257"/>
@@ -130,13 +130,13 @@
             <p14:sldId id="261"/>
           </p14:sldIdLst>
         </p14:section>
-        <p14:section name="The model" id="{5c1b3cfd-5638-9a33-58d5-7f895a2e268f}">
+        <p14:section name="The model" id="{e7051012-8c73-fd7a-61c6-a429ab3145fb}">
           <p14:sldIdLst>
             <p14:sldId id="262"/>
             <p14:sldId id="263"/>
           </p14:sldIdLst>
         </p14:section>
-        <p14:section name="Results" id="{bff05c9e-5350-fc9e-a1bc-a5ca9e23503c}">
+        <p14:section name="Results" id="{6f70587a-91e7-e1af-07af-3daf5fdd2bc9}">
           <p14:sldIdLst>
             <p14:sldId id="264"/>
             <p14:sldId id="265"/>
@@ -144,12 +144,12 @@
             <p14:sldId id="267"/>
           </p14:sldIdLst>
         </p14:section>
-        <p14:section name="Validation" id="{e569a8c1-abeb-152c-bec6-dd04644ace26}">
+        <p14:section name="Validation" id="{4313d352-190c-de3a-0abb-3fca065fe1c0}">
           <p14:sldIdLst>
             <p14:sldId id="268"/>
           </p14:sldIdLst>
         </p14:section>
-        <p14:section name="Close" id="{b73275a0-fad0-4d42-c4db-b551958915af}">
+        <p14:section name="Close" id="{24f3d447-6751-12b6-e3f2-65b5a9054412}">
           <p14:sldIdLst>
             <p14:sldId id="269"/>
           </p14:sldIdLst>
@@ -3647,7 +3647,7 @@
                   <a:schemeClr val="tx1"/>
                 </a:solidFill>
               </a:rPr>
-              <a:t>How large depositors exit in real runs: one-shot share about 0.35 there, 0.93 or more in the model.</a:t>
+              <a:t>How large depositors exit in real runs.</a:t>
             </a:r>
             <a:endParaRPr lang="en-US" sz="1200" dirty="0"/>
           </a:p>

</xml_diff>

<commit_message>
Deck: slide 3 columns without card shading
Co-Authored-By: Claude Fable 5.1 <noreply@anthropic.com>
</commit_message>
<xml_diff>
--- a/docs/deck_2026-10-26_seminar.pptx
+++ b/docs/deck_2026-10-26_seminar.pptx
@@ -120,7 +120,7 @@
   <p:extLst>
     <p:ext uri="{521415D9-36F7-43E2-AB2F-B90AF26B5E84}">
       <p14:sectionLst xmlns:p14="http://schemas.microsoft.com/office/powerpoint/2010/main">
-        <p14:section name="Opening" id="{b281086f-10c5-245c-420f-c960da7f8fbc}">
+        <p14:section name="Opening" id="{8ad3b9cd-eb38-cf3b-df61-9f00c8726f63}">
           <p14:sldIdLst>
             <p14:sldId id="256"/>
             <p14:sldId id="257"/>
@@ -130,13 +130,13 @@
             <p14:sldId id="261"/>
           </p14:sldIdLst>
         </p14:section>
-        <p14:section name="The model" id="{e7051012-8c73-fd7a-61c6-a429ab3145fb}">
+        <p14:section name="The model" id="{21fa26a8-ee32-d805-174b-c13f3ff7c2ee}">
           <p14:sldIdLst>
             <p14:sldId id="262"/>
             <p14:sldId id="263"/>
           </p14:sldIdLst>
         </p14:section>
-        <p14:section name="Results" id="{6f70587a-91e7-e1af-07af-3daf5fdd2bc9}">
+        <p14:section name="Results" id="{d956cebf-f002-c8d4-bcec-2e7f469fcc06}">
           <p14:sldIdLst>
             <p14:sldId id="264"/>
             <p14:sldId id="265"/>
@@ -144,12 +144,12 @@
             <p14:sldId id="267"/>
           </p14:sldIdLst>
         </p14:section>
-        <p14:section name="Validation" id="{4313d352-190c-de3a-0abb-3fca065fe1c0}">
+        <p14:section name="Validation" id="{62898186-09f2-1605-547b-463032f94ec9}">
           <p14:sldIdLst>
             <p14:sldId id="268"/>
           </p14:sldIdLst>
         </p14:section>
-        <p14:section name="Close" id="{24f3d447-6751-12b6-e3f2-65b5a9054412}">
+        <p14:section name="Close" id="{f2141c3d-d899-de71-8440-9eb3b0af1c00}">
           <p14:sldIdLst>
             <p14:sldId id="269"/>
           </p14:sldIdLst>
@@ -3931,34 +3931,7 @@
       </p:sp>
       <p:sp>
         <p:nvSpPr>
-          <p:cNvPr id="3" name="mech-0"/>
-          <p:cNvSpPr/>
-          <p:nvPr/>
-        </p:nvSpPr>
-        <p:spPr>
-          <a:xfrm>
-            <a:off x="457200" y="1051560"/>
-            <a:ext cx="4023360" cy="2514600"/>
-          </a:xfrm>
-          <a:prstGeom prst="roundRect">
-            <a:avLst>
-              <a:gd name="adj" fmla="val 2909"/>
-            </a:avLst>
-          </a:prstGeom>
-          <a:solidFill>
-            <a:schemeClr val="bg2"/>
-          </a:solidFill>
-          <a:ln w="12700">
-            <a:solidFill>
-              <a:schemeClr val="bg2"/>
-            </a:solidFill>
-            <a:prstDash val="solid"/>
-          </a:ln>
-        </p:spPr>
-      </p:sp>
-      <p:sp>
-        <p:nvSpPr>
-          <p:cNvPr id="4" name="mech-head"/>
+          <p:cNvPr id="3" name="mech-head"/>
           <p:cNvSpPr txBox="1"/>
           <p:nvPr/>
         </p:nvSpPr>
@@ -3994,7 +3967,7 @@
       </p:sp>
       <p:sp>
         <p:nvSpPr>
-          <p:cNvPr id="5" name="bullets"/>
+          <p:cNvPr id="4" name="bullets"/>
           <p:cNvSpPr txBox="1"/>
           <p:nvPr/>
         </p:nvSpPr>
@@ -4088,34 +4061,7 @@
       </p:sp>
       <p:sp>
         <p:nvSpPr>
-          <p:cNvPr id="6" name="mech-1"/>
-          <p:cNvSpPr/>
-          <p:nvPr/>
-        </p:nvSpPr>
-        <p:spPr>
-          <a:xfrm>
-            <a:off x="4663440" y="1051560"/>
-            <a:ext cx="4023360" cy="2514600"/>
-          </a:xfrm>
-          <a:prstGeom prst="roundRect">
-            <a:avLst>
-              <a:gd name="adj" fmla="val 2909"/>
-            </a:avLst>
-          </a:prstGeom>
-          <a:solidFill>
-            <a:schemeClr val="bg2"/>
-          </a:solidFill>
-          <a:ln w="12700">
-            <a:solidFill>
-              <a:schemeClr val="bg2"/>
-            </a:solidFill>
-            <a:prstDash val="solid"/>
-          </a:ln>
-        </p:spPr>
-      </p:sp>
-      <p:sp>
-        <p:nvSpPr>
-          <p:cNvPr id="7" name="mech-head"/>
+          <p:cNvPr id="5" name="mech-head"/>
           <p:cNvSpPr txBox="1"/>
           <p:nvPr/>
         </p:nvSpPr>
@@ -4151,7 +4097,7 @@
       </p:sp>
       <p:sp>
         <p:nvSpPr>
-          <p:cNvPr id="8" name="bullets"/>
+          <p:cNvPr id="6" name="bullets"/>
           <p:cNvSpPr txBox="1"/>
           <p:nvPr/>
         </p:nvSpPr>

</xml_diff>

<commit_message>
Deck: culture slide without its lead line; disposition sentence dropped
Co-Authored-By: Claude Fable 5.1 <noreply@anthropic.com>
</commit_message>
<xml_diff>
--- a/docs/deck_2026-10-26_seminar.pptx
+++ b/docs/deck_2026-10-26_seminar.pptx
@@ -120,7 +120,7 @@
   <p:extLst>
     <p:ext uri="{521415D9-36F7-43E2-AB2F-B90AF26B5E84}">
       <p14:sectionLst xmlns:p14="http://schemas.microsoft.com/office/powerpoint/2010/main">
-        <p14:section name="Opening" id="{8ad3b9cd-eb38-cf3b-df61-9f00c8726f63}">
+        <p14:section name="Opening" id="{c120e781-6f4e-3440-9e28-992d777fd984}">
           <p14:sldIdLst>
             <p14:sldId id="256"/>
             <p14:sldId id="257"/>
@@ -130,13 +130,13 @@
             <p14:sldId id="261"/>
           </p14:sldIdLst>
         </p14:section>
-        <p14:section name="The model" id="{21fa26a8-ee32-d805-174b-c13f3ff7c2ee}">
+        <p14:section name="The model" id="{37153be5-aebb-3165-4d48-73fceba3bdd1}">
           <p14:sldIdLst>
             <p14:sldId id="262"/>
             <p14:sldId id="263"/>
           </p14:sldIdLst>
         </p14:section>
-        <p14:section name="Results" id="{d956cebf-f002-c8d4-bcec-2e7f469fcc06}">
+        <p14:section name="Results" id="{195a147b-a6a6-80f3-9260-ed96a3502ce2}">
           <p14:sldIdLst>
             <p14:sldId id="264"/>
             <p14:sldId id="265"/>
@@ -144,12 +144,12 @@
             <p14:sldId id="267"/>
           </p14:sldIdLst>
         </p14:section>
-        <p14:section name="Validation" id="{62898186-09f2-1605-547b-463032f94ec9}">
+        <p14:section name="Validation" id="{2ac6484c-7871-1830-4175-e4e74f670d0a}">
           <p14:sldIdLst>
             <p14:sldId id="268"/>
           </p14:sldIdLst>
         </p14:section>
-        <p14:section name="Close" id="{f2141c3d-d899-de71-8440-9eb3b0af1c00}">
+        <p14:section name="Close" id="{825121fc-4db3-f1d9-7784-9aaae9366bd1}">
           <p14:sldIdLst>
             <p14:sldId id="269"/>
           </p14:sldIdLst>
@@ -4485,50 +4485,14 @@
       </p:sp>
       <p:sp>
         <p:nvSpPr>
-          <p:cNvPr id="3" name="step-lead"/>
+          <p:cNvPr id="3" name="step-items"/>
           <p:cNvSpPr txBox="1"/>
           <p:nvPr/>
         </p:nvSpPr>
         <p:spPr>
           <a:xfrm>
-            <a:off x="457200" y="1051560"/>
-            <a:ext cx="8229600" cy="868680"/>
-          </a:xfrm>
-          <a:prstGeom prst="rect">
-            <a:avLst/>
-          </a:prstGeom>
-          <a:noFill/>
-          <a:ln/>
-        </p:spPr>
-        <p:txBody>
-          <a:bodyPr wrap="square" lIns="0" tIns="0" rIns="0" bIns="0" rtlCol="0" anchor="ctr"/>
-          <a:lstStyle/>
-          <a:p>
-            <a:pPr indent="0" marL="0">
-              <a:buNone/>
-            </a:pPr>
-            <a:r>
-              <a:rPr lang="en-US" sz="1700" b="1" dirty="0">
-                <a:solidFill>
-                  <a:schemeClr val="tx2"/>
-                </a:solidFill>
-              </a:rPr>
-              <a:t>Culture supplies a weight that differs across depositors, is set before the run, and does not move with the information environment.</a:t>
-            </a:r>
-            <a:endParaRPr lang="en-US" sz="1700" dirty="0"/>
-          </a:p>
-        </p:txBody>
-      </p:sp>
-      <p:sp>
-        <p:nvSpPr>
-          <p:cNvPr id="4" name="step-items"/>
-          <p:cNvSpPr txBox="1"/>
-          <p:nvPr/>
-        </p:nvSpPr>
-        <p:spPr>
-          <a:xfrm>
-            <a:off x="457200" y="2103120"/>
-            <a:ext cx="8229600" cy="2103120"/>
+            <a:off x="457200" y="1188720"/>
+            <a:ext cx="8229600" cy="3017520"/>
           </a:xfrm>
           <a:prstGeom prst="rect">
             <a:avLst/>
@@ -4567,7 +4531,7 @@
                   <a:schemeClr val="tx1"/>
                 </a:solidFill>
               </a:rPr>
-              <a:t>Cultural values pass largely unchanged from parents to children (Guiso, Sapienza, Zingales; Bazzi et al.). The weight is a disposition, not a calculation.</a:t>
+              <a:t>Cultural values pass largely unchanged from parents to children (Guiso, Sapienza, Zingales; Bazzi et al.).</a:t>
             </a:r>
             <a:endParaRPr lang="en-US" sz="1400" dirty="0"/>
           </a:p>

</xml_diff>

<commit_message>
Deck: culture slide bullets reworded
Co-Authored-By: Claude Fable 5.1 <noreply@anthropic.com>
</commit_message>
<xml_diff>
--- a/docs/deck_2026-10-26_seminar.pptx
+++ b/docs/deck_2026-10-26_seminar.pptx
@@ -120,7 +120,7 @@
   <p:extLst>
     <p:ext uri="{521415D9-36F7-43E2-AB2F-B90AF26B5E84}">
       <p14:sectionLst xmlns:p14="http://schemas.microsoft.com/office/powerpoint/2010/main">
-        <p14:section name="Opening" id="{c120e781-6f4e-3440-9e28-992d777fd984}">
+        <p14:section name="Opening" id="{13e4db2b-f004-4929-528c-f2d17e2d1dd9}">
           <p14:sldIdLst>
             <p14:sldId id="256"/>
             <p14:sldId id="257"/>
@@ -130,13 +130,13 @@
             <p14:sldId id="261"/>
           </p14:sldIdLst>
         </p14:section>
-        <p14:section name="The model" id="{37153be5-aebb-3165-4d48-73fceba3bdd1}">
+        <p14:section name="The model" id="{f77a608f-a50b-b9ca-a202-5520211cbd29}">
           <p14:sldIdLst>
             <p14:sldId id="262"/>
             <p14:sldId id="263"/>
           </p14:sldIdLst>
         </p14:section>
-        <p14:section name="Results" id="{195a147b-a6a6-80f3-9260-ed96a3502ce2}">
+        <p14:section name="Results" id="{772b5bf7-aa53-b7b4-1131-512b348abced}">
           <p14:sldIdLst>
             <p14:sldId id="264"/>
             <p14:sldId id="265"/>
@@ -144,12 +144,12 @@
             <p14:sldId id="267"/>
           </p14:sldIdLst>
         </p14:section>
-        <p14:section name="Validation" id="{2ac6484c-7871-1830-4175-e4e74f670d0a}">
+        <p14:section name="Validation" id="{d3bdf570-f543-e169-e41b-803b868e27b7}">
           <p14:sldIdLst>
             <p14:sldId id="268"/>
           </p14:sldIdLst>
         </p14:section>
-        <p14:section name="Close" id="{825121fc-4db3-f1d9-7784-9aaae9366bd1}">
+        <p14:section name="Close" id="{bfa1e8a0-a0ca-6086-3258-0e5cde0f1140}">
           <p14:sldIdLst>
             <p14:sldId id="269"/>
           </p14:sldIdLst>
@@ -4517,7 +4517,7 @@
                   <a:schemeClr val="tx1"/>
                 </a:solidFill>
               </a:rPr>
-              <a:t>Transmitted, not chosen. </a:t>
+              <a:t>Transmitted weights. </a:t>
             </a:r>
             <a:pPr indent="0" marL="0">
               <a:spcAft>
@@ -4549,7 +4549,7 @@
                   <a:schemeClr val="tx1"/>
                 </a:solidFill>
               </a:rPr>
-              <a:t>Individualism is the right dimension. </a:t>
+              <a:t>Individualism </a:t>
             </a:r>
             <a:pPr indent="0" marL="0">
               <a:spcAft>
@@ -4563,7 +4563,7 @@
                   <a:schemeClr val="tx1"/>
                 </a:solidFill>
               </a:rPr>
-              <a:t>Self-reliance against deference to the group (Hofstede) is the private-against-social weighting the model already contains (Gorodnichenko–Roland).</a:t>
+              <a:t>as self-reliance against deference to the group (Hofstede) is the private-against-social weighting the model already contains (Gorodnichenko–Roland).</a:t>
             </a:r>
             <a:endParaRPr lang="en-US" sz="1400" dirty="0"/>
           </a:p>
@@ -4595,7 +4595,7 @@
                   <a:schemeClr val="tx1"/>
                 </a:solidFill>
               </a:rPr>
-              <a:t>Given names carry it (Twenge et al.), so the weight can be observed, not assumed.</a:t>
+              <a:t>Given names carry it (Twenge et al.), so we can observe the weight instead of assuming it.</a:t>
             </a:r>
             <a:endParaRPr lang="en-US" sz="1400" dirty="0"/>
           </a:p>

</xml_diff>

<commit_message>
Deck: title slide names the venue, Markets and Society 2026
Co-Authored-By: Claude Fable 5.1 <noreply@anthropic.com>
</commit_message>
<xml_diff>
--- a/docs/deck_2026-10-26_seminar.pptx
+++ b/docs/deck_2026-10-26_seminar.pptx
@@ -120,7 +120,7 @@
   <p:extLst>
     <p:ext uri="{521415D9-36F7-43E2-AB2F-B90AF26B5E84}">
       <p14:sectionLst xmlns:p14="http://schemas.microsoft.com/office/powerpoint/2010/main">
-        <p14:section name="Opening" id="{13e4db2b-f004-4929-528c-f2d17e2d1dd9}">
+        <p14:section name="Opening" id="{1fa76bfe-7eb0-a57a-f9ab-de26fbff9853}">
           <p14:sldIdLst>
             <p14:sldId id="256"/>
             <p14:sldId id="257"/>
@@ -130,13 +130,13 @@
             <p14:sldId id="261"/>
           </p14:sldIdLst>
         </p14:section>
-        <p14:section name="The model" id="{f77a608f-a50b-b9ca-a202-5520211cbd29}">
+        <p14:section name="The model" id="{8f63fa55-fca3-9d31-faae-e7cb022e0248}">
           <p14:sldIdLst>
             <p14:sldId id="262"/>
             <p14:sldId id="263"/>
           </p14:sldIdLst>
         </p14:section>
-        <p14:section name="Results" id="{772b5bf7-aa53-b7b4-1131-512b348abced}">
+        <p14:section name="Results" id="{a6b1f877-02e5-088c-4f93-467249faa465}">
           <p14:sldIdLst>
             <p14:sldId id="264"/>
             <p14:sldId id="265"/>
@@ -144,12 +144,12 @@
             <p14:sldId id="267"/>
           </p14:sldIdLst>
         </p14:section>
-        <p14:section name="Validation" id="{d3bdf570-f543-e169-e41b-803b868e27b7}">
+        <p14:section name="Validation" id="{1334211a-053c-a8a6-c071-afd4ab268bc9}">
           <p14:sldIdLst>
             <p14:sldId id="268"/>
           </p14:sldIdLst>
         </p14:section>
-        <p14:section name="Close" id="{bfa1e8a0-a0ca-6086-3258-0e5cde0f1140}">
+        <p14:section name="Close" id="{e97a2cb0-cb34-6c99-cf3d-f3279421fe24}">
           <p14:sldIdLst>
             <p14:sldId id="269"/>
           </p14:sldIdLst>
@@ -2556,6 +2556,20 @@
               <a:rPr lang="en-US" sz="1800" dirty="0">
                 <a:solidFill>
                   <a:schemeClr val="accent4"/>
+                </a:solidFill>
+              </a:rPr>
+              <a:t>Markets and Society 2026</a:t>
+            </a:r>
+            <a:endParaRPr lang="en-US" sz="1800" dirty="0"/>
+          </a:p>
+          <a:p>
+            <a:pPr algn="ctr" indent="0" marL="0">
+              <a:buNone/>
+            </a:pPr>
+            <a:r>
+              <a:rPr lang="en-US" sz="1400" dirty="0">
+                <a:solidFill>
+                  <a:schemeClr val="accent3"/>
                 </a:solidFill>
               </a:rPr>
               <a:t>Walter Stover  ·  George Mason University  ·  26 October 2026</a:t>

</xml_diff>

<commit_message>
Deck: title capitalised; title-slide name line in the venue style, year dropped
Co-Authored-By: Claude Fable 5.1 <noreply@anthropic.com>
</commit_message>
<xml_diff>
--- a/docs/deck_2026-10-26_seminar.pptx
+++ b/docs/deck_2026-10-26_seminar.pptx
@@ -120,7 +120,7 @@
   <p:extLst>
     <p:ext uri="{521415D9-36F7-43E2-AB2F-B90AF26B5E84}">
       <p14:sectionLst xmlns:p14="http://schemas.microsoft.com/office/powerpoint/2010/main">
-        <p14:section name="Opening" id="{1fa76bfe-7eb0-a57a-f9ab-de26fbff9853}">
+        <p14:section name="Opening" id="{9341bb9d-c2d3-e0f9-7b76-63ca8ef59693}">
           <p14:sldIdLst>
             <p14:sldId id="256"/>
             <p14:sldId id="257"/>
@@ -130,13 +130,13 @@
             <p14:sldId id="261"/>
           </p14:sldIdLst>
         </p14:section>
-        <p14:section name="The model" id="{8f63fa55-fca3-9d31-faae-e7cb022e0248}">
+        <p14:section name="The model" id="{ee055e89-27c8-e65c-8bed-a00f3f9ac758}">
           <p14:sldIdLst>
             <p14:sldId id="262"/>
             <p14:sldId id="263"/>
           </p14:sldIdLst>
         </p14:section>
-        <p14:section name="Results" id="{a6b1f877-02e5-088c-4f93-467249faa465}">
+        <p14:section name="Results" id="{678c6eee-6df7-4b05-ea56-efe1890bbe5f}">
           <p14:sldIdLst>
             <p14:sldId id="264"/>
             <p14:sldId id="265"/>
@@ -144,12 +144,12 @@
             <p14:sldId id="267"/>
           </p14:sldIdLst>
         </p14:section>
-        <p14:section name="Validation" id="{1334211a-053c-a8a6-c071-afd4ab268bc9}">
+        <p14:section name="Validation" id="{9281544c-dc74-9b41-9ac0-8a55072b59f4}">
           <p14:sldIdLst>
             <p14:sldId id="268"/>
           </p14:sldIdLst>
         </p14:section>
-        <p14:section name="Close" id="{e97a2cb0-cb34-6c99-cf3d-f3279421fe24}">
+        <p14:section name="Close" id="{7ff35129-9451-9346-e521-a21b60c5f462}">
           <p14:sldIdLst>
             <p14:sldId id="269"/>
           </p14:sldIdLst>
@@ -1977,7 +1977,7 @@
                   <a:schemeClr val="accent3"/>
                 </a:solidFill>
               </a:rPr>
-              <a:t>Agent-based Diamond–Dybvig with cultural heterogeneity</a:t>
+              <a:t>Agent-based Diamond–Dybvig with Cultural Heterogeneity</a:t>
             </a:r>
             <a:endParaRPr lang="en-US" sz="900" dirty="0"/>
           </a:p>
@@ -2520,7 +2520,7 @@
                   <a:schemeClr val="bg1"/>
                 </a:solidFill>
               </a:rPr>
-              <a:t>Agent-based Diamond–Dybvig with cultural heterogeneity</a:t>
+              <a:t>Agent-based Diamond–Dybvig with Cultural Heterogeneity</a:t>
             </a:r>
             <a:endParaRPr lang="en-US" sz="3400" dirty="0"/>
           </a:p>
@@ -2567,12 +2567,12 @@
               <a:buNone/>
             </a:pPr>
             <a:r>
-              <a:rPr lang="en-US" sz="1400" dirty="0">
-                <a:solidFill>
-                  <a:schemeClr val="accent3"/>
-                </a:solidFill>
-              </a:rPr>
-              <a:t>Walter Stover  ·  George Mason University  ·  26 October 2026</a:t>
+              <a:rPr lang="en-US" sz="1800" dirty="0">
+                <a:solidFill>
+                  <a:schemeClr val="accent4"/>
+                </a:solidFill>
+              </a:rPr>
+              <a:t>Walter Stover  ·  George Mason University  ·  26 October</a:t>
             </a:r>
             <a:endParaRPr lang="en-US" sz="1800" dirty="0"/>
           </a:p>

</xml_diff>

<commit_message>
Deck: section cards before the model and before the results
Co-Authored-By: Claude Fable 5.1 <noreply@anthropic.com>
</commit_message>
<xml_diff>
--- a/docs/deck_2026-10-26_seminar.pptx
+++ b/docs/deck_2026-10-26_seminar.pptx
@@ -19,9 +19,11 @@
     <p:sldId id="267" r:id="rId13"/>
     <p:sldId id="268" r:id="rId14"/>
     <p:sldId id="269" r:id="rId15"/>
+    <p:sldId id="270" r:id="rId16"/>
+    <p:sldId id="271" r:id="rId17"/>
   </p:sldIdLst>
   <p:notesMasterIdLst>
-    <p:notesMasterId r:id="rId16"/>
+    <p:notesMasterId r:id="rId18"/>
   </p:notesMasterIdLst>
   <p:sldSz cx="9144000" cy="5143500"/>
   <p:notesSz cx="5143500" cy="9144000"/>
@@ -120,38 +122,39 @@
   <p:extLst>
     <p:ext uri="{521415D9-36F7-43E2-AB2F-B90AF26B5E84}">
       <p14:sectionLst xmlns:p14="http://schemas.microsoft.com/office/powerpoint/2010/main">
-        <p14:section name="Opening" id="{9341bb9d-c2d3-e0f9-7b76-63ca8ef59693}">
+        <p14:section name="Opening" id="{4658e545-11c0-43ca-f693-22e28a4924bf}">
           <p14:sldIdLst>
             <p14:sldId id="256"/>
             <p14:sldId id="257"/>
             <p14:sldId id="258"/>
             <p14:sldId id="259"/>
             <p14:sldId id="260"/>
-            <p14:sldId id="261"/>
+            <p14:sldId id="262"/>
           </p14:sldIdLst>
         </p14:section>
-        <p14:section name="The model" id="{ee055e89-27c8-e65c-8bed-a00f3f9ac758}">
+        <p14:section name="The model" id="{8adb3581-b003-8914-350c-6fc655770fe6}">
           <p14:sldIdLst>
-            <p14:sldId id="262"/>
             <p14:sldId id="263"/>
+            <p14:sldId id="264"/>
           </p14:sldIdLst>
         </p14:section>
-        <p14:section name="Results" id="{678c6eee-6df7-4b05-ea56-efe1890bbe5f}">
+        <p14:section name="Results" id="{90084578-f552-8e86-299c-05d47401621d}">
           <p14:sldIdLst>
-            <p14:sldId id="264"/>
             <p14:sldId id="265"/>
             <p14:sldId id="266"/>
             <p14:sldId id="267"/>
+            <p14:sldId id="268"/>
+            <p14:sldId id="269"/>
           </p14:sldIdLst>
         </p14:section>
-        <p14:section name="Validation" id="{9281544c-dc74-9b41-9ac0-8a55072b59f4}">
+        <p14:section name="Validation" id="{b15d4de9-3e77-5966-dd7f-262bcb2e547c}">
           <p14:sldIdLst>
-            <p14:sldId id="268"/>
+            <p14:sldId id="270"/>
           </p14:sldIdLst>
         </p14:section>
-        <p14:section name="Close" id="{7ff35129-9451-9346-e521-a21b60c5f462}">
+        <p14:section name="Close" id="{19d0b0b1-2032-f5c4-417b-6e68be271e28}">
           <p14:sldIdLst>
-            <p14:sldId id="269"/>
+            <p14:sldId id="271"/>
           </p14:sldIdLst>
         </p14:section>
       </p14:sectionLst>
@@ -646,7 +649,7 @@
           <a:p>
             <a:r>
               <a:rPr lang="en-US" dirty="0"/>
-              <a:t>~2 min. Large difference (0.1, 0.9): 0.67 at mu 0 -&gt; 0.08 at mu 1; medium (0.2, 0.8) similar; small (0.3, 0.5): 0.25 -&gt; 0.09. Monotone, no interior peak. The difference between types matters most when collectivists dominate; lines converge at mu &gt;= 0.75. Includes pure cells (mu 0 and 1). If asked about Ch 1's non-monotonic prediction (P6): see backup.</a:t>
+              <a:t>Section card. ~0.1 min.</a:t>
             </a:r>
             <a:endParaRPr lang="en-US" dirty="0"/>
           </a:p>
@@ -734,7 +737,7 @@
           <a:p>
             <a:r>
               <a:rPr lang="en-US" dirty="0"/>
-              <a:t>~2.5 min. Large difference (0.1, 0.9): outdated pessimistic 0.48, none 0.31, accurate 0.29, outdated middling (y0 0.5) 0.18, outdated optimistic 0.16. Accurate news barely changes failure; stale optimistic halves it; stale pessimistic raises it by half. Small difference (0.3, 0.5) barely moves (0.09–0.15). All mu. Policy framing: the information environment (right to reassure), not sorting depositors by type.</a:t>
+              <a:t>~2 min. Collectivists jump from 0.15 to 0.93 once 20–35% of neighbours are out and reach 1.0; individualists plateau at ~0.25–0.30. Slopes: C 0.80, I 0.22 (difference +0.58, t 16.7). Lambda pairs pooled; reference bank.</a:t>
             </a:r>
             <a:endParaRPr lang="en-US" dirty="0"/>
           </a:p>
@@ -822,7 +825,7 @@
           <a:p>
             <a:r>
               <a:rPr lang="en-US" dirty="0"/>
-              <a:t>~2 min. Lambda pairs pooled. Uncapped (sigma 2.5) 0.61 -&gt; 0.11; capped at 1% 0.51 -&gt; 0.08; similar sizes (sigma 1) 0.50 -&gt; 0.08. Capping brings failure down to the no-concentration level at every mu. The mu gradient is the same in all three: culture's effect does not depend on concentration. One spoken sentence on what 'capped at 1%' means (no single depositor holds more than 1% of the bank).</a:t>
+              <a:t>~2 min. Large difference (0.1, 0.9): 0.67 at mu 0 -&gt; 0.08 at mu 1; medium (0.2, 0.8) similar; small (0.3, 0.5): 0.25 -&gt; 0.09. Monotone, no interior peak. The difference between types matters most when collectivists dominate; lines converge at mu &gt;= 0.75. Includes pure cells (mu 0 and 1). If asked about Ch 1's non-monotonic prediction (P6): see backup.</a:t>
             </a:r>
             <a:endParaRPr lang="en-US" dirty="0"/>
           </a:p>
@@ -910,7 +913,7 @@
           <a:p>
             <a:r>
               <a:rPr lang="en-US" dirty="0"/>
-              <a:t>~1.5 min. Ch 1's theory predicts: optimistic news -&gt; individualists run more than collectivists; pessimistic -&gt; collectivists run more. The lines rise through zero as predicted. Large difference reaches about ±0.1; small stays flat. Pre-registered tests: 3 of 4 support, on all three versions of the bank (r1k pooled: G1' +0.033, G4' -0.031, G2a' +0.093, Holm-significant; G3 counts against). Option: make this one sentence and move the figure to backup.</a:t>
+              <a:t>~2.5 min. Large difference (0.1, 0.9): outdated pessimistic 0.48, none 0.31, accurate 0.29, outdated middling (y0 0.5) 0.18, outdated optimistic 0.16. Accurate news barely changes failure; stale optimistic halves it; stale pessimistic raises it by half. Small difference (0.3, 0.5) barely moves (0.09–0.15). All mu. Policy framing: the information environment (right to reassure), not sorting depositors by type.</a:t>
             </a:r>
             <a:endParaRPr lang="en-US" dirty="0"/>
           </a:p>
@@ -998,7 +1001,7 @@
           <a:p>
             <a:r>
               <a:rPr lang="en-US" dirty="0"/>
-              <a:t>~2 min. Next steps from the outline: super-individuals (match how Celsius's largest depositors exit), deposit insurance and the reserve ratio on the fire-sale bank, topology and learning, and the full parameter sweep (stale public signal + no-signal baseline; CARA 0.1; sigma reported).</a:t>
+              <a:t>~2 min. Lambda pairs pooled. Uncapped (sigma 2.5) 0.61 -&gt; 0.11; capped at 1% 0.51 -&gt; 0.08; similar sizes (sigma 1) 0.50 -&gt; 0.08. Capping brings failure down to the no-concentration level at every mu. The mu gradient is the same in all three: culture's effect does not depend on concentration. One spoken sentence on what 'capped at 1%' means (no single depositor holds more than 1% of the bank).</a:t>
             </a:r>
             <a:endParaRPr lang="en-US" dirty="0"/>
           </a:p>
@@ -1022,6 +1025,182 @@
             <a:fld id="{F7021451-1387-4CA6-816F-3879F97B5CBC}" type="slidenum">
               <a:rPr lang="en-US"/>
               <a:t>14</a:t>
+            </a:fld>
+            <a:endParaRPr lang="en-US"/>
+          </a:p>
+        </p:txBody>
+      </p:sp>
+    </p:spTree>
+    <p:extLst>
+      <p:ext uri="{BB962C8B-B14F-4D97-AF65-F5344CB8AC3E}">
+        <p14:creationId xmlns:p14="http://schemas.microsoft.com/office/powerpoint/2010/main" val="1024086991"/>
+      </p:ext>
+    </p:extLst>
+  </p:cSld>
+  <p:clrMapOvr>
+    <a:masterClrMapping/>
+  </p:clrMapOvr>
+</p:notes>
+</file>
+
+<file path=ppt/notesSlides/notesSlide15.xml><?xml version="1.0" encoding="utf-8"?>
+<p:notes xmlns:a="http://schemas.openxmlformats.org/drawingml/2006/main" xmlns:r="http://schemas.openxmlformats.org/officeDocument/2006/relationships" xmlns:p="http://schemas.openxmlformats.org/presentationml/2006/main">
+  <p:cSld>
+    <p:spTree>
+      <p:nvGrpSpPr>
+        <p:cNvPr id="1" name=""/>
+        <p:cNvGrpSpPr/>
+        <p:nvPr/>
+      </p:nvGrpSpPr>
+      <p:grpSpPr>
+        <a:xfrm>
+          <a:off x="0" y="0"/>
+          <a:ext cx="0" cy="0"/>
+          <a:chOff x="0" y="0"/>
+          <a:chExt cx="0" cy="0"/>
+        </a:xfrm>
+      </p:grpSpPr>
+      <p:sp>
+        <p:nvSpPr>
+          <p:cNvPr id="2" name="Slide Image Placeholder 1"/>
+          <p:cNvSpPr>
+            <a:spLocks noGrp="1" noRot="1" noChangeAspect="1"/>
+          </p:cNvSpPr>
+          <p:nvPr>
+            <p:ph type="sldImg"/>
+          </p:nvPr>
+        </p:nvSpPr>
+        <p:spPr/>
+      </p:sp>
+      <p:sp>
+        <p:nvSpPr>
+          <p:cNvPr id="3" name="Notes Placeholder 2"/>
+          <p:cNvSpPr>
+            <a:spLocks noGrp="1"/>
+          </p:cNvSpPr>
+          <p:nvPr>
+            <p:ph type="body" idx="1"/>
+          </p:nvPr>
+        </p:nvSpPr>
+        <p:spPr/>
+        <p:txBody>
+          <a:bodyPr/>
+          <a:lstStyle/>
+          <a:p>
+            <a:r>
+              <a:rPr lang="en-US" dirty="0"/>
+              <a:t>~1.5 min. Ch 1's theory predicts: optimistic news -&gt; individualists run more than collectivists; pessimistic -&gt; collectivists run more. The lines rise through zero as predicted. Large difference reaches about ±0.1; small stays flat. Pre-registered tests: 3 of 4 support, on all three versions of the bank (r1k pooled: G1' +0.033, G4' -0.031, G2a' +0.093, Holm-significant; G3 counts against). Option: make this one sentence and move the figure to backup.</a:t>
+            </a:r>
+            <a:endParaRPr lang="en-US" dirty="0"/>
+          </a:p>
+        </p:txBody>
+      </p:sp>
+      <p:sp>
+        <p:nvSpPr>
+          <p:cNvPr id="4" name="Slide Number Placeholder 3"/>
+          <p:cNvSpPr>
+            <a:spLocks noGrp="1"/>
+          </p:cNvSpPr>
+          <p:nvPr>
+            <p:ph type="sldNum" sz="quarter" idx="10"/>
+          </p:nvPr>
+        </p:nvSpPr>
+        <p:spPr/>
+        <p:txBody>
+          <a:bodyPr/>
+          <a:lstStyle/>
+          <a:p>
+            <a:fld id="{F7021451-1387-4CA6-816F-3879F97B5CBC}" type="slidenum">
+              <a:rPr lang="en-US"/>
+              <a:t>15</a:t>
+            </a:fld>
+            <a:endParaRPr lang="en-US"/>
+          </a:p>
+        </p:txBody>
+      </p:sp>
+    </p:spTree>
+    <p:extLst>
+      <p:ext uri="{BB962C8B-B14F-4D97-AF65-F5344CB8AC3E}">
+        <p14:creationId xmlns:p14="http://schemas.microsoft.com/office/powerpoint/2010/main" val="1024086991"/>
+      </p:ext>
+    </p:extLst>
+  </p:cSld>
+  <p:clrMapOvr>
+    <a:masterClrMapping/>
+  </p:clrMapOvr>
+</p:notes>
+</file>
+
+<file path=ppt/notesSlides/notesSlide16.xml><?xml version="1.0" encoding="utf-8"?>
+<p:notes xmlns:a="http://schemas.openxmlformats.org/drawingml/2006/main" xmlns:r="http://schemas.openxmlformats.org/officeDocument/2006/relationships" xmlns:p="http://schemas.openxmlformats.org/presentationml/2006/main">
+  <p:cSld>
+    <p:spTree>
+      <p:nvGrpSpPr>
+        <p:cNvPr id="1" name=""/>
+        <p:cNvGrpSpPr/>
+        <p:nvPr/>
+      </p:nvGrpSpPr>
+      <p:grpSpPr>
+        <a:xfrm>
+          <a:off x="0" y="0"/>
+          <a:ext cx="0" cy="0"/>
+          <a:chOff x="0" y="0"/>
+          <a:chExt cx="0" cy="0"/>
+        </a:xfrm>
+      </p:grpSpPr>
+      <p:sp>
+        <p:nvSpPr>
+          <p:cNvPr id="2" name="Slide Image Placeholder 1"/>
+          <p:cNvSpPr>
+            <a:spLocks noGrp="1" noRot="1" noChangeAspect="1"/>
+          </p:cNvSpPr>
+          <p:nvPr>
+            <p:ph type="sldImg"/>
+          </p:nvPr>
+        </p:nvSpPr>
+        <p:spPr/>
+      </p:sp>
+      <p:sp>
+        <p:nvSpPr>
+          <p:cNvPr id="3" name="Notes Placeholder 2"/>
+          <p:cNvSpPr>
+            <a:spLocks noGrp="1"/>
+          </p:cNvSpPr>
+          <p:nvPr>
+            <p:ph type="body" idx="1"/>
+          </p:nvPr>
+        </p:nvSpPr>
+        <p:spPr/>
+        <p:txBody>
+          <a:bodyPr/>
+          <a:lstStyle/>
+          <a:p>
+            <a:r>
+              <a:rPr lang="en-US" dirty="0"/>
+              <a:t>~2 min. Next steps from the outline: super-individuals (match how Celsius's largest depositors exit), deposit insurance and the reserve ratio on the fire-sale bank, topology and learning, and the full parameter sweep (stale public signal + no-signal baseline; CARA 0.1; sigma reported).</a:t>
+            </a:r>
+            <a:endParaRPr lang="en-US" dirty="0"/>
+          </a:p>
+        </p:txBody>
+      </p:sp>
+      <p:sp>
+        <p:nvSpPr>
+          <p:cNvPr id="4" name="Slide Number Placeholder 3"/>
+          <p:cNvSpPr>
+            <a:spLocks noGrp="1"/>
+          </p:cNvSpPr>
+          <p:nvPr>
+            <p:ph type="sldNum" sz="quarter" idx="10"/>
+          </p:nvPr>
+        </p:nvSpPr>
+        <p:spPr/>
+        <p:txBody>
+          <a:bodyPr/>
+          <a:lstStyle/>
+          <a:p>
+            <a:fld id="{F7021451-1387-4CA6-816F-3879F97B5CBC}" type="slidenum">
+              <a:rPr lang="en-US"/>
+              <a:t>16</a:t>
             </a:fld>
             <a:endParaRPr lang="en-US"/>
           </a:p>
@@ -1438,7 +1617,7 @@
           <a:p>
             <a:r>
               <a:rPr lang="en-US" dirty="0"/>
-              <a:t>~1.5 min. The whole model in one line: a depositor blends what they are told with what they see, and the blend weight is a disposition, not a precision calculation (Chapter 1 writes it omega; the simulation writes it lambda). Subtracting the two types' estimates gives the wedge (lambda_C minus lambda_I)(x minus y): with the same pair of signals, the individualist's estimate is lower whenever private evidence is worse than the public line, so individualists run on a wider set of signals when the news is stale-optimistic, and the inclusion reverses when the news is stale-pessimistic. That is the sorting prediction the simulation tests. In the simulation, the public side is what neighbours do and what the news says, and lambda is drawn per agent in a cultural warm-up. Next: the simulation itself.</a:t>
+              <a:t>Section card. ~0.2 min.</a:t>
             </a:r>
             <a:endParaRPr lang="en-US" dirty="0"/>
           </a:p>
@@ -1526,7 +1705,7 @@
           <a:p>
             <a:r>
               <a:rPr lang="en-US" dirty="0"/>
-              <a:t>~2 min. Talk through the diagram. Left: N = 1,000 depositors, deposits log-normal (sigma 2.5) capped at 1% of the total (Celsius's largest account); types I and C from the warm-up; a Newman-Watts network; the fire-sale bank (reserves rD in cash, the rest plus equity in a long asset sold at a 60% haircut if cash runs short; it fails at period 2 if cash plus the asset at R(theta) is below its promises); theta uniform per run and a public signal that is absent, accurate or stale. Middle and right: warm-up, draw the world, shock, then the tick loop: observe neighbours and the news, blend each with your own information using lambda, value staying against withdrawing (a fraction, partial withdrawals allowed) by Monte Carlo, act. 25 initialisations x 10 draws per cell. Outcomes: D = individualists' minus collectivists' withdrawal share among those not hit by the shock; P(fail) = share of runs that fail. Risk aversion is in the model (CARA) but not on the slide.</a:t>
+              <a:t>~1.5 min. The whole model in one line: a depositor blends what they are told with what they see, and the blend weight is a disposition, not a precision calculation (Chapter 1 writes it omega; the simulation writes it lambda). Subtracting the two types' estimates gives the wedge (lambda_C minus lambda_I)(x minus y): with the same pair of signals, the individualist's estimate is lower whenever private evidence is worse than the public line, so individualists run on a wider set of signals when the news is stale-optimistic, and the inclusion reverses when the news is stale-pessimistic. That is the sorting prediction the simulation tests. In the simulation, the public side is what neighbours do and what the news says, and lambda is drawn per agent in a cultural warm-up. Next: the simulation itself.</a:t>
             </a:r>
             <a:endParaRPr lang="en-US" dirty="0"/>
           </a:p>
@@ -1614,7 +1793,7 @@
           <a:p>
             <a:r>
               <a:rPr lang="en-US" dirty="0"/>
-              <a:t>~1 min. Individualists put little weight on others (neighbours and public news) and more on their own information; collectivists the reverse. In the model: weight on the social side lambda; pairs shown in the figures (I, C): (0.1, 0.9) = large difference, (0.2, 0.8) = medium, (0.3, 0.5) = small. Type comes from a cultural warm-up on the network: the top mu share become individualists. Colours used throughout: orange = individualists, blue = collectivists.</a:t>
+              <a:t>~2 min. Talk through the diagram. Left: N = 1,000 depositors, deposits log-normal (sigma 2.5) capped at 1% of the total (Celsius's largest account); types I and C from the warm-up; a Newman-Watts network; the fire-sale bank (reserves rD in cash, the rest plus equity in a long asset sold at a 60% haircut if cash runs short; it fails at period 2 if cash plus the asset at R(theta) is below its promises); theta uniform per run and a public signal that is absent, accurate or stale. Middle and right: warm-up, draw the world, shock, then the tick loop: observe neighbours and the news, blend each with your own information using lambda, value staying against withdrawing (a fraction, partial withdrawals allowed) by Monte Carlo, act. 25 initialisations x 10 draws per cell. Outcomes: D = individualists' minus collectivists' withdrawal share among those not hit by the shock; P(fail) = share of runs that fail. Risk aversion is in the model (CARA) but not on the slide.</a:t>
             </a:r>
             <a:endParaRPr lang="en-US" dirty="0"/>
           </a:p>
@@ -1702,7 +1881,7 @@
           <a:p>
             <a:r>
               <a:rPr lang="en-US" dirty="0"/>
-              <a:t>~2 min. Collectivists jump from 0.15 to 0.93 once 20–35% of neighbours are out and reach 1.0; individualists plateau at ~0.25–0.30. Slopes: C 0.80, I 0.22 (difference +0.58, t 16.7). Lambda pairs pooled; reference bank.</a:t>
+              <a:t>~1 min. Individualists put little weight on others (neighbours and public news) and more on their own information; collectivists the reverse. In the model: weight on the social side lambda; pairs shown in the figures (I, C): (0.1, 0.9) = large difference, (0.2, 0.8) = medium, (0.3, 0.5) = small. Type comes from a cultural warm-up on the network: the top mu share become individualists. Colours used throughout: orange = individualists, blue = collectivists.</a:t>
             </a:r>
             <a:endParaRPr lang="en-US" dirty="0"/>
           </a:p>
@@ -2613,8 +2792,8 @@
         </p:nvSpPr>
         <p:spPr>
           <a:xfrm>
-            <a:off x="457200" y="274320"/>
-            <a:ext cx="8229600" cy="685800"/>
+            <a:off x="548640" y="1828800"/>
+            <a:ext cx="8046720" cy="1097280"/>
           </a:xfrm>
           <a:prstGeom prst="rect">
             <a:avLst/>
@@ -2630,83 +2809,44 @@
               <a:buNone/>
             </a:pPr>
             <a:r>
-              <a:rPr lang="en-US" sz="2400" b="1" dirty="0">
-                <a:solidFill>
-                  <a:schemeClr val="tx2"/>
-                </a:solidFill>
-              </a:rPr>
-              <a:t>More individualists, fewer failures</a:t>
-            </a:r>
-            <a:endParaRPr lang="en-US" sz="2400" dirty="0"/>
-          </a:p>
-        </p:txBody>
-      </p:sp>
-      <p:pic>
-        <p:nvPicPr>
-          <p:cNvPr id="3" name="e05" descr="Chance the bank fails by share of individualists: falls from about 0.67 with no individualists to about 0.08 with all individualists for the large difference pair; monotone for every pair.">    </p:cNvPr>
-          <p:cNvPicPr>
-            <a:picLocks noChangeAspect="1"/>
-          </p:cNvPicPr>
-          <p:nvPr/>
-        </p:nvPicPr>
-        <p:blipFill>
-          <a:blip r:embed="rId1"/>
-          <a:stretch>
-            <a:fillRect/>
-          </a:stretch>
-        </p:blipFill>
-        <p:spPr>
-          <a:xfrm>
-            <a:off x="1821553" y="1005840"/>
-            <a:ext cx="5500893" cy="3611880"/>
-          </a:xfrm>
-          <a:prstGeom prst="rect">
-            <a:avLst/>
-          </a:prstGeom>
-        </p:spPr>
-      </p:pic>
-      <p:sp>
-        <p:nvSpPr>
-          <p:cNvPr id="25" name="Slide Number Placeholder 0"/>
-          <p:cNvSpPr>
-            <a:spLocks noGrp="1"/>
-          </p:cNvSpPr>
-          <p:nvPr>
-            <p:ph type="sldNum" sz="quarter" idx="4294967295"/>
-          </p:nvPr>
-        </p:nvSpPr>
-        <p:spPr>
-          <a:xfrm>
-            <a:off x="8321040" y="4754880"/>
-            <a:ext cx="457200" cy="274320"/>
-          </a:xfrm>
-          <a:prstGeom prst="rect">
-            <a:avLst/>
-          </a:prstGeom>
-          <a:extLst>
-            <a:ext uri="{C572A759-6A51-4108-AA02-DFA0A04FC94B}">
-              <ma14:wrappingTextBoxFlag xmlns:ma14="http://schemas.microsoft.com/office/mac/drawingml/2011/main" val="0"/>
-            </a:ext>
-          </a:extLst>
-        </p:spPr>
-        <p:txBody>
-          <a:bodyPr/>
-          <a:lstStyle>
-            <a:lvl1pPr>
-              <a:defRPr sz="900">
-                <a:solidFill>
-                  <a:srgbClr val="6B7280"/>
-                </a:solidFill>
-              </a:defRPr>
-            </a:lvl1pPr>
-          </a:lstStyle>
-          <a:p>
-            <a:pPr algn="r"/>
-            <a:fld id="{F7021451-1387-4CA6-816F-3879F97B5CBC}" type="slidenum">
-              <a:rPr b="0" lang="en-US"/>
-              <a:t>10</a:t>
-            </a:fld>
-            <a:endParaRPr lang="en-US"/>
+              <a:rPr lang="en-US" sz="3200" b="1" dirty="0">
+                <a:solidFill>
+                  <a:schemeClr val="bg1"/>
+                </a:solidFill>
+              </a:rPr>
+              <a:t>Results</a:t>
+            </a:r>
+            <a:endParaRPr lang="en-US" sz="3200" dirty="0"/>
+          </a:p>
+        </p:txBody>
+      </p:sp>
+      <p:sp>
+        <p:nvSpPr>
+          <p:cNvPr id="4" name="Text 0"/>
+          <p:cNvSpPr/>
+          <p:nvPr>
+            <p:ph idx="101" type="body" hasCustomPrompt="1"/>
+          </p:nvPr>
+        </p:nvSpPr>
+        <p:spPr>
+          <a:xfrm>
+            <a:off x="548640" y="2971800"/>
+            <a:ext cx="8046720" cy="731520"/>
+          </a:xfrm>
+          <a:prstGeom prst="rect">
+            <a:avLst/>
+          </a:prstGeom>
+          <a:noFill/>
+          <a:ln/>
+        </p:spPr>
+        <p:txBody>
+          <a:bodyPr wrap="square" lIns="0" tIns="0" rIns="0" bIns="0" rtlCol="0" anchor="t"/>
+          <a:lstStyle/>
+          <a:p>
+            <a:pPr algn="ctr" indent="0" marL="0">
+              <a:buNone/>
+            </a:pPr>
+            <a:endParaRPr lang="en-US" sz="1600" dirty="0"/>
           </a:p>
         </p:txBody>
       </p:sp>
@@ -2767,7 +2907,7 @@
                   <a:schemeClr val="tx2"/>
                 </a:solidFill>
               </a:rPr>
-              <a:t>Outdated news cuts both ways</a:t>
+              <a:t>Collectivists herd</a:t>
             </a:r>
             <a:endParaRPr lang="en-US" sz="2400" dirty="0"/>
           </a:p>
@@ -2775,7 +2915,7 @@
       </p:sp>
       <p:pic>
         <p:nvPicPr>
-          <p:cNvPr id="3" name="e08" descr="Chance the bank fails by kind of public news: outdated pessimistic news raises it to about 0.48, accurate news barely changes it from no news (0.29 vs 0.31), outdated optimistic news lowers it to 0.16.">    </p:cNvPr>
+          <p:cNvPr id="3" name="e07" descr="Chance of withdrawing by share of neighbours who have withdrawn: collectivists jump to near 1 once 20 to 35 percent of neighbours are out; individualists level off near 0.25 to 0.30.">    </p:cNvPr>
           <p:cNvPicPr>
             <a:picLocks noChangeAspect="1"/>
           </p:cNvPicPr>
@@ -2789,8 +2929,8 @@
         </p:blipFill>
         <p:spPr>
           <a:xfrm>
-            <a:off x="730766" y="1005840"/>
-            <a:ext cx="7682469" cy="3611880"/>
+            <a:off x="1738480" y="1005840"/>
+            <a:ext cx="5667040" cy="3611880"/>
           </a:xfrm>
           <a:prstGeom prst="rect">
             <a:avLst/>
@@ -2899,7 +3039,7 @@
                   <a:schemeClr val="tx2"/>
                 </a:solidFill>
               </a:rPr>
-              <a:t>Varying the deposit-size distribution</a:t>
+              <a:t>More individualists, fewer failures</a:t>
             </a:r>
             <a:endParaRPr lang="en-US" sz="2400" dirty="0"/>
           </a:p>
@@ -2907,7 +3047,7 @@
       </p:sp>
       <p:pic>
         <p:nvPicPr>
-          <p:cNvPr id="3" name="e10" descr="Chance the bank fails by share of individualists for three deposit-size distributions: uncapped large deposits fail most often; capped at 1 percent matches the bank with similar-sized deposits at every share.">    </p:cNvPr>
+          <p:cNvPr id="3" name="e05" descr="Chance the bank fails by share of individualists: falls from about 0.67 with no individualists to about 0.08 with all individualists for the large difference pair; monotone for every pair.">    </p:cNvPr>
           <p:cNvPicPr>
             <a:picLocks noChangeAspect="1"/>
           </p:cNvPicPr>
@@ -2921,8 +3061,8 @@
         </p:blipFill>
         <p:spPr>
           <a:xfrm>
-            <a:off x="1861284" y="1005840"/>
-            <a:ext cx="5421432" cy="3611880"/>
+            <a:off x="1821553" y="1005840"/>
+            <a:ext cx="5500893" cy="3611880"/>
           </a:xfrm>
           <a:prstGeom prst="rect">
             <a:avLst/>
@@ -3031,7 +3171,7 @@
                   <a:schemeClr val="tx2"/>
                 </a:solidFill>
               </a:rPr>
-              <a:t>Does the model hold up?</a:t>
+              <a:t>Outdated news cuts both ways</a:t>
             </a:r>
             <a:endParaRPr lang="en-US" sz="2400" dirty="0"/>
           </a:p>
@@ -3039,7 +3179,7 @@
       </p:sp>
       <p:pic>
         <p:nvPicPr>
-          <p:cNvPr id="3" name="e01" descr="Individualists' run rate minus collectivists', relative to no news, against how far public news is from the truth: rises from negative when news is pessimistic to positive when optimistic, more steeply for the wide lambda gap.">    </p:cNvPr>
+          <p:cNvPr id="3" name="e08" descr="Chance the bank fails by kind of public news: outdated pessimistic news raises it to about 0.48, accurate news barely changes it from no news (0.29 vs 0.31), outdated optimistic news lowers it to 0.16.">    </p:cNvPr>
           <p:cNvPicPr>
             <a:picLocks noChangeAspect="1"/>
           </p:cNvPicPr>
@@ -3053,8 +3193,8 @@
         </p:blipFill>
         <p:spPr>
           <a:xfrm>
-            <a:off x="1711391" y="1005840"/>
-            <a:ext cx="5721218" cy="3611880"/>
+            <a:off x="730766" y="1005840"/>
+            <a:ext cx="7682469" cy="3611880"/>
           </a:xfrm>
           <a:prstGeom prst="rect">
             <a:avLst/>
@@ -3163,510 +3303,36 @@
                   <a:schemeClr val="tx2"/>
                 </a:solidFill>
               </a:rPr>
-              <a:t>Takeaways and next steps</a:t>
+              <a:t>Varying the deposit-size distribution</a:t>
             </a:r>
             <a:endParaRPr lang="en-US" sz="2400" dirty="0"/>
           </a:p>
         </p:txBody>
       </p:sp>
-      <p:sp>
-        <p:nvSpPr>
-          <p:cNvPr id="3" name="take-head"/>
-          <p:cNvSpPr txBox="1"/>
+      <p:pic>
+        <p:nvPicPr>
+          <p:cNvPr id="3" name="e10" descr="Chance the bank fails by share of individualists for three deposit-size distributions: uncapped large deposits fail most often; capped at 1 percent matches the bank with similar-sized deposits at every share.">    </p:cNvPr>
+          <p:cNvPicPr>
+            <a:picLocks noChangeAspect="1"/>
+          </p:cNvPicPr>
           <p:nvPr/>
-        </p:nvSpPr>
-        <p:spPr>
-          <a:xfrm>
-            <a:off x="457200" y="1051560"/>
-            <a:ext cx="2743200" cy="530352"/>
-          </a:xfrm>
-          <a:prstGeom prst="rect">
-            <a:avLst/>
-          </a:prstGeom>
-          <a:noFill/>
-          <a:ln/>
-        </p:spPr>
-        <p:txBody>
-          <a:bodyPr wrap="square" lIns="0" tIns="0" rIns="0" bIns="0" rtlCol="0" anchor="ctr"/>
-          <a:lstStyle/>
-          <a:p>
-            <a:pPr indent="0" marL="0">
-              <a:buNone/>
-            </a:pPr>
-            <a:r>
-              <a:rPr lang="en-US" sz="1300" b="1" dirty="0">
-                <a:solidFill>
-                  <a:schemeClr val="accent1"/>
-                </a:solidFill>
-              </a:rPr>
-              <a:t>1:  </a:t>
-            </a:r>
-            <a:pPr indent="0" marL="0">
-              <a:buNone/>
-            </a:pPr>
-            <a:r>
-              <a:rPr lang="en-US" sz="1300" b="1" dirty="0">
-                <a:solidFill>
-                  <a:schemeClr val="tx2"/>
-                </a:solidFill>
-              </a:rPr>
-              <a:t>Sorting follows the news</a:t>
-            </a:r>
-            <a:endParaRPr lang="en-US" sz="1300" dirty="0"/>
-          </a:p>
-        </p:txBody>
-      </p:sp>
-      <p:sp>
-        <p:nvSpPr>
-          <p:cNvPr id="4" name="take-body"/>
-          <p:cNvSpPr txBox="1"/>
-          <p:nvPr/>
-        </p:nvSpPr>
-        <p:spPr>
-          <a:xfrm>
-            <a:off x="3291840" y="1051560"/>
-            <a:ext cx="5394960" cy="530352"/>
-          </a:xfrm>
-          <a:prstGeom prst="rect">
-            <a:avLst/>
-          </a:prstGeom>
-          <a:noFill/>
-          <a:ln/>
-        </p:spPr>
-        <p:txBody>
-          <a:bodyPr wrap="square" lIns="0" tIns="0" rIns="0" bIns="0" rtlCol="0" anchor="ctr"/>
-          <a:lstStyle/>
-          <a:p>
-            <a:pPr indent="0" marL="0">
-              <a:buNone/>
-            </a:pPr>
-            <a:r>
-              <a:rPr lang="en-US" sz="1200" dirty="0">
-                <a:solidFill>
-                  <a:schemeClr val="tx1"/>
-                </a:solidFill>
-              </a:rPr>
-              <a:t>Optimistic public news makes individualists run relatively more; pessimistic news, collectivists.</a:t>
-            </a:r>
-            <a:endParaRPr lang="en-US" sz="1200" dirty="0"/>
-          </a:p>
-        </p:txBody>
-      </p:sp>
-      <p:sp>
-        <p:nvSpPr>
-          <p:cNvPr id="5" name="take-head"/>
-          <p:cNvSpPr txBox="1"/>
-          <p:nvPr/>
-        </p:nvSpPr>
-        <p:spPr>
-          <a:xfrm>
-            <a:off x="457200" y="1627632"/>
-            <a:ext cx="2743200" cy="530352"/>
-          </a:xfrm>
-          <a:prstGeom prst="rect">
-            <a:avLst/>
-          </a:prstGeom>
-          <a:noFill/>
-          <a:ln/>
-        </p:spPr>
-        <p:txBody>
-          <a:bodyPr wrap="square" lIns="0" tIns="0" rIns="0" bIns="0" rtlCol="0" anchor="ctr"/>
-          <a:lstStyle/>
-          <a:p>
-            <a:pPr indent="0" marL="0">
-              <a:buNone/>
-            </a:pPr>
-            <a:r>
-              <a:rPr lang="en-US" sz="1300" b="1" dirty="0">
-                <a:solidFill>
-                  <a:schemeClr val="accent1"/>
-                </a:solidFill>
-              </a:rPr>
-              <a:t>2:  </a:t>
-            </a:r>
-            <a:pPr indent="0" marL="0">
-              <a:buNone/>
-            </a:pPr>
-            <a:r>
-              <a:rPr lang="en-US" sz="1300" b="1" dirty="0">
-                <a:solidFill>
-                  <a:schemeClr val="tx2"/>
-                </a:solidFill>
-              </a:rPr>
-              <a:t>Collectivists herd</a:t>
-            </a:r>
-            <a:endParaRPr lang="en-US" sz="1300" dirty="0"/>
-          </a:p>
-        </p:txBody>
-      </p:sp>
-      <p:sp>
-        <p:nvSpPr>
-          <p:cNvPr id="6" name="take-body"/>
-          <p:cNvSpPr txBox="1"/>
-          <p:nvPr/>
-        </p:nvSpPr>
-        <p:spPr>
-          <a:xfrm>
-            <a:off x="3291840" y="1627632"/>
-            <a:ext cx="5394960" cy="530352"/>
-          </a:xfrm>
-          <a:prstGeom prst="rect">
-            <a:avLst/>
-          </a:prstGeom>
-          <a:noFill/>
-          <a:ln/>
-        </p:spPr>
-        <p:txBody>
-          <a:bodyPr wrap="square" lIns="0" tIns="0" rIns="0" bIns="0" rtlCol="0" anchor="ctr"/>
-          <a:lstStyle/>
-          <a:p>
-            <a:pPr indent="0" marL="0">
-              <a:buNone/>
-            </a:pPr>
-            <a:r>
-              <a:rPr lang="en-US" sz="1200" dirty="0">
-                <a:solidFill>
-                  <a:schemeClr val="tx1"/>
-                </a:solidFill>
-              </a:rPr>
-              <a:t>Their chance of withdrawing jumps from 0.15 to 0.93 once 20–35% of neighbours are out; individualists level off near 0.3.</a:t>
-            </a:r>
-            <a:endParaRPr lang="en-US" sz="1200" dirty="0"/>
-          </a:p>
-        </p:txBody>
-      </p:sp>
-      <p:sp>
-        <p:nvSpPr>
-          <p:cNvPr id="7" name="take-head"/>
-          <p:cNvSpPr txBox="1"/>
-          <p:nvPr/>
-        </p:nvSpPr>
-        <p:spPr>
-          <a:xfrm>
-            <a:off x="457200" y="2203704"/>
-            <a:ext cx="2743200" cy="530352"/>
-          </a:xfrm>
-          <a:prstGeom prst="rect">
-            <a:avLst/>
-          </a:prstGeom>
-          <a:noFill/>
-          <a:ln/>
-        </p:spPr>
-        <p:txBody>
-          <a:bodyPr wrap="square" lIns="0" tIns="0" rIns="0" bIns="0" rtlCol="0" anchor="ctr"/>
-          <a:lstStyle/>
-          <a:p>
-            <a:pPr indent="0" marL="0">
-              <a:buNone/>
-            </a:pPr>
-            <a:r>
-              <a:rPr lang="en-US" sz="1300" b="1" dirty="0">
-                <a:solidFill>
-                  <a:schemeClr val="accent1"/>
-                </a:solidFill>
-              </a:rPr>
-              <a:t>3:  </a:t>
-            </a:r>
-            <a:pPr indent="0" marL="0">
-              <a:buNone/>
-            </a:pPr>
-            <a:r>
-              <a:rPr lang="en-US" sz="1300" b="1" dirty="0">
-                <a:solidFill>
-                  <a:schemeClr val="tx2"/>
-                </a:solidFill>
-              </a:rPr>
-              <a:t>More individualists, fewer failures</a:t>
-            </a:r>
-            <a:endParaRPr lang="en-US" sz="1300" dirty="0"/>
-          </a:p>
-        </p:txBody>
-      </p:sp>
-      <p:sp>
-        <p:nvSpPr>
-          <p:cNvPr id="8" name="take-body"/>
-          <p:cNvSpPr txBox="1"/>
-          <p:nvPr/>
-        </p:nvSpPr>
-        <p:spPr>
-          <a:xfrm>
-            <a:off x="3291840" y="2203704"/>
-            <a:ext cx="5394960" cy="530352"/>
-          </a:xfrm>
-          <a:prstGeom prst="rect">
-            <a:avLst/>
-          </a:prstGeom>
-          <a:noFill/>
-          <a:ln/>
-        </p:spPr>
-        <p:txBody>
-          <a:bodyPr wrap="square" lIns="0" tIns="0" rIns="0" bIns="0" rtlCol="0" anchor="ctr"/>
-          <a:lstStyle/>
-          <a:p>
-            <a:pPr indent="0" marL="0">
-              <a:buNone/>
-            </a:pPr>
-            <a:r>
-              <a:rPr lang="en-US" sz="1200" dirty="0">
-                <a:solidFill>
-                  <a:schemeClr val="tx1"/>
-                </a:solidFill>
-              </a:rPr>
-              <a:t>P(fail) falls from 0.67 to 0.08 as the individualist share goes from 0 to 1.</a:t>
-            </a:r>
-            <a:endParaRPr lang="en-US" sz="1200" dirty="0"/>
-          </a:p>
-        </p:txBody>
-      </p:sp>
-      <p:sp>
-        <p:nvSpPr>
-          <p:cNvPr id="9" name="take-head"/>
-          <p:cNvSpPr txBox="1"/>
-          <p:nvPr/>
-        </p:nvSpPr>
-        <p:spPr>
-          <a:xfrm>
-            <a:off x="457200" y="2779776"/>
-            <a:ext cx="2743200" cy="530352"/>
-          </a:xfrm>
-          <a:prstGeom prst="rect">
-            <a:avLst/>
-          </a:prstGeom>
-          <a:noFill/>
-          <a:ln/>
-        </p:spPr>
-        <p:txBody>
-          <a:bodyPr wrap="square" lIns="0" tIns="0" rIns="0" bIns="0" rtlCol="0" anchor="ctr"/>
-          <a:lstStyle/>
-          <a:p>
-            <a:pPr indent="0" marL="0">
-              <a:buNone/>
-            </a:pPr>
-            <a:r>
-              <a:rPr lang="en-US" sz="1300" b="1" dirty="0">
-                <a:solidFill>
-                  <a:schemeClr val="accent1"/>
-                </a:solidFill>
-              </a:rPr>
-              <a:t>4:  </a:t>
-            </a:r>
-            <a:pPr indent="0" marL="0">
-              <a:buNone/>
-            </a:pPr>
-            <a:r>
-              <a:rPr lang="en-US" sz="1300" b="1" dirty="0">
-                <a:solidFill>
-                  <a:schemeClr val="tx2"/>
-                </a:solidFill>
-              </a:rPr>
-              <a:t>Stale news cuts both ways</a:t>
-            </a:r>
-            <a:endParaRPr lang="en-US" sz="1300" dirty="0"/>
-          </a:p>
-        </p:txBody>
-      </p:sp>
-      <p:sp>
-        <p:nvSpPr>
-          <p:cNvPr id="10" name="take-body"/>
-          <p:cNvSpPr txBox="1"/>
-          <p:nvPr/>
-        </p:nvSpPr>
-        <p:spPr>
-          <a:xfrm>
-            <a:off x="3291840" y="2779776"/>
-            <a:ext cx="5394960" cy="530352"/>
-          </a:xfrm>
-          <a:prstGeom prst="rect">
-            <a:avLst/>
-          </a:prstGeom>
-          <a:noFill/>
-          <a:ln/>
-        </p:spPr>
-        <p:txBody>
-          <a:bodyPr wrap="square" lIns="0" tIns="0" rIns="0" bIns="0" rtlCol="0" anchor="ctr"/>
-          <a:lstStyle/>
-          <a:p>
-            <a:pPr indent="0" marL="0">
-              <a:buNone/>
-            </a:pPr>
-            <a:r>
-              <a:rPr lang="en-US" sz="1200" dirty="0">
-                <a:solidFill>
-                  <a:schemeClr val="tx1"/>
-                </a:solidFill>
-              </a:rPr>
-              <a:t>A stale optimistic signal halves failure, a stale pessimistic one raises it by half. Accurate news barely moves it.</a:t>
-            </a:r>
-            <a:endParaRPr lang="en-US" sz="1200" dirty="0"/>
-          </a:p>
-        </p:txBody>
-      </p:sp>
-      <p:sp>
-        <p:nvSpPr>
-          <p:cNvPr id="11" name="take-head"/>
-          <p:cNvSpPr txBox="1"/>
-          <p:nvPr/>
-        </p:nvSpPr>
-        <p:spPr>
-          <a:xfrm>
-            <a:off x="457200" y="3355848"/>
-            <a:ext cx="2743200" cy="530352"/>
-          </a:xfrm>
-          <a:prstGeom prst="rect">
-            <a:avLst/>
-          </a:prstGeom>
-          <a:noFill/>
-          <a:ln/>
-        </p:spPr>
-        <p:txBody>
-          <a:bodyPr wrap="square" lIns="0" tIns="0" rIns="0" bIns="0" rtlCol="0" anchor="ctr"/>
-          <a:lstStyle/>
-          <a:p>
-            <a:pPr indent="0" marL="0">
-              <a:buNone/>
-            </a:pPr>
-            <a:r>
-              <a:rPr lang="en-US" sz="1300" b="1" dirty="0">
-                <a:solidFill>
-                  <a:schemeClr val="accent1"/>
-                </a:solidFill>
-              </a:rPr>
-              <a:t>5:  </a:t>
-            </a:r>
-            <a:pPr indent="0" marL="0">
-              <a:buNone/>
-            </a:pPr>
-            <a:r>
-              <a:rPr lang="en-US" sz="1300" b="1" dirty="0">
-                <a:solidFill>
-                  <a:schemeClr val="tx2"/>
-                </a:solidFill>
-              </a:rPr>
-              <a:t>Capping the largest deposits</a:t>
-            </a:r>
-            <a:endParaRPr lang="en-US" sz="1300" dirty="0"/>
-          </a:p>
-        </p:txBody>
-      </p:sp>
-      <p:sp>
-        <p:nvSpPr>
-          <p:cNvPr id="12" name="take-body"/>
-          <p:cNvSpPr txBox="1"/>
-          <p:nvPr/>
-        </p:nvSpPr>
-        <p:spPr>
-          <a:xfrm>
-            <a:off x="3291840" y="3355848"/>
-            <a:ext cx="5394960" cy="530352"/>
-          </a:xfrm>
-          <a:prstGeom prst="rect">
-            <a:avLst/>
-          </a:prstGeom>
-          <a:noFill/>
-          <a:ln/>
-        </p:spPr>
-        <p:txBody>
-          <a:bodyPr wrap="square" lIns="0" tIns="0" rIns="0" bIns="0" rtlCol="0" anchor="ctr"/>
-          <a:lstStyle/>
-          <a:p>
-            <a:pPr indent="0" marL="0">
-              <a:buNone/>
-            </a:pPr>
-            <a:r>
-              <a:rPr lang="en-US" sz="1200" dirty="0">
-                <a:solidFill>
-                  <a:schemeClr val="tx1"/>
-                </a:solidFill>
-              </a:rPr>
-              <a:t>A 1% cap brings failure down to the no-concentration bank’s level; the culture gradient is unchanged.</a:t>
-            </a:r>
-            <a:endParaRPr lang="en-US" sz="1200" dirty="0"/>
-          </a:p>
-        </p:txBody>
-      </p:sp>
-      <p:sp>
-        <p:nvSpPr>
-          <p:cNvPr id="13" name="take-head"/>
-          <p:cNvSpPr txBox="1"/>
-          <p:nvPr/>
-        </p:nvSpPr>
-        <p:spPr>
-          <a:xfrm>
-            <a:off x="457200" y="3931920"/>
-            <a:ext cx="2743200" cy="530352"/>
-          </a:xfrm>
-          <a:prstGeom prst="rect">
-            <a:avLst/>
-          </a:prstGeom>
-          <a:noFill/>
-          <a:ln/>
-        </p:spPr>
-        <p:txBody>
-          <a:bodyPr wrap="square" lIns="0" tIns="0" rIns="0" bIns="0" rtlCol="0" anchor="ctr"/>
-          <a:lstStyle/>
-          <a:p>
-            <a:pPr indent="0" marL="0">
-              <a:buNone/>
-            </a:pPr>
-            <a:r>
-              <a:rPr lang="en-US" sz="1300" b="1" dirty="0">
-                <a:solidFill>
-                  <a:schemeClr val="accent1"/>
-                </a:solidFill>
-              </a:rPr>
-              <a:t>6:  </a:t>
-            </a:r>
-            <a:pPr indent="0" marL="0">
-              <a:buNone/>
-            </a:pPr>
-            <a:r>
-              <a:rPr lang="en-US" sz="1300" b="1" dirty="0">
-                <a:solidFill>
-                  <a:schemeClr val="tx2"/>
-                </a:solidFill>
-              </a:rPr>
-              <a:t>Not yet matched</a:t>
-            </a:r>
-            <a:endParaRPr lang="en-US" sz="1300" dirty="0"/>
-          </a:p>
-        </p:txBody>
-      </p:sp>
-      <p:sp>
-        <p:nvSpPr>
-          <p:cNvPr id="14" name="take-body"/>
-          <p:cNvSpPr txBox="1"/>
-          <p:nvPr/>
-        </p:nvSpPr>
-        <p:spPr>
-          <a:xfrm>
-            <a:off x="3291840" y="3931920"/>
-            <a:ext cx="5394960" cy="530352"/>
-          </a:xfrm>
-          <a:prstGeom prst="rect">
-            <a:avLst/>
-          </a:prstGeom>
-          <a:noFill/>
-          <a:ln/>
-        </p:spPr>
-        <p:txBody>
-          <a:bodyPr wrap="square" lIns="0" tIns="0" rIns="0" bIns="0" rtlCol="0" anchor="ctr"/>
-          <a:lstStyle/>
-          <a:p>
-            <a:pPr indent="0" marL="0">
-              <a:buNone/>
-            </a:pPr>
-            <a:r>
-              <a:rPr lang="en-US" sz="1200" dirty="0">
-                <a:solidFill>
-                  <a:schemeClr val="tx1"/>
-                </a:solidFill>
-              </a:rPr>
-              <a:t>How large depositors exit in real runs.</a:t>
-            </a:r>
-            <a:endParaRPr lang="en-US" sz="1200" dirty="0"/>
-          </a:p>
-        </p:txBody>
-      </p:sp>
+        </p:nvPicPr>
+        <p:blipFill>
+          <a:blip r:embed="rId1"/>
+          <a:stretch>
+            <a:fillRect/>
+          </a:stretch>
+        </p:blipFill>
+        <p:spPr>
+          <a:xfrm>
+            <a:off x="1861284" y="1005840"/>
+            <a:ext cx="5421432" cy="3611880"/>
+          </a:xfrm>
+          <a:prstGeom prst="rect">
+            <a:avLst/>
+          </a:prstGeom>
+        </p:spPr>
+      </p:pic>
       <p:sp>
         <p:nvSpPr>
           <p:cNvPr id="25" name="Slide Number Placeholder 0"/>
@@ -3707,6 +3373,744 @@
             <a:fld id="{F7021451-1387-4CA6-816F-3879F97B5CBC}" type="slidenum">
               <a:rPr b="0" lang="en-US"/>
               <a:t>14</a:t>
+            </a:fld>
+            <a:endParaRPr lang="en-US"/>
+          </a:p>
+        </p:txBody>
+      </p:sp>
+    </p:spTree>
+  </p:cSld>
+  <p:clrMapOvr>
+    <a:masterClrMapping/>
+  </p:clrMapOvr>
+</p:sld>
+</file>
+
+<file path=ppt/slides/slide15.xml><?xml version="1.0" encoding="utf-8"?>
+<p:sld xmlns:a="http://schemas.openxmlformats.org/drawingml/2006/main" xmlns:r="http://schemas.openxmlformats.org/officeDocument/2006/relationships" xmlns:p="http://schemas.openxmlformats.org/presentationml/2006/main">
+  <p:cSld name="Slide 15">
+    <p:spTree>
+      <p:nvGrpSpPr>
+        <p:cNvPr id="1" name=""/>
+        <p:cNvGrpSpPr/>
+        <p:nvPr/>
+      </p:nvGrpSpPr>
+      <p:grpSpPr>
+        <a:xfrm>
+          <a:off x="0" y="0"/>
+          <a:ext cx="0" cy="0"/>
+          <a:chOff x="0" y="0"/>
+          <a:chExt cx="0" cy="0"/>
+        </a:xfrm>
+      </p:grpSpPr>
+      <p:sp>
+        <p:nvSpPr>
+          <p:cNvPr id="2" name="Text 0"/>
+          <p:cNvSpPr/>
+          <p:nvPr>
+            <p:ph idx="100" type="title" hasCustomPrompt="1"/>
+          </p:nvPr>
+        </p:nvSpPr>
+        <p:spPr>
+          <a:xfrm>
+            <a:off x="457200" y="274320"/>
+            <a:ext cx="8229600" cy="685800"/>
+          </a:xfrm>
+          <a:prstGeom prst="rect">
+            <a:avLst/>
+          </a:prstGeom>
+          <a:noFill/>
+          <a:ln/>
+        </p:spPr>
+        <p:txBody>
+          <a:bodyPr wrap="square" lIns="0" tIns="0" rIns="0" bIns="0" rtlCol="0" anchor="ctr"/>
+          <a:lstStyle/>
+          <a:p>
+            <a:pPr algn="ctr" indent="0" marL="0">
+              <a:buNone/>
+            </a:pPr>
+            <a:r>
+              <a:rPr lang="en-US" sz="2400" b="1" dirty="0">
+                <a:solidFill>
+                  <a:schemeClr val="tx2"/>
+                </a:solidFill>
+              </a:rPr>
+              <a:t>Does the model hold up?</a:t>
+            </a:r>
+            <a:endParaRPr lang="en-US" sz="2400" dirty="0"/>
+          </a:p>
+        </p:txBody>
+      </p:sp>
+      <p:pic>
+        <p:nvPicPr>
+          <p:cNvPr id="3" name="e01" descr="Individualists' run rate minus collectivists', relative to no news, against how far public news is from the truth: rises from negative when news is pessimistic to positive when optimistic, more steeply for the wide lambda gap.">    </p:cNvPr>
+          <p:cNvPicPr>
+            <a:picLocks noChangeAspect="1"/>
+          </p:cNvPicPr>
+          <p:nvPr/>
+        </p:nvPicPr>
+        <p:blipFill>
+          <a:blip r:embed="rId1"/>
+          <a:stretch>
+            <a:fillRect/>
+          </a:stretch>
+        </p:blipFill>
+        <p:spPr>
+          <a:xfrm>
+            <a:off x="1711391" y="1005840"/>
+            <a:ext cx="5721218" cy="3611880"/>
+          </a:xfrm>
+          <a:prstGeom prst="rect">
+            <a:avLst/>
+          </a:prstGeom>
+        </p:spPr>
+      </p:pic>
+      <p:sp>
+        <p:nvSpPr>
+          <p:cNvPr id="25" name="Slide Number Placeholder 0"/>
+          <p:cNvSpPr>
+            <a:spLocks noGrp="1"/>
+          </p:cNvSpPr>
+          <p:nvPr>
+            <p:ph type="sldNum" sz="quarter" idx="4294967295"/>
+          </p:nvPr>
+        </p:nvSpPr>
+        <p:spPr>
+          <a:xfrm>
+            <a:off x="8321040" y="4754880"/>
+            <a:ext cx="457200" cy="274320"/>
+          </a:xfrm>
+          <a:prstGeom prst="rect">
+            <a:avLst/>
+          </a:prstGeom>
+          <a:extLst>
+            <a:ext uri="{C572A759-6A51-4108-AA02-DFA0A04FC94B}">
+              <ma14:wrappingTextBoxFlag xmlns:ma14="http://schemas.microsoft.com/office/mac/drawingml/2011/main" val="0"/>
+            </a:ext>
+          </a:extLst>
+        </p:spPr>
+        <p:txBody>
+          <a:bodyPr/>
+          <a:lstStyle>
+            <a:lvl1pPr>
+              <a:defRPr sz="900">
+                <a:solidFill>
+                  <a:srgbClr val="6B7280"/>
+                </a:solidFill>
+              </a:defRPr>
+            </a:lvl1pPr>
+          </a:lstStyle>
+          <a:p>
+            <a:pPr algn="r"/>
+            <a:fld id="{F7021451-1387-4CA6-816F-3879F97B5CBC}" type="slidenum">
+              <a:rPr b="0" lang="en-US"/>
+              <a:t>15</a:t>
+            </a:fld>
+            <a:endParaRPr lang="en-US"/>
+          </a:p>
+        </p:txBody>
+      </p:sp>
+    </p:spTree>
+  </p:cSld>
+  <p:clrMapOvr>
+    <a:masterClrMapping/>
+  </p:clrMapOvr>
+</p:sld>
+</file>
+
+<file path=ppt/slides/slide16.xml><?xml version="1.0" encoding="utf-8"?>
+<p:sld xmlns:a="http://schemas.openxmlformats.org/drawingml/2006/main" xmlns:r="http://schemas.openxmlformats.org/officeDocument/2006/relationships" xmlns:p="http://schemas.openxmlformats.org/presentationml/2006/main">
+  <p:cSld name="Slide 16">
+    <p:spTree>
+      <p:nvGrpSpPr>
+        <p:cNvPr id="1" name=""/>
+        <p:cNvGrpSpPr/>
+        <p:nvPr/>
+      </p:nvGrpSpPr>
+      <p:grpSpPr>
+        <a:xfrm>
+          <a:off x="0" y="0"/>
+          <a:ext cx="0" cy="0"/>
+          <a:chOff x="0" y="0"/>
+          <a:chExt cx="0" cy="0"/>
+        </a:xfrm>
+      </p:grpSpPr>
+      <p:sp>
+        <p:nvSpPr>
+          <p:cNvPr id="2" name="Text 0"/>
+          <p:cNvSpPr/>
+          <p:nvPr>
+            <p:ph idx="100" type="title" hasCustomPrompt="1"/>
+          </p:nvPr>
+        </p:nvSpPr>
+        <p:spPr>
+          <a:xfrm>
+            <a:off x="457200" y="274320"/>
+            <a:ext cx="8229600" cy="685800"/>
+          </a:xfrm>
+          <a:prstGeom prst="rect">
+            <a:avLst/>
+          </a:prstGeom>
+          <a:noFill/>
+          <a:ln/>
+        </p:spPr>
+        <p:txBody>
+          <a:bodyPr wrap="square" lIns="0" tIns="0" rIns="0" bIns="0" rtlCol="0" anchor="ctr"/>
+          <a:lstStyle/>
+          <a:p>
+            <a:pPr algn="ctr" indent="0" marL="0">
+              <a:buNone/>
+            </a:pPr>
+            <a:r>
+              <a:rPr lang="en-US" sz="2400" b="1" dirty="0">
+                <a:solidFill>
+                  <a:schemeClr val="tx2"/>
+                </a:solidFill>
+              </a:rPr>
+              <a:t>Takeaways and next steps</a:t>
+            </a:r>
+            <a:endParaRPr lang="en-US" sz="2400" dirty="0"/>
+          </a:p>
+        </p:txBody>
+      </p:sp>
+      <p:sp>
+        <p:nvSpPr>
+          <p:cNvPr id="3" name="take-head"/>
+          <p:cNvSpPr txBox="1"/>
+          <p:nvPr/>
+        </p:nvSpPr>
+        <p:spPr>
+          <a:xfrm>
+            <a:off x="457200" y="1051560"/>
+            <a:ext cx="2743200" cy="530352"/>
+          </a:xfrm>
+          <a:prstGeom prst="rect">
+            <a:avLst/>
+          </a:prstGeom>
+          <a:noFill/>
+          <a:ln/>
+        </p:spPr>
+        <p:txBody>
+          <a:bodyPr wrap="square" lIns="0" tIns="0" rIns="0" bIns="0" rtlCol="0" anchor="ctr"/>
+          <a:lstStyle/>
+          <a:p>
+            <a:pPr indent="0" marL="0">
+              <a:buNone/>
+            </a:pPr>
+            <a:r>
+              <a:rPr lang="en-US" sz="1300" b="1" dirty="0">
+                <a:solidFill>
+                  <a:schemeClr val="accent1"/>
+                </a:solidFill>
+              </a:rPr>
+              <a:t>1:  </a:t>
+            </a:r>
+            <a:pPr indent="0" marL="0">
+              <a:buNone/>
+            </a:pPr>
+            <a:r>
+              <a:rPr lang="en-US" sz="1300" b="1" dirty="0">
+                <a:solidFill>
+                  <a:schemeClr val="tx2"/>
+                </a:solidFill>
+              </a:rPr>
+              <a:t>Sorting follows the news</a:t>
+            </a:r>
+            <a:endParaRPr lang="en-US" sz="1300" dirty="0"/>
+          </a:p>
+        </p:txBody>
+      </p:sp>
+      <p:sp>
+        <p:nvSpPr>
+          <p:cNvPr id="4" name="take-body"/>
+          <p:cNvSpPr txBox="1"/>
+          <p:nvPr/>
+        </p:nvSpPr>
+        <p:spPr>
+          <a:xfrm>
+            <a:off x="3291840" y="1051560"/>
+            <a:ext cx="5394960" cy="530352"/>
+          </a:xfrm>
+          <a:prstGeom prst="rect">
+            <a:avLst/>
+          </a:prstGeom>
+          <a:noFill/>
+          <a:ln/>
+        </p:spPr>
+        <p:txBody>
+          <a:bodyPr wrap="square" lIns="0" tIns="0" rIns="0" bIns="0" rtlCol="0" anchor="ctr"/>
+          <a:lstStyle/>
+          <a:p>
+            <a:pPr indent="0" marL="0">
+              <a:buNone/>
+            </a:pPr>
+            <a:r>
+              <a:rPr lang="en-US" sz="1200" dirty="0">
+                <a:solidFill>
+                  <a:schemeClr val="tx1"/>
+                </a:solidFill>
+              </a:rPr>
+              <a:t>Optimistic public news makes individualists run relatively more; pessimistic news, collectivists.</a:t>
+            </a:r>
+            <a:endParaRPr lang="en-US" sz="1200" dirty="0"/>
+          </a:p>
+        </p:txBody>
+      </p:sp>
+      <p:sp>
+        <p:nvSpPr>
+          <p:cNvPr id="5" name="take-head"/>
+          <p:cNvSpPr txBox="1"/>
+          <p:nvPr/>
+        </p:nvSpPr>
+        <p:spPr>
+          <a:xfrm>
+            <a:off x="457200" y="1627632"/>
+            <a:ext cx="2743200" cy="530352"/>
+          </a:xfrm>
+          <a:prstGeom prst="rect">
+            <a:avLst/>
+          </a:prstGeom>
+          <a:noFill/>
+          <a:ln/>
+        </p:spPr>
+        <p:txBody>
+          <a:bodyPr wrap="square" lIns="0" tIns="0" rIns="0" bIns="0" rtlCol="0" anchor="ctr"/>
+          <a:lstStyle/>
+          <a:p>
+            <a:pPr indent="0" marL="0">
+              <a:buNone/>
+            </a:pPr>
+            <a:r>
+              <a:rPr lang="en-US" sz="1300" b="1" dirty="0">
+                <a:solidFill>
+                  <a:schemeClr val="accent1"/>
+                </a:solidFill>
+              </a:rPr>
+              <a:t>2:  </a:t>
+            </a:r>
+            <a:pPr indent="0" marL="0">
+              <a:buNone/>
+            </a:pPr>
+            <a:r>
+              <a:rPr lang="en-US" sz="1300" b="1" dirty="0">
+                <a:solidFill>
+                  <a:schemeClr val="tx2"/>
+                </a:solidFill>
+              </a:rPr>
+              <a:t>Collectivists herd</a:t>
+            </a:r>
+            <a:endParaRPr lang="en-US" sz="1300" dirty="0"/>
+          </a:p>
+        </p:txBody>
+      </p:sp>
+      <p:sp>
+        <p:nvSpPr>
+          <p:cNvPr id="6" name="take-body"/>
+          <p:cNvSpPr txBox="1"/>
+          <p:nvPr/>
+        </p:nvSpPr>
+        <p:spPr>
+          <a:xfrm>
+            <a:off x="3291840" y="1627632"/>
+            <a:ext cx="5394960" cy="530352"/>
+          </a:xfrm>
+          <a:prstGeom prst="rect">
+            <a:avLst/>
+          </a:prstGeom>
+          <a:noFill/>
+          <a:ln/>
+        </p:spPr>
+        <p:txBody>
+          <a:bodyPr wrap="square" lIns="0" tIns="0" rIns="0" bIns="0" rtlCol="0" anchor="ctr"/>
+          <a:lstStyle/>
+          <a:p>
+            <a:pPr indent="0" marL="0">
+              <a:buNone/>
+            </a:pPr>
+            <a:r>
+              <a:rPr lang="en-US" sz="1200" dirty="0">
+                <a:solidFill>
+                  <a:schemeClr val="tx1"/>
+                </a:solidFill>
+              </a:rPr>
+              <a:t>Their chance of withdrawing jumps from 0.15 to 0.93 once 20–35% of neighbours are out; individualists level off near 0.3.</a:t>
+            </a:r>
+            <a:endParaRPr lang="en-US" sz="1200" dirty="0"/>
+          </a:p>
+        </p:txBody>
+      </p:sp>
+      <p:sp>
+        <p:nvSpPr>
+          <p:cNvPr id="7" name="take-head"/>
+          <p:cNvSpPr txBox="1"/>
+          <p:nvPr/>
+        </p:nvSpPr>
+        <p:spPr>
+          <a:xfrm>
+            <a:off x="457200" y="2203704"/>
+            <a:ext cx="2743200" cy="530352"/>
+          </a:xfrm>
+          <a:prstGeom prst="rect">
+            <a:avLst/>
+          </a:prstGeom>
+          <a:noFill/>
+          <a:ln/>
+        </p:spPr>
+        <p:txBody>
+          <a:bodyPr wrap="square" lIns="0" tIns="0" rIns="0" bIns="0" rtlCol="0" anchor="ctr"/>
+          <a:lstStyle/>
+          <a:p>
+            <a:pPr indent="0" marL="0">
+              <a:buNone/>
+            </a:pPr>
+            <a:r>
+              <a:rPr lang="en-US" sz="1300" b="1" dirty="0">
+                <a:solidFill>
+                  <a:schemeClr val="accent1"/>
+                </a:solidFill>
+              </a:rPr>
+              <a:t>3:  </a:t>
+            </a:r>
+            <a:pPr indent="0" marL="0">
+              <a:buNone/>
+            </a:pPr>
+            <a:r>
+              <a:rPr lang="en-US" sz="1300" b="1" dirty="0">
+                <a:solidFill>
+                  <a:schemeClr val="tx2"/>
+                </a:solidFill>
+              </a:rPr>
+              <a:t>More individualists, fewer failures</a:t>
+            </a:r>
+            <a:endParaRPr lang="en-US" sz="1300" dirty="0"/>
+          </a:p>
+        </p:txBody>
+      </p:sp>
+      <p:sp>
+        <p:nvSpPr>
+          <p:cNvPr id="8" name="take-body"/>
+          <p:cNvSpPr txBox="1"/>
+          <p:nvPr/>
+        </p:nvSpPr>
+        <p:spPr>
+          <a:xfrm>
+            <a:off x="3291840" y="2203704"/>
+            <a:ext cx="5394960" cy="530352"/>
+          </a:xfrm>
+          <a:prstGeom prst="rect">
+            <a:avLst/>
+          </a:prstGeom>
+          <a:noFill/>
+          <a:ln/>
+        </p:spPr>
+        <p:txBody>
+          <a:bodyPr wrap="square" lIns="0" tIns="0" rIns="0" bIns="0" rtlCol="0" anchor="ctr"/>
+          <a:lstStyle/>
+          <a:p>
+            <a:pPr indent="0" marL="0">
+              <a:buNone/>
+            </a:pPr>
+            <a:r>
+              <a:rPr lang="en-US" sz="1200" dirty="0">
+                <a:solidFill>
+                  <a:schemeClr val="tx1"/>
+                </a:solidFill>
+              </a:rPr>
+              <a:t>P(fail) falls from 0.67 to 0.08 as the individualist share goes from 0 to 1.</a:t>
+            </a:r>
+            <a:endParaRPr lang="en-US" sz="1200" dirty="0"/>
+          </a:p>
+        </p:txBody>
+      </p:sp>
+      <p:sp>
+        <p:nvSpPr>
+          <p:cNvPr id="9" name="take-head"/>
+          <p:cNvSpPr txBox="1"/>
+          <p:nvPr/>
+        </p:nvSpPr>
+        <p:spPr>
+          <a:xfrm>
+            <a:off x="457200" y="2779776"/>
+            <a:ext cx="2743200" cy="530352"/>
+          </a:xfrm>
+          <a:prstGeom prst="rect">
+            <a:avLst/>
+          </a:prstGeom>
+          <a:noFill/>
+          <a:ln/>
+        </p:spPr>
+        <p:txBody>
+          <a:bodyPr wrap="square" lIns="0" tIns="0" rIns="0" bIns="0" rtlCol="0" anchor="ctr"/>
+          <a:lstStyle/>
+          <a:p>
+            <a:pPr indent="0" marL="0">
+              <a:buNone/>
+            </a:pPr>
+            <a:r>
+              <a:rPr lang="en-US" sz="1300" b="1" dirty="0">
+                <a:solidFill>
+                  <a:schemeClr val="accent1"/>
+                </a:solidFill>
+              </a:rPr>
+              <a:t>4:  </a:t>
+            </a:r>
+            <a:pPr indent="0" marL="0">
+              <a:buNone/>
+            </a:pPr>
+            <a:r>
+              <a:rPr lang="en-US" sz="1300" b="1" dirty="0">
+                <a:solidFill>
+                  <a:schemeClr val="tx2"/>
+                </a:solidFill>
+              </a:rPr>
+              <a:t>Stale news cuts both ways</a:t>
+            </a:r>
+            <a:endParaRPr lang="en-US" sz="1300" dirty="0"/>
+          </a:p>
+        </p:txBody>
+      </p:sp>
+      <p:sp>
+        <p:nvSpPr>
+          <p:cNvPr id="10" name="take-body"/>
+          <p:cNvSpPr txBox="1"/>
+          <p:nvPr/>
+        </p:nvSpPr>
+        <p:spPr>
+          <a:xfrm>
+            <a:off x="3291840" y="2779776"/>
+            <a:ext cx="5394960" cy="530352"/>
+          </a:xfrm>
+          <a:prstGeom prst="rect">
+            <a:avLst/>
+          </a:prstGeom>
+          <a:noFill/>
+          <a:ln/>
+        </p:spPr>
+        <p:txBody>
+          <a:bodyPr wrap="square" lIns="0" tIns="0" rIns="0" bIns="0" rtlCol="0" anchor="ctr"/>
+          <a:lstStyle/>
+          <a:p>
+            <a:pPr indent="0" marL="0">
+              <a:buNone/>
+            </a:pPr>
+            <a:r>
+              <a:rPr lang="en-US" sz="1200" dirty="0">
+                <a:solidFill>
+                  <a:schemeClr val="tx1"/>
+                </a:solidFill>
+              </a:rPr>
+              <a:t>A stale optimistic signal halves failure, a stale pessimistic one raises it by half. Accurate news barely moves it.</a:t>
+            </a:r>
+            <a:endParaRPr lang="en-US" sz="1200" dirty="0"/>
+          </a:p>
+        </p:txBody>
+      </p:sp>
+      <p:sp>
+        <p:nvSpPr>
+          <p:cNvPr id="11" name="take-head"/>
+          <p:cNvSpPr txBox="1"/>
+          <p:nvPr/>
+        </p:nvSpPr>
+        <p:spPr>
+          <a:xfrm>
+            <a:off x="457200" y="3355848"/>
+            <a:ext cx="2743200" cy="530352"/>
+          </a:xfrm>
+          <a:prstGeom prst="rect">
+            <a:avLst/>
+          </a:prstGeom>
+          <a:noFill/>
+          <a:ln/>
+        </p:spPr>
+        <p:txBody>
+          <a:bodyPr wrap="square" lIns="0" tIns="0" rIns="0" bIns="0" rtlCol="0" anchor="ctr"/>
+          <a:lstStyle/>
+          <a:p>
+            <a:pPr indent="0" marL="0">
+              <a:buNone/>
+            </a:pPr>
+            <a:r>
+              <a:rPr lang="en-US" sz="1300" b="1" dirty="0">
+                <a:solidFill>
+                  <a:schemeClr val="accent1"/>
+                </a:solidFill>
+              </a:rPr>
+              <a:t>5:  </a:t>
+            </a:r>
+            <a:pPr indent="0" marL="0">
+              <a:buNone/>
+            </a:pPr>
+            <a:r>
+              <a:rPr lang="en-US" sz="1300" b="1" dirty="0">
+                <a:solidFill>
+                  <a:schemeClr val="tx2"/>
+                </a:solidFill>
+              </a:rPr>
+              <a:t>Capping the largest deposits</a:t>
+            </a:r>
+            <a:endParaRPr lang="en-US" sz="1300" dirty="0"/>
+          </a:p>
+        </p:txBody>
+      </p:sp>
+      <p:sp>
+        <p:nvSpPr>
+          <p:cNvPr id="12" name="take-body"/>
+          <p:cNvSpPr txBox="1"/>
+          <p:nvPr/>
+        </p:nvSpPr>
+        <p:spPr>
+          <a:xfrm>
+            <a:off x="3291840" y="3355848"/>
+            <a:ext cx="5394960" cy="530352"/>
+          </a:xfrm>
+          <a:prstGeom prst="rect">
+            <a:avLst/>
+          </a:prstGeom>
+          <a:noFill/>
+          <a:ln/>
+        </p:spPr>
+        <p:txBody>
+          <a:bodyPr wrap="square" lIns="0" tIns="0" rIns="0" bIns="0" rtlCol="0" anchor="ctr"/>
+          <a:lstStyle/>
+          <a:p>
+            <a:pPr indent="0" marL="0">
+              <a:buNone/>
+            </a:pPr>
+            <a:r>
+              <a:rPr lang="en-US" sz="1200" dirty="0">
+                <a:solidFill>
+                  <a:schemeClr val="tx1"/>
+                </a:solidFill>
+              </a:rPr>
+              <a:t>A 1% cap brings failure down to the no-concentration bank’s level; the culture gradient is unchanged.</a:t>
+            </a:r>
+            <a:endParaRPr lang="en-US" sz="1200" dirty="0"/>
+          </a:p>
+        </p:txBody>
+      </p:sp>
+      <p:sp>
+        <p:nvSpPr>
+          <p:cNvPr id="13" name="take-head"/>
+          <p:cNvSpPr txBox="1"/>
+          <p:nvPr/>
+        </p:nvSpPr>
+        <p:spPr>
+          <a:xfrm>
+            <a:off x="457200" y="3931920"/>
+            <a:ext cx="2743200" cy="530352"/>
+          </a:xfrm>
+          <a:prstGeom prst="rect">
+            <a:avLst/>
+          </a:prstGeom>
+          <a:noFill/>
+          <a:ln/>
+        </p:spPr>
+        <p:txBody>
+          <a:bodyPr wrap="square" lIns="0" tIns="0" rIns="0" bIns="0" rtlCol="0" anchor="ctr"/>
+          <a:lstStyle/>
+          <a:p>
+            <a:pPr indent="0" marL="0">
+              <a:buNone/>
+            </a:pPr>
+            <a:r>
+              <a:rPr lang="en-US" sz="1300" b="1" dirty="0">
+                <a:solidFill>
+                  <a:schemeClr val="accent1"/>
+                </a:solidFill>
+              </a:rPr>
+              <a:t>6:  </a:t>
+            </a:r>
+            <a:pPr indent="0" marL="0">
+              <a:buNone/>
+            </a:pPr>
+            <a:r>
+              <a:rPr lang="en-US" sz="1300" b="1" dirty="0">
+                <a:solidFill>
+                  <a:schemeClr val="tx2"/>
+                </a:solidFill>
+              </a:rPr>
+              <a:t>Not yet matched</a:t>
+            </a:r>
+            <a:endParaRPr lang="en-US" sz="1300" dirty="0"/>
+          </a:p>
+        </p:txBody>
+      </p:sp>
+      <p:sp>
+        <p:nvSpPr>
+          <p:cNvPr id="14" name="take-body"/>
+          <p:cNvSpPr txBox="1"/>
+          <p:nvPr/>
+        </p:nvSpPr>
+        <p:spPr>
+          <a:xfrm>
+            <a:off x="3291840" y="3931920"/>
+            <a:ext cx="5394960" cy="530352"/>
+          </a:xfrm>
+          <a:prstGeom prst="rect">
+            <a:avLst/>
+          </a:prstGeom>
+          <a:noFill/>
+          <a:ln/>
+        </p:spPr>
+        <p:txBody>
+          <a:bodyPr wrap="square" lIns="0" tIns="0" rIns="0" bIns="0" rtlCol="0" anchor="ctr"/>
+          <a:lstStyle/>
+          <a:p>
+            <a:pPr indent="0" marL="0">
+              <a:buNone/>
+            </a:pPr>
+            <a:r>
+              <a:rPr lang="en-US" sz="1200" dirty="0">
+                <a:solidFill>
+                  <a:schemeClr val="tx1"/>
+                </a:solidFill>
+              </a:rPr>
+              <a:t>How large depositors exit in real runs.</a:t>
+            </a:r>
+            <a:endParaRPr lang="en-US" sz="1200" dirty="0"/>
+          </a:p>
+        </p:txBody>
+      </p:sp>
+      <p:sp>
+        <p:nvSpPr>
+          <p:cNvPr id="25" name="Slide Number Placeholder 0"/>
+          <p:cNvSpPr>
+            <a:spLocks noGrp="1"/>
+          </p:cNvSpPr>
+          <p:nvPr>
+            <p:ph type="sldNum" sz="quarter" idx="4294967295"/>
+          </p:nvPr>
+        </p:nvSpPr>
+        <p:spPr>
+          <a:xfrm>
+            <a:off x="8321040" y="4754880"/>
+            <a:ext cx="457200" cy="274320"/>
+          </a:xfrm>
+          <a:prstGeom prst="rect">
+            <a:avLst/>
+          </a:prstGeom>
+          <a:extLst>
+            <a:ext uri="{C572A759-6A51-4108-AA02-DFA0A04FC94B}">
+              <ma14:wrappingTextBoxFlag xmlns:ma14="http://schemas.microsoft.com/office/mac/drawingml/2011/main" val="0"/>
+            </a:ext>
+          </a:extLst>
+        </p:spPr>
+        <p:txBody>
+          <a:bodyPr/>
+          <a:lstStyle>
+            <a:lvl1pPr>
+              <a:defRPr sz="900">
+                <a:solidFill>
+                  <a:srgbClr val="6B7280"/>
+                </a:solidFill>
+              </a:defRPr>
+            </a:lvl1pPr>
+          </a:lstStyle>
+          <a:p>
+            <a:pPr algn="r"/>
+            <a:fld id="{F7021451-1387-4CA6-816F-3879F97B5CBC}" type="slidenum">
+              <a:rPr b="0" lang="en-US"/>
+              <a:t>16</a:t>
             </a:fld>
             <a:endParaRPr lang="en-US"/>
           </a:p>
@@ -4695,8 +5099,8 @@
         </p:nvSpPr>
         <p:spPr>
           <a:xfrm>
-            <a:off x="457200" y="274320"/>
-            <a:ext cx="8229600" cy="685800"/>
+            <a:off x="548640" y="1828800"/>
+            <a:ext cx="8046720" cy="1097280"/>
           </a:xfrm>
           <a:prstGeom prst="rect">
             <a:avLst/>
@@ -4712,27 +5116,29 @@
               <a:buNone/>
             </a:pPr>
             <a:r>
-              <a:rPr lang="en-US" sz="2400" b="1" dirty="0">
-                <a:solidFill>
-                  <a:schemeClr val="tx2"/>
-                </a:solidFill>
-              </a:rPr>
-              <a:t>The model: one weight on two signals</a:t>
-            </a:r>
-            <a:endParaRPr lang="en-US" sz="2400" dirty="0"/>
-          </a:p>
-        </p:txBody>
-      </p:sp>
-      <p:sp>
-        <p:nvSpPr>
-          <p:cNvPr id="3" name="eq"/>
-          <p:cNvSpPr txBox="1"/>
-          <p:nvPr/>
-        </p:nvSpPr>
-        <p:spPr>
-          <a:xfrm>
-            <a:off x="640080" y="1234440"/>
-            <a:ext cx="7863840" cy="685800"/>
+              <a:rPr lang="en-US" sz="3200" b="1" dirty="0">
+                <a:solidFill>
+                  <a:schemeClr val="bg1"/>
+                </a:solidFill>
+              </a:rPr>
+              <a:t>An agent-based bank run model with culturally heterogeneous signal interpretation</a:t>
+            </a:r>
+            <a:endParaRPr lang="en-US" sz="3200" dirty="0"/>
+          </a:p>
+        </p:txBody>
+      </p:sp>
+      <p:sp>
+        <p:nvSpPr>
+          <p:cNvPr id="4" name="Text 0"/>
+          <p:cNvSpPr/>
+          <p:nvPr>
+            <p:ph idx="101" type="body" hasCustomPrompt="1"/>
+          </p:nvPr>
+        </p:nvSpPr>
+        <p:spPr>
+          <a:xfrm>
+            <a:off x="548640" y="2971800"/>
+            <a:ext cx="8046720" cy="731520"/>
           </a:xfrm>
           <a:prstGeom prst="rect">
             <a:avLst/>
@@ -4741,539 +5147,13 @@
           <a:ln/>
         </p:spPr>
         <p:txBody>
-          <a:bodyPr wrap="square" lIns="0" tIns="0" rIns="0" bIns="0" rtlCol="0" anchor="ctr"/>
+          <a:bodyPr wrap="square" lIns="0" tIns="0" rIns="0" bIns="0" rtlCol="0" anchor="t"/>
           <a:lstStyle/>
           <a:p>
             <a:pPr algn="ctr" indent="0" marL="0">
               <a:buNone/>
             </a:pPr>
-            <a:r>
-              <a:rPr lang="en-US" sz="3000" i="1" dirty="0">
-                <a:solidFill>
-                  <a:schemeClr val="tx2"/>
-                </a:solidFill>
-                <a:latin typeface="Cambria" pitchFamily="34" charset="0"/>
-                <a:ea typeface="Cambria" pitchFamily="34" charset="-122"/>
-                <a:cs typeface="Cambria" pitchFamily="34" charset="-120"/>
-              </a:rPr>
-              <a:t>ŝ</a:t>
-            </a:r>
-            <a:pPr algn="ctr" indent="0" marL="0">
-              <a:buNone/>
-            </a:pPr>
-            <a:r>
-              <a:rPr lang="en-US" sz="3000" i="1" baseline="-40000" dirty="0">
-                <a:solidFill>
-                  <a:schemeClr val="tx2"/>
-                </a:solidFill>
-                <a:latin typeface="Cambria" pitchFamily="34" charset="0"/>
-                <a:ea typeface="Cambria" pitchFamily="34" charset="-122"/>
-                <a:cs typeface="Cambria" pitchFamily="34" charset="-120"/>
-              </a:rPr>
-              <a:t>i</a:t>
-            </a:r>
-            <a:pPr algn="ctr" indent="0" marL="0">
-              <a:buNone/>
-            </a:pPr>
-            <a:r>
-              <a:rPr lang="en-US" sz="3000" dirty="0">
-                <a:solidFill>
-                  <a:schemeClr val="tx2"/>
-                </a:solidFill>
-                <a:latin typeface="Cambria" pitchFamily="34" charset="0"/>
-                <a:ea typeface="Cambria" pitchFamily="34" charset="-122"/>
-                <a:cs typeface="Cambria" pitchFamily="34" charset="-120"/>
-              </a:rPr>
-              <a:t>  =  λ</a:t>
-            </a:r>
-            <a:pPr algn="ctr" indent="0" marL="0">
-              <a:buNone/>
-            </a:pPr>
-            <a:r>
-              <a:rPr lang="en-US" sz="3000" i="1" baseline="-40000" dirty="0">
-                <a:solidFill>
-                  <a:schemeClr val="tx2"/>
-                </a:solidFill>
-                <a:latin typeface="Cambria" pitchFamily="34" charset="0"/>
-                <a:ea typeface="Cambria" pitchFamily="34" charset="-122"/>
-                <a:cs typeface="Cambria" pitchFamily="34" charset="-120"/>
-              </a:rPr>
-              <a:t>i</a:t>
-            </a:r>
-            <a:pPr algn="ctr" indent="0" marL="0">
-              <a:buNone/>
-            </a:pPr>
-            <a:r>
-              <a:rPr lang="en-US" sz="3000" dirty="0">
-                <a:solidFill>
-                  <a:schemeClr val="tx2"/>
-                </a:solidFill>
-                <a:latin typeface="Cambria" pitchFamily="34" charset="0"/>
-                <a:ea typeface="Cambria" pitchFamily="34" charset="-122"/>
-                <a:cs typeface="Cambria" pitchFamily="34" charset="-120"/>
-              </a:rPr>
-              <a:t> · </a:t>
-            </a:r>
-            <a:pPr algn="ctr" indent="0" marL="0">
-              <a:buNone/>
-            </a:pPr>
-            <a:r>
-              <a:rPr lang="en-US" sz="3000" i="1" dirty="0">
-                <a:solidFill>
-                  <a:schemeClr val="tx2"/>
-                </a:solidFill>
-                <a:latin typeface="Cambria" pitchFamily="34" charset="0"/>
-                <a:ea typeface="Cambria" pitchFamily="34" charset="-122"/>
-                <a:cs typeface="Cambria" pitchFamily="34" charset="-120"/>
-              </a:rPr>
-              <a:t>y</a:t>
-            </a:r>
-            <a:pPr algn="ctr" indent="0" marL="0">
-              <a:buNone/>
-            </a:pPr>
-            <a:r>
-              <a:rPr lang="en-US" sz="3000" dirty="0">
-                <a:solidFill>
-                  <a:schemeClr val="tx2"/>
-                </a:solidFill>
-                <a:latin typeface="Cambria" pitchFamily="34" charset="0"/>
-                <a:ea typeface="Cambria" pitchFamily="34" charset="-122"/>
-                <a:cs typeface="Cambria" pitchFamily="34" charset="-120"/>
-              </a:rPr>
-              <a:t>  +  (1 − λ</a:t>
-            </a:r>
-            <a:pPr algn="ctr" indent="0" marL="0">
-              <a:buNone/>
-            </a:pPr>
-            <a:r>
-              <a:rPr lang="en-US" sz="3000" i="1" baseline="-40000" dirty="0">
-                <a:solidFill>
-                  <a:schemeClr val="tx2"/>
-                </a:solidFill>
-                <a:latin typeface="Cambria" pitchFamily="34" charset="0"/>
-                <a:ea typeface="Cambria" pitchFamily="34" charset="-122"/>
-                <a:cs typeface="Cambria" pitchFamily="34" charset="-120"/>
-              </a:rPr>
-              <a:t>i</a:t>
-            </a:r>
-            <a:pPr algn="ctr" indent="0" marL="0">
-              <a:buNone/>
-            </a:pPr>
-            <a:r>
-              <a:rPr lang="en-US" sz="3000" dirty="0">
-                <a:solidFill>
-                  <a:schemeClr val="tx2"/>
-                </a:solidFill>
-                <a:latin typeface="Cambria" pitchFamily="34" charset="0"/>
-                <a:ea typeface="Cambria" pitchFamily="34" charset="-122"/>
-                <a:cs typeface="Cambria" pitchFamily="34" charset="-120"/>
-              </a:rPr>
-              <a:t>) · </a:t>
-            </a:r>
-            <a:pPr algn="ctr" indent="0" marL="0">
-              <a:buNone/>
-            </a:pPr>
-            <a:r>
-              <a:rPr lang="en-US" sz="3000" i="1" dirty="0">
-                <a:solidFill>
-                  <a:schemeClr val="tx2"/>
-                </a:solidFill>
-                <a:latin typeface="Cambria" pitchFamily="34" charset="0"/>
-                <a:ea typeface="Cambria" pitchFamily="34" charset="-122"/>
-                <a:cs typeface="Cambria" pitchFamily="34" charset="-120"/>
-              </a:rPr>
-              <a:t>x</a:t>
-            </a:r>
-            <a:pPr algn="ctr" indent="0" marL="0">
-              <a:buNone/>
-            </a:pPr>
-            <a:r>
-              <a:rPr lang="en-US" sz="3000" i="1" baseline="-40000" dirty="0">
-                <a:solidFill>
-                  <a:schemeClr val="tx2"/>
-                </a:solidFill>
-                <a:latin typeface="Cambria" pitchFamily="34" charset="0"/>
-                <a:ea typeface="Cambria" pitchFamily="34" charset="-122"/>
-                <a:cs typeface="Cambria" pitchFamily="34" charset="-120"/>
-              </a:rPr>
-              <a:t>i</a:t>
-            </a:r>
-            <a:endParaRPr lang="en-US" sz="3000" dirty="0"/>
-          </a:p>
-        </p:txBody>
-      </p:sp>
-      <p:sp>
-        <p:nvSpPr>
-          <p:cNvPr id="4" name="types"/>
-          <p:cNvSpPr txBox="1"/>
-          <p:nvPr/>
-        </p:nvSpPr>
-        <p:spPr>
-          <a:xfrm>
-            <a:off x="457200" y="2240280"/>
-            <a:ext cx="8229600" cy="685800"/>
-          </a:xfrm>
-          <a:prstGeom prst="rect">
-            <a:avLst/>
-          </a:prstGeom>
-          <a:noFill/>
-          <a:ln/>
-        </p:spPr>
-        <p:txBody>
-          <a:bodyPr wrap="square" lIns="0" tIns="0" rIns="0" bIns="0" rtlCol="0" anchor="ctr"/>
-          <a:lstStyle/>
-          <a:p>
-            <a:pPr algn="ctr" indent="0" marL="0">
-              <a:buNone/>
-            </a:pPr>
-            <a:r>
-              <a:rPr lang="en-US" sz="3000" b="1" dirty="0">
-                <a:solidFill>
-                  <a:srgbClr val="EB6834"/>
-                </a:solidFill>
-                <a:latin typeface="Cambria" pitchFamily="34" charset="0"/>
-                <a:ea typeface="Cambria" pitchFamily="34" charset="-122"/>
-                <a:cs typeface="Cambria" pitchFamily="34" charset="-120"/>
-              </a:rPr>
-              <a:t>Individualists </a:t>
-            </a:r>
-            <a:pPr algn="ctr" indent="0" marL="0">
-              <a:buNone/>
-            </a:pPr>
-            <a:r>
-              <a:rPr lang="en-US" sz="3000" dirty="0">
-                <a:solidFill>
-                  <a:schemeClr val="tx2"/>
-                </a:solidFill>
-                <a:latin typeface="Cambria" pitchFamily="34" charset="0"/>
-                <a:ea typeface="Cambria" pitchFamily="34" charset="-122"/>
-                <a:cs typeface="Cambria" pitchFamily="34" charset="-120"/>
-              </a:rPr>
-              <a:t>λ</a:t>
-            </a:r>
-            <a:pPr algn="ctr" indent="0" marL="0">
-              <a:buNone/>
-            </a:pPr>
-            <a:r>
-              <a:rPr lang="en-US" sz="3000" baseline="-40000" dirty="0">
-                <a:solidFill>
-                  <a:schemeClr val="tx2"/>
-                </a:solidFill>
-                <a:latin typeface="Cambria" pitchFamily="34" charset="0"/>
-                <a:ea typeface="Cambria" pitchFamily="34" charset="-122"/>
-                <a:cs typeface="Cambria" pitchFamily="34" charset="-120"/>
-              </a:rPr>
-              <a:t>I</a:t>
-            </a:r>
-            <a:pPr algn="ctr" indent="0" marL="0">
-              <a:buNone/>
-            </a:pPr>
-            <a:r>
-              <a:rPr lang="en-US" sz="3000" dirty="0">
-                <a:solidFill>
-                  <a:schemeClr val="tx2"/>
-                </a:solidFill>
-                <a:latin typeface="Cambria" pitchFamily="34" charset="0"/>
-                <a:ea typeface="Cambria" pitchFamily="34" charset="-122"/>
-                <a:cs typeface="Cambria" pitchFamily="34" charset="-120"/>
-              </a:rPr>
-              <a:t>  &lt;  λ</a:t>
-            </a:r>
-            <a:pPr algn="ctr" indent="0" marL="0">
-              <a:buNone/>
-            </a:pPr>
-            <a:r>
-              <a:rPr lang="en-US" sz="3000" baseline="-40000" dirty="0">
-                <a:solidFill>
-                  <a:schemeClr val="tx2"/>
-                </a:solidFill>
-                <a:latin typeface="Cambria" pitchFamily="34" charset="0"/>
-                <a:ea typeface="Cambria" pitchFamily="34" charset="-122"/>
-                <a:cs typeface="Cambria" pitchFamily="34" charset="-120"/>
-              </a:rPr>
-              <a:t>C</a:t>
-            </a:r>
-            <a:pPr algn="ctr" indent="0" marL="0">
-              <a:buNone/>
-            </a:pPr>
-            <a:r>
-              <a:rPr lang="en-US" sz="3000" b="1" dirty="0">
-                <a:solidFill>
-                  <a:srgbClr val="2A78D6"/>
-                </a:solidFill>
-                <a:latin typeface="Cambria" pitchFamily="34" charset="0"/>
-                <a:ea typeface="Cambria" pitchFamily="34" charset="-122"/>
-                <a:cs typeface="Cambria" pitchFamily="34" charset="-120"/>
-              </a:rPr>
-              <a:t> collectivists</a:t>
-            </a:r>
-            <a:endParaRPr lang="en-US" sz="3000" dirty="0"/>
-          </a:p>
-        </p:txBody>
-      </p:sp>
-      <p:sp>
-        <p:nvSpPr>
-          <p:cNvPr id="5" name="eq2"/>
-          <p:cNvSpPr txBox="1"/>
-          <p:nvPr/>
-        </p:nvSpPr>
-        <p:spPr>
-          <a:xfrm>
-            <a:off x="640080" y="3246120"/>
-            <a:ext cx="7863840" cy="685800"/>
-          </a:xfrm>
-          <a:prstGeom prst="rect">
-            <a:avLst/>
-          </a:prstGeom>
-          <a:noFill/>
-          <a:ln/>
-        </p:spPr>
-        <p:txBody>
-          <a:bodyPr wrap="square" lIns="0" tIns="0" rIns="0" bIns="0" rtlCol="0" anchor="ctr"/>
-          <a:lstStyle/>
-          <a:p>
-            <a:pPr algn="ctr" indent="0" marL="0">
-              <a:buNone/>
-            </a:pPr>
-            <a:r>
-              <a:rPr lang="en-US" sz="3000" i="1" dirty="0">
-                <a:solidFill>
-                  <a:schemeClr val="tx2"/>
-                </a:solidFill>
-                <a:latin typeface="Cambria" pitchFamily="34" charset="0"/>
-                <a:ea typeface="Cambria" pitchFamily="34" charset="-122"/>
-                <a:cs typeface="Cambria" pitchFamily="34" charset="-120"/>
-              </a:rPr>
-              <a:t>ŝ</a:t>
-            </a:r>
-            <a:pPr algn="ctr" indent="0" marL="0">
-              <a:buNone/>
-            </a:pPr>
-            <a:r>
-              <a:rPr lang="en-US" sz="3000" baseline="-40000" dirty="0">
-                <a:solidFill>
-                  <a:schemeClr val="tx2"/>
-                </a:solidFill>
-                <a:latin typeface="Cambria" pitchFamily="34" charset="0"/>
-                <a:ea typeface="Cambria" pitchFamily="34" charset="-122"/>
-                <a:cs typeface="Cambria" pitchFamily="34" charset="-120"/>
-              </a:rPr>
-              <a:t>I</a:t>
-            </a:r>
-            <a:pPr algn="ctr" indent="0" marL="0">
-              <a:buNone/>
-            </a:pPr>
-            <a:r>
-              <a:rPr lang="en-US" sz="3000" dirty="0">
-                <a:solidFill>
-                  <a:schemeClr val="tx2"/>
-                </a:solidFill>
-                <a:latin typeface="Cambria" pitchFamily="34" charset="0"/>
-                <a:ea typeface="Cambria" pitchFamily="34" charset="-122"/>
-                <a:cs typeface="Cambria" pitchFamily="34" charset="-120"/>
-              </a:rPr>
-              <a:t>  −  </a:t>
-            </a:r>
-            <a:pPr algn="ctr" indent="0" marL="0">
-              <a:buNone/>
-            </a:pPr>
-            <a:r>
-              <a:rPr lang="en-US" sz="3000" i="1" dirty="0">
-                <a:solidFill>
-                  <a:schemeClr val="tx2"/>
-                </a:solidFill>
-                <a:latin typeface="Cambria" pitchFamily="34" charset="0"/>
-                <a:ea typeface="Cambria" pitchFamily="34" charset="-122"/>
-                <a:cs typeface="Cambria" pitchFamily="34" charset="-120"/>
-              </a:rPr>
-              <a:t>ŝ</a:t>
-            </a:r>
-            <a:pPr algn="ctr" indent="0" marL="0">
-              <a:buNone/>
-            </a:pPr>
-            <a:r>
-              <a:rPr lang="en-US" sz="3000" baseline="-40000" dirty="0">
-                <a:solidFill>
-                  <a:schemeClr val="tx2"/>
-                </a:solidFill>
-                <a:latin typeface="Cambria" pitchFamily="34" charset="0"/>
-                <a:ea typeface="Cambria" pitchFamily="34" charset="-122"/>
-                <a:cs typeface="Cambria" pitchFamily="34" charset="-120"/>
-              </a:rPr>
-              <a:t>C</a:t>
-            </a:r>
-            <a:pPr algn="ctr" indent="0" marL="0">
-              <a:buNone/>
-            </a:pPr>
-            <a:r>
-              <a:rPr lang="en-US" sz="3000" dirty="0">
-                <a:solidFill>
-                  <a:schemeClr val="tx2"/>
-                </a:solidFill>
-                <a:latin typeface="Cambria" pitchFamily="34" charset="0"/>
-                <a:ea typeface="Cambria" pitchFamily="34" charset="-122"/>
-                <a:cs typeface="Cambria" pitchFamily="34" charset="-120"/>
-              </a:rPr>
-              <a:t>  =  (λ</a:t>
-            </a:r>
-            <a:pPr algn="ctr" indent="0" marL="0">
-              <a:buNone/>
-            </a:pPr>
-            <a:r>
-              <a:rPr lang="en-US" sz="3000" baseline="-40000" dirty="0">
-                <a:solidFill>
-                  <a:schemeClr val="tx2"/>
-                </a:solidFill>
-                <a:latin typeface="Cambria" pitchFamily="34" charset="0"/>
-                <a:ea typeface="Cambria" pitchFamily="34" charset="-122"/>
-                <a:cs typeface="Cambria" pitchFamily="34" charset="-120"/>
-              </a:rPr>
-              <a:t>C</a:t>
-            </a:r>
-            <a:pPr algn="ctr" indent="0" marL="0">
-              <a:buNone/>
-            </a:pPr>
-            <a:r>
-              <a:rPr lang="en-US" sz="3000" dirty="0">
-                <a:solidFill>
-                  <a:schemeClr val="tx2"/>
-                </a:solidFill>
-                <a:latin typeface="Cambria" pitchFamily="34" charset="0"/>
-                <a:ea typeface="Cambria" pitchFamily="34" charset="-122"/>
-                <a:cs typeface="Cambria" pitchFamily="34" charset="-120"/>
-              </a:rPr>
-              <a:t> − λ</a:t>
-            </a:r>
-            <a:pPr algn="ctr" indent="0" marL="0">
-              <a:buNone/>
-            </a:pPr>
-            <a:r>
-              <a:rPr lang="en-US" sz="3000" baseline="-40000" dirty="0">
-                <a:solidFill>
-                  <a:schemeClr val="tx2"/>
-                </a:solidFill>
-                <a:latin typeface="Cambria" pitchFamily="34" charset="0"/>
-                <a:ea typeface="Cambria" pitchFamily="34" charset="-122"/>
-                <a:cs typeface="Cambria" pitchFamily="34" charset="-120"/>
-              </a:rPr>
-              <a:t>I</a:t>
-            </a:r>
-            <a:pPr algn="ctr" indent="0" marL="0">
-              <a:buNone/>
-            </a:pPr>
-            <a:r>
-              <a:rPr lang="en-US" sz="3000" dirty="0">
-                <a:solidFill>
-                  <a:schemeClr val="tx2"/>
-                </a:solidFill>
-                <a:latin typeface="Cambria" pitchFamily="34" charset="0"/>
-                <a:ea typeface="Cambria" pitchFamily="34" charset="-122"/>
-                <a:cs typeface="Cambria" pitchFamily="34" charset="-120"/>
-              </a:rPr>
-              <a:t>) · (</a:t>
-            </a:r>
-            <a:pPr algn="ctr" indent="0" marL="0">
-              <a:buNone/>
-            </a:pPr>
-            <a:r>
-              <a:rPr lang="en-US" sz="3000" i="1" dirty="0">
-                <a:solidFill>
-                  <a:schemeClr val="tx2"/>
-                </a:solidFill>
-                <a:latin typeface="Cambria" pitchFamily="34" charset="0"/>
-                <a:ea typeface="Cambria" pitchFamily="34" charset="-122"/>
-                <a:cs typeface="Cambria" pitchFamily="34" charset="-120"/>
-              </a:rPr>
-              <a:t>x</a:t>
-            </a:r>
-            <a:pPr algn="ctr" indent="0" marL="0">
-              <a:buNone/>
-            </a:pPr>
-            <a:r>
-              <a:rPr lang="en-US" sz="3000" dirty="0">
-                <a:solidFill>
-                  <a:schemeClr val="tx2"/>
-                </a:solidFill>
-                <a:latin typeface="Cambria" pitchFamily="34" charset="0"/>
-                <a:ea typeface="Cambria" pitchFamily="34" charset="-122"/>
-                <a:cs typeface="Cambria" pitchFamily="34" charset="-120"/>
-              </a:rPr>
-              <a:t> − </a:t>
-            </a:r>
-            <a:pPr algn="ctr" indent="0" marL="0">
-              <a:buNone/>
-            </a:pPr>
-            <a:r>
-              <a:rPr lang="en-US" sz="3000" i="1" dirty="0">
-                <a:solidFill>
-                  <a:schemeClr val="tx2"/>
-                </a:solidFill>
-                <a:latin typeface="Cambria" pitchFamily="34" charset="0"/>
-                <a:ea typeface="Cambria" pitchFamily="34" charset="-122"/>
-                <a:cs typeface="Cambria" pitchFamily="34" charset="-120"/>
-              </a:rPr>
-              <a:t>y</a:t>
-            </a:r>
-            <a:pPr algn="ctr" indent="0" marL="0">
-              <a:buNone/>
-            </a:pPr>
-            <a:r>
-              <a:rPr lang="en-US" sz="3000" dirty="0">
-                <a:solidFill>
-                  <a:schemeClr val="tx2"/>
-                </a:solidFill>
-                <a:latin typeface="Cambria" pitchFamily="34" charset="0"/>
-                <a:ea typeface="Cambria" pitchFamily="34" charset="-122"/>
-                <a:cs typeface="Cambria" pitchFamily="34" charset="-120"/>
-              </a:rPr>
-              <a:t>)</a:t>
-            </a:r>
-            <a:endParaRPr lang="en-US" sz="3000" dirty="0"/>
-          </a:p>
-        </p:txBody>
-      </p:sp>
-      <p:sp>
-        <p:nvSpPr>
-          <p:cNvPr id="25" name="Slide Number Placeholder 0"/>
-          <p:cNvSpPr>
-            <a:spLocks noGrp="1"/>
-          </p:cNvSpPr>
-          <p:nvPr>
-            <p:ph type="sldNum" sz="quarter" idx="4294967295"/>
-          </p:nvPr>
-        </p:nvSpPr>
-        <p:spPr>
-          <a:xfrm>
-            <a:off x="8321040" y="4754880"/>
-            <a:ext cx="457200" cy="274320"/>
-          </a:xfrm>
-          <a:prstGeom prst="rect">
-            <a:avLst/>
-          </a:prstGeom>
-          <a:extLst>
-            <a:ext uri="{C572A759-6A51-4108-AA02-DFA0A04FC94B}">
-              <ma14:wrappingTextBoxFlag xmlns:ma14="http://schemas.microsoft.com/office/mac/drawingml/2011/main" val="0"/>
-            </a:ext>
-          </a:extLst>
-        </p:spPr>
-        <p:txBody>
-          <a:bodyPr/>
-          <a:lstStyle>
-            <a:lvl1pPr>
-              <a:defRPr sz="900">
-                <a:solidFill>
-                  <a:srgbClr val="6B7280"/>
-                </a:solidFill>
-              </a:defRPr>
-            </a:lvl1pPr>
-          </a:lstStyle>
-          <a:p>
-            <a:pPr algn="r"/>
-            <a:fld id="{F7021451-1387-4CA6-816F-3879F97B5CBC}" type="slidenum">
-              <a:rPr b="0" lang="en-US"/>
-              <a:t>6</a:t>
-            </a:fld>
-            <a:endParaRPr lang="en-US"/>
+            <a:endParaRPr lang="en-US" sz="1600" dirty="0"/>
           </a:p>
         </p:txBody>
       </p:sp>
@@ -5334,36 +5214,521 @@
                   <a:schemeClr val="tx2"/>
                 </a:solidFill>
               </a:rPr>
-              <a:t>The model in one picture</a:t>
+              <a:t>The model: one weight on two signals</a:t>
             </a:r>
             <a:endParaRPr lang="en-US" sz="2400" dirty="0"/>
           </a:p>
         </p:txBody>
       </p:sp>
-      <p:pic>
-        <p:nvPicPr>
-          <p:cNvPr id="3" name="odd" descr="Model overview in three columns. Entities: depositors with log-normal deposits capped at 1% of the total, a type and a private signal; a Newman–Watts network; a bank with reserves, a long asset that sells at a discount when cash runs short, and a return that rises with the fundamental; the environment draws the fundamental and a public signal. Schedule: cultural warm-up, draw the run’s world, an exogenous shock, then a tick loop in which each banked depositor observes neighbours and the public signal, forms beliefs with weight λ on the social side, values staying against withdrawing by Monte Carlo, and acts; then period 2 settles the bank and the run is recorded.">    </p:cNvPr>
-          <p:cNvPicPr>
-            <a:picLocks noChangeAspect="1"/>
-          </p:cNvPicPr>
+      <p:sp>
+        <p:nvSpPr>
+          <p:cNvPr id="3" name="eq"/>
+          <p:cNvSpPr txBox="1"/>
           <p:nvPr/>
-        </p:nvPicPr>
-        <p:blipFill>
-          <a:blip r:embed="rId1"/>
-          <a:stretch>
-            <a:fillRect/>
-          </a:stretch>
-        </p:blipFill>
-        <p:spPr>
-          <a:xfrm>
-            <a:off x="755294" y="960120"/>
-            <a:ext cx="7633411" cy="3657600"/>
-          </a:xfrm>
-          <a:prstGeom prst="rect">
-            <a:avLst/>
-          </a:prstGeom>
-        </p:spPr>
-      </p:pic>
+        </p:nvSpPr>
+        <p:spPr>
+          <a:xfrm>
+            <a:off x="640080" y="1234440"/>
+            <a:ext cx="7863840" cy="685800"/>
+          </a:xfrm>
+          <a:prstGeom prst="rect">
+            <a:avLst/>
+          </a:prstGeom>
+          <a:noFill/>
+          <a:ln/>
+        </p:spPr>
+        <p:txBody>
+          <a:bodyPr wrap="square" lIns="0" tIns="0" rIns="0" bIns="0" rtlCol="0" anchor="ctr"/>
+          <a:lstStyle/>
+          <a:p>
+            <a:pPr algn="ctr" indent="0" marL="0">
+              <a:buNone/>
+            </a:pPr>
+            <a:r>
+              <a:rPr lang="en-US" sz="3000" i="1" dirty="0">
+                <a:solidFill>
+                  <a:schemeClr val="tx2"/>
+                </a:solidFill>
+                <a:latin typeface="Cambria" pitchFamily="34" charset="0"/>
+                <a:ea typeface="Cambria" pitchFamily="34" charset="-122"/>
+                <a:cs typeface="Cambria" pitchFamily="34" charset="-120"/>
+              </a:rPr>
+              <a:t>ŝ</a:t>
+            </a:r>
+            <a:pPr algn="ctr" indent="0" marL="0">
+              <a:buNone/>
+            </a:pPr>
+            <a:r>
+              <a:rPr lang="en-US" sz="3000" i="1" baseline="-40000" dirty="0">
+                <a:solidFill>
+                  <a:schemeClr val="tx2"/>
+                </a:solidFill>
+                <a:latin typeface="Cambria" pitchFamily="34" charset="0"/>
+                <a:ea typeface="Cambria" pitchFamily="34" charset="-122"/>
+                <a:cs typeface="Cambria" pitchFamily="34" charset="-120"/>
+              </a:rPr>
+              <a:t>i</a:t>
+            </a:r>
+            <a:pPr algn="ctr" indent="0" marL="0">
+              <a:buNone/>
+            </a:pPr>
+            <a:r>
+              <a:rPr lang="en-US" sz="3000" dirty="0">
+                <a:solidFill>
+                  <a:schemeClr val="tx2"/>
+                </a:solidFill>
+                <a:latin typeface="Cambria" pitchFamily="34" charset="0"/>
+                <a:ea typeface="Cambria" pitchFamily="34" charset="-122"/>
+                <a:cs typeface="Cambria" pitchFamily="34" charset="-120"/>
+              </a:rPr>
+              <a:t>  =  λ</a:t>
+            </a:r>
+            <a:pPr algn="ctr" indent="0" marL="0">
+              <a:buNone/>
+            </a:pPr>
+            <a:r>
+              <a:rPr lang="en-US" sz="3000" i="1" baseline="-40000" dirty="0">
+                <a:solidFill>
+                  <a:schemeClr val="tx2"/>
+                </a:solidFill>
+                <a:latin typeface="Cambria" pitchFamily="34" charset="0"/>
+                <a:ea typeface="Cambria" pitchFamily="34" charset="-122"/>
+                <a:cs typeface="Cambria" pitchFamily="34" charset="-120"/>
+              </a:rPr>
+              <a:t>i</a:t>
+            </a:r>
+            <a:pPr algn="ctr" indent="0" marL="0">
+              <a:buNone/>
+            </a:pPr>
+            <a:r>
+              <a:rPr lang="en-US" sz="3000" dirty="0">
+                <a:solidFill>
+                  <a:schemeClr val="tx2"/>
+                </a:solidFill>
+                <a:latin typeface="Cambria" pitchFamily="34" charset="0"/>
+                <a:ea typeface="Cambria" pitchFamily="34" charset="-122"/>
+                <a:cs typeface="Cambria" pitchFamily="34" charset="-120"/>
+              </a:rPr>
+              <a:t> · </a:t>
+            </a:r>
+            <a:pPr algn="ctr" indent="0" marL="0">
+              <a:buNone/>
+            </a:pPr>
+            <a:r>
+              <a:rPr lang="en-US" sz="3000" i="1" dirty="0">
+                <a:solidFill>
+                  <a:schemeClr val="tx2"/>
+                </a:solidFill>
+                <a:latin typeface="Cambria" pitchFamily="34" charset="0"/>
+                <a:ea typeface="Cambria" pitchFamily="34" charset="-122"/>
+                <a:cs typeface="Cambria" pitchFamily="34" charset="-120"/>
+              </a:rPr>
+              <a:t>y</a:t>
+            </a:r>
+            <a:pPr algn="ctr" indent="0" marL="0">
+              <a:buNone/>
+            </a:pPr>
+            <a:r>
+              <a:rPr lang="en-US" sz="3000" dirty="0">
+                <a:solidFill>
+                  <a:schemeClr val="tx2"/>
+                </a:solidFill>
+                <a:latin typeface="Cambria" pitchFamily="34" charset="0"/>
+                <a:ea typeface="Cambria" pitchFamily="34" charset="-122"/>
+                <a:cs typeface="Cambria" pitchFamily="34" charset="-120"/>
+              </a:rPr>
+              <a:t>  +  (1 − λ</a:t>
+            </a:r>
+            <a:pPr algn="ctr" indent="0" marL="0">
+              <a:buNone/>
+            </a:pPr>
+            <a:r>
+              <a:rPr lang="en-US" sz="3000" i="1" baseline="-40000" dirty="0">
+                <a:solidFill>
+                  <a:schemeClr val="tx2"/>
+                </a:solidFill>
+                <a:latin typeface="Cambria" pitchFamily="34" charset="0"/>
+                <a:ea typeface="Cambria" pitchFamily="34" charset="-122"/>
+                <a:cs typeface="Cambria" pitchFamily="34" charset="-120"/>
+              </a:rPr>
+              <a:t>i</a:t>
+            </a:r>
+            <a:pPr algn="ctr" indent="0" marL="0">
+              <a:buNone/>
+            </a:pPr>
+            <a:r>
+              <a:rPr lang="en-US" sz="3000" dirty="0">
+                <a:solidFill>
+                  <a:schemeClr val="tx2"/>
+                </a:solidFill>
+                <a:latin typeface="Cambria" pitchFamily="34" charset="0"/>
+                <a:ea typeface="Cambria" pitchFamily="34" charset="-122"/>
+                <a:cs typeface="Cambria" pitchFamily="34" charset="-120"/>
+              </a:rPr>
+              <a:t>) · </a:t>
+            </a:r>
+            <a:pPr algn="ctr" indent="0" marL="0">
+              <a:buNone/>
+            </a:pPr>
+            <a:r>
+              <a:rPr lang="en-US" sz="3000" i="1" dirty="0">
+                <a:solidFill>
+                  <a:schemeClr val="tx2"/>
+                </a:solidFill>
+                <a:latin typeface="Cambria" pitchFamily="34" charset="0"/>
+                <a:ea typeface="Cambria" pitchFamily="34" charset="-122"/>
+                <a:cs typeface="Cambria" pitchFamily="34" charset="-120"/>
+              </a:rPr>
+              <a:t>x</a:t>
+            </a:r>
+            <a:pPr algn="ctr" indent="0" marL="0">
+              <a:buNone/>
+            </a:pPr>
+            <a:r>
+              <a:rPr lang="en-US" sz="3000" i="1" baseline="-40000" dirty="0">
+                <a:solidFill>
+                  <a:schemeClr val="tx2"/>
+                </a:solidFill>
+                <a:latin typeface="Cambria" pitchFamily="34" charset="0"/>
+                <a:ea typeface="Cambria" pitchFamily="34" charset="-122"/>
+                <a:cs typeface="Cambria" pitchFamily="34" charset="-120"/>
+              </a:rPr>
+              <a:t>i</a:t>
+            </a:r>
+            <a:endParaRPr lang="en-US" sz="3000" dirty="0"/>
+          </a:p>
+        </p:txBody>
+      </p:sp>
+      <p:sp>
+        <p:nvSpPr>
+          <p:cNvPr id="4" name="types"/>
+          <p:cNvSpPr txBox="1"/>
+          <p:nvPr/>
+        </p:nvSpPr>
+        <p:spPr>
+          <a:xfrm>
+            <a:off x="457200" y="2240280"/>
+            <a:ext cx="8229600" cy="685800"/>
+          </a:xfrm>
+          <a:prstGeom prst="rect">
+            <a:avLst/>
+          </a:prstGeom>
+          <a:noFill/>
+          <a:ln/>
+        </p:spPr>
+        <p:txBody>
+          <a:bodyPr wrap="square" lIns="0" tIns="0" rIns="0" bIns="0" rtlCol="0" anchor="ctr"/>
+          <a:lstStyle/>
+          <a:p>
+            <a:pPr algn="ctr" indent="0" marL="0">
+              <a:buNone/>
+            </a:pPr>
+            <a:r>
+              <a:rPr lang="en-US" sz="3000" b="1" dirty="0">
+                <a:solidFill>
+                  <a:srgbClr val="EB6834"/>
+                </a:solidFill>
+                <a:latin typeface="Cambria" pitchFamily="34" charset="0"/>
+                <a:ea typeface="Cambria" pitchFamily="34" charset="-122"/>
+                <a:cs typeface="Cambria" pitchFamily="34" charset="-120"/>
+              </a:rPr>
+              <a:t>Individualists </a:t>
+            </a:r>
+            <a:pPr algn="ctr" indent="0" marL="0">
+              <a:buNone/>
+            </a:pPr>
+            <a:r>
+              <a:rPr lang="en-US" sz="3000" dirty="0">
+                <a:solidFill>
+                  <a:schemeClr val="tx2"/>
+                </a:solidFill>
+                <a:latin typeface="Cambria" pitchFamily="34" charset="0"/>
+                <a:ea typeface="Cambria" pitchFamily="34" charset="-122"/>
+                <a:cs typeface="Cambria" pitchFamily="34" charset="-120"/>
+              </a:rPr>
+              <a:t>λ</a:t>
+            </a:r>
+            <a:pPr algn="ctr" indent="0" marL="0">
+              <a:buNone/>
+            </a:pPr>
+            <a:r>
+              <a:rPr lang="en-US" sz="3000" baseline="-40000" dirty="0">
+                <a:solidFill>
+                  <a:schemeClr val="tx2"/>
+                </a:solidFill>
+                <a:latin typeface="Cambria" pitchFamily="34" charset="0"/>
+                <a:ea typeface="Cambria" pitchFamily="34" charset="-122"/>
+                <a:cs typeface="Cambria" pitchFamily="34" charset="-120"/>
+              </a:rPr>
+              <a:t>I</a:t>
+            </a:r>
+            <a:pPr algn="ctr" indent="0" marL="0">
+              <a:buNone/>
+            </a:pPr>
+            <a:r>
+              <a:rPr lang="en-US" sz="3000" dirty="0">
+                <a:solidFill>
+                  <a:schemeClr val="tx2"/>
+                </a:solidFill>
+                <a:latin typeface="Cambria" pitchFamily="34" charset="0"/>
+                <a:ea typeface="Cambria" pitchFamily="34" charset="-122"/>
+                <a:cs typeface="Cambria" pitchFamily="34" charset="-120"/>
+              </a:rPr>
+              <a:t>  &lt;  λ</a:t>
+            </a:r>
+            <a:pPr algn="ctr" indent="0" marL="0">
+              <a:buNone/>
+            </a:pPr>
+            <a:r>
+              <a:rPr lang="en-US" sz="3000" baseline="-40000" dirty="0">
+                <a:solidFill>
+                  <a:schemeClr val="tx2"/>
+                </a:solidFill>
+                <a:latin typeface="Cambria" pitchFamily="34" charset="0"/>
+                <a:ea typeface="Cambria" pitchFamily="34" charset="-122"/>
+                <a:cs typeface="Cambria" pitchFamily="34" charset="-120"/>
+              </a:rPr>
+              <a:t>C</a:t>
+            </a:r>
+            <a:pPr algn="ctr" indent="0" marL="0">
+              <a:buNone/>
+            </a:pPr>
+            <a:r>
+              <a:rPr lang="en-US" sz="3000" b="1" dirty="0">
+                <a:solidFill>
+                  <a:srgbClr val="2A78D6"/>
+                </a:solidFill>
+                <a:latin typeface="Cambria" pitchFamily="34" charset="0"/>
+                <a:ea typeface="Cambria" pitchFamily="34" charset="-122"/>
+                <a:cs typeface="Cambria" pitchFamily="34" charset="-120"/>
+              </a:rPr>
+              <a:t> collectivists</a:t>
+            </a:r>
+            <a:endParaRPr lang="en-US" sz="3000" dirty="0"/>
+          </a:p>
+        </p:txBody>
+      </p:sp>
+      <p:sp>
+        <p:nvSpPr>
+          <p:cNvPr id="5" name="eq2"/>
+          <p:cNvSpPr txBox="1"/>
+          <p:nvPr/>
+        </p:nvSpPr>
+        <p:spPr>
+          <a:xfrm>
+            <a:off x="640080" y="3246120"/>
+            <a:ext cx="7863840" cy="685800"/>
+          </a:xfrm>
+          <a:prstGeom prst="rect">
+            <a:avLst/>
+          </a:prstGeom>
+          <a:noFill/>
+          <a:ln/>
+        </p:spPr>
+        <p:txBody>
+          <a:bodyPr wrap="square" lIns="0" tIns="0" rIns="0" bIns="0" rtlCol="0" anchor="ctr"/>
+          <a:lstStyle/>
+          <a:p>
+            <a:pPr algn="ctr" indent="0" marL="0">
+              <a:buNone/>
+            </a:pPr>
+            <a:r>
+              <a:rPr lang="en-US" sz="3000" i="1" dirty="0">
+                <a:solidFill>
+                  <a:schemeClr val="tx2"/>
+                </a:solidFill>
+                <a:latin typeface="Cambria" pitchFamily="34" charset="0"/>
+                <a:ea typeface="Cambria" pitchFamily="34" charset="-122"/>
+                <a:cs typeface="Cambria" pitchFamily="34" charset="-120"/>
+              </a:rPr>
+              <a:t>ŝ</a:t>
+            </a:r>
+            <a:pPr algn="ctr" indent="0" marL="0">
+              <a:buNone/>
+            </a:pPr>
+            <a:r>
+              <a:rPr lang="en-US" sz="3000" baseline="-40000" dirty="0">
+                <a:solidFill>
+                  <a:schemeClr val="tx2"/>
+                </a:solidFill>
+                <a:latin typeface="Cambria" pitchFamily="34" charset="0"/>
+                <a:ea typeface="Cambria" pitchFamily="34" charset="-122"/>
+                <a:cs typeface="Cambria" pitchFamily="34" charset="-120"/>
+              </a:rPr>
+              <a:t>I</a:t>
+            </a:r>
+            <a:pPr algn="ctr" indent="0" marL="0">
+              <a:buNone/>
+            </a:pPr>
+            <a:r>
+              <a:rPr lang="en-US" sz="3000" dirty="0">
+                <a:solidFill>
+                  <a:schemeClr val="tx2"/>
+                </a:solidFill>
+                <a:latin typeface="Cambria" pitchFamily="34" charset="0"/>
+                <a:ea typeface="Cambria" pitchFamily="34" charset="-122"/>
+                <a:cs typeface="Cambria" pitchFamily="34" charset="-120"/>
+              </a:rPr>
+              <a:t>  −  </a:t>
+            </a:r>
+            <a:pPr algn="ctr" indent="0" marL="0">
+              <a:buNone/>
+            </a:pPr>
+            <a:r>
+              <a:rPr lang="en-US" sz="3000" i="1" dirty="0">
+                <a:solidFill>
+                  <a:schemeClr val="tx2"/>
+                </a:solidFill>
+                <a:latin typeface="Cambria" pitchFamily="34" charset="0"/>
+                <a:ea typeface="Cambria" pitchFamily="34" charset="-122"/>
+                <a:cs typeface="Cambria" pitchFamily="34" charset="-120"/>
+              </a:rPr>
+              <a:t>ŝ</a:t>
+            </a:r>
+            <a:pPr algn="ctr" indent="0" marL="0">
+              <a:buNone/>
+            </a:pPr>
+            <a:r>
+              <a:rPr lang="en-US" sz="3000" baseline="-40000" dirty="0">
+                <a:solidFill>
+                  <a:schemeClr val="tx2"/>
+                </a:solidFill>
+                <a:latin typeface="Cambria" pitchFamily="34" charset="0"/>
+                <a:ea typeface="Cambria" pitchFamily="34" charset="-122"/>
+                <a:cs typeface="Cambria" pitchFamily="34" charset="-120"/>
+              </a:rPr>
+              <a:t>C</a:t>
+            </a:r>
+            <a:pPr algn="ctr" indent="0" marL="0">
+              <a:buNone/>
+            </a:pPr>
+            <a:r>
+              <a:rPr lang="en-US" sz="3000" dirty="0">
+                <a:solidFill>
+                  <a:schemeClr val="tx2"/>
+                </a:solidFill>
+                <a:latin typeface="Cambria" pitchFamily="34" charset="0"/>
+                <a:ea typeface="Cambria" pitchFamily="34" charset="-122"/>
+                <a:cs typeface="Cambria" pitchFamily="34" charset="-120"/>
+              </a:rPr>
+              <a:t>  =  (λ</a:t>
+            </a:r>
+            <a:pPr algn="ctr" indent="0" marL="0">
+              <a:buNone/>
+            </a:pPr>
+            <a:r>
+              <a:rPr lang="en-US" sz="3000" baseline="-40000" dirty="0">
+                <a:solidFill>
+                  <a:schemeClr val="tx2"/>
+                </a:solidFill>
+                <a:latin typeface="Cambria" pitchFamily="34" charset="0"/>
+                <a:ea typeface="Cambria" pitchFamily="34" charset="-122"/>
+                <a:cs typeface="Cambria" pitchFamily="34" charset="-120"/>
+              </a:rPr>
+              <a:t>C</a:t>
+            </a:r>
+            <a:pPr algn="ctr" indent="0" marL="0">
+              <a:buNone/>
+            </a:pPr>
+            <a:r>
+              <a:rPr lang="en-US" sz="3000" dirty="0">
+                <a:solidFill>
+                  <a:schemeClr val="tx2"/>
+                </a:solidFill>
+                <a:latin typeface="Cambria" pitchFamily="34" charset="0"/>
+                <a:ea typeface="Cambria" pitchFamily="34" charset="-122"/>
+                <a:cs typeface="Cambria" pitchFamily="34" charset="-120"/>
+              </a:rPr>
+              <a:t> − λ</a:t>
+            </a:r>
+            <a:pPr algn="ctr" indent="0" marL="0">
+              <a:buNone/>
+            </a:pPr>
+            <a:r>
+              <a:rPr lang="en-US" sz="3000" baseline="-40000" dirty="0">
+                <a:solidFill>
+                  <a:schemeClr val="tx2"/>
+                </a:solidFill>
+                <a:latin typeface="Cambria" pitchFamily="34" charset="0"/>
+                <a:ea typeface="Cambria" pitchFamily="34" charset="-122"/>
+                <a:cs typeface="Cambria" pitchFamily="34" charset="-120"/>
+              </a:rPr>
+              <a:t>I</a:t>
+            </a:r>
+            <a:pPr algn="ctr" indent="0" marL="0">
+              <a:buNone/>
+            </a:pPr>
+            <a:r>
+              <a:rPr lang="en-US" sz="3000" dirty="0">
+                <a:solidFill>
+                  <a:schemeClr val="tx2"/>
+                </a:solidFill>
+                <a:latin typeface="Cambria" pitchFamily="34" charset="0"/>
+                <a:ea typeface="Cambria" pitchFamily="34" charset="-122"/>
+                <a:cs typeface="Cambria" pitchFamily="34" charset="-120"/>
+              </a:rPr>
+              <a:t>) · (</a:t>
+            </a:r>
+            <a:pPr algn="ctr" indent="0" marL="0">
+              <a:buNone/>
+            </a:pPr>
+            <a:r>
+              <a:rPr lang="en-US" sz="3000" i="1" dirty="0">
+                <a:solidFill>
+                  <a:schemeClr val="tx2"/>
+                </a:solidFill>
+                <a:latin typeface="Cambria" pitchFamily="34" charset="0"/>
+                <a:ea typeface="Cambria" pitchFamily="34" charset="-122"/>
+                <a:cs typeface="Cambria" pitchFamily="34" charset="-120"/>
+              </a:rPr>
+              <a:t>x</a:t>
+            </a:r>
+            <a:pPr algn="ctr" indent="0" marL="0">
+              <a:buNone/>
+            </a:pPr>
+            <a:r>
+              <a:rPr lang="en-US" sz="3000" dirty="0">
+                <a:solidFill>
+                  <a:schemeClr val="tx2"/>
+                </a:solidFill>
+                <a:latin typeface="Cambria" pitchFamily="34" charset="0"/>
+                <a:ea typeface="Cambria" pitchFamily="34" charset="-122"/>
+                <a:cs typeface="Cambria" pitchFamily="34" charset="-120"/>
+              </a:rPr>
+              <a:t> − </a:t>
+            </a:r>
+            <a:pPr algn="ctr" indent="0" marL="0">
+              <a:buNone/>
+            </a:pPr>
+            <a:r>
+              <a:rPr lang="en-US" sz="3000" i="1" dirty="0">
+                <a:solidFill>
+                  <a:schemeClr val="tx2"/>
+                </a:solidFill>
+                <a:latin typeface="Cambria" pitchFamily="34" charset="0"/>
+                <a:ea typeface="Cambria" pitchFamily="34" charset="-122"/>
+                <a:cs typeface="Cambria" pitchFamily="34" charset="-120"/>
+              </a:rPr>
+              <a:t>y</a:t>
+            </a:r>
+            <a:pPr algn="ctr" indent="0" marL="0">
+              <a:buNone/>
+            </a:pPr>
+            <a:r>
+              <a:rPr lang="en-US" sz="3000" dirty="0">
+                <a:solidFill>
+                  <a:schemeClr val="tx2"/>
+                </a:solidFill>
+                <a:latin typeface="Cambria" pitchFamily="34" charset="0"/>
+                <a:ea typeface="Cambria" pitchFamily="34" charset="-122"/>
+                <a:cs typeface="Cambria" pitchFamily="34" charset="-120"/>
+              </a:rPr>
+              <a:t>)</a:t>
+            </a:r>
+            <a:endParaRPr lang="en-US" sz="3000" dirty="0"/>
+          </a:p>
+        </p:txBody>
+      </p:sp>
       <p:sp>
         <p:nvSpPr>
           <p:cNvPr id="25" name="Slide Number Placeholder 0"/>
@@ -5466,614 +5831,36 @@
                   <a:schemeClr val="tx2"/>
                 </a:solidFill>
               </a:rPr>
-              <a:t>Individualists and collectivists: who listens to whom</a:t>
+              <a:t>The model in one picture</a:t>
             </a:r>
             <a:endParaRPr lang="en-US" sz="2400" dirty="0"/>
           </a:p>
         </p:txBody>
       </p:sp>
-      <p:sp>
-        <p:nvSpPr>
-          <p:cNvPr id="3" name="type-head"/>
-          <p:cNvSpPr txBox="1"/>
+      <p:pic>
+        <p:nvPicPr>
+          <p:cNvPr id="3" name="odd" descr="Model overview in three columns. Entities: depositors with log-normal deposits capped at 1% of the total, a type and a private signal; a Newman–Watts network; a bank with reserves, a long asset that sells at a discount when cash runs short, and a return that rises with the fundamental; the environment draws the fundamental and a public signal. Schedule: cultural warm-up, draw the run’s world, an exogenous shock, then a tick loop in which each banked depositor observes neighbours and the public signal, forms beliefs with weight λ on the social side, values staying against withdrawing by Monte Carlo, and acts; then period 2 settles the bank and the run is recorded.">    </p:cNvPr>
+          <p:cNvPicPr>
+            <a:picLocks noChangeAspect="1"/>
+          </p:cNvPicPr>
           <p:nvPr/>
-        </p:nvSpPr>
-        <p:spPr>
-          <a:xfrm>
-            <a:off x="640080" y="1143000"/>
-            <a:ext cx="3657600" cy="365760"/>
-          </a:xfrm>
-          <a:prstGeom prst="rect">
-            <a:avLst/>
-          </a:prstGeom>
-          <a:noFill/>
-          <a:ln/>
-        </p:spPr>
-        <p:txBody>
-          <a:bodyPr wrap="square" lIns="0" tIns="0" rIns="0" bIns="0" rtlCol="0" anchor="ctr"/>
-          <a:lstStyle/>
-          <a:p>
-            <a:pPr indent="0" marL="0">
-              <a:buNone/>
-            </a:pPr>
-            <a:r>
-              <a:rPr lang="en-US" sz="1800" b="1" dirty="0">
-                <a:solidFill>
-                  <a:srgbClr val="EB6834"/>
-                </a:solidFill>
-              </a:rPr>
-              <a:t>Individualists</a:t>
-            </a:r>
-            <a:endParaRPr lang="en-US" sz="1800" dirty="0"/>
-          </a:p>
-        </p:txBody>
-      </p:sp>
-      <p:sp>
-        <p:nvSpPr>
-          <p:cNvPr id="4" name="bullets"/>
-          <p:cNvSpPr txBox="1"/>
-          <p:nvPr/>
-        </p:nvSpPr>
-        <p:spPr>
-          <a:xfrm>
-            <a:off x="640080" y="1600200"/>
-            <a:ext cx="3657600" cy="1737360"/>
-          </a:xfrm>
-          <a:prstGeom prst="rect">
-            <a:avLst/>
-          </a:prstGeom>
-          <a:noFill/>
-          <a:ln/>
-        </p:spPr>
-        <p:txBody>
-          <a:bodyPr wrap="square" lIns="0" tIns="0" rIns="0" bIns="0" rtlCol="0" anchor="t"/>
-          <a:lstStyle/>
-          <a:p>
-            <a:pPr marL="177800" indent="-177800">
-              <a:spcAft>
-                <a:spcPts val="500"/>
-              </a:spcAft>
-              <a:buSzPct val="100000"/>
-              <a:buChar char="•"/>
-            </a:pPr>
-            <a:r>
-              <a:rPr lang="en-US" sz="1300" dirty="0">
-                <a:solidFill>
-                  <a:schemeClr val="tx1"/>
-                </a:solidFill>
-              </a:rPr>
-              <a:t>Trust their own information about the bank</a:t>
-            </a:r>
-            <a:endParaRPr lang="en-US" sz="1300" dirty="0"/>
-          </a:p>
-          <a:p>
-            <a:pPr marL="177800" indent="-177800">
-              <a:spcAft>
-                <a:spcPts val="500"/>
-              </a:spcAft>
-              <a:buSzPct val="100000"/>
-              <a:buChar char="•"/>
-            </a:pPr>
-            <a:r>
-              <a:rPr lang="en-US" sz="1300" dirty="0">
-                <a:solidFill>
-                  <a:schemeClr val="tx1"/>
-                </a:solidFill>
-              </a:rPr>
-              <a:t>Put little weight on what neighbours do or on public news</a:t>
-            </a:r>
-            <a:endParaRPr lang="en-US" sz="1300" dirty="0"/>
-          </a:p>
-          <a:p>
-            <a:pPr marL="177800" indent="-177800">
-              <a:spcAft>
-                <a:spcPts val="500"/>
-              </a:spcAft>
-              <a:buSzPct val="100000"/>
-              <a:buChar char="•"/>
-            </a:pPr>
-            <a:r>
-              <a:rPr lang="en-US" sz="1300" dirty="0">
-                <a:solidFill>
-                  <a:schemeClr val="tx1"/>
-                </a:solidFill>
-              </a:rPr>
-              <a:t>Weight on the social side: λ = 0.1 to 0.3</a:t>
-            </a:r>
-            <a:endParaRPr lang="en-US" sz="1300" dirty="0"/>
-          </a:p>
-          <a:p>
-            <a:pPr marL="177800" indent="-177800">
-              <a:spcAft>
-                <a:spcPts val="500"/>
-              </a:spcAft>
-              <a:buSzPct val="100000"/>
-              <a:buChar char="•"/>
-            </a:pPr>
-            <a:r>
-              <a:rPr lang="en-US" sz="1300" dirty="0">
-                <a:solidFill>
-                  <a:schemeClr val="tx1"/>
-                </a:solidFill>
-              </a:rPr>
-              <a:t>Act on what they see themselves</a:t>
-            </a:r>
-            <a:endParaRPr lang="en-US" sz="1300" dirty="0"/>
-          </a:p>
-        </p:txBody>
-      </p:sp>
-      <p:sp>
-        <p:nvSpPr>
-          <p:cNvPr id="5" name="type-head"/>
-          <p:cNvSpPr txBox="1"/>
-          <p:nvPr/>
-        </p:nvSpPr>
-        <p:spPr>
-          <a:xfrm>
-            <a:off x="4846320" y="1143000"/>
-            <a:ext cx="3657600" cy="365760"/>
-          </a:xfrm>
-          <a:prstGeom prst="rect">
-            <a:avLst/>
-          </a:prstGeom>
-          <a:noFill/>
-          <a:ln/>
-        </p:spPr>
-        <p:txBody>
-          <a:bodyPr wrap="square" lIns="0" tIns="0" rIns="0" bIns="0" rtlCol="0" anchor="ctr"/>
-          <a:lstStyle/>
-          <a:p>
-            <a:pPr indent="0" marL="0">
-              <a:buNone/>
-            </a:pPr>
-            <a:r>
-              <a:rPr lang="en-US" sz="1800" b="1" dirty="0">
-                <a:solidFill>
-                  <a:srgbClr val="2A78D6"/>
-                </a:solidFill>
-              </a:rPr>
-              <a:t>Collectivists</a:t>
-            </a:r>
-            <a:endParaRPr lang="en-US" sz="1800" dirty="0"/>
-          </a:p>
-        </p:txBody>
-      </p:sp>
-      <p:sp>
-        <p:nvSpPr>
-          <p:cNvPr id="6" name="bullets"/>
-          <p:cNvSpPr txBox="1"/>
-          <p:nvPr/>
-        </p:nvSpPr>
-        <p:spPr>
-          <a:xfrm>
-            <a:off x="4846320" y="1600200"/>
-            <a:ext cx="3657600" cy="1737360"/>
-          </a:xfrm>
-          <a:prstGeom prst="rect">
-            <a:avLst/>
-          </a:prstGeom>
-          <a:noFill/>
-          <a:ln/>
-        </p:spPr>
-        <p:txBody>
-          <a:bodyPr wrap="square" lIns="0" tIns="0" rIns="0" bIns="0" rtlCol="0" anchor="t"/>
-          <a:lstStyle/>
-          <a:p>
-            <a:pPr marL="177800" indent="-177800">
-              <a:spcAft>
-                <a:spcPts val="500"/>
-              </a:spcAft>
-              <a:buSzPct val="100000"/>
-              <a:buChar char="•"/>
-            </a:pPr>
-            <a:r>
-              <a:rPr lang="en-US" sz="1300" dirty="0">
-                <a:solidFill>
-                  <a:schemeClr val="tx1"/>
-                </a:solidFill>
-              </a:rPr>
-              <a:t>Watch what neighbours do and what the public news says</a:t>
-            </a:r>
-            <a:endParaRPr lang="en-US" sz="1300" dirty="0"/>
-          </a:p>
-          <a:p>
-            <a:pPr marL="177800" indent="-177800">
-              <a:spcAft>
-                <a:spcPts val="500"/>
-              </a:spcAft>
-              <a:buSzPct val="100000"/>
-              <a:buChar char="•"/>
-            </a:pPr>
-            <a:r>
-              <a:rPr lang="en-US" sz="1300" dirty="0">
-                <a:solidFill>
-                  <a:schemeClr val="tx1"/>
-                </a:solidFill>
-              </a:rPr>
-              <a:t>Put little weight on their own information</a:t>
-            </a:r>
-            <a:endParaRPr lang="en-US" sz="1300" dirty="0"/>
-          </a:p>
-          <a:p>
-            <a:pPr marL="177800" indent="-177800">
-              <a:spcAft>
-                <a:spcPts val="500"/>
-              </a:spcAft>
-              <a:buSzPct val="100000"/>
-              <a:buChar char="•"/>
-            </a:pPr>
-            <a:r>
-              <a:rPr lang="en-US" sz="1300" dirty="0">
-                <a:solidFill>
-                  <a:schemeClr val="tx1"/>
-                </a:solidFill>
-              </a:rPr>
-              <a:t>Weight on the social side: λ = 0.5 to 0.9</a:t>
-            </a:r>
-            <a:endParaRPr lang="en-US" sz="1300" dirty="0"/>
-          </a:p>
-          <a:p>
-            <a:pPr marL="177800" indent="-177800">
-              <a:spcAft>
-                <a:spcPts val="500"/>
-              </a:spcAft>
-              <a:buSzPct val="100000"/>
-              <a:buChar char="•"/>
-            </a:pPr>
-            <a:r>
-              <a:rPr lang="en-US" sz="1300" dirty="0">
-                <a:solidFill>
-                  <a:schemeClr val="tx1"/>
-                </a:solidFill>
-              </a:rPr>
-              <a:t>Move when others move</a:t>
-            </a:r>
-            <a:endParaRPr lang="en-US" sz="1300" dirty="0"/>
-          </a:p>
-        </p:txBody>
-      </p:sp>
-      <p:sp>
-        <p:nvSpPr>
-          <p:cNvPr id="7" name="pairs-head"/>
-          <p:cNvSpPr txBox="1"/>
-          <p:nvPr/>
-        </p:nvSpPr>
-        <p:spPr>
-          <a:xfrm>
-            <a:off x="457200" y="3886200"/>
-            <a:ext cx="8229600" cy="329184"/>
-          </a:xfrm>
-          <a:prstGeom prst="rect">
-            <a:avLst/>
-          </a:prstGeom>
-          <a:noFill/>
-          <a:ln/>
-        </p:spPr>
-        <p:txBody>
-          <a:bodyPr wrap="square" lIns="0" tIns="0" rIns="0" bIns="0" rtlCol="0" anchor="ctr"/>
-          <a:lstStyle/>
-          <a:p>
-            <a:pPr algn="ctr" indent="0" marL="0">
-              <a:buNone/>
-            </a:pPr>
-            <a:r>
-              <a:rPr lang="en-US" sz="1300" b="1" dirty="0">
-                <a:solidFill>
-                  <a:schemeClr val="tx2"/>
-                </a:solidFill>
-              </a:rPr>
-              <a:t>Signal interpretation gap</a:t>
-            </a:r>
-            <a:endParaRPr lang="en-US" sz="1300" dirty="0"/>
-          </a:p>
-        </p:txBody>
-      </p:sp>
-      <p:sp>
-        <p:nvSpPr>
-          <p:cNvPr id="8" name="chip"/>
-          <p:cNvSpPr/>
-          <p:nvPr/>
-        </p:nvSpPr>
-        <p:spPr>
-          <a:xfrm>
-            <a:off x="2057400" y="3429000"/>
-            <a:ext cx="914400" cy="329184"/>
-          </a:xfrm>
-          <a:prstGeom prst="roundRect">
-            <a:avLst>
-              <a:gd name="adj" fmla="val 16667"/>
-            </a:avLst>
-          </a:prstGeom>
-          <a:solidFill>
-            <a:schemeClr val="tx2"/>
-          </a:solidFill>
-          <a:ln w="12700">
-            <a:solidFill>
-              <a:schemeClr val="tx2"/>
-            </a:solidFill>
-            <a:prstDash val="solid"/>
-          </a:ln>
-        </p:spPr>
-      </p:sp>
-      <p:sp>
-        <p:nvSpPr>
-          <p:cNvPr id="9" name="chip-label"/>
-          <p:cNvSpPr txBox="1"/>
-          <p:nvPr/>
-        </p:nvSpPr>
-        <p:spPr>
-          <a:xfrm>
-            <a:off x="2057400" y="3429000"/>
-            <a:ext cx="914400" cy="329184"/>
-          </a:xfrm>
-          <a:prstGeom prst="rect">
-            <a:avLst/>
-          </a:prstGeom>
-          <a:noFill/>
-          <a:ln/>
-        </p:spPr>
-        <p:txBody>
-          <a:bodyPr wrap="square" lIns="0" tIns="0" rIns="0" bIns="0" rtlCol="0" anchor="ctr"/>
-          <a:lstStyle/>
-          <a:p>
-            <a:pPr algn="ctr" indent="0" marL="0">
-              <a:buNone/>
-            </a:pPr>
-            <a:r>
-              <a:rPr lang="en-US" sz="1100" b="1" dirty="0">
-                <a:solidFill>
-                  <a:schemeClr val="bg1"/>
-                </a:solidFill>
-                <a:latin typeface="Cambria" pitchFamily="34" charset="0"/>
-                <a:ea typeface="Cambria" pitchFamily="34" charset="-122"/>
-                <a:cs typeface="Cambria" pitchFamily="34" charset="-120"/>
-              </a:rPr>
-              <a:t>(0.1, 0.9)</a:t>
-            </a:r>
-            <a:endParaRPr lang="en-US" sz="1100" dirty="0"/>
-          </a:p>
-        </p:txBody>
-      </p:sp>
-      <p:sp>
-        <p:nvSpPr>
-          <p:cNvPr id="10" name="pair-label"/>
-          <p:cNvSpPr txBox="1"/>
-          <p:nvPr/>
-        </p:nvSpPr>
-        <p:spPr>
-          <a:xfrm>
-            <a:off x="3017520" y="3429000"/>
-            <a:ext cx="777240" cy="329184"/>
-          </a:xfrm>
-          <a:prstGeom prst="rect">
-            <a:avLst/>
-          </a:prstGeom>
-          <a:noFill/>
-          <a:ln/>
-        </p:spPr>
-        <p:txBody>
-          <a:bodyPr wrap="square" lIns="0" tIns="0" rIns="0" bIns="0" rtlCol="0" anchor="ctr"/>
-          <a:lstStyle/>
-          <a:p>
-            <a:pPr indent="0" marL="0">
-              <a:buNone/>
-            </a:pPr>
-            <a:r>
-              <a:rPr lang="en-US" sz="1200" dirty="0">
-                <a:solidFill>
-                  <a:schemeClr val="accent3"/>
-                </a:solidFill>
-              </a:rPr>
-              <a:t>wide gap</a:t>
-            </a:r>
-            <a:endParaRPr lang="en-US" sz="1200" dirty="0"/>
-          </a:p>
-        </p:txBody>
-      </p:sp>
-      <p:sp>
-        <p:nvSpPr>
-          <p:cNvPr id="11" name="chip"/>
-          <p:cNvSpPr/>
-          <p:nvPr/>
-        </p:nvSpPr>
-        <p:spPr>
-          <a:xfrm>
-            <a:off x="3794760" y="3429000"/>
-            <a:ext cx="914400" cy="329184"/>
-          </a:xfrm>
-          <a:prstGeom prst="roundRect">
-            <a:avLst>
-              <a:gd name="adj" fmla="val 16667"/>
-            </a:avLst>
-          </a:prstGeom>
-          <a:solidFill>
-            <a:schemeClr val="accent3"/>
-          </a:solidFill>
-          <a:ln w="12700">
-            <a:solidFill>
-              <a:schemeClr val="accent3"/>
-            </a:solidFill>
-            <a:prstDash val="solid"/>
-          </a:ln>
-        </p:spPr>
-      </p:sp>
-      <p:sp>
-        <p:nvSpPr>
-          <p:cNvPr id="12" name="chip-label"/>
-          <p:cNvSpPr txBox="1"/>
-          <p:nvPr/>
-        </p:nvSpPr>
-        <p:spPr>
-          <a:xfrm>
-            <a:off x="3794760" y="3429000"/>
-            <a:ext cx="914400" cy="329184"/>
-          </a:xfrm>
-          <a:prstGeom prst="rect">
-            <a:avLst/>
-          </a:prstGeom>
-          <a:noFill/>
-          <a:ln/>
-        </p:spPr>
-        <p:txBody>
-          <a:bodyPr wrap="square" lIns="0" tIns="0" rIns="0" bIns="0" rtlCol="0" anchor="ctr"/>
-          <a:lstStyle/>
-          <a:p>
-            <a:pPr algn="ctr" indent="0" marL="0">
-              <a:buNone/>
-            </a:pPr>
-            <a:r>
-              <a:rPr lang="en-US" sz="1100" b="1" dirty="0">
-                <a:solidFill>
-                  <a:schemeClr val="bg1"/>
-                </a:solidFill>
-                <a:latin typeface="Cambria" pitchFamily="34" charset="0"/>
-                <a:ea typeface="Cambria" pitchFamily="34" charset="-122"/>
-                <a:cs typeface="Cambria" pitchFamily="34" charset="-120"/>
-              </a:rPr>
-              <a:t>(0.2, 0.8)</a:t>
-            </a:r>
-            <a:endParaRPr lang="en-US" sz="1100" dirty="0"/>
-          </a:p>
-        </p:txBody>
-      </p:sp>
-      <p:sp>
-        <p:nvSpPr>
-          <p:cNvPr id="13" name="pair-label"/>
-          <p:cNvSpPr txBox="1"/>
-          <p:nvPr/>
-        </p:nvSpPr>
-        <p:spPr>
-          <a:xfrm>
-            <a:off x="4754880" y="3429000"/>
-            <a:ext cx="777240" cy="329184"/>
-          </a:xfrm>
-          <a:prstGeom prst="rect">
-            <a:avLst/>
-          </a:prstGeom>
-          <a:noFill/>
-          <a:ln/>
-        </p:spPr>
-        <p:txBody>
-          <a:bodyPr wrap="square" lIns="0" tIns="0" rIns="0" bIns="0" rtlCol="0" anchor="ctr"/>
-          <a:lstStyle/>
-          <a:p>
-            <a:pPr indent="0" marL="0">
-              <a:buNone/>
-            </a:pPr>
-            <a:r>
-              <a:rPr lang="en-US" sz="1200" dirty="0">
-                <a:solidFill>
-                  <a:schemeClr val="accent3"/>
-                </a:solidFill>
-              </a:rPr>
-              <a:t>medium</a:t>
-            </a:r>
-            <a:endParaRPr lang="en-US" sz="1200" dirty="0"/>
-          </a:p>
-        </p:txBody>
-      </p:sp>
-      <p:sp>
-        <p:nvSpPr>
-          <p:cNvPr id="14" name="chip"/>
-          <p:cNvSpPr/>
-          <p:nvPr/>
-        </p:nvSpPr>
-        <p:spPr>
-          <a:xfrm>
-            <a:off x="5532120" y="3429000"/>
-            <a:ext cx="914400" cy="329184"/>
-          </a:xfrm>
-          <a:prstGeom prst="roundRect">
-            <a:avLst>
-              <a:gd name="adj" fmla="val 16667"/>
-            </a:avLst>
-          </a:prstGeom>
-          <a:solidFill>
-            <a:schemeClr val="accent4"/>
-          </a:solidFill>
-          <a:ln w="12700">
-            <a:solidFill>
-              <a:schemeClr val="accent4"/>
-            </a:solidFill>
-            <a:prstDash val="solid"/>
-          </a:ln>
-        </p:spPr>
-      </p:sp>
-      <p:sp>
-        <p:nvSpPr>
-          <p:cNvPr id="15" name="chip-label"/>
-          <p:cNvSpPr txBox="1"/>
-          <p:nvPr/>
-        </p:nvSpPr>
-        <p:spPr>
-          <a:xfrm>
-            <a:off x="5532120" y="3429000"/>
-            <a:ext cx="914400" cy="329184"/>
-          </a:xfrm>
-          <a:prstGeom prst="rect">
-            <a:avLst/>
-          </a:prstGeom>
-          <a:noFill/>
-          <a:ln/>
-        </p:spPr>
-        <p:txBody>
-          <a:bodyPr wrap="square" lIns="0" tIns="0" rIns="0" bIns="0" rtlCol="0" anchor="ctr"/>
-          <a:lstStyle/>
-          <a:p>
-            <a:pPr algn="ctr" indent="0" marL="0">
-              <a:buNone/>
-            </a:pPr>
-            <a:r>
-              <a:rPr lang="en-US" sz="1100" b="1" dirty="0">
-                <a:solidFill>
-                  <a:schemeClr val="tx1"/>
-                </a:solidFill>
-                <a:latin typeface="Cambria" pitchFamily="34" charset="0"/>
-                <a:ea typeface="Cambria" pitchFamily="34" charset="-122"/>
-                <a:cs typeface="Cambria" pitchFamily="34" charset="-120"/>
-              </a:rPr>
-              <a:t>(0.3, 0.5)</a:t>
-            </a:r>
-            <a:endParaRPr lang="en-US" sz="1100" dirty="0"/>
-          </a:p>
-        </p:txBody>
-      </p:sp>
-      <p:sp>
-        <p:nvSpPr>
-          <p:cNvPr id="16" name="pair-label"/>
-          <p:cNvSpPr txBox="1"/>
-          <p:nvPr/>
-        </p:nvSpPr>
-        <p:spPr>
-          <a:xfrm>
-            <a:off x="6492240" y="3429000"/>
-            <a:ext cx="777240" cy="329184"/>
-          </a:xfrm>
-          <a:prstGeom prst="rect">
-            <a:avLst/>
-          </a:prstGeom>
-          <a:noFill/>
-          <a:ln/>
-        </p:spPr>
-        <p:txBody>
-          <a:bodyPr wrap="square" lIns="0" tIns="0" rIns="0" bIns="0" rtlCol="0" anchor="ctr"/>
-          <a:lstStyle/>
-          <a:p>
-            <a:pPr indent="0" marL="0">
-              <a:buNone/>
-            </a:pPr>
-            <a:r>
-              <a:rPr lang="en-US" sz="1200" dirty="0">
-                <a:solidFill>
-                  <a:schemeClr val="accent3"/>
-                </a:solidFill>
-              </a:rPr>
-              <a:t>narrow</a:t>
-            </a:r>
-            <a:endParaRPr lang="en-US" sz="1200" dirty="0"/>
-          </a:p>
-        </p:txBody>
-      </p:sp>
+        </p:nvPicPr>
+        <p:blipFill>
+          <a:blip r:embed="rId1"/>
+          <a:stretch>
+            <a:fillRect/>
+          </a:stretch>
+        </p:blipFill>
+        <p:spPr>
+          <a:xfrm>
+            <a:off x="755294" y="960120"/>
+            <a:ext cx="7633411" cy="3657600"/>
+          </a:xfrm>
+          <a:prstGeom prst="rect">
+            <a:avLst/>
+          </a:prstGeom>
+        </p:spPr>
+      </p:pic>
       <p:sp>
         <p:nvSpPr>
           <p:cNvPr id="25" name="Slide Number Placeholder 0"/>
@@ -6176,36 +5963,614 @@
                   <a:schemeClr val="tx2"/>
                 </a:solidFill>
               </a:rPr>
-              <a:t>Collectivists herd</a:t>
+              <a:t>Individualists and collectivists: who listens to whom</a:t>
             </a:r>
             <a:endParaRPr lang="en-US" sz="2400" dirty="0"/>
           </a:p>
         </p:txBody>
       </p:sp>
-      <p:pic>
-        <p:nvPicPr>
-          <p:cNvPr id="3" name="e07" descr="Chance of withdrawing by share of neighbours who have withdrawn: collectivists jump to near 1 once 20 to 35 percent of neighbours are out; individualists level off near 0.25 to 0.30.">    </p:cNvPr>
-          <p:cNvPicPr>
-            <a:picLocks noChangeAspect="1"/>
-          </p:cNvPicPr>
+      <p:sp>
+        <p:nvSpPr>
+          <p:cNvPr id="3" name="type-head"/>
+          <p:cNvSpPr txBox="1"/>
           <p:nvPr/>
-        </p:nvPicPr>
-        <p:blipFill>
-          <a:blip r:embed="rId1"/>
-          <a:stretch>
-            <a:fillRect/>
-          </a:stretch>
-        </p:blipFill>
-        <p:spPr>
-          <a:xfrm>
-            <a:off x="1738480" y="1005840"/>
-            <a:ext cx="5667040" cy="3611880"/>
-          </a:xfrm>
-          <a:prstGeom prst="rect">
-            <a:avLst/>
-          </a:prstGeom>
-        </p:spPr>
-      </p:pic>
+        </p:nvSpPr>
+        <p:spPr>
+          <a:xfrm>
+            <a:off x="640080" y="1143000"/>
+            <a:ext cx="3657600" cy="365760"/>
+          </a:xfrm>
+          <a:prstGeom prst="rect">
+            <a:avLst/>
+          </a:prstGeom>
+          <a:noFill/>
+          <a:ln/>
+        </p:spPr>
+        <p:txBody>
+          <a:bodyPr wrap="square" lIns="0" tIns="0" rIns="0" bIns="0" rtlCol="0" anchor="ctr"/>
+          <a:lstStyle/>
+          <a:p>
+            <a:pPr indent="0" marL="0">
+              <a:buNone/>
+            </a:pPr>
+            <a:r>
+              <a:rPr lang="en-US" sz="1800" b="1" dirty="0">
+                <a:solidFill>
+                  <a:srgbClr val="EB6834"/>
+                </a:solidFill>
+              </a:rPr>
+              <a:t>Individualists</a:t>
+            </a:r>
+            <a:endParaRPr lang="en-US" sz="1800" dirty="0"/>
+          </a:p>
+        </p:txBody>
+      </p:sp>
+      <p:sp>
+        <p:nvSpPr>
+          <p:cNvPr id="4" name="bullets"/>
+          <p:cNvSpPr txBox="1"/>
+          <p:nvPr/>
+        </p:nvSpPr>
+        <p:spPr>
+          <a:xfrm>
+            <a:off x="640080" y="1600200"/>
+            <a:ext cx="3657600" cy="1737360"/>
+          </a:xfrm>
+          <a:prstGeom prst="rect">
+            <a:avLst/>
+          </a:prstGeom>
+          <a:noFill/>
+          <a:ln/>
+        </p:spPr>
+        <p:txBody>
+          <a:bodyPr wrap="square" lIns="0" tIns="0" rIns="0" bIns="0" rtlCol="0" anchor="t"/>
+          <a:lstStyle/>
+          <a:p>
+            <a:pPr marL="177800" indent="-177800">
+              <a:spcAft>
+                <a:spcPts val="500"/>
+              </a:spcAft>
+              <a:buSzPct val="100000"/>
+              <a:buChar char="•"/>
+            </a:pPr>
+            <a:r>
+              <a:rPr lang="en-US" sz="1300" dirty="0">
+                <a:solidFill>
+                  <a:schemeClr val="tx1"/>
+                </a:solidFill>
+              </a:rPr>
+              <a:t>Trust their own information about the bank</a:t>
+            </a:r>
+            <a:endParaRPr lang="en-US" sz="1300" dirty="0"/>
+          </a:p>
+          <a:p>
+            <a:pPr marL="177800" indent="-177800">
+              <a:spcAft>
+                <a:spcPts val="500"/>
+              </a:spcAft>
+              <a:buSzPct val="100000"/>
+              <a:buChar char="•"/>
+            </a:pPr>
+            <a:r>
+              <a:rPr lang="en-US" sz="1300" dirty="0">
+                <a:solidFill>
+                  <a:schemeClr val="tx1"/>
+                </a:solidFill>
+              </a:rPr>
+              <a:t>Put little weight on what neighbours do or on public news</a:t>
+            </a:r>
+            <a:endParaRPr lang="en-US" sz="1300" dirty="0"/>
+          </a:p>
+          <a:p>
+            <a:pPr marL="177800" indent="-177800">
+              <a:spcAft>
+                <a:spcPts val="500"/>
+              </a:spcAft>
+              <a:buSzPct val="100000"/>
+              <a:buChar char="•"/>
+            </a:pPr>
+            <a:r>
+              <a:rPr lang="en-US" sz="1300" dirty="0">
+                <a:solidFill>
+                  <a:schemeClr val="tx1"/>
+                </a:solidFill>
+              </a:rPr>
+              <a:t>Weight on the social side: λ = 0.1 to 0.3</a:t>
+            </a:r>
+            <a:endParaRPr lang="en-US" sz="1300" dirty="0"/>
+          </a:p>
+          <a:p>
+            <a:pPr marL="177800" indent="-177800">
+              <a:spcAft>
+                <a:spcPts val="500"/>
+              </a:spcAft>
+              <a:buSzPct val="100000"/>
+              <a:buChar char="•"/>
+            </a:pPr>
+            <a:r>
+              <a:rPr lang="en-US" sz="1300" dirty="0">
+                <a:solidFill>
+                  <a:schemeClr val="tx1"/>
+                </a:solidFill>
+              </a:rPr>
+              <a:t>Act on what they see themselves</a:t>
+            </a:r>
+            <a:endParaRPr lang="en-US" sz="1300" dirty="0"/>
+          </a:p>
+        </p:txBody>
+      </p:sp>
+      <p:sp>
+        <p:nvSpPr>
+          <p:cNvPr id="5" name="type-head"/>
+          <p:cNvSpPr txBox="1"/>
+          <p:nvPr/>
+        </p:nvSpPr>
+        <p:spPr>
+          <a:xfrm>
+            <a:off x="4846320" y="1143000"/>
+            <a:ext cx="3657600" cy="365760"/>
+          </a:xfrm>
+          <a:prstGeom prst="rect">
+            <a:avLst/>
+          </a:prstGeom>
+          <a:noFill/>
+          <a:ln/>
+        </p:spPr>
+        <p:txBody>
+          <a:bodyPr wrap="square" lIns="0" tIns="0" rIns="0" bIns="0" rtlCol="0" anchor="ctr"/>
+          <a:lstStyle/>
+          <a:p>
+            <a:pPr indent="0" marL="0">
+              <a:buNone/>
+            </a:pPr>
+            <a:r>
+              <a:rPr lang="en-US" sz="1800" b="1" dirty="0">
+                <a:solidFill>
+                  <a:srgbClr val="2A78D6"/>
+                </a:solidFill>
+              </a:rPr>
+              <a:t>Collectivists</a:t>
+            </a:r>
+            <a:endParaRPr lang="en-US" sz="1800" dirty="0"/>
+          </a:p>
+        </p:txBody>
+      </p:sp>
+      <p:sp>
+        <p:nvSpPr>
+          <p:cNvPr id="6" name="bullets"/>
+          <p:cNvSpPr txBox="1"/>
+          <p:nvPr/>
+        </p:nvSpPr>
+        <p:spPr>
+          <a:xfrm>
+            <a:off x="4846320" y="1600200"/>
+            <a:ext cx="3657600" cy="1737360"/>
+          </a:xfrm>
+          <a:prstGeom prst="rect">
+            <a:avLst/>
+          </a:prstGeom>
+          <a:noFill/>
+          <a:ln/>
+        </p:spPr>
+        <p:txBody>
+          <a:bodyPr wrap="square" lIns="0" tIns="0" rIns="0" bIns="0" rtlCol="0" anchor="t"/>
+          <a:lstStyle/>
+          <a:p>
+            <a:pPr marL="177800" indent="-177800">
+              <a:spcAft>
+                <a:spcPts val="500"/>
+              </a:spcAft>
+              <a:buSzPct val="100000"/>
+              <a:buChar char="•"/>
+            </a:pPr>
+            <a:r>
+              <a:rPr lang="en-US" sz="1300" dirty="0">
+                <a:solidFill>
+                  <a:schemeClr val="tx1"/>
+                </a:solidFill>
+              </a:rPr>
+              <a:t>Watch what neighbours do and what the public news says</a:t>
+            </a:r>
+            <a:endParaRPr lang="en-US" sz="1300" dirty="0"/>
+          </a:p>
+          <a:p>
+            <a:pPr marL="177800" indent="-177800">
+              <a:spcAft>
+                <a:spcPts val="500"/>
+              </a:spcAft>
+              <a:buSzPct val="100000"/>
+              <a:buChar char="•"/>
+            </a:pPr>
+            <a:r>
+              <a:rPr lang="en-US" sz="1300" dirty="0">
+                <a:solidFill>
+                  <a:schemeClr val="tx1"/>
+                </a:solidFill>
+              </a:rPr>
+              <a:t>Put little weight on their own information</a:t>
+            </a:r>
+            <a:endParaRPr lang="en-US" sz="1300" dirty="0"/>
+          </a:p>
+          <a:p>
+            <a:pPr marL="177800" indent="-177800">
+              <a:spcAft>
+                <a:spcPts val="500"/>
+              </a:spcAft>
+              <a:buSzPct val="100000"/>
+              <a:buChar char="•"/>
+            </a:pPr>
+            <a:r>
+              <a:rPr lang="en-US" sz="1300" dirty="0">
+                <a:solidFill>
+                  <a:schemeClr val="tx1"/>
+                </a:solidFill>
+              </a:rPr>
+              <a:t>Weight on the social side: λ = 0.5 to 0.9</a:t>
+            </a:r>
+            <a:endParaRPr lang="en-US" sz="1300" dirty="0"/>
+          </a:p>
+          <a:p>
+            <a:pPr marL="177800" indent="-177800">
+              <a:spcAft>
+                <a:spcPts val="500"/>
+              </a:spcAft>
+              <a:buSzPct val="100000"/>
+              <a:buChar char="•"/>
+            </a:pPr>
+            <a:r>
+              <a:rPr lang="en-US" sz="1300" dirty="0">
+                <a:solidFill>
+                  <a:schemeClr val="tx1"/>
+                </a:solidFill>
+              </a:rPr>
+              <a:t>Move when others move</a:t>
+            </a:r>
+            <a:endParaRPr lang="en-US" sz="1300" dirty="0"/>
+          </a:p>
+        </p:txBody>
+      </p:sp>
+      <p:sp>
+        <p:nvSpPr>
+          <p:cNvPr id="7" name="pairs-head"/>
+          <p:cNvSpPr txBox="1"/>
+          <p:nvPr/>
+        </p:nvSpPr>
+        <p:spPr>
+          <a:xfrm>
+            <a:off x="457200" y="3886200"/>
+            <a:ext cx="8229600" cy="329184"/>
+          </a:xfrm>
+          <a:prstGeom prst="rect">
+            <a:avLst/>
+          </a:prstGeom>
+          <a:noFill/>
+          <a:ln/>
+        </p:spPr>
+        <p:txBody>
+          <a:bodyPr wrap="square" lIns="0" tIns="0" rIns="0" bIns="0" rtlCol="0" anchor="ctr"/>
+          <a:lstStyle/>
+          <a:p>
+            <a:pPr algn="ctr" indent="0" marL="0">
+              <a:buNone/>
+            </a:pPr>
+            <a:r>
+              <a:rPr lang="en-US" sz="1300" b="1" dirty="0">
+                <a:solidFill>
+                  <a:schemeClr val="tx2"/>
+                </a:solidFill>
+              </a:rPr>
+              <a:t>Signal interpretation gap</a:t>
+            </a:r>
+            <a:endParaRPr lang="en-US" sz="1300" dirty="0"/>
+          </a:p>
+        </p:txBody>
+      </p:sp>
+      <p:sp>
+        <p:nvSpPr>
+          <p:cNvPr id="8" name="chip"/>
+          <p:cNvSpPr/>
+          <p:nvPr/>
+        </p:nvSpPr>
+        <p:spPr>
+          <a:xfrm>
+            <a:off x="2057400" y="3429000"/>
+            <a:ext cx="914400" cy="329184"/>
+          </a:xfrm>
+          <a:prstGeom prst="roundRect">
+            <a:avLst>
+              <a:gd name="adj" fmla="val 16667"/>
+            </a:avLst>
+          </a:prstGeom>
+          <a:solidFill>
+            <a:schemeClr val="tx2"/>
+          </a:solidFill>
+          <a:ln w="12700">
+            <a:solidFill>
+              <a:schemeClr val="tx2"/>
+            </a:solidFill>
+            <a:prstDash val="solid"/>
+          </a:ln>
+        </p:spPr>
+      </p:sp>
+      <p:sp>
+        <p:nvSpPr>
+          <p:cNvPr id="9" name="chip-label"/>
+          <p:cNvSpPr txBox="1"/>
+          <p:nvPr/>
+        </p:nvSpPr>
+        <p:spPr>
+          <a:xfrm>
+            <a:off x="2057400" y="3429000"/>
+            <a:ext cx="914400" cy="329184"/>
+          </a:xfrm>
+          <a:prstGeom prst="rect">
+            <a:avLst/>
+          </a:prstGeom>
+          <a:noFill/>
+          <a:ln/>
+        </p:spPr>
+        <p:txBody>
+          <a:bodyPr wrap="square" lIns="0" tIns="0" rIns="0" bIns="0" rtlCol="0" anchor="ctr"/>
+          <a:lstStyle/>
+          <a:p>
+            <a:pPr algn="ctr" indent="0" marL="0">
+              <a:buNone/>
+            </a:pPr>
+            <a:r>
+              <a:rPr lang="en-US" sz="1100" b="1" dirty="0">
+                <a:solidFill>
+                  <a:schemeClr val="bg1"/>
+                </a:solidFill>
+                <a:latin typeface="Cambria" pitchFamily="34" charset="0"/>
+                <a:ea typeface="Cambria" pitchFamily="34" charset="-122"/>
+                <a:cs typeface="Cambria" pitchFamily="34" charset="-120"/>
+              </a:rPr>
+              <a:t>(0.1, 0.9)</a:t>
+            </a:r>
+            <a:endParaRPr lang="en-US" sz="1100" dirty="0"/>
+          </a:p>
+        </p:txBody>
+      </p:sp>
+      <p:sp>
+        <p:nvSpPr>
+          <p:cNvPr id="10" name="pair-label"/>
+          <p:cNvSpPr txBox="1"/>
+          <p:nvPr/>
+        </p:nvSpPr>
+        <p:spPr>
+          <a:xfrm>
+            <a:off x="3017520" y="3429000"/>
+            <a:ext cx="777240" cy="329184"/>
+          </a:xfrm>
+          <a:prstGeom prst="rect">
+            <a:avLst/>
+          </a:prstGeom>
+          <a:noFill/>
+          <a:ln/>
+        </p:spPr>
+        <p:txBody>
+          <a:bodyPr wrap="square" lIns="0" tIns="0" rIns="0" bIns="0" rtlCol="0" anchor="ctr"/>
+          <a:lstStyle/>
+          <a:p>
+            <a:pPr indent="0" marL="0">
+              <a:buNone/>
+            </a:pPr>
+            <a:r>
+              <a:rPr lang="en-US" sz="1200" dirty="0">
+                <a:solidFill>
+                  <a:schemeClr val="accent3"/>
+                </a:solidFill>
+              </a:rPr>
+              <a:t>wide gap</a:t>
+            </a:r>
+            <a:endParaRPr lang="en-US" sz="1200" dirty="0"/>
+          </a:p>
+        </p:txBody>
+      </p:sp>
+      <p:sp>
+        <p:nvSpPr>
+          <p:cNvPr id="11" name="chip"/>
+          <p:cNvSpPr/>
+          <p:nvPr/>
+        </p:nvSpPr>
+        <p:spPr>
+          <a:xfrm>
+            <a:off x="3794760" y="3429000"/>
+            <a:ext cx="914400" cy="329184"/>
+          </a:xfrm>
+          <a:prstGeom prst="roundRect">
+            <a:avLst>
+              <a:gd name="adj" fmla="val 16667"/>
+            </a:avLst>
+          </a:prstGeom>
+          <a:solidFill>
+            <a:schemeClr val="accent3"/>
+          </a:solidFill>
+          <a:ln w="12700">
+            <a:solidFill>
+              <a:schemeClr val="accent3"/>
+            </a:solidFill>
+            <a:prstDash val="solid"/>
+          </a:ln>
+        </p:spPr>
+      </p:sp>
+      <p:sp>
+        <p:nvSpPr>
+          <p:cNvPr id="12" name="chip-label"/>
+          <p:cNvSpPr txBox="1"/>
+          <p:nvPr/>
+        </p:nvSpPr>
+        <p:spPr>
+          <a:xfrm>
+            <a:off x="3794760" y="3429000"/>
+            <a:ext cx="914400" cy="329184"/>
+          </a:xfrm>
+          <a:prstGeom prst="rect">
+            <a:avLst/>
+          </a:prstGeom>
+          <a:noFill/>
+          <a:ln/>
+        </p:spPr>
+        <p:txBody>
+          <a:bodyPr wrap="square" lIns="0" tIns="0" rIns="0" bIns="0" rtlCol="0" anchor="ctr"/>
+          <a:lstStyle/>
+          <a:p>
+            <a:pPr algn="ctr" indent="0" marL="0">
+              <a:buNone/>
+            </a:pPr>
+            <a:r>
+              <a:rPr lang="en-US" sz="1100" b="1" dirty="0">
+                <a:solidFill>
+                  <a:schemeClr val="bg1"/>
+                </a:solidFill>
+                <a:latin typeface="Cambria" pitchFamily="34" charset="0"/>
+                <a:ea typeface="Cambria" pitchFamily="34" charset="-122"/>
+                <a:cs typeface="Cambria" pitchFamily="34" charset="-120"/>
+              </a:rPr>
+              <a:t>(0.2, 0.8)</a:t>
+            </a:r>
+            <a:endParaRPr lang="en-US" sz="1100" dirty="0"/>
+          </a:p>
+        </p:txBody>
+      </p:sp>
+      <p:sp>
+        <p:nvSpPr>
+          <p:cNvPr id="13" name="pair-label"/>
+          <p:cNvSpPr txBox="1"/>
+          <p:nvPr/>
+        </p:nvSpPr>
+        <p:spPr>
+          <a:xfrm>
+            <a:off x="4754880" y="3429000"/>
+            <a:ext cx="777240" cy="329184"/>
+          </a:xfrm>
+          <a:prstGeom prst="rect">
+            <a:avLst/>
+          </a:prstGeom>
+          <a:noFill/>
+          <a:ln/>
+        </p:spPr>
+        <p:txBody>
+          <a:bodyPr wrap="square" lIns="0" tIns="0" rIns="0" bIns="0" rtlCol="0" anchor="ctr"/>
+          <a:lstStyle/>
+          <a:p>
+            <a:pPr indent="0" marL="0">
+              <a:buNone/>
+            </a:pPr>
+            <a:r>
+              <a:rPr lang="en-US" sz="1200" dirty="0">
+                <a:solidFill>
+                  <a:schemeClr val="accent3"/>
+                </a:solidFill>
+              </a:rPr>
+              <a:t>medium</a:t>
+            </a:r>
+            <a:endParaRPr lang="en-US" sz="1200" dirty="0"/>
+          </a:p>
+        </p:txBody>
+      </p:sp>
+      <p:sp>
+        <p:nvSpPr>
+          <p:cNvPr id="14" name="chip"/>
+          <p:cNvSpPr/>
+          <p:nvPr/>
+        </p:nvSpPr>
+        <p:spPr>
+          <a:xfrm>
+            <a:off x="5532120" y="3429000"/>
+            <a:ext cx="914400" cy="329184"/>
+          </a:xfrm>
+          <a:prstGeom prst="roundRect">
+            <a:avLst>
+              <a:gd name="adj" fmla="val 16667"/>
+            </a:avLst>
+          </a:prstGeom>
+          <a:solidFill>
+            <a:schemeClr val="accent4"/>
+          </a:solidFill>
+          <a:ln w="12700">
+            <a:solidFill>
+              <a:schemeClr val="accent4"/>
+            </a:solidFill>
+            <a:prstDash val="solid"/>
+          </a:ln>
+        </p:spPr>
+      </p:sp>
+      <p:sp>
+        <p:nvSpPr>
+          <p:cNvPr id="15" name="chip-label"/>
+          <p:cNvSpPr txBox="1"/>
+          <p:nvPr/>
+        </p:nvSpPr>
+        <p:spPr>
+          <a:xfrm>
+            <a:off x="5532120" y="3429000"/>
+            <a:ext cx="914400" cy="329184"/>
+          </a:xfrm>
+          <a:prstGeom prst="rect">
+            <a:avLst/>
+          </a:prstGeom>
+          <a:noFill/>
+          <a:ln/>
+        </p:spPr>
+        <p:txBody>
+          <a:bodyPr wrap="square" lIns="0" tIns="0" rIns="0" bIns="0" rtlCol="0" anchor="ctr"/>
+          <a:lstStyle/>
+          <a:p>
+            <a:pPr algn="ctr" indent="0" marL="0">
+              <a:buNone/>
+            </a:pPr>
+            <a:r>
+              <a:rPr lang="en-US" sz="1100" b="1" dirty="0">
+                <a:solidFill>
+                  <a:schemeClr val="tx1"/>
+                </a:solidFill>
+                <a:latin typeface="Cambria" pitchFamily="34" charset="0"/>
+                <a:ea typeface="Cambria" pitchFamily="34" charset="-122"/>
+                <a:cs typeface="Cambria" pitchFamily="34" charset="-120"/>
+              </a:rPr>
+              <a:t>(0.3, 0.5)</a:t>
+            </a:r>
+            <a:endParaRPr lang="en-US" sz="1100" dirty="0"/>
+          </a:p>
+        </p:txBody>
+      </p:sp>
+      <p:sp>
+        <p:nvSpPr>
+          <p:cNvPr id="16" name="pair-label"/>
+          <p:cNvSpPr txBox="1"/>
+          <p:nvPr/>
+        </p:nvSpPr>
+        <p:spPr>
+          <a:xfrm>
+            <a:off x="6492240" y="3429000"/>
+            <a:ext cx="777240" cy="329184"/>
+          </a:xfrm>
+          <a:prstGeom prst="rect">
+            <a:avLst/>
+          </a:prstGeom>
+          <a:noFill/>
+          <a:ln/>
+        </p:spPr>
+        <p:txBody>
+          <a:bodyPr wrap="square" lIns="0" tIns="0" rIns="0" bIns="0" rtlCol="0" anchor="ctr"/>
+          <a:lstStyle/>
+          <a:p>
+            <a:pPr indent="0" marL="0">
+              <a:buNone/>
+            </a:pPr>
+            <a:r>
+              <a:rPr lang="en-US" sz="1200" dirty="0">
+                <a:solidFill>
+                  <a:schemeClr val="accent3"/>
+                </a:solidFill>
+              </a:rPr>
+              <a:t>narrow</a:t>
+            </a:r>
+            <a:endParaRPr lang="en-US" sz="1200" dirty="0"/>
+          </a:p>
+        </p:txBody>
+      </p:sp>
       <p:sp>
         <p:nvSpPr>
           <p:cNvPr id="25" name="Slide Number Placeholder 0"/>

</xml_diff>

<commit_message>
Deck: individualists in red (D62828) in the text and the herding figure; stopgap recolour script
Co-Authored-By: Claude Fable 5.1 <noreply@anthropic.com>
</commit_message>
<xml_diff>
--- a/docs/deck_2026-10-26_seminar.pptx
+++ b/docs/deck_2026-10-26_seminar.pptx
@@ -122,7 +122,7 @@
   <p:extLst>
     <p:ext uri="{521415D9-36F7-43E2-AB2F-B90AF26B5E84}">
       <p14:sectionLst xmlns:p14="http://schemas.microsoft.com/office/powerpoint/2010/main">
-        <p14:section name="Opening" id="{4658e545-11c0-43ca-f693-22e28a4924bf}">
+        <p14:section name="Opening" id="{ed600e3b-1275-a80f-2c4f-ee723e1245b3}">
           <p14:sldIdLst>
             <p14:sldId id="256"/>
             <p14:sldId id="257"/>
@@ -132,13 +132,13 @@
             <p14:sldId id="262"/>
           </p14:sldIdLst>
         </p14:section>
-        <p14:section name="The model" id="{8adb3581-b003-8914-350c-6fc655770fe6}">
+        <p14:section name="The model" id="{2f868b52-186f-7a43-bf93-9398eceea952}">
           <p14:sldIdLst>
             <p14:sldId id="263"/>
             <p14:sldId id="264"/>
           </p14:sldIdLst>
         </p14:section>
-        <p14:section name="Results" id="{90084578-f552-8e86-299c-05d47401621d}">
+        <p14:section name="Results" id="{b8a4100a-4eae-9c37-0dd0-858f18d9db70}">
           <p14:sldIdLst>
             <p14:sldId id="265"/>
             <p14:sldId id="266"/>
@@ -147,12 +147,12 @@
             <p14:sldId id="269"/>
           </p14:sldIdLst>
         </p14:section>
-        <p14:section name="Validation" id="{b15d4de9-3e77-5966-dd7f-262bcb2e547c}">
+        <p14:section name="Validation" id="{4ff5f7c7-474e-bc74-f6fb-c7637f8bae2a}">
           <p14:sldIdLst>
             <p14:sldId id="270"/>
           </p14:sldIdLst>
         </p14:section>
-        <p14:section name="Close" id="{19d0b0b1-2032-f5c4-417b-6e68be271e28}">
+        <p14:section name="Close" id="{5b39c763-0bb8-fb51-1988-2d9216822688}">
           <p14:sldIdLst>
             <p14:sldId id="271"/>
           </p14:sldIdLst>
@@ -5426,7 +5426,7 @@
             <a:r>
               <a:rPr lang="en-US" sz="3000" b="1" dirty="0">
                 <a:solidFill>
-                  <a:srgbClr val="EB6834"/>
+                  <a:srgbClr val="D62828"/>
                 </a:solidFill>
                 <a:latin typeface="Cambria" pitchFamily="34" charset="0"/>
                 <a:ea typeface="Cambria" pitchFamily="34" charset="-122"/>
@@ -5996,7 +5996,7 @@
             <a:r>
               <a:rPr lang="en-US" sz="1800" b="1" dirty="0">
                 <a:solidFill>
-                  <a:srgbClr val="EB6834"/>
+                  <a:srgbClr val="D62828"/>
                 </a:solidFill>
               </a:rPr>
               <a:t>Individualists</a:t>

</xml_diff>

<commit_message>
Deck: model section card shortened to An agent-based bank run model
Co-Authored-By: Claude Fable 5.1 <noreply@anthropic.com>
</commit_message>
<xml_diff>
--- a/docs/deck_2026-10-26_seminar.pptx
+++ b/docs/deck_2026-10-26_seminar.pptx
@@ -122,7 +122,7 @@
   <p:extLst>
     <p:ext uri="{521415D9-36F7-43E2-AB2F-B90AF26B5E84}">
       <p14:sectionLst xmlns:p14="http://schemas.microsoft.com/office/powerpoint/2010/main">
-        <p14:section name="Opening" id="{ed600e3b-1275-a80f-2c4f-ee723e1245b3}">
+        <p14:section name="Opening" id="{795e3b42-6817-3d83-12bd-e2c827b8ce7f}">
           <p14:sldIdLst>
             <p14:sldId id="256"/>
             <p14:sldId id="257"/>
@@ -132,13 +132,13 @@
             <p14:sldId id="262"/>
           </p14:sldIdLst>
         </p14:section>
-        <p14:section name="The model" id="{2f868b52-186f-7a43-bf93-9398eceea952}">
+        <p14:section name="The model" id="{1445559a-9fef-cd07-96c5-9e716de719f2}">
           <p14:sldIdLst>
             <p14:sldId id="263"/>
             <p14:sldId id="264"/>
           </p14:sldIdLst>
         </p14:section>
-        <p14:section name="Results" id="{b8a4100a-4eae-9c37-0dd0-858f18d9db70}">
+        <p14:section name="Results" id="{5952e06b-c898-3c48-8730-6571701602d6}">
           <p14:sldIdLst>
             <p14:sldId id="265"/>
             <p14:sldId id="266"/>
@@ -147,12 +147,12 @@
             <p14:sldId id="269"/>
           </p14:sldIdLst>
         </p14:section>
-        <p14:section name="Validation" id="{4ff5f7c7-474e-bc74-f6fb-c7637f8bae2a}">
+        <p14:section name="Validation" id="{22546429-4435-0580-b38e-7a7d4cf27411}">
           <p14:sldIdLst>
             <p14:sldId id="270"/>
           </p14:sldIdLst>
         </p14:section>
-        <p14:section name="Close" id="{5b39c763-0bb8-fb51-1988-2d9216822688}">
+        <p14:section name="Close" id="{7855dd14-854f-0d15-547b-8ea7af6c6d9f}">
           <p14:sldIdLst>
             <p14:sldId id="271"/>
           </p14:sldIdLst>
@@ -5121,7 +5121,7 @@
                   <a:schemeClr val="bg1"/>
                 </a:solidFill>
               </a:rPr>
-              <a:t>An agent-based bank run model with culturally heterogeneous signal interpretation</a:t>
+              <a:t>An agent-based bank run model</a:t>
             </a:r>
             <a:endParaRPr lang="en-US" sz="3200" dirty="0"/>
           </a:p>

</xml_diff>

<commit_message>
Deck: model section card reads An agent-based bank run model / with culture
Co-Authored-By: Claude Opus 5.5 <noreply@anthropic.com>
</commit_message>
<xml_diff>
--- a/docs/deck_2026-10-26_seminar.pptx
+++ b/docs/deck_2026-10-26_seminar.pptx
@@ -5122,6 +5122,21 @@
                 </a:solidFill>
               </a:rPr>
               <a:t>An agent-based bank run model</a:t>
+            </a:r>
+            <a:br>
+              <a:rPr lang="en-US" sz="3200" b="1" dirty="0">
+                <a:solidFill>
+                  <a:schemeClr val="bg1"/>
+                </a:solidFill>
+              </a:rPr>
+            </a:br>
+            <a:r>
+              <a:rPr lang="en-US" sz="3200" b="1" dirty="0">
+                <a:solidFill>
+                  <a:schemeClr val="bg1"/>
+                </a:solidFill>
+              </a:rPr>
+              <a:t>with culture</a:t>
             </a:r>
             <a:endParaRPr lang="en-US" sz="3200" dirty="0"/>
           </a:p>

</xml_diff>

<commit_message>
Deck: slide 2 pairs the 1931 American Union Bank run photo (National Archives, public domain) with the FSB screenshot
Co-Authored-By: Claude Opus 5.5 <noreply@anthropic.com>
</commit_message>
<xml_diff>
--- a/docs/deck_2026-10-26_seminar.pptx
+++ b/docs/deck_2026-10-26_seminar.pptx
@@ -122,7 +122,7 @@
   <p:extLst>
     <p:ext uri="{521415D9-36F7-43E2-AB2F-B90AF26B5E84}">
       <p14:sectionLst xmlns:p14="http://schemas.microsoft.com/office/powerpoint/2010/main">
-        <p14:section name="Opening" id="{795e3b42-6817-3d83-12bd-e2c827b8ce7f}">
+        <p14:section name="Opening" id="{e50f61ee-7bef-7ce8-4b28-4b59a5327a61}">
           <p14:sldIdLst>
             <p14:sldId id="256"/>
             <p14:sldId id="257"/>
@@ -132,13 +132,13 @@
             <p14:sldId id="262"/>
           </p14:sldIdLst>
         </p14:section>
-        <p14:section name="The model" id="{1445559a-9fef-cd07-96c5-9e716de719f2}">
+        <p14:section name="The model" id="{93910c9f-1099-270d-c07f-5103a4462bd3}">
           <p14:sldIdLst>
             <p14:sldId id="263"/>
             <p14:sldId id="264"/>
           </p14:sldIdLst>
         </p14:section>
-        <p14:section name="Results" id="{5952e06b-c898-3c48-8730-6571701602d6}">
+        <p14:section name="Results" id="{72fcd71d-aa50-e9e8-c28d-1957eafc80c4}">
           <p14:sldIdLst>
             <p14:sldId id="265"/>
             <p14:sldId id="266"/>
@@ -147,12 +147,12 @@
             <p14:sldId id="269"/>
           </p14:sldIdLst>
         </p14:section>
-        <p14:section name="Validation" id="{22546429-4435-0580-b38e-7a7d4cf27411}">
+        <p14:section name="Validation" id="{2e89d5aa-f328-3aec-2413-2c4b74dc54f0}">
           <p14:sldIdLst>
             <p14:sldId id="270"/>
           </p14:sldIdLst>
         </p14:section>
-        <p14:section name="Close" id="{7855dd14-854f-0d15-547b-8ea7af6c6d9f}">
+        <p14:section name="Close" id="{244f6fad-fb3d-8a9f-c084-bd96c103640b}">
           <p14:sldIdLst>
             <p14:sldId id="271"/>
           </p14:sldIdLst>
@@ -1265,7 +1265,7 @@
           <a:p>
             <a:r>
               <a:rPr lang="en-US" dirty="0"/>
-              <a:t>~1.5 min. Raise the question only: who runs? Theory (Diamond–Dybvig) says runs can happen; it is silent on who runs first and how a run spreads. The screenshot: the FSB warned the G20 on 12 October 2026 that a fully reserved stablecoin can still face a redemption run. Even a regulator thinking about a modern run asks whether one happens, not who starts it. Alternative screenshot in figures/deck is not provided; the Nano Banc failure (25 September 2026, American Banker) was a capital failure, not a run.</a:t>
+              <a:t>~1.5 min. Photo: the 1931 run on the American Union Bank, New York (National Archives, public domain). Raise the question only: who runs? Theory (Diamond–Dybvig) says runs can happen; it is silent on who runs first and how a run spreads. The screenshot: the FSB warned the G20 on 12 October 2026 that a fully reserved stablecoin can still face a redemption run. Even a regulator thinking about a modern run asks whether one happens, not who starts it. Alternative screenshot in figures/deck is not provided; the Nano Banc failure (25 September 2026, American Banker) was a capital failure, not a run.</a:t>
             </a:r>
             <a:endParaRPr lang="en-US" dirty="0"/>
           </a:p>
@@ -4181,7 +4181,7 @@
       </p:sp>
       <p:pic>
         <p:nvPicPr>
-          <p:cNvPr id="3" name="news" descr="Screenshot of a CryptoSlate news article dated 12 October 2026: Global watchdog warns the $300 billion stablecoin market could face bank runs even with full reserves. The FSB says cross-border liquidity mismatches could trigger redemption crises and threaten dollar pegs as regulators prepare for G20 discussions.">    </p:cNvPr>
+          <p:cNvPr id="3" name="aub" descr="Black-and-white photograph from 1931: a dense crowd of depositors in hats and suits packs the sidewalk outside the American Union Bank in New York, at the corner of West 37th Street, during a bank run.">    </p:cNvPr>
           <p:cNvPicPr>
             <a:picLocks noChangeAspect="1"/>
           </p:cNvPicPr>
@@ -4195,8 +4195,8 @@
         </p:blipFill>
         <p:spPr>
           <a:xfrm>
-            <a:off x="2414267" y="1051560"/>
-            <a:ext cx="4315465" cy="3337560"/>
+            <a:off x="477591" y="1051560"/>
+            <a:ext cx="3982578" cy="3108960"/>
           </a:xfrm>
           <a:prstGeom prst="rect">
             <a:avLst/>
@@ -4211,8 +4211,68 @@
         </p:nvSpPr>
         <p:spPr>
           <a:xfrm>
-            <a:off x="2414267" y="4434840"/>
-            <a:ext cx="4315465" cy="274320"/>
+            <a:off x="477591" y="4206240"/>
+            <a:ext cx="3982578" cy="274320"/>
+          </a:xfrm>
+          <a:prstGeom prst="rect">
+            <a:avLst/>
+          </a:prstGeom>
+          <a:noFill/>
+          <a:ln/>
+        </p:spPr>
+        <p:txBody>
+          <a:bodyPr wrap="square" lIns="0" tIns="0" rIns="0" bIns="0" rtlCol="0" anchor="ctr"/>
+          <a:lstStyle/>
+          <a:p>
+            <a:pPr indent="0" marL="0">
+              <a:buNone/>
+            </a:pPr>
+            <a:r>
+              <a:rPr lang="en-US" sz="1000" i="1" dirty="0">
+                <a:solidFill>
+                  <a:schemeClr val="accent3"/>
+                </a:solidFill>
+              </a:rPr>
+              <a:t>Run on the American Union Bank, New York, 1931. National Archives; public domain.</a:t>
+            </a:r>
+            <a:endParaRPr lang="en-US" sz="1000" dirty="0"/>
+          </a:p>
+        </p:txBody>
+      </p:sp>
+      <p:pic>
+        <p:nvPicPr>
+          <p:cNvPr id="5" name="news" descr="Screenshot of a CryptoSlate news article dated 12 October 2026: Global watchdog warns the $300 billion stablecoin market could face bank runs even with full reserves. The FSB says cross-border liquidity mismatches could trigger redemption crises and threaten dollar pegs as regulators prepare for G20 discussions.">    </p:cNvPr>
+          <p:cNvPicPr>
+            <a:picLocks noChangeAspect="1"/>
+          </p:cNvPicPr>
+          <p:nvPr/>
+        </p:nvPicPr>
+        <p:blipFill>
+          <a:blip r:embed="rId2"/>
+          <a:stretch>
+            <a:fillRect/>
+          </a:stretch>
+        </p:blipFill>
+        <p:spPr>
+          <a:xfrm>
+            <a:off x="4665177" y="1051560"/>
+            <a:ext cx="4019885" cy="3108960"/>
+          </a:xfrm>
+          <a:prstGeom prst="rect">
+            <a:avLst/>
+          </a:prstGeom>
+        </p:spPr>
+      </p:pic>
+      <p:sp>
+        <p:nvSpPr>
+          <p:cNvPr id="6" name="caption"/>
+          <p:cNvSpPr txBox="1"/>
+          <p:nvPr/>
+        </p:nvSpPr>
+        <p:spPr>
+          <a:xfrm>
+            <a:off x="4665177" y="4206240"/>
+            <a:ext cx="4019885" cy="274320"/>
           </a:xfrm>
           <a:prstGeom prst="rect">
             <a:avLst/>
@@ -5123,13 +5183,12 @@
               </a:rPr>
               <a:t>An agent-based bank run model</a:t>
             </a:r>
-            <a:br>
-              <a:rPr lang="en-US" sz="3200" b="1" dirty="0">
-                <a:solidFill>
-                  <a:schemeClr val="bg1"/>
-                </a:solidFill>
-              </a:rPr>
-            </a:br>
+            <a:endParaRPr lang="en-US" sz="3200" dirty="0"/>
+          </a:p>
+          <a:p>
+            <a:pPr algn="ctr" indent="0" marL="0">
+              <a:buNone/>
+            </a:pPr>
             <a:r>
               <a:rPr lang="en-US" sz="3200" b="1" dirty="0">
                 <a:solidFill>

</xml_diff>